<commit_message>
Backdrop VOA: product glow pedestals, glass stats bar, numbered Mantiz list
Co-Authored-By: Claude Opus 5.5 <noreply@anthropic.com>
Claude-Session: https://claude.ai/code/session_013QJi2k1EkL4AWCx1Ymi9NU
</commit_message>
<xml_diff>
--- a/backdrop-voa/backdrop-VOA.pptx
+++ b/backdrop-voa/backdrop-VOA.pptx
@@ -1138,7 +1138,7 @@
         </p:blipFill>
         <p:spPr>
           <a:xfrm>
-            <a:off x="3390900" y="2858790"/>
+            <a:off x="3390900" y="2836565"/>
             <a:ext cx="1676400" cy="419100"/>
           </a:xfrm>
           <a:prstGeom prst="rect">
@@ -1162,7 +1162,7 @@
         </p:blipFill>
         <p:spPr>
           <a:xfrm>
-            <a:off x="5213416" y="2723952"/>
+            <a:off x="5213416" y="2701727"/>
             <a:ext cx="3670168" cy="1234877"/>
           </a:xfrm>
           <a:prstGeom prst="rect">
@@ -1186,7 +1186,7 @@
         </p:blipFill>
         <p:spPr>
           <a:xfrm>
-            <a:off x="7102773" y="4448870"/>
+            <a:off x="7102773" y="4382195"/>
             <a:ext cx="1720354" cy="419098"/>
           </a:xfrm>
           <a:prstGeom prst="rect">
@@ -1210,7 +1210,7 @@
         </p:blipFill>
         <p:spPr>
           <a:xfrm>
-            <a:off x="3308392" y="4217789"/>
+            <a:off x="3308392" y="4151114"/>
             <a:ext cx="3670215" cy="1198761"/>
           </a:xfrm>
           <a:prstGeom prst="rect">
@@ -1531,7 +1531,7 @@
         </p:nvSpPr>
         <p:spPr>
           <a:xfrm>
-            <a:off x="3536425" y="3384570"/>
+            <a:off x="3536425" y="3362345"/>
             <a:ext cx="1385251" cy="548640"/>
           </a:xfrm>
           <a:prstGeom prst="rect">
@@ -1587,7 +1587,7 @@
         </p:nvSpPr>
         <p:spPr>
           <a:xfrm>
-            <a:off x="7148513" y="4997510"/>
+            <a:off x="7148513" y="4930835"/>
             <a:ext cx="1628775" cy="274320"/>
           </a:xfrm>
           <a:prstGeom prst="rect">
@@ -1626,8 +1626,8 @@
         </p:nvSpPr>
         <p:spPr>
           <a:xfrm>
-            <a:off x="3253645" y="5608915"/>
-            <a:ext cx="1407986" cy="268129"/>
+            <a:off x="3314700" y="5558115"/>
+            <a:ext cx="1447800" cy="268129"/>
           </a:xfrm>
           <a:prstGeom prst="rect">
             <a:avLst/>
@@ -1665,8 +1665,8 @@
         </p:nvSpPr>
         <p:spPr>
           <a:xfrm>
-            <a:off x="3253645" y="5867400"/>
-            <a:ext cx="1407986" cy="152400"/>
+            <a:off x="3314700" y="5816600"/>
+            <a:ext cx="1447800" cy="152400"/>
           </a:xfrm>
           <a:prstGeom prst="rect">
             <a:avLst/>
@@ -1704,8 +1704,8 @@
         </p:nvSpPr>
         <p:spPr>
           <a:xfrm>
-            <a:off x="4679220" y="5608915"/>
-            <a:ext cx="1407986" cy="268129"/>
+            <a:off x="4693095" y="5558115"/>
+            <a:ext cx="1440561" cy="268129"/>
           </a:xfrm>
           <a:prstGeom prst="rect">
             <a:avLst/>
@@ -1743,8 +1743,8 @@
         </p:nvSpPr>
         <p:spPr>
           <a:xfrm>
-            <a:off x="4679220" y="5867400"/>
-            <a:ext cx="1407986" cy="152400"/>
+            <a:off x="4693095" y="5816600"/>
+            <a:ext cx="1440561" cy="152400"/>
           </a:xfrm>
           <a:prstGeom prst="rect">
             <a:avLst/>
@@ -1782,8 +1782,8 @@
         </p:nvSpPr>
         <p:spPr>
           <a:xfrm>
-            <a:off x="6104795" y="5608915"/>
-            <a:ext cx="1407986" cy="268129"/>
+            <a:off x="6064695" y="5558115"/>
+            <a:ext cx="1440561" cy="268129"/>
           </a:xfrm>
           <a:prstGeom prst="rect">
             <a:avLst/>
@@ -1821,8 +1821,8 @@
         </p:nvSpPr>
         <p:spPr>
           <a:xfrm>
-            <a:off x="6104795" y="5867400"/>
-            <a:ext cx="1407986" cy="152400"/>
+            <a:off x="6064695" y="5816600"/>
+            <a:ext cx="1440561" cy="152400"/>
           </a:xfrm>
           <a:prstGeom prst="rect">
             <a:avLst/>
@@ -1860,8 +1860,8 @@
         </p:nvSpPr>
         <p:spPr>
           <a:xfrm>
-            <a:off x="7530370" y="5608915"/>
-            <a:ext cx="1407986" cy="268129"/>
+            <a:off x="7436294" y="5558115"/>
+            <a:ext cx="1440561" cy="268129"/>
           </a:xfrm>
           <a:prstGeom prst="rect">
             <a:avLst/>
@@ -1899,8 +1899,8 @@
         </p:nvSpPr>
         <p:spPr>
           <a:xfrm>
-            <a:off x="7530370" y="5867400"/>
-            <a:ext cx="1407986" cy="152400"/>
+            <a:off x="7436294" y="5816600"/>
+            <a:ext cx="1440561" cy="152400"/>
           </a:xfrm>
           <a:prstGeom prst="rect">
             <a:avLst/>
@@ -1938,7 +1938,7 @@
         </p:nvSpPr>
         <p:spPr>
           <a:xfrm>
-            <a:off x="9461500" y="2702560"/>
+            <a:off x="9461500" y="2753360"/>
             <a:ext cx="2461260" cy="220980"/>
           </a:xfrm>
           <a:prstGeom prst="rect">
@@ -1977,8 +1977,47 @@
         </p:nvSpPr>
         <p:spPr>
           <a:xfrm>
-            <a:off x="9461500" y="3037840"/>
-            <a:ext cx="2461260" cy="236220"/>
+            <a:off x="9461500" y="3114040"/>
+            <a:ext cx="292100" cy="350520"/>
+          </a:xfrm>
+          <a:prstGeom prst="rect">
+            <a:avLst/>
+          </a:prstGeom>
+          <a:noFill/>
+          <a:ln/>
+        </p:spPr>
+        <p:txBody>
+          <a:bodyPr wrap="square" lIns="0" tIns="0" rIns="0" bIns="0" rtlCol="0" anchor="ctr"/>
+          <a:lstStyle/>
+          <a:p>
+            <a:pPr algn="ctr" indent="0" marL="0">
+              <a:buNone/>
+            </a:pPr>
+            <a:r>
+              <a:rPr lang="en-US" sz="900" b="1" dirty="0">
+                <a:solidFill>
+                  <a:srgbClr val="FFFFFF"/>
+                </a:solidFill>
+                <a:latin typeface="Arial" pitchFamily="34" charset="0"/>
+                <a:ea typeface="Arial" pitchFamily="34" charset="-122"/>
+                <a:cs typeface="Arial" pitchFamily="34" charset="-120"/>
+              </a:rPr>
+              <a:t>01</a:t>
+            </a:r>
+            <a:endParaRPr lang="en-US" sz="900" dirty="0"/>
+          </a:p>
+        </p:txBody>
+      </p:sp>
+      <p:sp>
+        <p:nvSpPr>
+          <p:cNvPr id="36" name="Text 17"/>
+          <p:cNvSpPr txBox="1"/>
+          <p:nvPr/>
+        </p:nvSpPr>
+        <p:spPr>
+          <a:xfrm>
+            <a:off x="9855200" y="3088640"/>
+            <a:ext cx="2059156" cy="236220"/>
           </a:xfrm>
           <a:prstGeom prst="rect">
             <a:avLst/>
@@ -2010,14 +2049,14 @@
       </p:sp>
       <p:sp>
         <p:nvSpPr>
-          <p:cNvPr id="36" name="Text 17"/>
-          <p:cNvSpPr txBox="1"/>
-          <p:nvPr/>
-        </p:nvSpPr>
-        <p:spPr>
-          <a:xfrm>
-            <a:off x="9461500" y="3263265"/>
-            <a:ext cx="2461260" cy="198120"/>
+          <p:cNvPr id="37" name="Text 18"/>
+          <p:cNvSpPr txBox="1"/>
+          <p:nvPr/>
+        </p:nvSpPr>
+        <p:spPr>
+          <a:xfrm>
+            <a:off x="9855200" y="3309620"/>
+            <a:ext cx="2059156" cy="175260"/>
           </a:xfrm>
           <a:prstGeom prst="rect">
             <a:avLst/>
@@ -2033,7 +2072,7 @@
               <a:buNone/>
             </a:pPr>
             <a:r>
-              <a:rPr lang="en-US" sz="1100" dirty="0">
+              <a:rPr lang="en-US" sz="1000" dirty="0">
                 <a:solidFill>
                   <a:srgbClr val="1D2B5C"/>
                 </a:solidFill>
@@ -2043,20 +2082,59 @@
               </a:rPr>
               <a:t>Lồng cột sống thắt lưng in 3D</a:t>
             </a:r>
-            <a:endParaRPr lang="en-US" sz="1100" dirty="0"/>
-          </a:p>
-        </p:txBody>
-      </p:sp>
-      <p:sp>
-        <p:nvSpPr>
-          <p:cNvPr id="37" name="Text 18"/>
-          <p:cNvSpPr txBox="1"/>
-          <p:nvPr/>
-        </p:nvSpPr>
-        <p:spPr>
-          <a:xfrm>
-            <a:off x="9461500" y="3742690"/>
-            <a:ext cx="2461260" cy="236220"/>
+            <a:endParaRPr lang="en-US" sz="1000" dirty="0"/>
+          </a:p>
+        </p:txBody>
+      </p:sp>
+      <p:sp>
+        <p:nvSpPr>
+          <p:cNvPr id="38" name="Text 19"/>
+          <p:cNvSpPr txBox="1"/>
+          <p:nvPr/>
+        </p:nvSpPr>
+        <p:spPr>
+          <a:xfrm>
+            <a:off x="9461500" y="3793490"/>
+            <a:ext cx="292100" cy="350520"/>
+          </a:xfrm>
+          <a:prstGeom prst="rect">
+            <a:avLst/>
+          </a:prstGeom>
+          <a:noFill/>
+          <a:ln/>
+        </p:spPr>
+        <p:txBody>
+          <a:bodyPr wrap="square" lIns="0" tIns="0" rIns="0" bIns="0" rtlCol="0" anchor="ctr"/>
+          <a:lstStyle/>
+          <a:p>
+            <a:pPr algn="ctr" indent="0" marL="0">
+              <a:buNone/>
+            </a:pPr>
+            <a:r>
+              <a:rPr lang="en-US" sz="900" b="1" dirty="0">
+                <a:solidFill>
+                  <a:srgbClr val="FFFFFF"/>
+                </a:solidFill>
+                <a:latin typeface="Arial" pitchFamily="34" charset="0"/>
+                <a:ea typeface="Arial" pitchFamily="34" charset="-122"/>
+                <a:cs typeface="Arial" pitchFamily="34" charset="-120"/>
+              </a:rPr>
+              <a:t>02</a:t>
+            </a:r>
+            <a:endParaRPr lang="en-US" sz="900" dirty="0"/>
+          </a:p>
+        </p:txBody>
+      </p:sp>
+      <p:sp>
+        <p:nvSpPr>
+          <p:cNvPr id="39" name="Text 20"/>
+          <p:cNvSpPr txBox="1"/>
+          <p:nvPr/>
+        </p:nvSpPr>
+        <p:spPr>
+          <a:xfrm>
+            <a:off x="9855200" y="3768090"/>
+            <a:ext cx="1600611" cy="236220"/>
           </a:xfrm>
           <a:prstGeom prst="rect">
             <a:avLst/>
@@ -2088,14 +2166,14 @@
       </p:sp>
       <p:sp>
         <p:nvSpPr>
-          <p:cNvPr id="38" name="Text 19"/>
-          <p:cNvSpPr txBox="1"/>
-          <p:nvPr/>
-        </p:nvSpPr>
-        <p:spPr>
-          <a:xfrm>
-            <a:off x="9461500" y="3968115"/>
-            <a:ext cx="2461260" cy="198120"/>
+          <p:cNvPr id="40" name="Text 21"/>
+          <p:cNvSpPr txBox="1"/>
+          <p:nvPr/>
+        </p:nvSpPr>
+        <p:spPr>
+          <a:xfrm>
+            <a:off x="9855200" y="3989070"/>
+            <a:ext cx="1600611" cy="175260"/>
           </a:xfrm>
           <a:prstGeom prst="rect">
             <a:avLst/>
@@ -2111,7 +2189,7 @@
               <a:buNone/>
             </a:pPr>
             <a:r>
-              <a:rPr lang="en-US" sz="1100" dirty="0">
+              <a:rPr lang="en-US" sz="1000" dirty="0">
                 <a:solidFill>
                   <a:srgbClr val="1D2B5C"/>
                 </a:solidFill>
@@ -2121,20 +2199,59 @@
               </a:rPr>
               <a:t>Lồng cột sống cổ in 3D</a:t>
             </a:r>
-            <a:endParaRPr lang="en-US" sz="1100" dirty="0"/>
-          </a:p>
-        </p:txBody>
-      </p:sp>
-      <p:sp>
-        <p:nvSpPr>
-          <p:cNvPr id="39" name="Text 20"/>
-          <p:cNvSpPr txBox="1"/>
-          <p:nvPr/>
-        </p:nvSpPr>
-        <p:spPr>
-          <a:xfrm>
-            <a:off x="9461500" y="4447540"/>
-            <a:ext cx="2461260" cy="236220"/>
+            <a:endParaRPr lang="en-US" sz="1000" dirty="0"/>
+          </a:p>
+        </p:txBody>
+      </p:sp>
+      <p:sp>
+        <p:nvSpPr>
+          <p:cNvPr id="41" name="Text 22"/>
+          <p:cNvSpPr txBox="1"/>
+          <p:nvPr/>
+        </p:nvSpPr>
+        <p:spPr>
+          <a:xfrm>
+            <a:off x="9461500" y="4472940"/>
+            <a:ext cx="292100" cy="350520"/>
+          </a:xfrm>
+          <a:prstGeom prst="rect">
+            <a:avLst/>
+          </a:prstGeom>
+          <a:noFill/>
+          <a:ln/>
+        </p:spPr>
+        <p:txBody>
+          <a:bodyPr wrap="square" lIns="0" tIns="0" rIns="0" bIns="0" rtlCol="0" anchor="ctr"/>
+          <a:lstStyle/>
+          <a:p>
+            <a:pPr algn="ctr" indent="0" marL="0">
+              <a:buNone/>
+            </a:pPr>
+            <a:r>
+              <a:rPr lang="en-US" sz="900" b="1" dirty="0">
+                <a:solidFill>
+                  <a:srgbClr val="FFFFFF"/>
+                </a:solidFill>
+                <a:latin typeface="Arial" pitchFamily="34" charset="0"/>
+                <a:ea typeface="Arial" pitchFamily="34" charset="-122"/>
+                <a:cs typeface="Arial" pitchFamily="34" charset="-120"/>
+              </a:rPr>
+              <a:t>03</a:t>
+            </a:r>
+            <a:endParaRPr lang="en-US" sz="900" dirty="0"/>
+          </a:p>
+        </p:txBody>
+      </p:sp>
+      <p:sp>
+        <p:nvSpPr>
+          <p:cNvPr id="42" name="Text 23"/>
+          <p:cNvSpPr txBox="1"/>
+          <p:nvPr/>
+        </p:nvSpPr>
+        <p:spPr>
+          <a:xfrm>
+            <a:off x="9855200" y="4447540"/>
+            <a:ext cx="1045583" cy="236220"/>
           </a:xfrm>
           <a:prstGeom prst="rect">
             <a:avLst/>
@@ -2166,14 +2283,14 @@
       </p:sp>
       <p:sp>
         <p:nvSpPr>
-          <p:cNvPr id="40" name="Text 21"/>
-          <p:cNvSpPr txBox="1"/>
-          <p:nvPr/>
-        </p:nvSpPr>
-        <p:spPr>
-          <a:xfrm>
-            <a:off x="9461500" y="4672965"/>
-            <a:ext cx="2461260" cy="198120"/>
+          <p:cNvPr id="43" name="Text 24"/>
+          <p:cNvSpPr txBox="1"/>
+          <p:nvPr/>
+        </p:nvSpPr>
+        <p:spPr>
+          <a:xfrm>
+            <a:off x="9855200" y="4668520"/>
+            <a:ext cx="1045583" cy="175260"/>
           </a:xfrm>
           <a:prstGeom prst="rect">
             <a:avLst/>
@@ -2189,7 +2306,7 @@
               <a:buNone/>
             </a:pPr>
             <a:r>
-              <a:rPr lang="en-US" sz="1100" dirty="0">
+              <a:rPr lang="en-US" sz="1000" dirty="0">
                 <a:solidFill>
                   <a:srgbClr val="1D2B5C"/>
                 </a:solidFill>
@@ -2199,20 +2316,59 @@
               </a:rPr>
               <a:t>Vít cuống sống</a:t>
             </a:r>
-            <a:endParaRPr lang="en-US" sz="1100" dirty="0"/>
-          </a:p>
-        </p:txBody>
-      </p:sp>
-      <p:sp>
-        <p:nvSpPr>
-          <p:cNvPr id="41" name="Text 22"/>
+            <a:endParaRPr lang="en-US" sz="1000" dirty="0"/>
+          </a:p>
+        </p:txBody>
+      </p:sp>
+      <p:sp>
+        <p:nvSpPr>
+          <p:cNvPr id="44" name="Text 25"/>
           <p:cNvSpPr txBox="1"/>
           <p:nvPr/>
         </p:nvSpPr>
         <p:spPr>
           <a:xfrm>
             <a:off x="9461500" y="5152390"/>
-            <a:ext cx="2461260" cy="236220"/>
+            <a:ext cx="292100" cy="350520"/>
+          </a:xfrm>
+          <a:prstGeom prst="rect">
+            <a:avLst/>
+          </a:prstGeom>
+          <a:noFill/>
+          <a:ln/>
+        </p:spPr>
+        <p:txBody>
+          <a:bodyPr wrap="square" lIns="0" tIns="0" rIns="0" bIns="0" rtlCol="0" anchor="ctr"/>
+          <a:lstStyle/>
+          <a:p>
+            <a:pPr algn="ctr" indent="0" marL="0">
+              <a:buNone/>
+            </a:pPr>
+            <a:r>
+              <a:rPr lang="en-US" sz="900" b="1" dirty="0">
+                <a:solidFill>
+                  <a:srgbClr val="FFFFFF"/>
+                </a:solidFill>
+                <a:latin typeface="Arial" pitchFamily="34" charset="0"/>
+                <a:ea typeface="Arial" pitchFamily="34" charset="-122"/>
+                <a:cs typeface="Arial" pitchFamily="34" charset="-120"/>
+              </a:rPr>
+              <a:t>04</a:t>
+            </a:r>
+            <a:endParaRPr lang="en-US" sz="900" dirty="0"/>
+          </a:p>
+        </p:txBody>
+      </p:sp>
+      <p:sp>
+        <p:nvSpPr>
+          <p:cNvPr id="45" name="Text 26"/>
+          <p:cNvSpPr txBox="1"/>
+          <p:nvPr/>
+        </p:nvSpPr>
+        <p:spPr>
+          <a:xfrm>
+            <a:off x="9855200" y="5126990"/>
+            <a:ext cx="1875353" cy="236220"/>
           </a:xfrm>
           <a:prstGeom prst="rect">
             <a:avLst/>
@@ -2244,14 +2400,14 @@
       </p:sp>
       <p:sp>
         <p:nvSpPr>
-          <p:cNvPr id="42" name="Text 23"/>
-          <p:cNvSpPr txBox="1"/>
-          <p:nvPr/>
-        </p:nvSpPr>
-        <p:spPr>
-          <a:xfrm>
-            <a:off x="9461500" y="5377815"/>
-            <a:ext cx="2461260" cy="198120"/>
+          <p:cNvPr id="46" name="Text 27"/>
+          <p:cNvSpPr txBox="1"/>
+          <p:nvPr/>
+        </p:nvSpPr>
+        <p:spPr>
+          <a:xfrm>
+            <a:off x="9855200" y="5347970"/>
+            <a:ext cx="1875353" cy="175260"/>
           </a:xfrm>
           <a:prstGeom prst="rect">
             <a:avLst/>
@@ -2267,7 +2423,7 @@
               <a:buNone/>
             </a:pPr>
             <a:r>
-              <a:rPr lang="en-US" sz="1100" dirty="0">
+              <a:rPr lang="en-US" sz="1000" dirty="0">
                 <a:solidFill>
                   <a:srgbClr val="1D2B5C"/>
                 </a:solidFill>
@@ -2277,13 +2433,13 @@
               </a:rPr>
               <a:t>Vít qua da ít xâm lấn</a:t>
             </a:r>
-            <a:endParaRPr lang="en-US" sz="1100" dirty="0"/>
-          </a:p>
-        </p:txBody>
-      </p:sp>
-      <p:sp>
-        <p:nvSpPr>
-          <p:cNvPr id="43" name="Text 24"/>
+            <a:endParaRPr lang="en-US" sz="1000" dirty="0"/>
+          </a:p>
+        </p:txBody>
+      </p:sp>
+      <p:sp>
+        <p:nvSpPr>
+          <p:cNvPr id="47" name="Text 28"/>
           <p:cNvSpPr txBox="1"/>
           <p:nvPr/>
         </p:nvSpPr>
@@ -2322,7 +2478,7 @@
       </p:sp>
       <p:sp>
         <p:nvSpPr>
-          <p:cNvPr id="44" name="Text 25"/>
+          <p:cNvPr id="48" name="Text 29"/>
           <p:cNvSpPr txBox="1"/>
           <p:nvPr/>
         </p:nvSpPr>

</xml_diff>

<commit_message>
Backdrop VOA: brand header with QR row, robot callout bubbles with leader lines
Co-Authored-By: Claude Opus 5.5 <noreply@anthropic.com>
Claude-Session: https://claude.ai/code/session_013QJi2k1EkL4AWCx1Ymi9NU
</commit_message>
<xml_diff>
--- a/backdrop-voa/backdrop-VOA.pptx
+++ b/backdrop-voa/backdrop-VOA.pptx
@@ -884,7 +884,7 @@
       </p:grpSpPr>
       <p:pic>
         <p:nvPicPr>
-          <p:cNvPr id="2" name="Image 0" descr="tl_emblem.png">    </p:cNvPr>
+          <p:cNvPr id="2" name="Image 0" descr="Logo Thăng Long Quốc Tế">    </p:cNvPr>
           <p:cNvPicPr>
             <a:picLocks noChangeAspect="1"/>
           </p:cNvPicPr>
@@ -898,8 +898,8 @@
         </p:blipFill>
         <p:spPr>
           <a:xfrm>
-            <a:off x="8665964" y="317513"/>
-            <a:ext cx="757238" cy="749274"/>
+            <a:off x="457229" y="340519"/>
+            <a:ext cx="749242" cy="741363"/>
           </a:xfrm>
           <a:prstGeom prst="rect">
             <a:avLst/>
@@ -908,7 +908,7 @@
       </p:pic>
       <p:pic>
         <p:nvPicPr>
-          <p:cNvPr id="3" name="Image 1" descr="Dịch vụ Y Khoa Thăng Long Quốc Tế">    </p:cNvPr>
+          <p:cNvPr id="3" name="Image 1" descr="QR Facebook">    </p:cNvPr>
           <p:cNvPicPr>
             <a:picLocks noChangeAspect="1"/>
           </p:cNvPicPr>
@@ -922,8 +922,8 @@
         </p:blipFill>
         <p:spPr>
           <a:xfrm>
-            <a:off x="9524802" y="514353"/>
-            <a:ext cx="2146498" cy="355595"/>
+            <a:off x="8216900" y="279400"/>
+            <a:ext cx="749300" cy="749300"/>
           </a:xfrm>
           <a:prstGeom prst="rect">
             <a:avLst/>
@@ -932,7 +932,7 @@
       </p:pic>
       <p:pic>
         <p:nvPicPr>
-          <p:cNvPr id="4" name="Image 2" descr="Allgens">    </p:cNvPr>
+          <p:cNvPr id="4" name="Image 2" descr="QR Zalo">    </p:cNvPr>
           <p:cNvPicPr>
             <a:picLocks noChangeAspect="1"/>
           </p:cNvPicPr>
@@ -946,8 +946,8 @@
         </p:blipFill>
         <p:spPr>
           <a:xfrm>
-            <a:off x="539750" y="1409714"/>
-            <a:ext cx="1172766" cy="495272"/>
+            <a:off x="9156700" y="279400"/>
+            <a:ext cx="749300" cy="749300"/>
           </a:xfrm>
           <a:prstGeom prst="rect">
             <a:avLst/>
@@ -956,7 +956,7 @@
       </p:pic>
       <p:pic>
         <p:nvPicPr>
-          <p:cNvPr id="5" name="Image 3" descr="FDA">    </p:cNvPr>
+          <p:cNvPr id="5" name="Image 3" descr="QR TikTok">    </p:cNvPr>
           <p:cNvPicPr>
             <a:picLocks noChangeAspect="1"/>
           </p:cNvPicPr>
@@ -970,8 +970,8 @@
         </p:blipFill>
         <p:spPr>
           <a:xfrm>
-            <a:off x="4032845" y="1549417"/>
-            <a:ext cx="543818" cy="215867"/>
+            <a:off x="10096500" y="279400"/>
+            <a:ext cx="749300" cy="749300"/>
           </a:xfrm>
           <a:prstGeom prst="rect">
             <a:avLst/>
@@ -980,7 +980,7 @@
       </p:pic>
       <p:pic>
         <p:nvPicPr>
-          <p:cNvPr id="6" name="Image 4" descr="ISO">    </p:cNvPr>
+          <p:cNvPr id="6" name="Image 4" descr="QR Instagram">    </p:cNvPr>
           <p:cNvPicPr>
             <a:picLocks noChangeAspect="1"/>
           </p:cNvPicPr>
@@ -994,8 +994,8 @@
         </p:blipFill>
         <p:spPr>
           <a:xfrm>
-            <a:off x="4665563" y="1549419"/>
-            <a:ext cx="522387" cy="215862"/>
+            <a:off x="11036300" y="279400"/>
+            <a:ext cx="749300" cy="749300"/>
           </a:xfrm>
           <a:prstGeom prst="rect">
             <a:avLst/>
@@ -1004,7 +1004,7 @@
       </p:pic>
       <p:pic>
         <p:nvPicPr>
-          <p:cNvPr id="7" name="Image 5" descr="BonGold">    </p:cNvPr>
+          <p:cNvPr id="7" name="Image 5" descr="Allgens">    </p:cNvPr>
           <p:cNvPicPr>
             <a:picLocks noChangeAspect="1"/>
           </p:cNvPicPr>
@@ -1018,8 +1018,8 @@
         </p:blipFill>
         <p:spPr>
           <a:xfrm>
-            <a:off x="736600" y="3316089"/>
-            <a:ext cx="1219200" cy="304800"/>
+            <a:off x="539750" y="1492262"/>
+            <a:ext cx="1142702" cy="482575"/>
           </a:xfrm>
           <a:prstGeom prst="rect">
             <a:avLst/>
@@ -1028,7 +1028,7 @@
       </p:pic>
       <p:pic>
         <p:nvPicPr>
-          <p:cNvPr id="8" name="Image 6" descr="40.png">    </p:cNvPr>
+          <p:cNvPr id="8" name="Image 6" descr="FDA">    </p:cNvPr>
           <p:cNvPicPr>
             <a:picLocks noChangeAspect="1"/>
           </p:cNvPicPr>
@@ -1042,8 +1042,8 @@
         </p:blipFill>
         <p:spPr>
           <a:xfrm>
-            <a:off x="2203560" y="3190875"/>
-            <a:ext cx="2971580" cy="999827"/>
+            <a:off x="3790652" y="1631958"/>
+            <a:ext cx="511870" cy="203185"/>
           </a:xfrm>
           <a:prstGeom prst="rect">
             <a:avLst/>
@@ -1052,7 +1052,7 @@
       </p:pic>
       <p:pic>
         <p:nvPicPr>
-          <p:cNvPr id="9" name="Image 7" descr="Skulheal">    </p:cNvPr>
+          <p:cNvPr id="9" name="Image 7" descr="ISO">    </p:cNvPr>
           <p:cNvPicPr>
             <a:picLocks noChangeAspect="1"/>
           </p:cNvPicPr>
@@ -1066,8 +1066,8 @@
         </p:blipFill>
         <p:spPr>
           <a:xfrm>
-            <a:off x="3755926" y="4852494"/>
-            <a:ext cx="1251148" cy="304794"/>
+            <a:off x="4378722" y="1631953"/>
+            <a:ext cx="491728" cy="203193"/>
           </a:xfrm>
           <a:prstGeom prst="rect">
             <a:avLst/>
@@ -1076,7 +1076,7 @@
       </p:pic>
       <p:pic>
         <p:nvPicPr>
-          <p:cNvPr id="10" name="Image 8" descr="36.png">    </p:cNvPr>
+          <p:cNvPr id="10" name="Image 8" descr="BonGold">    </p:cNvPr>
           <p:cNvPicPr>
             <a:picLocks noChangeAspect="1"/>
           </p:cNvPicPr>
@@ -1090,8 +1090,8 @@
         </p:blipFill>
         <p:spPr>
           <a:xfrm>
-            <a:off x="552584" y="4649788"/>
-            <a:ext cx="2971532" cy="970558"/>
+            <a:off x="711200" y="3360738"/>
+            <a:ext cx="1117600" cy="279400"/>
           </a:xfrm>
           <a:prstGeom prst="rect">
             <a:avLst/>
@@ -1100,7 +1100,7 @@
       </p:pic>
       <p:pic>
         <p:nvPicPr>
-          <p:cNvPr id="11" name="Image 9" descr="Curexo">    </p:cNvPr>
+          <p:cNvPr id="11" name="Image 9" descr="40.png">    </p:cNvPr>
           <p:cNvPicPr>
             <a:picLocks noChangeAspect="1"/>
           </p:cNvPicPr>
@@ -1114,8 +1114,8 @@
         </p:blipFill>
         <p:spPr>
           <a:xfrm>
-            <a:off x="5702300" y="1524003"/>
-            <a:ext cx="1002407" cy="253995"/>
+            <a:off x="2063879" y="3244155"/>
+            <a:ext cx="2806443" cy="944265"/>
           </a:xfrm>
           <a:prstGeom prst="rect">
             <a:avLst/>
@@ -1124,7 +1124,7 @@
       </p:pic>
       <p:pic>
         <p:nvPicPr>
-          <p:cNvPr id="12" name="Image 10" descr="CE">    </p:cNvPr>
+          <p:cNvPr id="12" name="Image 10" descr="Skulheal">    </p:cNvPr>
           <p:cNvPicPr>
             <a:picLocks noChangeAspect="1"/>
           </p:cNvPicPr>
@@ -1138,8 +1138,8 @@
         </p:blipFill>
         <p:spPr>
           <a:xfrm>
-            <a:off x="6793607" y="1568473"/>
-            <a:ext cx="232767" cy="165053"/>
+            <a:off x="3566716" y="4906967"/>
+            <a:ext cx="1146870" cy="279391"/>
           </a:xfrm>
           <a:prstGeom prst="rect">
             <a:avLst/>
@@ -1148,7 +1148,7 @@
       </p:pic>
       <p:pic>
         <p:nvPicPr>
-          <p:cNvPr id="13" name="Image 11" descr="FDA">    </p:cNvPr>
+          <p:cNvPr id="13" name="Image 11" descr="36.png">    </p:cNvPr>
           <p:cNvPicPr>
             <a:picLocks noChangeAspect="1"/>
           </p:cNvPicPr>
@@ -1162,8 +1162,8 @@
         </p:blipFill>
         <p:spPr>
           <a:xfrm>
-            <a:off x="7077174" y="1568450"/>
-            <a:ext cx="415925" cy="165100"/>
+            <a:off x="539809" y="4715272"/>
+            <a:ext cx="2806582" cy="916682"/>
           </a:xfrm>
           <a:prstGeom prst="rect">
             <a:avLst/>
@@ -1172,7 +1172,7 @@
       </p:pic>
       <p:pic>
         <p:nvPicPr>
-          <p:cNvPr id="14" name="Image 12" descr="Mantiz">    </p:cNvPr>
+          <p:cNvPr id="14" name="Image 12" descr="Curexo">    </p:cNvPr>
           <p:cNvPicPr>
             <a:picLocks noChangeAspect="1"/>
           </p:cNvPicPr>
@@ -1186,8 +1186,8 @@
         </p:blipFill>
         <p:spPr>
           <a:xfrm>
-            <a:off x="8397974" y="1524010"/>
-            <a:ext cx="1034058" cy="253979"/>
+            <a:off x="5397500" y="1593855"/>
+            <a:ext cx="1052513" cy="266691"/>
           </a:xfrm>
           <a:prstGeom prst="rect">
             <a:avLst/>
@@ -1196,7 +1196,7 @@
       </p:pic>
       <p:pic>
         <p:nvPicPr>
-          <p:cNvPr id="15" name="Image 13" descr="ISO 13485">    </p:cNvPr>
+          <p:cNvPr id="15" name="Image 13" descr="CE">    </p:cNvPr>
           <p:cNvPicPr>
             <a:picLocks noChangeAspect="1"/>
           </p:cNvPicPr>
@@ -1210,8 +1210,8 @@
         </p:blipFill>
         <p:spPr>
           <a:xfrm>
-            <a:off x="9520932" y="1504957"/>
-            <a:ext cx="271562" cy="292087"/>
+            <a:off x="6538913" y="1644673"/>
+            <a:ext cx="232767" cy="165053"/>
           </a:xfrm>
           <a:prstGeom prst="rect">
             <a:avLst/>
@@ -1220,7 +1220,7 @@
       </p:pic>
       <p:pic>
         <p:nvPicPr>
-          <p:cNvPr id="16" name="Image 14" descr="GMP">    </p:cNvPr>
+          <p:cNvPr id="16" name="Image 14" descr="FDA">    </p:cNvPr>
           <p:cNvPicPr>
             <a:picLocks noChangeAspect="1"/>
           </p:cNvPicPr>
@@ -1234,8 +1234,8 @@
         </p:blipFill>
         <p:spPr>
           <a:xfrm>
-            <a:off x="9843294" y="1504956"/>
-            <a:ext cx="354806" cy="292088"/>
+            <a:off x="6822480" y="1644650"/>
+            <a:ext cx="415925" cy="165100"/>
           </a:xfrm>
           <a:prstGeom prst="rect">
             <a:avLst/>
@@ -1244,7 +1244,7 @@
       </p:pic>
       <p:pic>
         <p:nvPicPr>
-          <p:cNvPr id="17" name="Image 15" descr="CUVIS Spine">    </p:cNvPr>
+          <p:cNvPr id="17" name="Image 15" descr="Mantiz">    </p:cNvPr>
           <p:cNvPicPr>
             <a:picLocks noChangeAspect="1"/>
           </p:cNvPicPr>
@@ -1258,8 +1258,8 @@
         </p:blipFill>
         <p:spPr>
           <a:xfrm>
-            <a:off x="6080621" y="2419358"/>
-            <a:ext cx="1224459" cy="279384"/>
+            <a:off x="9779397" y="1593850"/>
+            <a:ext cx="1085850" cy="266700"/>
           </a:xfrm>
           <a:prstGeom prst="rect">
             <a:avLst/>
@@ -1268,7 +1268,7 @@
       </p:pic>
       <p:pic>
         <p:nvPicPr>
-          <p:cNvPr id="18" name="Image 16" descr="37.png">    </p:cNvPr>
+          <p:cNvPr id="18" name="Image 16" descr="ISO 13485">    </p:cNvPr>
           <p:cNvPicPr>
             <a:picLocks noChangeAspect="1"/>
           </p:cNvPicPr>
@@ -1282,8 +1282,8 @@
         </p:blipFill>
         <p:spPr>
           <a:xfrm>
-            <a:off x="5676900" y="3393424"/>
-            <a:ext cx="2032000" cy="1855501"/>
+            <a:off x="10954147" y="1574807"/>
+            <a:ext cx="283369" cy="304786"/>
           </a:xfrm>
           <a:prstGeom prst="rect">
             <a:avLst/>
@@ -1292,7 +1292,7 @@
       </p:pic>
       <p:pic>
         <p:nvPicPr>
-          <p:cNvPr id="19" name="Image 17" descr="25.png">    </p:cNvPr>
+          <p:cNvPr id="19" name="Image 17" descr="GMP">    </p:cNvPr>
           <p:cNvPicPr>
             <a:picLocks noChangeAspect="1"/>
           </p:cNvPicPr>
@@ -1306,8 +1306,8 @@
         </p:blipFill>
         <p:spPr>
           <a:xfrm>
-            <a:off x="7936908" y="2969121"/>
-            <a:ext cx="279989" cy="208459"/>
+            <a:off x="11288316" y="1574826"/>
+            <a:ext cx="370185" cy="304748"/>
           </a:xfrm>
           <a:prstGeom prst="rect">
             <a:avLst/>
@@ -1316,7 +1316,7 @@
       </p:pic>
       <p:pic>
         <p:nvPicPr>
-          <p:cNvPr id="20" name="Image 18" descr="26.png">    </p:cNvPr>
+          <p:cNvPr id="20" name="Image 18" descr="CUVIS Spine">    </p:cNvPr>
           <p:cNvPicPr>
             <a:picLocks noChangeAspect="1"/>
           </p:cNvPicPr>
@@ -1330,8 +1330,8 @@
         </p:blipFill>
         <p:spPr>
           <a:xfrm>
-            <a:off x="8229644" y="2965648"/>
-            <a:ext cx="279906" cy="215503"/>
+            <a:off x="5473700" y="2451108"/>
+            <a:ext cx="1168797" cy="266683"/>
           </a:xfrm>
           <a:prstGeom prst="rect">
             <a:avLst/>
@@ -1340,7 +1340,7 @@
       </p:pic>
       <p:pic>
         <p:nvPicPr>
-          <p:cNvPr id="21" name="Image 19" descr="28.png">    </p:cNvPr>
+          <p:cNvPr id="21" name="Image 19" descr="Robot CUVIS Spine">    </p:cNvPr>
           <p:cNvPicPr>
             <a:picLocks noChangeAspect="1"/>
           </p:cNvPicPr>
@@ -1354,8 +1354,8 @@
         </p:blipFill>
         <p:spPr>
           <a:xfrm>
-            <a:off x="7936950" y="3523059"/>
-            <a:ext cx="279904" cy="243681"/>
+            <a:off x="6324600" y="2800389"/>
+            <a:ext cx="3789859" cy="3460673"/>
           </a:xfrm>
           <a:prstGeom prst="rect">
             <a:avLst/>
@@ -1364,7 +1364,7 @@
       </p:pic>
       <p:pic>
         <p:nvPicPr>
-          <p:cNvPr id="22" name="Image 20" descr="29.png">    </p:cNvPr>
+          <p:cNvPr id="22" name="Image 20" descr="25.png">    </p:cNvPr>
           <p:cNvPicPr>
             <a:picLocks noChangeAspect="1"/>
           </p:cNvPicPr>
@@ -1378,8 +1378,8 @@
         </p:blipFill>
         <p:spPr>
           <a:xfrm>
-            <a:off x="8229638" y="3527127"/>
-            <a:ext cx="279919" cy="235446"/>
+            <a:off x="9860075" y="3737868"/>
+            <a:ext cx="236411" cy="176014"/>
           </a:xfrm>
           <a:prstGeom prst="rect">
             <a:avLst/>
@@ -1388,7 +1388,7 @@
       </p:pic>
       <p:pic>
         <p:nvPicPr>
-          <p:cNvPr id="23" name="Image 21" descr="31.png">    </p:cNvPr>
+          <p:cNvPr id="23" name="Image 21" descr="26.png">    </p:cNvPr>
           <p:cNvPicPr>
             <a:picLocks noChangeAspect="1"/>
           </p:cNvPicPr>
@@ -1402,8 +1402,8 @@
         </p:blipFill>
         <p:spPr>
           <a:xfrm>
-            <a:off x="8031859" y="4121150"/>
-            <a:ext cx="369983" cy="406301"/>
+            <a:off x="10109245" y="3734891"/>
+            <a:ext cx="236348" cy="181967"/>
           </a:xfrm>
           <a:prstGeom prst="rect">
             <a:avLst/>
@@ -1412,7 +1412,7 @@
       </p:pic>
       <p:pic>
         <p:nvPicPr>
-          <p:cNvPr id="24" name="Image 22" descr="33.png">    </p:cNvPr>
+          <p:cNvPr id="24" name="Image 22" descr="28.png">    </p:cNvPr>
           <p:cNvPicPr>
             <a:picLocks noChangeAspect="1"/>
           </p:cNvPicPr>
@@ -1426,8 +1426,8 @@
         </p:blipFill>
         <p:spPr>
           <a:xfrm>
-            <a:off x="7939732" y="4730750"/>
-            <a:ext cx="554236" cy="406301"/>
+            <a:off x="9860097" y="4230985"/>
+            <a:ext cx="236369" cy="205780"/>
           </a:xfrm>
           <a:prstGeom prst="rect">
             <a:avLst/>
@@ -1436,7 +1436,7 @@
       </p:pic>
       <p:pic>
         <p:nvPicPr>
-          <p:cNvPr id="25" name="Image 23" descr="QR Zalo">    </p:cNvPr>
+          <p:cNvPr id="25" name="Image 23" descr="29.png">    </p:cNvPr>
           <p:cNvPicPr>
             <a:picLocks noChangeAspect="1"/>
           </p:cNvPicPr>
@@ -1450,8 +1450,8 @@
         </p:blipFill>
         <p:spPr>
           <a:xfrm>
-            <a:off x="10718800" y="2205038"/>
-            <a:ext cx="927100" cy="927100"/>
+            <a:off x="10109223" y="4234458"/>
+            <a:ext cx="236392" cy="198834"/>
           </a:xfrm>
           <a:prstGeom prst="rect">
             <a:avLst/>
@@ -1460,7 +1460,7 @@
       </p:pic>
       <p:pic>
         <p:nvPicPr>
-          <p:cNvPr id="26" name="Image 24" descr="QR TikTok">    </p:cNvPr>
+          <p:cNvPr id="26" name="Image 24" descr="31.png">    </p:cNvPr>
           <p:cNvPicPr>
             <a:picLocks noChangeAspect="1"/>
           </p:cNvPicPr>
@@ -1474,8 +1474,8 @@
         </p:blipFill>
         <p:spPr>
           <a:xfrm>
-            <a:off x="10718800" y="3360738"/>
-            <a:ext cx="927100" cy="927100"/>
+            <a:off x="9934588" y="4759325"/>
+            <a:ext cx="323724" cy="355501"/>
           </a:xfrm>
           <a:prstGeom prst="rect">
             <a:avLst/>
@@ -1484,7 +1484,7 @@
       </p:pic>
       <p:pic>
         <p:nvPicPr>
-          <p:cNvPr id="27" name="Image 25" descr="QR Instagram">    </p:cNvPr>
+          <p:cNvPr id="27" name="Image 25" descr="33.png">    </p:cNvPr>
           <p:cNvPicPr>
             <a:picLocks noChangeAspect="1"/>
           </p:cNvPicPr>
@@ -1498,8 +1498,8 @@
         </p:blipFill>
         <p:spPr>
           <a:xfrm>
-            <a:off x="10718800" y="4516438"/>
-            <a:ext cx="927100" cy="927100"/>
+            <a:off x="9855248" y="5306318"/>
+            <a:ext cx="482503" cy="353715"/>
           </a:xfrm>
           <a:prstGeom prst="rect">
             <a:avLst/>
@@ -1514,8 +1514,8 @@
         </p:nvSpPr>
         <p:spPr>
           <a:xfrm>
-            <a:off x="355600" y="273594"/>
-            <a:ext cx="6341251" cy="525863"/>
+            <a:off x="1473200" y="378143"/>
+            <a:ext cx="7491799" cy="386715"/>
           </a:xfrm>
           <a:prstGeom prst="rect">
             <a:avLst/>
@@ -1531,7 +1531,7 @@
               <a:buNone/>
             </a:pPr>
             <a:r>
-              <a:rPr lang="en-US" sz="3500" b="1" spc="50" kern="0" dirty="0">
+              <a:rPr lang="en-US" sz="2500" b="1" spc="50" kern="0" dirty="0">
                 <a:solidFill>
                   <a:srgbClr val="FFFFFF"/>
                 </a:solidFill>
@@ -1539,9 +1539,23 @@
                 <a:ea typeface="Arial" pitchFamily="34" charset="-122"/>
                 <a:cs typeface="Arial" pitchFamily="34" charset="-120"/>
               </a:rPr>
-              <a:t>CÔNG NGHỆ TIÊN TIẾN</a:t>
-            </a:r>
-            <a:endParaRPr lang="en-US" sz="3500" dirty="0"/>
+              <a:t>DỊCH VỤ Y KHOA </a:t>
+            </a:r>
+            <a:pPr algn="l" indent="0" marL="0">
+              <a:buNone/>
+            </a:pPr>
+            <a:r>
+              <a:rPr lang="en-US" sz="2500" b="1" spc="50" kern="0" dirty="0">
+                <a:solidFill>
+                  <a:srgbClr val="8ED14F"/>
+                </a:solidFill>
+                <a:latin typeface="Arial" pitchFamily="34" charset="0"/>
+                <a:ea typeface="Arial" pitchFamily="34" charset="-122"/>
+                <a:cs typeface="Arial" pitchFamily="34" charset="-120"/>
+              </a:rPr>
+              <a:t>THĂNG LONG QUỐC TẾ</a:t>
+            </a:r>
+            <a:endParaRPr lang="en-US" sz="2500" dirty="0"/>
           </a:p>
         </p:txBody>
       </p:sp>
@@ -1553,8 +1567,8 @@
         </p:nvSpPr>
         <p:spPr>
           <a:xfrm>
-            <a:off x="355600" y="806879"/>
-            <a:ext cx="6341251" cy="287274"/>
+            <a:off x="1473200" y="798132"/>
+            <a:ext cx="7491799" cy="235712"/>
           </a:xfrm>
           <a:prstGeom prst="rect">
             <a:avLst/>
@@ -1570,7 +1584,255 @@
               <a:buNone/>
             </a:pPr>
             <a:r>
-              <a:rPr lang="en-US" sz="1700" b="1" dirty="0">
+              <a:rPr lang="en-US" sz="1400" b="1" dirty="0">
+                <a:solidFill>
+                  <a:srgbClr val="CFE6FF"/>
+                </a:solidFill>
+                <a:latin typeface="Arial" pitchFamily="34" charset="0"/>
+                <a:ea typeface="Arial" pitchFamily="34" charset="-122"/>
+                <a:cs typeface="Arial" pitchFamily="34" charset="-120"/>
+              </a:rPr>
+              <a:t>Công nghệ tiên tiến trong Phẫu thuật Cột sống &amp; Chấn thương Chỉnh hình</a:t>
+            </a:r>
+            <a:endParaRPr lang="en-US" sz="1400" dirty="0"/>
+          </a:p>
+        </p:txBody>
+      </p:sp>
+      <p:sp>
+        <p:nvSpPr>
+          <p:cNvPr id="30" name="Text 2"/>
+          <p:cNvSpPr txBox="1"/>
+          <p:nvPr/>
+        </p:nvSpPr>
+        <p:spPr>
+          <a:xfrm>
+            <a:off x="8369201" y="1039114"/>
+            <a:ext cx="506956" cy="125222"/>
+          </a:xfrm>
+          <a:prstGeom prst="rect">
+            <a:avLst/>
+          </a:prstGeom>
+          <a:noFill/>
+          <a:ln/>
+        </p:spPr>
+        <p:txBody>
+          <a:bodyPr wrap="square" lIns="0" tIns="0" rIns="0" bIns="0" rtlCol="0" anchor="ctr"/>
+          <a:lstStyle/>
+          <a:p>
+            <a:pPr algn="l" indent="0" marL="0">
+              <a:buNone/>
+            </a:pPr>
+            <a:r>
+              <a:rPr lang="en-US" sz="750" b="1" dirty="0">
+                <a:solidFill>
+                  <a:srgbClr val="0A3170"/>
+                </a:solidFill>
+                <a:latin typeface="Arial" pitchFamily="34" charset="0"/>
+                <a:ea typeface="Arial" pitchFamily="34" charset="-122"/>
+                <a:cs typeface="Arial" pitchFamily="34" charset="-120"/>
+              </a:rPr>
+              <a:t>Facebook</a:t>
+            </a:r>
+            <a:endParaRPr lang="en-US" sz="750" dirty="0"/>
+          </a:p>
+        </p:txBody>
+      </p:sp>
+      <p:sp>
+        <p:nvSpPr>
+          <p:cNvPr id="31" name="Text 3"/>
+          <p:cNvSpPr txBox="1"/>
+          <p:nvPr/>
+        </p:nvSpPr>
+        <p:spPr>
+          <a:xfrm>
+            <a:off x="9433421" y="1039114"/>
+            <a:ext cx="223278" cy="125222"/>
+          </a:xfrm>
+          <a:prstGeom prst="rect">
+            <a:avLst/>
+          </a:prstGeom>
+          <a:noFill/>
+          <a:ln/>
+        </p:spPr>
+        <p:txBody>
+          <a:bodyPr wrap="square" lIns="0" tIns="0" rIns="0" bIns="0" rtlCol="0" anchor="ctr"/>
+          <a:lstStyle/>
+          <a:p>
+            <a:pPr algn="l" indent="0" marL="0">
+              <a:buNone/>
+            </a:pPr>
+            <a:r>
+              <a:rPr lang="en-US" sz="750" b="1" dirty="0">
+                <a:solidFill>
+                  <a:srgbClr val="0A3170"/>
+                </a:solidFill>
+                <a:latin typeface="Arial" pitchFamily="34" charset="0"/>
+                <a:ea typeface="Arial" pitchFamily="34" charset="-122"/>
+                <a:cs typeface="Arial" pitchFamily="34" charset="-120"/>
+              </a:rPr>
+              <a:t>Zalo</a:t>
+            </a:r>
+            <a:endParaRPr lang="en-US" sz="750" dirty="0"/>
+          </a:p>
+        </p:txBody>
+      </p:sp>
+      <p:sp>
+        <p:nvSpPr>
+          <p:cNvPr id="32" name="Text 4"/>
+          <p:cNvSpPr txBox="1"/>
+          <p:nvPr/>
+        </p:nvSpPr>
+        <p:spPr>
+          <a:xfrm>
+            <a:off x="10322024" y="1039114"/>
+            <a:ext cx="340007" cy="125222"/>
+          </a:xfrm>
+          <a:prstGeom prst="rect">
+            <a:avLst/>
+          </a:prstGeom>
+          <a:noFill/>
+          <a:ln/>
+        </p:spPr>
+        <p:txBody>
+          <a:bodyPr wrap="square" lIns="0" tIns="0" rIns="0" bIns="0" rtlCol="0" anchor="ctr"/>
+          <a:lstStyle/>
+          <a:p>
+            <a:pPr algn="l" indent="0" marL="0">
+              <a:buNone/>
+            </a:pPr>
+            <a:r>
+              <a:rPr lang="en-US" sz="750" b="1" dirty="0">
+                <a:solidFill>
+                  <a:srgbClr val="0A3170"/>
+                </a:solidFill>
+                <a:latin typeface="Arial" pitchFamily="34" charset="0"/>
+                <a:ea typeface="Arial" pitchFamily="34" charset="-122"/>
+                <a:cs typeface="Arial" pitchFamily="34" charset="-120"/>
+              </a:rPr>
+              <a:t>TikTok</a:t>
+            </a:r>
+            <a:endParaRPr lang="en-US" sz="750" dirty="0"/>
+          </a:p>
+        </p:txBody>
+      </p:sp>
+      <p:sp>
+        <p:nvSpPr>
+          <p:cNvPr id="33" name="Text 5"/>
+          <p:cNvSpPr txBox="1"/>
+          <p:nvPr/>
+        </p:nvSpPr>
+        <p:spPr>
+          <a:xfrm>
+            <a:off x="11183243" y="1039114"/>
+            <a:ext cx="519059" cy="125222"/>
+          </a:xfrm>
+          <a:prstGeom prst="rect">
+            <a:avLst/>
+          </a:prstGeom>
+          <a:noFill/>
+          <a:ln/>
+        </p:spPr>
+        <p:txBody>
+          <a:bodyPr wrap="square" lIns="0" tIns="0" rIns="0" bIns="0" rtlCol="0" anchor="ctr"/>
+          <a:lstStyle/>
+          <a:p>
+            <a:pPr algn="l" indent="0" marL="0">
+              <a:buNone/>
+            </a:pPr>
+            <a:r>
+              <a:rPr lang="en-US" sz="750" b="1" dirty="0">
+                <a:solidFill>
+                  <a:srgbClr val="0A3170"/>
+                </a:solidFill>
+                <a:latin typeface="Arial" pitchFamily="34" charset="0"/>
+                <a:ea typeface="Arial" pitchFamily="34" charset="-122"/>
+                <a:cs typeface="Arial" pitchFamily="34" charset="-120"/>
+              </a:rPr>
+              <a:t>Instagram</a:t>
+            </a:r>
+            <a:endParaRPr lang="en-US" sz="750" dirty="0"/>
+          </a:p>
+        </p:txBody>
+      </p:sp>
+      <p:sp>
+        <p:nvSpPr>
+          <p:cNvPr id="34" name="Text 6"/>
+          <p:cNvSpPr txBox="1"/>
+          <p:nvPr/>
+        </p:nvSpPr>
+        <p:spPr>
+          <a:xfrm>
+            <a:off x="236601" y="2153158"/>
+            <a:ext cx="4936998" cy="176784"/>
+          </a:xfrm>
+          <a:prstGeom prst="rect">
+            <a:avLst/>
+          </a:prstGeom>
+          <a:noFill/>
+          <a:ln/>
+        </p:spPr>
+        <p:txBody>
+          <a:bodyPr wrap="square" lIns="0" tIns="0" rIns="0" bIns="0" rtlCol="0" anchor="ctr"/>
+          <a:lstStyle/>
+          <a:p>
+            <a:pPr algn="ctr" indent="0" marL="0">
+              <a:buNone/>
+            </a:pPr>
+            <a:r>
+              <a:rPr lang="en-US" sz="1050" b="1" spc="75" kern="0" dirty="0">
+                <a:solidFill>
+                  <a:srgbClr val="CFE6FF"/>
+                </a:solidFill>
+                <a:latin typeface="Arial" pitchFamily="34" charset="0"/>
+                <a:ea typeface="Arial" pitchFamily="34" charset="-122"/>
+                <a:cs typeface="Arial" pitchFamily="34" charset="-120"/>
+              </a:rPr>
+              <a:t>VẬT LIỆU XƯƠNG SINH HỌC COLLAGEN KHOÁNG HÓA</a:t>
+            </a:r>
+            <a:endParaRPr lang="en-US" sz="1050" dirty="0"/>
+          </a:p>
+        </p:txBody>
+      </p:sp>
+      <p:sp>
+        <p:nvSpPr>
+          <p:cNvPr id="35" name="Text 7"/>
+          <p:cNvSpPr txBox="1"/>
+          <p:nvPr/>
+        </p:nvSpPr>
+        <p:spPr>
+          <a:xfrm>
+            <a:off x="1416943" y="2374646"/>
+            <a:ext cx="3269879" cy="279908"/>
+          </a:xfrm>
+          <a:prstGeom prst="rect">
+            <a:avLst/>
+          </a:prstGeom>
+          <a:noFill/>
+          <a:ln/>
+        </p:spPr>
+        <p:txBody>
+          <a:bodyPr wrap="square" lIns="0" tIns="0" rIns="0" bIns="0" rtlCol="0" anchor="ctr"/>
+          <a:lstStyle/>
+          <a:p>
+            <a:pPr algn="l" indent="0" marL="0">
+              <a:buNone/>
+            </a:pPr>
+            <a:r>
+              <a:rPr lang="en-US" sz="1650" b="1" dirty="0">
+                <a:solidFill>
+                  <a:srgbClr val="FFFFFF"/>
+                </a:solidFill>
+                <a:latin typeface="Arial" pitchFamily="34" charset="0"/>
+                <a:ea typeface="Arial" pitchFamily="34" charset="-122"/>
+                <a:cs typeface="Arial" pitchFamily="34" charset="-120"/>
+              </a:rPr>
+              <a:t>Đạt chứng nhận </a:t>
+            </a:r>
+            <a:pPr algn="l" indent="0" marL="0">
+              <a:buNone/>
+            </a:pPr>
+            <a:r>
+              <a:rPr lang="en-US" sz="1650" b="1" dirty="0">
                 <a:solidFill>
                   <a:srgbClr val="8ED14F"/>
                 </a:solidFill>
@@ -1578,22 +1840,75 @@
                 <a:ea typeface="Arial" pitchFamily="34" charset="-122"/>
                 <a:cs typeface="Arial" pitchFamily="34" charset="-120"/>
               </a:rPr>
-              <a:t>trong Phẫu thuật Cột sống &amp; Chấn thương Chỉnh hình</a:t>
-            </a:r>
-            <a:endParaRPr lang="en-US" sz="1700" dirty="0"/>
-          </a:p>
-        </p:txBody>
-      </p:sp>
-      <p:sp>
-        <p:nvSpPr>
-          <p:cNvPr id="30" name="Text 2"/>
-          <p:cNvSpPr txBox="1"/>
-          <p:nvPr/>
-        </p:nvSpPr>
-        <p:spPr>
-          <a:xfrm>
-            <a:off x="228854" y="2088134"/>
-            <a:ext cx="5269992" cy="198882"/>
+              <a:t>FDA Hoa Kỳ</a:t>
+            </a:r>
+            <a:endParaRPr lang="en-US" sz="1650" dirty="0"/>
+          </a:p>
+        </p:txBody>
+      </p:sp>
+      <p:sp>
+        <p:nvSpPr>
+          <p:cNvPr id="36" name="Text 8"/>
+          <p:cNvSpPr txBox="1"/>
+          <p:nvPr/>
+        </p:nvSpPr>
+        <p:spPr>
+          <a:xfrm>
+            <a:off x="1067098" y="2679446"/>
+            <a:ext cx="4067526" cy="279908"/>
+          </a:xfrm>
+          <a:prstGeom prst="rect">
+            <a:avLst/>
+          </a:prstGeom>
+          <a:noFill/>
+          <a:ln/>
+        </p:spPr>
+        <p:txBody>
+          <a:bodyPr wrap="square" lIns="0" tIns="0" rIns="0" bIns="0" rtlCol="0" anchor="ctr"/>
+          <a:lstStyle/>
+          <a:p>
+            <a:pPr algn="l" indent="0" marL="0">
+              <a:buNone/>
+            </a:pPr>
+            <a:r>
+              <a:rPr lang="en-US" sz="1650" b="1" dirty="0">
+                <a:solidFill>
+                  <a:srgbClr val="FFFFFF"/>
+                </a:solidFill>
+                <a:latin typeface="Arial" pitchFamily="34" charset="0"/>
+                <a:ea typeface="Arial" pitchFamily="34" charset="-122"/>
+                <a:cs typeface="Arial" pitchFamily="34" charset="-120"/>
+              </a:rPr>
+              <a:t>Tương đồng cao với </a:t>
+            </a:r>
+            <a:pPr algn="l" indent="0" marL="0">
+              <a:buNone/>
+            </a:pPr>
+            <a:r>
+              <a:rPr lang="en-US" sz="1650" b="1" dirty="0">
+                <a:solidFill>
+                  <a:srgbClr val="8ED14F"/>
+                </a:solidFill>
+                <a:latin typeface="Arial" pitchFamily="34" charset="0"/>
+                <a:ea typeface="Arial" pitchFamily="34" charset="-122"/>
+                <a:cs typeface="Arial" pitchFamily="34" charset="-120"/>
+              </a:rPr>
+              <a:t>xương tự thân</a:t>
+            </a:r>
+            <a:endParaRPr lang="en-US" sz="1650" dirty="0"/>
+          </a:p>
+        </p:txBody>
+      </p:sp>
+      <p:sp>
+        <p:nvSpPr>
+          <p:cNvPr id="37" name="Text 9"/>
+          <p:cNvSpPr txBox="1"/>
+          <p:nvPr/>
+        </p:nvSpPr>
+        <p:spPr>
+          <a:xfrm>
+            <a:off x="715877" y="3732339"/>
+            <a:ext cx="1108246" cy="412496"/>
           </a:xfrm>
           <a:prstGeom prst="rect">
             <a:avLst/>
@@ -1609,7 +1924,141 @@
               <a:buNone/>
             </a:pPr>
             <a:r>
-              <a:rPr lang="en-US" sz="1150" b="1" spc="100" kern="0" dirty="0">
+              <a:rPr lang="en-US" sz="1200" b="1" dirty="0">
+                <a:solidFill>
+                  <a:srgbClr val="FFFFFF"/>
+                </a:solidFill>
+                <a:latin typeface="Arial" pitchFamily="34" charset="0"/>
+                <a:ea typeface="Arial" pitchFamily="34" charset="-122"/>
+                <a:cs typeface="Arial" pitchFamily="34" charset="-120"/>
+              </a:rPr>
+              <a:t>Chấn thương</a:t>
+            </a:r>
+            <a:endParaRPr lang="en-US" sz="1200" dirty="0"/>
+          </a:p>
+          <a:p>
+            <a:pPr algn="ctr" indent="0" marL="0">
+              <a:buNone/>
+            </a:pPr>
+            <a:r>
+              <a:rPr lang="en-US" sz="1200" b="1" dirty="0">
+                <a:solidFill>
+                  <a:srgbClr val="FFFFFF"/>
+                </a:solidFill>
+                <a:latin typeface="Arial" pitchFamily="34" charset="0"/>
+                <a:ea typeface="Arial" pitchFamily="34" charset="-122"/>
+                <a:cs typeface="Arial" pitchFamily="34" charset="-120"/>
+              </a:rPr>
+              <a:t>chỉnh hình</a:t>
+            </a:r>
+            <a:endParaRPr lang="en-US" sz="1200" dirty="0"/>
+          </a:p>
+        </p:txBody>
+      </p:sp>
+      <p:sp>
+        <p:nvSpPr>
+          <p:cNvPr id="38" name="Text 10"/>
+          <p:cNvSpPr txBox="1"/>
+          <p:nvPr/>
+        </p:nvSpPr>
+        <p:spPr>
+          <a:xfrm>
+            <a:off x="3488690" y="5292789"/>
+            <a:ext cx="1303020" cy="206248"/>
+          </a:xfrm>
+          <a:prstGeom prst="rect">
+            <a:avLst/>
+          </a:prstGeom>
+          <a:noFill/>
+          <a:ln/>
+        </p:spPr>
+        <p:txBody>
+          <a:bodyPr wrap="square" lIns="0" tIns="0" rIns="0" bIns="0" rtlCol="0" anchor="ctr"/>
+          <a:lstStyle/>
+          <a:p>
+            <a:pPr algn="ctr" indent="0" marL="0">
+              <a:buNone/>
+            </a:pPr>
+            <a:r>
+              <a:rPr lang="en-US" sz="1200" b="1" dirty="0">
+                <a:solidFill>
+                  <a:srgbClr val="FFFFFF"/>
+                </a:solidFill>
+                <a:latin typeface="Arial" pitchFamily="34" charset="0"/>
+                <a:ea typeface="Arial" pitchFamily="34" charset="-122"/>
+                <a:cs typeface="Arial" pitchFamily="34" charset="-120"/>
+              </a:rPr>
+              <a:t>Ngoại thần kinh</a:t>
+            </a:r>
+            <a:endParaRPr lang="en-US" sz="1200" dirty="0"/>
+          </a:p>
+        </p:txBody>
+      </p:sp>
+      <p:sp>
+        <p:nvSpPr>
+          <p:cNvPr id="39" name="Text 11"/>
+          <p:cNvSpPr txBox="1"/>
+          <p:nvPr/>
+        </p:nvSpPr>
+        <p:spPr>
+          <a:xfrm>
+            <a:off x="515366" y="6028436"/>
+            <a:ext cx="1534668" cy="243078"/>
+          </a:xfrm>
+          <a:prstGeom prst="rect">
+            <a:avLst/>
+          </a:prstGeom>
+          <a:noFill/>
+          <a:ln/>
+        </p:spPr>
+        <p:txBody>
+          <a:bodyPr wrap="square" lIns="0" tIns="0" rIns="0" bIns="0" rtlCol="0" anchor="ctr"/>
+          <a:lstStyle/>
+          <a:p>
+            <a:pPr algn="ctr" indent="0" marL="0">
+              <a:buNone/>
+            </a:pPr>
+            <a:r>
+              <a:rPr lang="en-US" sz="1500" b="1" dirty="0">
+                <a:solidFill>
+                  <a:srgbClr val="8ED14F"/>
+                </a:solidFill>
+                <a:latin typeface="Arial" pitchFamily="34" charset="0"/>
+                <a:ea typeface="Arial" pitchFamily="34" charset="-122"/>
+                <a:cs typeface="Arial" pitchFamily="34" charset="-120"/>
+              </a:rPr>
+              <a:t>45 : 55</a:t>
+            </a:r>
+            <a:endParaRPr lang="en-US" sz="1500" dirty="0"/>
+          </a:p>
+        </p:txBody>
+      </p:sp>
+      <p:sp>
+        <p:nvSpPr>
+          <p:cNvPr id="40" name="Text 12"/>
+          <p:cNvSpPr txBox="1"/>
+          <p:nvPr/>
+        </p:nvSpPr>
+        <p:spPr>
+          <a:xfrm>
+            <a:off x="515366" y="6264656"/>
+            <a:ext cx="1534668" cy="132588"/>
+          </a:xfrm>
+          <a:prstGeom prst="rect">
+            <a:avLst/>
+          </a:prstGeom>
+          <a:noFill/>
+          <a:ln/>
+        </p:spPr>
+        <p:txBody>
+          <a:bodyPr wrap="square" lIns="0" tIns="0" rIns="0" bIns="0" rtlCol="0" anchor="ctr"/>
+          <a:lstStyle/>
+          <a:p>
+            <a:pPr algn="ctr" indent="0" marL="0">
+              <a:buNone/>
+            </a:pPr>
+            <a:r>
+              <a:rPr lang="en-US" sz="800" dirty="0">
                 <a:solidFill>
                   <a:srgbClr val="CFE6FF"/>
                 </a:solidFill>
@@ -1617,22 +2066,270 @@
                 <a:ea typeface="Arial" pitchFamily="34" charset="-122"/>
                 <a:cs typeface="Arial" pitchFamily="34" charset="-120"/>
               </a:rPr>
-              <a:t>VẬT LIỆU XƯƠNG SINH HỌC COLLAGEN KHOÁNG HÓA</a:t>
-            </a:r>
-            <a:endParaRPr lang="en-US" sz="1150" dirty="0"/>
-          </a:p>
-        </p:txBody>
-      </p:sp>
-      <p:sp>
-        <p:nvSpPr>
-          <p:cNvPr id="31" name="Text 3"/>
-          <p:cNvSpPr txBox="1"/>
-          <p:nvPr/>
-        </p:nvSpPr>
-        <p:spPr>
-          <a:xfrm>
-            <a:off x="1525885" y="2329688"/>
-            <a:ext cx="3368963" cy="287274"/>
+              <a:t>Collagen I : nano-HA</a:t>
+            </a:r>
+            <a:endParaRPr lang="en-US" sz="800" dirty="0"/>
+          </a:p>
+        </p:txBody>
+      </p:sp>
+      <p:sp>
+        <p:nvSpPr>
+          <p:cNvPr id="41" name="Text 13"/>
+          <p:cNvSpPr txBox="1"/>
+          <p:nvPr/>
+        </p:nvSpPr>
+        <p:spPr>
+          <a:xfrm>
+            <a:off x="1944561" y="6028436"/>
+            <a:ext cx="1527429" cy="243078"/>
+          </a:xfrm>
+          <a:prstGeom prst="rect">
+            <a:avLst/>
+          </a:prstGeom>
+          <a:noFill/>
+          <a:ln/>
+        </p:spPr>
+        <p:txBody>
+          <a:bodyPr wrap="square" lIns="0" tIns="0" rIns="0" bIns="0" rtlCol="0" anchor="ctr"/>
+          <a:lstStyle/>
+          <a:p>
+            <a:pPr algn="ctr" indent="0" marL="0">
+              <a:buNone/>
+            </a:pPr>
+            <a:r>
+              <a:rPr lang="en-US" sz="1500" b="1" dirty="0">
+                <a:solidFill>
+                  <a:srgbClr val="8ED14F"/>
+                </a:solidFill>
+                <a:latin typeface="Arial" pitchFamily="34" charset="0"/>
+                <a:ea typeface="Arial" pitchFamily="34" charset="-122"/>
+                <a:cs typeface="Arial" pitchFamily="34" charset="-120"/>
+              </a:rPr>
+              <a:t>70–80%</a:t>
+            </a:r>
+            <a:endParaRPr lang="en-US" sz="1500" dirty="0"/>
+          </a:p>
+        </p:txBody>
+      </p:sp>
+      <p:sp>
+        <p:nvSpPr>
+          <p:cNvPr id="42" name="Text 14"/>
+          <p:cNvSpPr txBox="1"/>
+          <p:nvPr/>
+        </p:nvSpPr>
+        <p:spPr>
+          <a:xfrm>
+            <a:off x="1944561" y="6264656"/>
+            <a:ext cx="1527429" cy="132588"/>
+          </a:xfrm>
+          <a:prstGeom prst="rect">
+            <a:avLst/>
+          </a:prstGeom>
+          <a:noFill/>
+          <a:ln/>
+        </p:spPr>
+        <p:txBody>
+          <a:bodyPr wrap="square" lIns="0" tIns="0" rIns="0" bIns="0" rtlCol="0" anchor="ctr"/>
+          <a:lstStyle/>
+          <a:p>
+            <a:pPr algn="ctr" indent="0" marL="0">
+              <a:buNone/>
+            </a:pPr>
+            <a:r>
+              <a:rPr lang="en-US" sz="800" dirty="0">
+                <a:solidFill>
+                  <a:srgbClr val="CFE6FF"/>
+                </a:solidFill>
+                <a:latin typeface="Arial" pitchFamily="34" charset="0"/>
+                <a:ea typeface="Arial" pitchFamily="34" charset="-122"/>
+                <a:cs typeface="Arial" pitchFamily="34" charset="-120"/>
+              </a:rPr>
+              <a:t>Độ xốp</a:t>
+            </a:r>
+            <a:endParaRPr lang="en-US" sz="800" dirty="0"/>
+          </a:p>
+        </p:txBody>
+      </p:sp>
+      <p:sp>
+        <p:nvSpPr>
+          <p:cNvPr id="43" name="Text 15"/>
+          <p:cNvSpPr txBox="1"/>
+          <p:nvPr/>
+        </p:nvSpPr>
+        <p:spPr>
+          <a:xfrm>
+            <a:off x="3366961" y="6028436"/>
+            <a:ext cx="1527429" cy="243078"/>
+          </a:xfrm>
+          <a:prstGeom prst="rect">
+            <a:avLst/>
+          </a:prstGeom>
+          <a:noFill/>
+          <a:ln/>
+        </p:spPr>
+        <p:txBody>
+          <a:bodyPr wrap="square" lIns="0" tIns="0" rIns="0" bIns="0" rtlCol="0" anchor="ctr"/>
+          <a:lstStyle/>
+          <a:p>
+            <a:pPr algn="ctr" indent="0" marL="0">
+              <a:buNone/>
+            </a:pPr>
+            <a:r>
+              <a:rPr lang="en-US" sz="1500" b="1" dirty="0">
+                <a:solidFill>
+                  <a:srgbClr val="8ED14F"/>
+                </a:solidFill>
+                <a:latin typeface="Arial" pitchFamily="34" charset="0"/>
+                <a:ea typeface="Arial" pitchFamily="34" charset="-122"/>
+                <a:cs typeface="Arial" pitchFamily="34" charset="-120"/>
+              </a:rPr>
+              <a:t>&gt;200.000</a:t>
+            </a:r>
+            <a:endParaRPr lang="en-US" sz="1500" dirty="0"/>
+          </a:p>
+        </p:txBody>
+      </p:sp>
+      <p:sp>
+        <p:nvSpPr>
+          <p:cNvPr id="44" name="Text 16"/>
+          <p:cNvSpPr txBox="1"/>
+          <p:nvPr/>
+        </p:nvSpPr>
+        <p:spPr>
+          <a:xfrm>
+            <a:off x="3366961" y="6264656"/>
+            <a:ext cx="1527429" cy="132588"/>
+          </a:xfrm>
+          <a:prstGeom prst="rect">
+            <a:avLst/>
+          </a:prstGeom>
+          <a:noFill/>
+          <a:ln/>
+        </p:spPr>
+        <p:txBody>
+          <a:bodyPr wrap="square" lIns="0" tIns="0" rIns="0" bIns="0" rtlCol="0" anchor="ctr"/>
+          <a:lstStyle/>
+          <a:p>
+            <a:pPr algn="ctr" indent="0" marL="0">
+              <a:buNone/>
+            </a:pPr>
+            <a:r>
+              <a:rPr lang="en-US" sz="800" dirty="0">
+                <a:solidFill>
+                  <a:srgbClr val="CFE6FF"/>
+                </a:solidFill>
+                <a:latin typeface="Arial" pitchFamily="34" charset="0"/>
+                <a:ea typeface="Arial" pitchFamily="34" charset="-122"/>
+                <a:cs typeface="Arial" pitchFamily="34" charset="-120"/>
+              </a:rPr>
+              <a:t>Ca lâm sàng</a:t>
+            </a:r>
+            <a:endParaRPr lang="en-US" sz="800" dirty="0"/>
+          </a:p>
+        </p:txBody>
+      </p:sp>
+      <p:sp>
+        <p:nvSpPr>
+          <p:cNvPr id="45" name="Text 17"/>
+          <p:cNvSpPr txBox="1"/>
+          <p:nvPr/>
+        </p:nvSpPr>
+        <p:spPr>
+          <a:xfrm>
+            <a:off x="4930267" y="2130552"/>
+            <a:ext cx="7195566" cy="228346"/>
+          </a:xfrm>
+          <a:prstGeom prst="rect">
+            <a:avLst/>
+          </a:prstGeom>
+          <a:noFill/>
+          <a:ln/>
+        </p:spPr>
+        <p:txBody>
+          <a:bodyPr wrap="square" lIns="0" tIns="0" rIns="0" bIns="0" rtlCol="0" anchor="ctr"/>
+          <a:lstStyle/>
+          <a:p>
+            <a:pPr algn="ctr" indent="0" marL="0">
+              <a:buNone/>
+            </a:pPr>
+            <a:r>
+              <a:rPr lang="en-US" sz="1350" b="1" spc="50" kern="0" dirty="0">
+                <a:solidFill>
+                  <a:srgbClr val="FFFFFF"/>
+                </a:solidFill>
+                <a:latin typeface="Arial" pitchFamily="34" charset="0"/>
+                <a:ea typeface="Arial" pitchFamily="34" charset="-122"/>
+                <a:cs typeface="Arial" pitchFamily="34" charset="-120"/>
+              </a:rPr>
+              <a:t>GIẢI PHÁP TÍCH HỢP CHO </a:t>
+            </a:r>
+            <a:pPr algn="ctr" indent="0" marL="0">
+              <a:buNone/>
+            </a:pPr>
+            <a:r>
+              <a:rPr lang="en-US" sz="1350" b="1" spc="50" kern="0" dirty="0">
+                <a:solidFill>
+                  <a:srgbClr val="8ED14F"/>
+                </a:solidFill>
+                <a:latin typeface="Arial" pitchFamily="34" charset="0"/>
+                <a:ea typeface="Arial" pitchFamily="34" charset="-122"/>
+                <a:cs typeface="Arial" pitchFamily="34" charset="-120"/>
+              </a:rPr>
+              <a:t>PHẪU THUẬT CỘT SỐNG</a:t>
+            </a:r>
+            <a:endParaRPr lang="en-US" sz="1350" dirty="0"/>
+          </a:p>
+        </p:txBody>
+      </p:sp>
+      <p:sp>
+        <p:nvSpPr>
+          <p:cNvPr id="46" name="Text 18"/>
+          <p:cNvSpPr txBox="1"/>
+          <p:nvPr/>
+        </p:nvSpPr>
+        <p:spPr>
+          <a:xfrm>
+            <a:off x="7029450" y="2457196"/>
+            <a:ext cx="241300" cy="279908"/>
+          </a:xfrm>
+          <a:prstGeom prst="rect">
+            <a:avLst/>
+          </a:prstGeom>
+          <a:noFill/>
+          <a:ln/>
+        </p:spPr>
+        <p:txBody>
+          <a:bodyPr wrap="square" lIns="0" tIns="0" rIns="0" bIns="0" rtlCol="0" anchor="ctr"/>
+          <a:lstStyle/>
+          <a:p>
+            <a:pPr algn="ctr" indent="0" marL="0">
+              <a:buNone/>
+            </a:pPr>
+            <a:r>
+              <a:rPr lang="en-US" sz="850" b="1" dirty="0">
+                <a:solidFill>
+                  <a:srgbClr val="04122E"/>
+                </a:solidFill>
+                <a:latin typeface="Arial" pitchFamily="34" charset="0"/>
+                <a:ea typeface="Arial" pitchFamily="34" charset="-122"/>
+                <a:cs typeface="Arial" pitchFamily="34" charset="-120"/>
+              </a:rPr>
+              <a:t>01</a:t>
+            </a:r>
+            <a:endParaRPr lang="en-US" sz="850" dirty="0"/>
+          </a:p>
+        </p:txBody>
+      </p:sp>
+      <p:sp>
+        <p:nvSpPr>
+          <p:cNvPr id="47" name="Text 19"/>
+          <p:cNvSpPr txBox="1"/>
+          <p:nvPr/>
+        </p:nvSpPr>
+        <p:spPr>
+          <a:xfrm>
+            <a:off x="7334250" y="2513140"/>
+            <a:ext cx="1458206" cy="167922"/>
           </a:xfrm>
           <a:prstGeom prst="rect">
             <a:avLst/>
@@ -1648,7 +2345,7 @@
               <a:buNone/>
             </a:pPr>
             <a:r>
-              <a:rPr lang="en-US" sz="1700" b="1" dirty="0">
+              <a:rPr lang="en-US" sz="950" b="1" dirty="0">
                 <a:solidFill>
                   <a:srgbClr val="FFFFFF"/>
                 </a:solidFill>
@@ -1656,36 +2353,139 @@
                 <a:ea typeface="Arial" pitchFamily="34" charset="-122"/>
                 <a:cs typeface="Arial" pitchFamily="34" charset="-120"/>
               </a:rPr>
-              <a:t>Đạt chứng nhận </a:t>
-            </a:r>
+              <a:t>Giảm phơi nhiễm tia X</a:t>
+            </a:r>
+            <a:endParaRPr lang="en-US" sz="950" dirty="0"/>
+          </a:p>
+        </p:txBody>
+      </p:sp>
+      <p:sp>
+        <p:nvSpPr>
+          <p:cNvPr id="48" name="Text 20"/>
+          <p:cNvSpPr txBox="1"/>
+          <p:nvPr/>
+        </p:nvSpPr>
+        <p:spPr>
+          <a:xfrm>
+            <a:off x="8202414" y="2939796"/>
+            <a:ext cx="241300" cy="279908"/>
+          </a:xfrm>
+          <a:prstGeom prst="rect">
+            <a:avLst/>
+          </a:prstGeom>
+          <a:noFill/>
+          <a:ln/>
+        </p:spPr>
+        <p:txBody>
+          <a:bodyPr wrap="square" lIns="0" tIns="0" rIns="0" bIns="0" rtlCol="0" anchor="ctr"/>
+          <a:lstStyle/>
+          <a:p>
+            <a:pPr algn="ctr" indent="0" marL="0">
+              <a:buNone/>
+            </a:pPr>
+            <a:r>
+              <a:rPr lang="en-US" sz="850" b="1" dirty="0">
+                <a:solidFill>
+                  <a:srgbClr val="04122E"/>
+                </a:solidFill>
+                <a:latin typeface="Arial" pitchFamily="34" charset="0"/>
+                <a:ea typeface="Arial" pitchFamily="34" charset="-122"/>
+                <a:cs typeface="Arial" pitchFamily="34" charset="-120"/>
+              </a:rPr>
+              <a:t>02</a:t>
+            </a:r>
+            <a:endParaRPr lang="en-US" sz="850" dirty="0"/>
+          </a:p>
+        </p:txBody>
+      </p:sp>
+      <p:sp>
+        <p:nvSpPr>
+          <p:cNvPr id="49" name="Text 21"/>
+          <p:cNvSpPr txBox="1"/>
+          <p:nvPr/>
+        </p:nvSpPr>
+        <p:spPr>
+          <a:xfrm>
+            <a:off x="8507214" y="2995740"/>
+            <a:ext cx="1131320" cy="167922"/>
+          </a:xfrm>
+          <a:prstGeom prst="rect">
+            <a:avLst/>
+          </a:prstGeom>
+          <a:noFill/>
+          <a:ln/>
+        </p:spPr>
+        <p:txBody>
+          <a:bodyPr wrap="square" lIns="0" tIns="0" rIns="0" bIns="0" rtlCol="0" anchor="ctr"/>
+          <a:lstStyle/>
+          <a:p>
             <a:pPr algn="l" indent="0" marL="0">
               <a:buNone/>
             </a:pPr>
             <a:r>
-              <a:rPr lang="en-US" sz="1700" b="1" dirty="0">
-                <a:solidFill>
-                  <a:srgbClr val="8ED14F"/>
-                </a:solidFill>
-                <a:latin typeface="Arial" pitchFamily="34" charset="0"/>
-                <a:ea typeface="Arial" pitchFamily="34" charset="-122"/>
-                <a:cs typeface="Arial" pitchFamily="34" charset="-120"/>
-              </a:rPr>
-              <a:t>FDA Hoa Kỳ</a:t>
-            </a:r>
-            <a:endParaRPr lang="en-US" sz="1700" dirty="0"/>
-          </a:p>
-        </p:txBody>
-      </p:sp>
-      <p:sp>
-        <p:nvSpPr>
-          <p:cNvPr id="32" name="Text 4"/>
-          <p:cNvSpPr txBox="1"/>
-          <p:nvPr/>
-        </p:nvSpPr>
-        <p:spPr>
-          <a:xfrm>
-            <a:off x="1165423" y="2640838"/>
-            <a:ext cx="4190815" cy="287274"/>
+              <a:rPr lang="en-US" sz="950" b="1" dirty="0">
+                <a:solidFill>
+                  <a:srgbClr val="FFFFFF"/>
+                </a:solidFill>
+                <a:latin typeface="Arial" pitchFamily="34" charset="0"/>
+                <a:ea typeface="Arial" pitchFamily="34" charset="-122"/>
+                <a:cs typeface="Arial" pitchFamily="34" charset="-120"/>
+              </a:rPr>
+              <a:t>Độ chính xác cao</a:t>
+            </a:r>
+            <a:endParaRPr lang="en-US" sz="950" dirty="0"/>
+          </a:p>
+        </p:txBody>
+      </p:sp>
+      <p:sp>
+        <p:nvSpPr>
+          <p:cNvPr id="50" name="Text 22"/>
+          <p:cNvSpPr txBox="1"/>
+          <p:nvPr/>
+        </p:nvSpPr>
+        <p:spPr>
+          <a:xfrm>
+            <a:off x="5441950" y="4712637"/>
+            <a:ext cx="241300" cy="279908"/>
+          </a:xfrm>
+          <a:prstGeom prst="rect">
+            <a:avLst/>
+          </a:prstGeom>
+          <a:noFill/>
+          <a:ln/>
+        </p:spPr>
+        <p:txBody>
+          <a:bodyPr wrap="square" lIns="0" tIns="0" rIns="0" bIns="0" rtlCol="0" anchor="ctr"/>
+          <a:lstStyle/>
+          <a:p>
+            <a:pPr algn="ctr" indent="0" marL="0">
+              <a:buNone/>
+            </a:pPr>
+            <a:r>
+              <a:rPr lang="en-US" sz="850" b="1" dirty="0">
+                <a:solidFill>
+                  <a:srgbClr val="04122E"/>
+                </a:solidFill>
+                <a:latin typeface="Arial" pitchFamily="34" charset="0"/>
+                <a:ea typeface="Arial" pitchFamily="34" charset="-122"/>
+                <a:cs typeface="Arial" pitchFamily="34" charset="-120"/>
+              </a:rPr>
+              <a:t>03</a:t>
+            </a:r>
+            <a:endParaRPr lang="en-US" sz="850" dirty="0"/>
+          </a:p>
+        </p:txBody>
+      </p:sp>
+      <p:sp>
+        <p:nvSpPr>
+          <p:cNvPr id="51" name="Text 23"/>
+          <p:cNvSpPr txBox="1"/>
+          <p:nvPr/>
+        </p:nvSpPr>
+        <p:spPr>
+          <a:xfrm>
+            <a:off x="5746750" y="4600758"/>
+            <a:ext cx="710892" cy="503765"/>
           </a:xfrm>
           <a:prstGeom prst="rect">
             <a:avLst/>
@@ -1701,7 +2501,7 @@
               <a:buNone/>
             </a:pPr>
             <a:r>
-              <a:rPr lang="en-US" sz="1700" b="1" dirty="0">
+              <a:rPr lang="en-US" sz="950" b="1" dirty="0">
                 <a:solidFill>
                   <a:srgbClr val="FFFFFF"/>
                 </a:solidFill>
@@ -1709,36 +2509,56 @@
                 <a:ea typeface="Arial" pitchFamily="34" charset="-122"/>
                 <a:cs typeface="Arial" pitchFamily="34" charset="-120"/>
               </a:rPr>
-              <a:t>Tương đồng cao với </a:t>
-            </a:r>
+              <a:t>Tối ưu hóa</a:t>
+            </a:r>
+            <a:endParaRPr lang="en-US" sz="950" dirty="0"/>
+          </a:p>
+          <a:p>
             <a:pPr algn="l" indent="0" marL="0">
               <a:buNone/>
             </a:pPr>
             <a:r>
-              <a:rPr lang="en-US" sz="1700" b="1" dirty="0">
-                <a:solidFill>
-                  <a:srgbClr val="8ED14F"/>
-                </a:solidFill>
-                <a:latin typeface="Arial" pitchFamily="34" charset="0"/>
-                <a:ea typeface="Arial" pitchFamily="34" charset="-122"/>
-                <a:cs typeface="Arial" pitchFamily="34" charset="-120"/>
-              </a:rPr>
-              <a:t>xương tự thân</a:t>
-            </a:r>
-            <a:endParaRPr lang="en-US" sz="1700" dirty="0"/>
-          </a:p>
-        </p:txBody>
-      </p:sp>
-      <p:sp>
-        <p:nvSpPr>
-          <p:cNvPr id="33" name="Text 5"/>
-          <p:cNvSpPr txBox="1"/>
-          <p:nvPr/>
-        </p:nvSpPr>
-        <p:spPr>
-          <a:xfrm>
-            <a:off x="769003" y="3718425"/>
-            <a:ext cx="1154394" cy="427228"/>
+              <a:rPr lang="en-US" sz="950" b="1" dirty="0">
+                <a:solidFill>
+                  <a:srgbClr val="FFFFFF"/>
+                </a:solidFill>
+                <a:latin typeface="Arial" pitchFamily="34" charset="0"/>
+                <a:ea typeface="Arial" pitchFamily="34" charset="-122"/>
+                <a:cs typeface="Arial" pitchFamily="34" charset="-120"/>
+              </a:rPr>
+              <a:t>quy trình</a:t>
+            </a:r>
+            <a:endParaRPr lang="en-US" sz="950" dirty="0"/>
+          </a:p>
+          <a:p>
+            <a:pPr algn="l" indent="0" marL="0">
+              <a:buNone/>
+            </a:pPr>
+            <a:r>
+              <a:rPr lang="en-US" sz="950" b="1" dirty="0">
+                <a:solidFill>
+                  <a:srgbClr val="FFFFFF"/>
+                </a:solidFill>
+                <a:latin typeface="Arial" pitchFamily="34" charset="0"/>
+                <a:ea typeface="Arial" pitchFamily="34" charset="-122"/>
+                <a:cs typeface="Arial" pitchFamily="34" charset="-120"/>
+              </a:rPr>
+              <a:t>phẫu thuật</a:t>
+            </a:r>
+            <a:endParaRPr lang="en-US" sz="950" dirty="0"/>
+          </a:p>
+        </p:txBody>
+      </p:sp>
+      <p:sp>
+        <p:nvSpPr>
+          <p:cNvPr id="52" name="Text 24"/>
+          <p:cNvSpPr txBox="1"/>
+          <p:nvPr/>
+        </p:nvSpPr>
+        <p:spPr>
+          <a:xfrm>
+            <a:off x="9823450" y="3241675"/>
+            <a:ext cx="1200249" cy="184150"/>
           </a:xfrm>
           <a:prstGeom prst="rect">
             <a:avLst/>
@@ -1754,7 +2574,46 @@
               <a:buNone/>
             </a:pPr>
             <a:r>
-              <a:rPr lang="en-US" sz="1250" b="1" dirty="0">
+              <a:rPr lang="en-US" sz="750" b="1" spc="100" kern="0" dirty="0">
+                <a:solidFill>
+                  <a:srgbClr val="0A3170"/>
+                </a:solidFill>
+                <a:latin typeface="Arial" pitchFamily="34" charset="0"/>
+                <a:ea typeface="Arial" pitchFamily="34" charset="-122"/>
+                <a:cs typeface="Arial" pitchFamily="34" charset="-120"/>
+              </a:rPr>
+              <a:t>CÔNG NGHỆ IN 3D</a:t>
+            </a:r>
+            <a:endParaRPr lang="en-US" sz="750" dirty="0"/>
+          </a:p>
+        </p:txBody>
+      </p:sp>
+      <p:sp>
+        <p:nvSpPr>
+          <p:cNvPr id="53" name="Text 25"/>
+          <p:cNvSpPr txBox="1"/>
+          <p:nvPr/>
+        </p:nvSpPr>
+        <p:spPr>
+          <a:xfrm>
+            <a:off x="9823450" y="3442589"/>
+            <a:ext cx="2026920" cy="125222"/>
+          </a:xfrm>
+          <a:prstGeom prst="rect">
+            <a:avLst/>
+          </a:prstGeom>
+          <a:noFill/>
+          <a:ln/>
+        </p:spPr>
+        <p:txBody>
+          <a:bodyPr wrap="square" lIns="0" tIns="0" rIns="0" bIns="0" rtlCol="0" anchor="ctr"/>
+          <a:lstStyle/>
+          <a:p>
+            <a:pPr algn="l" indent="0" marL="0">
+              <a:buNone/>
+            </a:pPr>
+            <a:r>
+              <a:rPr lang="en-US" sz="750" b="1" dirty="0">
                 <a:solidFill>
                   <a:srgbClr val="FFFFFF"/>
                 </a:solidFill>
@@ -1762,133 +2621,350 @@
                 <a:ea typeface="Arial" pitchFamily="34" charset="-122"/>
                 <a:cs typeface="Arial" pitchFamily="34" charset="-120"/>
               </a:rPr>
-              <a:t>Chấn thương</a:t>
-            </a:r>
-            <a:endParaRPr lang="en-US" sz="1250" dirty="0"/>
-          </a:p>
+              <a:t>Cấu trúc xốp tối ưu hóa tích hợp xương</a:t>
+            </a:r>
+            <a:endParaRPr lang="en-US" sz="750" dirty="0"/>
+          </a:p>
+        </p:txBody>
+      </p:sp>
+      <p:sp>
+        <p:nvSpPr>
+          <p:cNvPr id="54" name="Text 26"/>
+          <p:cNvSpPr txBox="1"/>
+          <p:nvPr/>
+        </p:nvSpPr>
+        <p:spPr>
+          <a:xfrm>
+            <a:off x="10458450" y="3684524"/>
+            <a:ext cx="1061871" cy="162052"/>
+          </a:xfrm>
+          <a:prstGeom prst="rect">
+            <a:avLst/>
+          </a:prstGeom>
+          <a:noFill/>
+          <a:ln/>
+        </p:spPr>
+        <p:txBody>
+          <a:bodyPr wrap="square" lIns="0" tIns="0" rIns="0" bIns="0" rtlCol="0" anchor="ctr"/>
+          <a:lstStyle/>
+          <a:p>
+            <a:pPr algn="l" indent="0" marL="0">
+              <a:buNone/>
+            </a:pPr>
+            <a:r>
+              <a:rPr lang="en-US" sz="950" b="1" spc="15" kern="0" dirty="0">
+                <a:solidFill>
+                  <a:srgbClr val="FFFFFF"/>
+                </a:solidFill>
+                <a:latin typeface="Arial" pitchFamily="34" charset="0"/>
+                <a:ea typeface="Arial" pitchFamily="34" charset="-122"/>
+                <a:cs typeface="Arial" pitchFamily="34" charset="-120"/>
+              </a:rPr>
+              <a:t>PANTHER</a:t>
+            </a:r>
+            <a:endParaRPr lang="en-US" sz="950" dirty="0"/>
+          </a:p>
+        </p:txBody>
+      </p:sp>
+      <p:sp>
+        <p:nvSpPr>
+          <p:cNvPr id="55" name="Text 27"/>
+          <p:cNvSpPr txBox="1"/>
+          <p:nvPr/>
+        </p:nvSpPr>
+        <p:spPr>
+          <a:xfrm>
+            <a:off x="10458450" y="3839464"/>
+            <a:ext cx="1061871" cy="125222"/>
+          </a:xfrm>
+          <a:prstGeom prst="rect">
+            <a:avLst/>
+          </a:prstGeom>
+          <a:noFill/>
+          <a:ln/>
+        </p:spPr>
+        <p:txBody>
+          <a:bodyPr wrap="square" lIns="0" tIns="0" rIns="0" bIns="0" rtlCol="0" anchor="ctr"/>
+          <a:lstStyle/>
+          <a:p>
+            <a:pPr algn="l" indent="0" marL="0">
+              <a:buNone/>
+            </a:pPr>
+            <a:r>
+              <a:rPr lang="en-US" sz="750" dirty="0">
+                <a:solidFill>
+                  <a:srgbClr val="CFE6FF"/>
+                </a:solidFill>
+                <a:latin typeface="Arial" pitchFamily="34" charset="0"/>
+                <a:ea typeface="Arial" pitchFamily="34" charset="-122"/>
+                <a:cs typeface="Arial" pitchFamily="34" charset="-120"/>
+              </a:rPr>
+              <a:t>Lồng thắt lưng in 3D</a:t>
+            </a:r>
+            <a:endParaRPr lang="en-US" sz="750" dirty="0"/>
+          </a:p>
+        </p:txBody>
+      </p:sp>
+      <p:sp>
+        <p:nvSpPr>
+          <p:cNvPr id="56" name="Text 28"/>
+          <p:cNvSpPr txBox="1"/>
+          <p:nvPr/>
+        </p:nvSpPr>
+        <p:spPr>
+          <a:xfrm>
+            <a:off x="10458450" y="4192524"/>
+            <a:ext cx="717905" cy="162052"/>
+          </a:xfrm>
+          <a:prstGeom prst="rect">
+            <a:avLst/>
+          </a:prstGeom>
+          <a:noFill/>
+          <a:ln/>
+        </p:spPr>
+        <p:txBody>
+          <a:bodyPr wrap="square" lIns="0" tIns="0" rIns="0" bIns="0" rtlCol="0" anchor="ctr"/>
+          <a:lstStyle/>
+          <a:p>
+            <a:pPr algn="l" indent="0" marL="0">
+              <a:buNone/>
+            </a:pPr>
+            <a:r>
+              <a:rPr lang="en-US" sz="950" b="1" spc="15" kern="0" dirty="0">
+                <a:solidFill>
+                  <a:srgbClr val="FFFFFF"/>
+                </a:solidFill>
+                <a:latin typeface="Arial" pitchFamily="34" charset="0"/>
+                <a:ea typeface="Arial" pitchFamily="34" charset="-122"/>
+                <a:cs typeface="Arial" pitchFamily="34" charset="-120"/>
+              </a:rPr>
+              <a:t>PETRA</a:t>
+            </a:r>
+            <a:endParaRPr lang="en-US" sz="950" dirty="0"/>
+          </a:p>
+        </p:txBody>
+      </p:sp>
+      <p:sp>
+        <p:nvSpPr>
+          <p:cNvPr id="57" name="Text 29"/>
+          <p:cNvSpPr txBox="1"/>
+          <p:nvPr/>
+        </p:nvSpPr>
+        <p:spPr>
+          <a:xfrm>
+            <a:off x="10458450" y="4347464"/>
+            <a:ext cx="717905" cy="125222"/>
+          </a:xfrm>
+          <a:prstGeom prst="rect">
+            <a:avLst/>
+          </a:prstGeom>
+          <a:noFill/>
+          <a:ln/>
+        </p:spPr>
+        <p:txBody>
+          <a:bodyPr wrap="square" lIns="0" tIns="0" rIns="0" bIns="0" rtlCol="0" anchor="ctr"/>
+          <a:lstStyle/>
+          <a:p>
+            <a:pPr algn="l" indent="0" marL="0">
+              <a:buNone/>
+            </a:pPr>
+            <a:r>
+              <a:rPr lang="en-US" sz="750" dirty="0">
+                <a:solidFill>
+                  <a:srgbClr val="CFE6FF"/>
+                </a:solidFill>
+                <a:latin typeface="Arial" pitchFamily="34" charset="0"/>
+                <a:ea typeface="Arial" pitchFamily="34" charset="-122"/>
+                <a:cs typeface="Arial" pitchFamily="34" charset="-120"/>
+              </a:rPr>
+              <a:t>Lồng cổ in 3D</a:t>
+            </a:r>
+            <a:endParaRPr lang="en-US" sz="750" dirty="0"/>
+          </a:p>
+        </p:txBody>
+      </p:sp>
+      <p:sp>
+        <p:nvSpPr>
+          <p:cNvPr id="58" name="Text 30"/>
+          <p:cNvSpPr txBox="1"/>
+          <p:nvPr/>
+        </p:nvSpPr>
+        <p:spPr>
+          <a:xfrm>
+            <a:off x="10452100" y="4795774"/>
+            <a:ext cx="784187" cy="162052"/>
+          </a:xfrm>
+          <a:prstGeom prst="rect">
+            <a:avLst/>
+          </a:prstGeom>
+          <a:noFill/>
+          <a:ln/>
+        </p:spPr>
+        <p:txBody>
+          <a:bodyPr wrap="square" lIns="0" tIns="0" rIns="0" bIns="0" rtlCol="0" anchor="ctr"/>
+          <a:lstStyle/>
+          <a:p>
+            <a:pPr algn="l" indent="0" marL="0">
+              <a:buNone/>
+            </a:pPr>
+            <a:r>
+              <a:rPr lang="en-US" sz="950" b="1" spc="15" kern="0" dirty="0">
+                <a:solidFill>
+                  <a:srgbClr val="FFFFFF"/>
+                </a:solidFill>
+                <a:latin typeface="Arial" pitchFamily="34" charset="0"/>
+                <a:ea typeface="Arial" pitchFamily="34" charset="-122"/>
+                <a:cs typeface="Arial" pitchFamily="34" charset="-120"/>
+              </a:rPr>
+              <a:t>QUATTRO</a:t>
+            </a:r>
+            <a:endParaRPr lang="en-US" sz="950" dirty="0"/>
+          </a:p>
+        </p:txBody>
+      </p:sp>
+      <p:sp>
+        <p:nvSpPr>
+          <p:cNvPr id="59" name="Text 31"/>
+          <p:cNvSpPr txBox="1"/>
+          <p:nvPr/>
+        </p:nvSpPr>
+        <p:spPr>
+          <a:xfrm>
+            <a:off x="10452100" y="4950714"/>
+            <a:ext cx="784187" cy="125222"/>
+          </a:xfrm>
+          <a:prstGeom prst="rect">
+            <a:avLst/>
+          </a:prstGeom>
+          <a:noFill/>
+          <a:ln/>
+        </p:spPr>
+        <p:txBody>
+          <a:bodyPr wrap="square" lIns="0" tIns="0" rIns="0" bIns="0" rtlCol="0" anchor="ctr"/>
+          <a:lstStyle/>
+          <a:p>
+            <a:pPr algn="l" indent="0" marL="0">
+              <a:buNone/>
+            </a:pPr>
+            <a:r>
+              <a:rPr lang="en-US" sz="750" dirty="0">
+                <a:solidFill>
+                  <a:srgbClr val="CFE6FF"/>
+                </a:solidFill>
+                <a:latin typeface="Arial" pitchFamily="34" charset="0"/>
+                <a:ea typeface="Arial" pitchFamily="34" charset="-122"/>
+                <a:cs typeface="Arial" pitchFamily="34" charset="-120"/>
+              </a:rPr>
+              <a:t>Vít cuống sống</a:t>
+            </a:r>
+            <a:endParaRPr lang="en-US" sz="750" dirty="0"/>
+          </a:p>
+        </p:txBody>
+      </p:sp>
+      <p:sp>
+        <p:nvSpPr>
+          <p:cNvPr id="60" name="Text 32"/>
+          <p:cNvSpPr txBox="1"/>
+          <p:nvPr/>
+        </p:nvSpPr>
+        <p:spPr>
+          <a:xfrm>
+            <a:off x="10452100" y="5329174"/>
+            <a:ext cx="1424047" cy="162052"/>
+          </a:xfrm>
+          <a:prstGeom prst="rect">
+            <a:avLst/>
+          </a:prstGeom>
+          <a:noFill/>
+          <a:ln/>
+        </p:spPr>
+        <p:txBody>
+          <a:bodyPr wrap="square" lIns="0" tIns="0" rIns="0" bIns="0" rtlCol="0" anchor="ctr"/>
+          <a:lstStyle/>
+          <a:p>
+            <a:pPr algn="l" indent="0" marL="0">
+              <a:buNone/>
+            </a:pPr>
+            <a:r>
+              <a:rPr lang="en-US" sz="950" b="1" spc="15" kern="0" dirty="0">
+                <a:solidFill>
+                  <a:srgbClr val="FFFFFF"/>
+                </a:solidFill>
+                <a:latin typeface="Arial" pitchFamily="34" charset="0"/>
+                <a:ea typeface="Arial" pitchFamily="34" charset="-122"/>
+                <a:cs typeface="Arial" pitchFamily="34" charset="-120"/>
+              </a:rPr>
+              <a:t>QUATTRO GADGET</a:t>
+            </a:r>
+            <a:endParaRPr lang="en-US" sz="950" dirty="0"/>
+          </a:p>
+        </p:txBody>
+      </p:sp>
+      <p:sp>
+        <p:nvSpPr>
+          <p:cNvPr id="61" name="Text 33"/>
+          <p:cNvSpPr txBox="1"/>
+          <p:nvPr/>
+        </p:nvSpPr>
+        <p:spPr>
+          <a:xfrm>
+            <a:off x="10452100" y="5496814"/>
+            <a:ext cx="1049994" cy="125222"/>
+          </a:xfrm>
+          <a:prstGeom prst="rect">
+            <a:avLst/>
+          </a:prstGeom>
+          <a:noFill/>
+          <a:ln/>
+        </p:spPr>
+        <p:txBody>
+          <a:bodyPr wrap="square" lIns="0" tIns="0" rIns="0" bIns="0" rtlCol="0" anchor="ctr"/>
+          <a:lstStyle/>
+          <a:p>
+            <a:pPr algn="l" indent="0" marL="0">
+              <a:buNone/>
+            </a:pPr>
+            <a:r>
+              <a:rPr lang="en-US" sz="750" dirty="0">
+                <a:solidFill>
+                  <a:srgbClr val="CFE6FF"/>
+                </a:solidFill>
+                <a:latin typeface="Arial" pitchFamily="34" charset="0"/>
+                <a:ea typeface="Arial" pitchFamily="34" charset="-122"/>
+                <a:cs typeface="Arial" pitchFamily="34" charset="-120"/>
+              </a:rPr>
+              <a:t>Vít qua da ít xâm lấn</a:t>
+            </a:r>
+            <a:endParaRPr lang="en-US" sz="750" dirty="0"/>
+          </a:p>
+        </p:txBody>
+      </p:sp>
+      <p:sp>
+        <p:nvSpPr>
+          <p:cNvPr id="62" name="Text 34"/>
+          <p:cNvSpPr txBox="1"/>
+          <p:nvPr/>
+        </p:nvSpPr>
+        <p:spPr>
+          <a:xfrm>
+            <a:off x="11411248" y="5482082"/>
+            <a:ext cx="290016" cy="154686"/>
+          </a:xfrm>
+          <a:prstGeom prst="rect">
+            <a:avLst/>
+          </a:prstGeom>
+          <a:noFill/>
+          <a:ln/>
+        </p:spPr>
+        <p:txBody>
+          <a:bodyPr wrap="square" lIns="0" tIns="0" rIns="0" bIns="0" rtlCol="0" anchor="ctr"/>
+          <a:lstStyle/>
           <a:p>
             <a:pPr algn="ctr" indent="0" marL="0">
               <a:buNone/>
             </a:pPr>
             <a:r>
-              <a:rPr lang="en-US" sz="1250" b="1" dirty="0">
-                <a:solidFill>
-                  <a:srgbClr val="FFFFFF"/>
-                </a:solidFill>
-                <a:latin typeface="Arial" pitchFamily="34" charset="0"/>
-                <a:ea typeface="Arial" pitchFamily="34" charset="-122"/>
-                <a:cs typeface="Arial" pitchFamily="34" charset="-120"/>
-              </a:rPr>
-              <a:t>chỉnh hình</a:t>
-            </a:r>
-            <a:endParaRPr lang="en-US" sz="1250" dirty="0"/>
-          </a:p>
-        </p:txBody>
-      </p:sp>
-      <p:sp>
-        <p:nvSpPr>
-          <p:cNvPr id="34" name="Text 6"/>
-          <p:cNvSpPr txBox="1"/>
-          <p:nvPr/>
-        </p:nvSpPr>
-        <p:spPr>
-          <a:xfrm>
-            <a:off x="3702844" y="5269559"/>
-            <a:ext cx="1357313" cy="213614"/>
-          </a:xfrm>
-          <a:prstGeom prst="rect">
-            <a:avLst/>
-          </a:prstGeom>
-          <a:noFill/>
-          <a:ln/>
-        </p:spPr>
-        <p:txBody>
-          <a:bodyPr wrap="square" lIns="0" tIns="0" rIns="0" bIns="0" rtlCol="0" anchor="ctr"/>
-          <a:lstStyle/>
-          <a:p>
-            <a:pPr algn="ctr" indent="0" marL="0">
-              <a:buNone/>
-            </a:pPr>
-            <a:r>
-              <a:rPr lang="en-US" sz="1250" b="1" dirty="0">
-                <a:solidFill>
-                  <a:srgbClr val="FFFFFF"/>
-                </a:solidFill>
-                <a:latin typeface="Arial" pitchFamily="34" charset="0"/>
-                <a:ea typeface="Arial" pitchFamily="34" charset="-122"/>
-                <a:cs typeface="Arial" pitchFamily="34" charset="-120"/>
-              </a:rPr>
-              <a:t>Ngoại thần kinh</a:t>
-            </a:r>
-            <a:endParaRPr lang="en-US" sz="1250" dirty="0"/>
-          </a:p>
-        </p:txBody>
-      </p:sp>
-      <p:sp>
-        <p:nvSpPr>
-          <p:cNvPr id="35" name="Text 7"/>
-          <p:cNvSpPr txBox="1"/>
-          <p:nvPr/>
-        </p:nvSpPr>
-        <p:spPr>
-          <a:xfrm>
-            <a:off x="521253" y="5982835"/>
-            <a:ext cx="1645628" cy="251135"/>
-          </a:xfrm>
-          <a:prstGeom prst="rect">
-            <a:avLst/>
-          </a:prstGeom>
-          <a:noFill/>
-          <a:ln/>
-        </p:spPr>
-        <p:txBody>
-          <a:bodyPr wrap="square" lIns="0" tIns="0" rIns="0" bIns="0" rtlCol="0" anchor="ctr"/>
-          <a:lstStyle/>
-          <a:p>
-            <a:pPr algn="ctr" indent="0" marL="0">
-              <a:buNone/>
-            </a:pPr>
-            <a:r>
-              <a:rPr lang="en-US" sz="1550" b="1" dirty="0">
-                <a:solidFill>
-                  <a:srgbClr val="8ED14F"/>
-                </a:solidFill>
-                <a:latin typeface="Arial" pitchFamily="34" charset="0"/>
-                <a:ea typeface="Arial" pitchFamily="34" charset="-122"/>
-                <a:cs typeface="Arial" pitchFamily="34" charset="-120"/>
-              </a:rPr>
-              <a:t>45 : 55</a:t>
-            </a:r>
-            <a:endParaRPr lang="en-US" sz="1550" dirty="0"/>
-          </a:p>
-        </p:txBody>
-      </p:sp>
-      <p:sp>
-        <p:nvSpPr>
-          <p:cNvPr id="36" name="Text 8"/>
-          <p:cNvSpPr txBox="1"/>
-          <p:nvPr/>
-        </p:nvSpPr>
-        <p:spPr>
-          <a:xfrm>
-            <a:off x="521253" y="6225540"/>
-            <a:ext cx="1645628" cy="147320"/>
-          </a:xfrm>
-          <a:prstGeom prst="rect">
-            <a:avLst/>
-          </a:prstGeom>
-          <a:noFill/>
-          <a:ln/>
-        </p:spPr>
-        <p:txBody>
-          <a:bodyPr wrap="square" lIns="0" tIns="0" rIns="0" bIns="0" rtlCol="0" anchor="ctr"/>
-          <a:lstStyle/>
-          <a:p>
-            <a:pPr algn="ctr" indent="0" marL="0">
-              <a:buNone/>
-            </a:pPr>
-            <a:r>
-              <a:rPr lang="en-US" sz="850" dirty="0">
+              <a:rPr lang="en-US" sz="750" spc="50" kern="0" dirty="0">
                 <a:solidFill>
                   <a:srgbClr val="CFE6FF"/>
                 </a:solidFill>
@@ -1896,962 +2972,9 @@
                 <a:ea typeface="Arial" pitchFamily="34" charset="-122"/>
                 <a:cs typeface="Arial" pitchFamily="34" charset="-120"/>
               </a:rPr>
-              <a:t>Collagen I : nano-HA</a:t>
-            </a:r>
-            <a:endParaRPr lang="en-US" sz="850" dirty="0"/>
-          </a:p>
-        </p:txBody>
-      </p:sp>
-      <p:sp>
-        <p:nvSpPr>
-          <p:cNvPr id="37" name="Text 9"/>
-          <p:cNvSpPr txBox="1"/>
-          <p:nvPr/>
-        </p:nvSpPr>
-        <p:spPr>
-          <a:xfrm>
-            <a:off x="2047781" y="5982835"/>
-            <a:ext cx="1638389" cy="251135"/>
-          </a:xfrm>
-          <a:prstGeom prst="rect">
-            <a:avLst/>
-          </a:prstGeom>
-          <a:noFill/>
-          <a:ln/>
-        </p:spPr>
-        <p:txBody>
-          <a:bodyPr wrap="square" lIns="0" tIns="0" rIns="0" bIns="0" rtlCol="0" anchor="ctr"/>
-          <a:lstStyle/>
-          <a:p>
-            <a:pPr algn="ctr" indent="0" marL="0">
-              <a:buNone/>
-            </a:pPr>
-            <a:r>
-              <a:rPr lang="en-US" sz="1550" b="1" dirty="0">
-                <a:solidFill>
-                  <a:srgbClr val="8ED14F"/>
-                </a:solidFill>
-                <a:latin typeface="Arial" pitchFamily="34" charset="0"/>
-                <a:ea typeface="Arial" pitchFamily="34" charset="-122"/>
-                <a:cs typeface="Arial" pitchFamily="34" charset="-120"/>
-              </a:rPr>
-              <a:t>70–80%</a:t>
-            </a:r>
-            <a:endParaRPr lang="en-US" sz="1550" dirty="0"/>
-          </a:p>
-        </p:txBody>
-      </p:sp>
-      <p:sp>
-        <p:nvSpPr>
-          <p:cNvPr id="38" name="Text 10"/>
-          <p:cNvSpPr txBox="1"/>
-          <p:nvPr/>
-        </p:nvSpPr>
-        <p:spPr>
-          <a:xfrm>
-            <a:off x="2047781" y="6225540"/>
-            <a:ext cx="1638389" cy="147320"/>
-          </a:xfrm>
-          <a:prstGeom prst="rect">
-            <a:avLst/>
-          </a:prstGeom>
-          <a:noFill/>
-          <a:ln/>
-        </p:spPr>
-        <p:txBody>
-          <a:bodyPr wrap="square" lIns="0" tIns="0" rIns="0" bIns="0" rtlCol="0" anchor="ctr"/>
-          <a:lstStyle/>
-          <a:p>
-            <a:pPr algn="ctr" indent="0" marL="0">
-              <a:buNone/>
-            </a:pPr>
-            <a:r>
-              <a:rPr lang="en-US" sz="850" dirty="0">
-                <a:solidFill>
-                  <a:srgbClr val="CFE6FF"/>
-                </a:solidFill>
-                <a:latin typeface="Arial" pitchFamily="34" charset="0"/>
-                <a:ea typeface="Arial" pitchFamily="34" charset="-122"/>
-                <a:cs typeface="Arial" pitchFamily="34" charset="-120"/>
-              </a:rPr>
-              <a:t>Độ xốp</a:t>
-            </a:r>
-            <a:endParaRPr lang="en-US" sz="850" dirty="0"/>
-          </a:p>
-        </p:txBody>
-      </p:sp>
-      <p:sp>
-        <p:nvSpPr>
-          <p:cNvPr id="39" name="Text 11"/>
-          <p:cNvSpPr txBox="1"/>
-          <p:nvPr/>
-        </p:nvSpPr>
-        <p:spPr>
-          <a:xfrm>
-            <a:off x="3567514" y="5982835"/>
-            <a:ext cx="1638389" cy="251135"/>
-          </a:xfrm>
-          <a:prstGeom prst="rect">
-            <a:avLst/>
-          </a:prstGeom>
-          <a:noFill/>
-          <a:ln/>
-        </p:spPr>
-        <p:txBody>
-          <a:bodyPr wrap="square" lIns="0" tIns="0" rIns="0" bIns="0" rtlCol="0" anchor="ctr"/>
-          <a:lstStyle/>
-          <a:p>
-            <a:pPr algn="ctr" indent="0" marL="0">
-              <a:buNone/>
-            </a:pPr>
-            <a:r>
-              <a:rPr lang="en-US" sz="1550" b="1" dirty="0">
-                <a:solidFill>
-                  <a:srgbClr val="8ED14F"/>
-                </a:solidFill>
-                <a:latin typeface="Arial" pitchFamily="34" charset="0"/>
-                <a:ea typeface="Arial" pitchFamily="34" charset="-122"/>
-                <a:cs typeface="Arial" pitchFamily="34" charset="-120"/>
-              </a:rPr>
-              <a:t>&gt;200.000</a:t>
-            </a:r>
-            <a:endParaRPr lang="en-US" sz="1550" dirty="0"/>
-          </a:p>
-        </p:txBody>
-      </p:sp>
-      <p:sp>
-        <p:nvSpPr>
-          <p:cNvPr id="40" name="Text 12"/>
-          <p:cNvSpPr txBox="1"/>
-          <p:nvPr/>
-        </p:nvSpPr>
-        <p:spPr>
-          <a:xfrm>
-            <a:off x="3567514" y="6225540"/>
-            <a:ext cx="1638389" cy="147320"/>
-          </a:xfrm>
-          <a:prstGeom prst="rect">
-            <a:avLst/>
-          </a:prstGeom>
-          <a:noFill/>
-          <a:ln/>
-        </p:spPr>
-        <p:txBody>
-          <a:bodyPr wrap="square" lIns="0" tIns="0" rIns="0" bIns="0" rtlCol="0" anchor="ctr"/>
-          <a:lstStyle/>
-          <a:p>
-            <a:pPr algn="ctr" indent="0" marL="0">
-              <a:buNone/>
-            </a:pPr>
-            <a:r>
-              <a:rPr lang="en-US" sz="850" dirty="0">
-                <a:solidFill>
-                  <a:srgbClr val="CFE6FF"/>
-                </a:solidFill>
-                <a:latin typeface="Arial" pitchFamily="34" charset="0"/>
-                <a:ea typeface="Arial" pitchFamily="34" charset="-122"/>
-                <a:cs typeface="Arial" pitchFamily="34" charset="-120"/>
-              </a:rPr>
-              <a:t>Ca lâm sàng</a:t>
-            </a:r>
-            <a:endParaRPr lang="en-US" sz="850" dirty="0"/>
-          </a:p>
-        </p:txBody>
-      </p:sp>
-      <p:sp>
-        <p:nvSpPr>
-          <p:cNvPr id="41" name="Text 13"/>
-          <p:cNvSpPr txBox="1"/>
-          <p:nvPr/>
-        </p:nvSpPr>
-        <p:spPr>
-          <a:xfrm>
-            <a:off x="5358638" y="2080768"/>
-            <a:ext cx="5183124" cy="213614"/>
-          </a:xfrm>
-          <a:prstGeom prst="rect">
-            <a:avLst/>
-          </a:prstGeom>
-          <a:noFill/>
-          <a:ln/>
-        </p:spPr>
-        <p:txBody>
-          <a:bodyPr wrap="square" lIns="0" tIns="0" rIns="0" bIns="0" rtlCol="0" anchor="ctr"/>
-          <a:lstStyle/>
-          <a:p>
-            <a:pPr algn="ctr" indent="0" marL="0">
-              <a:buNone/>
-            </a:pPr>
-            <a:r>
-              <a:rPr lang="en-US" sz="1250" b="1" spc="50" kern="0" dirty="0">
-                <a:solidFill>
-                  <a:srgbClr val="FFFFFF"/>
-                </a:solidFill>
-                <a:latin typeface="Arial" pitchFamily="34" charset="0"/>
-                <a:ea typeface="Arial" pitchFamily="34" charset="-122"/>
-                <a:cs typeface="Arial" pitchFamily="34" charset="-120"/>
-              </a:rPr>
-              <a:t>GIẢI PHÁP TÍCH HỢP CHO PHẪU THUẬT CỘT SỐNG</a:t>
-            </a:r>
-            <a:endParaRPr lang="en-US" sz="1250" dirty="0"/>
-          </a:p>
-        </p:txBody>
-      </p:sp>
-      <p:sp>
-        <p:nvSpPr>
-          <p:cNvPr id="42" name="Text 14"/>
-          <p:cNvSpPr txBox="1"/>
-          <p:nvPr/>
-        </p:nvSpPr>
-        <p:spPr>
-          <a:xfrm>
-            <a:off x="5892800" y="5891657"/>
-            <a:ext cx="1071711" cy="154686"/>
-          </a:xfrm>
-          <a:prstGeom prst="rect">
-            <a:avLst/>
-          </a:prstGeom>
-          <a:noFill/>
-          <a:ln/>
-        </p:spPr>
-        <p:txBody>
-          <a:bodyPr wrap="square" lIns="0" tIns="0" rIns="0" bIns="0" rtlCol="0" anchor="ctr"/>
-          <a:lstStyle/>
-          <a:p>
-            <a:pPr algn="l" indent="0" marL="0">
-              <a:buNone/>
-            </a:pPr>
-            <a:r>
-              <a:rPr lang="en-US" sz="900" b="1" dirty="0">
-                <a:solidFill>
-                  <a:srgbClr val="FFFFFF"/>
-                </a:solidFill>
-                <a:latin typeface="Arial" pitchFamily="34" charset="0"/>
-                <a:ea typeface="Arial" pitchFamily="34" charset="-122"/>
-                <a:cs typeface="Arial" pitchFamily="34" charset="-120"/>
-              </a:rPr>
-              <a:t>Độ chính xác cao</a:t>
-            </a:r>
-            <a:endParaRPr lang="en-US" sz="900" dirty="0"/>
-          </a:p>
-        </p:txBody>
-      </p:sp>
-      <p:sp>
-        <p:nvSpPr>
-          <p:cNvPr id="43" name="Text 15"/>
-          <p:cNvSpPr txBox="1"/>
-          <p:nvPr/>
-        </p:nvSpPr>
-        <p:spPr>
-          <a:xfrm>
-            <a:off x="5892800" y="6101207"/>
-            <a:ext cx="1381405" cy="154686"/>
-          </a:xfrm>
-          <a:prstGeom prst="rect">
-            <a:avLst/>
-          </a:prstGeom>
-          <a:noFill/>
-          <a:ln/>
-        </p:spPr>
-        <p:txBody>
-          <a:bodyPr wrap="square" lIns="0" tIns="0" rIns="0" bIns="0" rtlCol="0" anchor="ctr"/>
-          <a:lstStyle/>
-          <a:p>
-            <a:pPr algn="l" indent="0" marL="0">
-              <a:buNone/>
-            </a:pPr>
-            <a:r>
-              <a:rPr lang="en-US" sz="900" b="1" dirty="0">
-                <a:solidFill>
-                  <a:srgbClr val="FFFFFF"/>
-                </a:solidFill>
-                <a:latin typeface="Arial" pitchFamily="34" charset="0"/>
-                <a:ea typeface="Arial" pitchFamily="34" charset="-122"/>
-                <a:cs typeface="Arial" pitchFamily="34" charset="-120"/>
-              </a:rPr>
-              <a:t>Giảm phơi nhiễm tia X</a:t>
-            </a:r>
-            <a:endParaRPr lang="en-US" sz="900" dirty="0"/>
-          </a:p>
-        </p:txBody>
-      </p:sp>
-      <p:sp>
-        <p:nvSpPr>
-          <p:cNvPr id="44" name="Text 16"/>
-          <p:cNvSpPr txBox="1"/>
-          <p:nvPr/>
-        </p:nvSpPr>
-        <p:spPr>
-          <a:xfrm>
-            <a:off x="5892800" y="6310757"/>
-            <a:ext cx="1969121" cy="154686"/>
-          </a:xfrm>
-          <a:prstGeom prst="rect">
-            <a:avLst/>
-          </a:prstGeom>
-          <a:noFill/>
-          <a:ln/>
-        </p:spPr>
-        <p:txBody>
-          <a:bodyPr wrap="square" lIns="0" tIns="0" rIns="0" bIns="0" rtlCol="0" anchor="ctr"/>
-          <a:lstStyle/>
-          <a:p>
-            <a:pPr algn="l" indent="0" marL="0">
-              <a:buNone/>
-            </a:pPr>
-            <a:r>
-              <a:rPr lang="en-US" sz="900" b="1" dirty="0">
-                <a:solidFill>
-                  <a:srgbClr val="FFFFFF"/>
-                </a:solidFill>
-                <a:latin typeface="Arial" pitchFamily="34" charset="0"/>
-                <a:ea typeface="Arial" pitchFamily="34" charset="-122"/>
-                <a:cs typeface="Arial" pitchFamily="34" charset="-120"/>
-              </a:rPr>
-              <a:t>Tối ưu hóa quy trình phẫu thuật</a:t>
-            </a:r>
-            <a:endParaRPr lang="en-US" sz="900" dirty="0"/>
-          </a:p>
-        </p:txBody>
-      </p:sp>
-      <p:sp>
-        <p:nvSpPr>
-          <p:cNvPr id="45" name="Text 17"/>
-          <p:cNvSpPr txBox="1"/>
-          <p:nvPr/>
-        </p:nvSpPr>
-        <p:spPr>
-          <a:xfrm>
-            <a:off x="7893050" y="2425700"/>
-            <a:ext cx="1200249" cy="184150"/>
-          </a:xfrm>
-          <a:prstGeom prst="rect">
-            <a:avLst/>
-          </a:prstGeom>
-          <a:noFill/>
-          <a:ln/>
-        </p:spPr>
-        <p:txBody>
-          <a:bodyPr wrap="square" lIns="0" tIns="0" rIns="0" bIns="0" rtlCol="0" anchor="ctr"/>
-          <a:lstStyle/>
-          <a:p>
-            <a:pPr algn="ctr" indent="0" marL="0">
-              <a:buNone/>
-            </a:pPr>
-            <a:r>
-              <a:rPr lang="en-US" sz="750" b="1" spc="100" kern="0" dirty="0">
-                <a:solidFill>
-                  <a:srgbClr val="0A3170"/>
-                </a:solidFill>
-                <a:latin typeface="Arial" pitchFamily="34" charset="0"/>
-                <a:ea typeface="Arial" pitchFamily="34" charset="-122"/>
-                <a:cs typeface="Arial" pitchFamily="34" charset="-120"/>
-              </a:rPr>
-              <a:t>CÔNG NGHỆ IN 3D</a:t>
+              <a:t>MIS</a:t>
             </a:r>
             <a:endParaRPr lang="en-US" sz="750" dirty="0"/>
-          </a:p>
-        </p:txBody>
-      </p:sp>
-      <p:sp>
-        <p:nvSpPr>
-          <p:cNvPr id="46" name="Text 18"/>
-          <p:cNvSpPr txBox="1"/>
-          <p:nvPr/>
-        </p:nvSpPr>
-        <p:spPr>
-          <a:xfrm>
-            <a:off x="7893050" y="2625090"/>
-            <a:ext cx="2562606" cy="147320"/>
-          </a:xfrm>
-          <a:prstGeom prst="rect">
-            <a:avLst/>
-          </a:prstGeom>
-          <a:noFill/>
-          <a:ln/>
-        </p:spPr>
-        <p:txBody>
-          <a:bodyPr wrap="square" lIns="0" tIns="0" rIns="0" bIns="0" rtlCol="0" anchor="ctr"/>
-          <a:lstStyle/>
-          <a:p>
-            <a:pPr algn="l" indent="0" marL="0">
-              <a:buNone/>
-            </a:pPr>
-            <a:r>
-              <a:rPr lang="en-US" sz="850" b="1" dirty="0">
-                <a:solidFill>
-                  <a:srgbClr val="FFFFFF"/>
-                </a:solidFill>
-                <a:latin typeface="Arial" pitchFamily="34" charset="0"/>
-                <a:ea typeface="Arial" pitchFamily="34" charset="-122"/>
-                <a:cs typeface="Arial" pitchFamily="34" charset="-120"/>
-              </a:rPr>
-              <a:t>Cấu trúc xốp tối ưu hóa tích hợp xương</a:t>
-            </a:r>
-            <a:endParaRPr lang="en-US" sz="850" dirty="0"/>
-          </a:p>
-        </p:txBody>
-      </p:sp>
-      <p:sp>
-        <p:nvSpPr>
-          <p:cNvPr id="47" name="Text 19"/>
-          <p:cNvSpPr txBox="1"/>
-          <p:nvPr/>
-        </p:nvSpPr>
-        <p:spPr>
-          <a:xfrm>
-            <a:off x="8642350" y="2915158"/>
-            <a:ext cx="1203371" cy="176784"/>
-          </a:xfrm>
-          <a:prstGeom prst="rect">
-            <a:avLst/>
-          </a:prstGeom>
-          <a:noFill/>
-          <a:ln/>
-        </p:spPr>
-        <p:txBody>
-          <a:bodyPr wrap="square" lIns="0" tIns="0" rIns="0" bIns="0" rtlCol="0" anchor="ctr"/>
-          <a:lstStyle/>
-          <a:p>
-            <a:pPr algn="l" indent="0" marL="0">
-              <a:buNone/>
-            </a:pPr>
-            <a:r>
-              <a:rPr lang="en-US" sz="1050" b="1" spc="25" kern="0" dirty="0">
-                <a:solidFill>
-                  <a:srgbClr val="FFFFFF"/>
-                </a:solidFill>
-                <a:latin typeface="Arial" pitchFamily="34" charset="0"/>
-                <a:ea typeface="Arial" pitchFamily="34" charset="-122"/>
-                <a:cs typeface="Arial" pitchFamily="34" charset="-120"/>
-              </a:rPr>
-              <a:t>PANTHER</a:t>
-            </a:r>
-            <a:endParaRPr lang="en-US" sz="1050" dirty="0"/>
-          </a:p>
-        </p:txBody>
-      </p:sp>
-      <p:sp>
-        <p:nvSpPr>
-          <p:cNvPr id="48" name="Text 20"/>
-          <p:cNvSpPr txBox="1"/>
-          <p:nvPr/>
-        </p:nvSpPr>
-        <p:spPr>
-          <a:xfrm>
-            <a:off x="8642350" y="3082290"/>
-            <a:ext cx="1203371" cy="147320"/>
-          </a:xfrm>
-          <a:prstGeom prst="rect">
-            <a:avLst/>
-          </a:prstGeom>
-          <a:noFill/>
-          <a:ln/>
-        </p:spPr>
-        <p:txBody>
-          <a:bodyPr wrap="square" lIns="0" tIns="0" rIns="0" bIns="0" rtlCol="0" anchor="ctr"/>
-          <a:lstStyle/>
-          <a:p>
-            <a:pPr algn="l" indent="0" marL="0">
-              <a:buNone/>
-            </a:pPr>
-            <a:r>
-              <a:rPr lang="en-US" sz="850" dirty="0">
-                <a:solidFill>
-                  <a:srgbClr val="CFE6FF"/>
-                </a:solidFill>
-                <a:latin typeface="Arial" pitchFamily="34" charset="0"/>
-                <a:ea typeface="Arial" pitchFamily="34" charset="-122"/>
-                <a:cs typeface="Arial" pitchFamily="34" charset="-120"/>
-              </a:rPr>
-              <a:t>Lồng thắt lưng in 3D</a:t>
-            </a:r>
-            <a:endParaRPr lang="en-US" sz="850" dirty="0"/>
-          </a:p>
-        </p:txBody>
-      </p:sp>
-      <p:sp>
-        <p:nvSpPr>
-          <p:cNvPr id="49" name="Text 21"/>
-          <p:cNvSpPr txBox="1"/>
-          <p:nvPr/>
-        </p:nvSpPr>
-        <p:spPr>
-          <a:xfrm>
-            <a:off x="8642350" y="3486658"/>
-            <a:ext cx="813596" cy="176784"/>
-          </a:xfrm>
-          <a:prstGeom prst="rect">
-            <a:avLst/>
-          </a:prstGeom>
-          <a:noFill/>
-          <a:ln/>
-        </p:spPr>
-        <p:txBody>
-          <a:bodyPr wrap="square" lIns="0" tIns="0" rIns="0" bIns="0" rtlCol="0" anchor="ctr"/>
-          <a:lstStyle/>
-          <a:p>
-            <a:pPr algn="l" indent="0" marL="0">
-              <a:buNone/>
-            </a:pPr>
-            <a:r>
-              <a:rPr lang="en-US" sz="1050" b="1" spc="25" kern="0" dirty="0">
-                <a:solidFill>
-                  <a:srgbClr val="FFFFFF"/>
-                </a:solidFill>
-                <a:latin typeface="Arial" pitchFamily="34" charset="0"/>
-                <a:ea typeface="Arial" pitchFamily="34" charset="-122"/>
-                <a:cs typeface="Arial" pitchFamily="34" charset="-120"/>
-              </a:rPr>
-              <a:t>PETRA</a:t>
-            </a:r>
-            <a:endParaRPr lang="en-US" sz="1050" dirty="0"/>
-          </a:p>
-        </p:txBody>
-      </p:sp>
-      <p:sp>
-        <p:nvSpPr>
-          <p:cNvPr id="50" name="Text 22"/>
-          <p:cNvSpPr txBox="1"/>
-          <p:nvPr/>
-        </p:nvSpPr>
-        <p:spPr>
-          <a:xfrm>
-            <a:off x="8642350" y="3653790"/>
-            <a:ext cx="813596" cy="147320"/>
-          </a:xfrm>
-          <a:prstGeom prst="rect">
-            <a:avLst/>
-          </a:prstGeom>
-          <a:noFill/>
-          <a:ln/>
-        </p:spPr>
-        <p:txBody>
-          <a:bodyPr wrap="square" lIns="0" tIns="0" rIns="0" bIns="0" rtlCol="0" anchor="ctr"/>
-          <a:lstStyle/>
-          <a:p>
-            <a:pPr algn="l" indent="0" marL="0">
-              <a:buNone/>
-            </a:pPr>
-            <a:r>
-              <a:rPr lang="en-US" sz="850" dirty="0">
-                <a:solidFill>
-                  <a:srgbClr val="CFE6FF"/>
-                </a:solidFill>
-                <a:latin typeface="Arial" pitchFamily="34" charset="0"/>
-                <a:ea typeface="Arial" pitchFamily="34" charset="-122"/>
-                <a:cs typeface="Arial" pitchFamily="34" charset="-120"/>
-              </a:rPr>
-              <a:t>Lồng cổ in 3D</a:t>
-            </a:r>
-            <a:endParaRPr lang="en-US" sz="850" dirty="0"/>
-          </a:p>
-        </p:txBody>
-      </p:sp>
-      <p:sp>
-        <p:nvSpPr>
-          <p:cNvPr id="51" name="Text 23"/>
-          <p:cNvSpPr txBox="1"/>
-          <p:nvPr/>
-        </p:nvSpPr>
-        <p:spPr>
-          <a:xfrm>
-            <a:off x="8636000" y="4166108"/>
-            <a:ext cx="888813" cy="176784"/>
-          </a:xfrm>
-          <a:prstGeom prst="rect">
-            <a:avLst/>
-          </a:prstGeom>
-          <a:noFill/>
-          <a:ln/>
-        </p:spPr>
-        <p:txBody>
-          <a:bodyPr wrap="square" lIns="0" tIns="0" rIns="0" bIns="0" rtlCol="0" anchor="ctr"/>
-          <a:lstStyle/>
-          <a:p>
-            <a:pPr algn="l" indent="0" marL="0">
-              <a:buNone/>
-            </a:pPr>
-            <a:r>
-              <a:rPr lang="en-US" sz="1050" b="1" spc="25" kern="0" dirty="0">
-                <a:solidFill>
-                  <a:srgbClr val="FFFFFF"/>
-                </a:solidFill>
-                <a:latin typeface="Arial" pitchFamily="34" charset="0"/>
-                <a:ea typeface="Arial" pitchFamily="34" charset="-122"/>
-                <a:cs typeface="Arial" pitchFamily="34" charset="-120"/>
-              </a:rPr>
-              <a:t>QUATTRO</a:t>
-            </a:r>
-            <a:endParaRPr lang="en-US" sz="1050" dirty="0"/>
-          </a:p>
-        </p:txBody>
-      </p:sp>
-      <p:sp>
-        <p:nvSpPr>
-          <p:cNvPr id="52" name="Text 24"/>
-          <p:cNvSpPr txBox="1"/>
-          <p:nvPr/>
-        </p:nvSpPr>
-        <p:spPr>
-          <a:xfrm>
-            <a:off x="8636000" y="4333240"/>
-            <a:ext cx="888813" cy="147320"/>
-          </a:xfrm>
-          <a:prstGeom prst="rect">
-            <a:avLst/>
-          </a:prstGeom>
-          <a:noFill/>
-          <a:ln/>
-        </p:spPr>
-        <p:txBody>
-          <a:bodyPr wrap="square" lIns="0" tIns="0" rIns="0" bIns="0" rtlCol="0" anchor="ctr"/>
-          <a:lstStyle/>
-          <a:p>
-            <a:pPr algn="l" indent="0" marL="0">
-              <a:buNone/>
-            </a:pPr>
-            <a:r>
-              <a:rPr lang="en-US" sz="850" dirty="0">
-                <a:solidFill>
-                  <a:srgbClr val="CFE6FF"/>
-                </a:solidFill>
-                <a:latin typeface="Arial" pitchFamily="34" charset="0"/>
-                <a:ea typeface="Arial" pitchFamily="34" charset="-122"/>
-                <a:cs typeface="Arial" pitchFamily="34" charset="-120"/>
-              </a:rPr>
-              <a:t>Vít cuống sống</a:t>
-            </a:r>
-            <a:endParaRPr lang="en-US" sz="850" dirty="0"/>
-          </a:p>
-        </p:txBody>
-      </p:sp>
-      <p:sp>
-        <p:nvSpPr>
-          <p:cNvPr id="53" name="Text 25"/>
-          <p:cNvSpPr txBox="1"/>
-          <p:nvPr/>
-        </p:nvSpPr>
-        <p:spPr>
-          <a:xfrm>
-            <a:off x="8636000" y="4775708"/>
-            <a:ext cx="1600045" cy="176784"/>
-          </a:xfrm>
-          <a:prstGeom prst="rect">
-            <a:avLst/>
-          </a:prstGeom>
-          <a:noFill/>
-          <a:ln/>
-        </p:spPr>
-        <p:txBody>
-          <a:bodyPr wrap="square" lIns="0" tIns="0" rIns="0" bIns="0" rtlCol="0" anchor="ctr"/>
-          <a:lstStyle/>
-          <a:p>
-            <a:pPr algn="l" indent="0" marL="0">
-              <a:buNone/>
-            </a:pPr>
-            <a:r>
-              <a:rPr lang="en-US" sz="1050" b="1" spc="25" kern="0" dirty="0">
-                <a:solidFill>
-                  <a:srgbClr val="FFFFFF"/>
-                </a:solidFill>
-                <a:latin typeface="Arial" pitchFamily="34" charset="0"/>
-                <a:ea typeface="Arial" pitchFamily="34" charset="-122"/>
-                <a:cs typeface="Arial" pitchFamily="34" charset="-120"/>
-              </a:rPr>
-              <a:t>QUATTRO GADGET</a:t>
-            </a:r>
-            <a:endParaRPr lang="en-US" sz="1050" dirty="0"/>
-          </a:p>
-        </p:txBody>
-      </p:sp>
-      <p:sp>
-        <p:nvSpPr>
-          <p:cNvPr id="54" name="Text 26"/>
-          <p:cNvSpPr txBox="1"/>
-          <p:nvPr/>
-        </p:nvSpPr>
-        <p:spPr>
-          <a:xfrm>
-            <a:off x="8636000" y="4942840"/>
-            <a:ext cx="1600045" cy="147320"/>
-          </a:xfrm>
-          <a:prstGeom prst="rect">
-            <a:avLst/>
-          </a:prstGeom>
-          <a:noFill/>
-          <a:ln/>
-        </p:spPr>
-        <p:txBody>
-          <a:bodyPr wrap="square" lIns="0" tIns="0" rIns="0" bIns="0" rtlCol="0" anchor="ctr"/>
-          <a:lstStyle/>
-          <a:p>
-            <a:pPr algn="l" indent="0" marL="0">
-              <a:buNone/>
-            </a:pPr>
-            <a:r>
-              <a:rPr lang="en-US" sz="850" dirty="0">
-                <a:solidFill>
-                  <a:srgbClr val="CFE6FF"/>
-                </a:solidFill>
-                <a:latin typeface="Arial" pitchFamily="34" charset="0"/>
-                <a:ea typeface="Arial" pitchFamily="34" charset="-122"/>
-                <a:cs typeface="Arial" pitchFamily="34" charset="-120"/>
-              </a:rPr>
-              <a:t>Vít qua da · Ít xâm lấn (MIS)</a:t>
-            </a:r>
-            <a:endParaRPr lang="en-US" sz="850" dirty="0"/>
-          </a:p>
-        </p:txBody>
-      </p:sp>
-      <p:sp>
-        <p:nvSpPr>
-          <p:cNvPr id="55" name="Text 27"/>
-          <p:cNvSpPr txBox="1"/>
-          <p:nvPr/>
-        </p:nvSpPr>
-        <p:spPr>
-          <a:xfrm>
-            <a:off x="10559577" y="1803082"/>
-            <a:ext cx="1245447" cy="349885"/>
-          </a:xfrm>
-          <a:prstGeom prst="rect">
-            <a:avLst/>
-          </a:prstGeom>
-          <a:noFill/>
-          <a:ln/>
-        </p:spPr>
-        <p:txBody>
-          <a:bodyPr wrap="square" lIns="0" tIns="0" rIns="0" bIns="0" rtlCol="0" anchor="ctr"/>
-          <a:lstStyle/>
-          <a:p>
-            <a:pPr algn="ctr" indent="0" marL="0">
-              <a:buNone/>
-            </a:pPr>
-            <a:r>
-              <a:rPr lang="en-US" sz="950" b="1" spc="100" kern="0" dirty="0">
-                <a:solidFill>
-                  <a:srgbClr val="0A3170"/>
-                </a:solidFill>
-                <a:latin typeface="Arial" pitchFamily="34" charset="0"/>
-                <a:ea typeface="Arial" pitchFamily="34" charset="-122"/>
-                <a:cs typeface="Arial" pitchFamily="34" charset="-120"/>
-              </a:rPr>
-              <a:t>KẾT NỐI</a:t>
-            </a:r>
-            <a:endParaRPr lang="en-US" sz="950" dirty="0"/>
-          </a:p>
-          <a:p>
-            <a:pPr algn="ctr" indent="0" marL="0">
-              <a:buNone/>
-            </a:pPr>
-            <a:r>
-              <a:rPr lang="en-US" sz="950" b="1" spc="100" kern="0" dirty="0">
-                <a:solidFill>
-                  <a:srgbClr val="0A3170"/>
-                </a:solidFill>
-                <a:latin typeface="Arial" pitchFamily="34" charset="0"/>
-                <a:ea typeface="Arial" pitchFamily="34" charset="-122"/>
-                <a:cs typeface="Arial" pitchFamily="34" charset="-120"/>
-              </a:rPr>
-              <a:t>VỚI CHÚNG TÔI</a:t>
-            </a:r>
-            <a:endParaRPr lang="en-US" sz="950" dirty="0"/>
-          </a:p>
-        </p:txBody>
-      </p:sp>
-      <p:sp>
-        <p:nvSpPr>
-          <p:cNvPr id="56" name="Text 28"/>
-          <p:cNvSpPr txBox="1"/>
-          <p:nvPr/>
-        </p:nvSpPr>
-        <p:spPr>
-          <a:xfrm>
-            <a:off x="11071324" y="3147378"/>
-            <a:ext cx="253026" cy="147320"/>
-          </a:xfrm>
-          <a:prstGeom prst="rect">
-            <a:avLst/>
-          </a:prstGeom>
-          <a:noFill/>
-          <a:ln/>
-        </p:spPr>
-        <p:txBody>
-          <a:bodyPr wrap="square" lIns="0" tIns="0" rIns="0" bIns="0" rtlCol="0" anchor="ctr"/>
-          <a:lstStyle/>
-          <a:p>
-            <a:pPr algn="l" indent="0" marL="0">
-              <a:buNone/>
-            </a:pPr>
-            <a:r>
-              <a:rPr lang="en-US" sz="850" b="1" dirty="0">
-                <a:solidFill>
-                  <a:srgbClr val="0A3170"/>
-                </a:solidFill>
-                <a:latin typeface="Arial" pitchFamily="34" charset="0"/>
-                <a:ea typeface="Arial" pitchFamily="34" charset="-122"/>
-                <a:cs typeface="Arial" pitchFamily="34" charset="-120"/>
-              </a:rPr>
-              <a:t>Zalo</a:t>
-            </a:r>
-            <a:endParaRPr lang="en-US" sz="850" dirty="0"/>
-          </a:p>
-        </p:txBody>
-      </p:sp>
-      <p:sp>
-        <p:nvSpPr>
-          <p:cNvPr id="57" name="Text 29"/>
-          <p:cNvSpPr txBox="1"/>
-          <p:nvPr/>
-        </p:nvSpPr>
-        <p:spPr>
-          <a:xfrm>
-            <a:off x="11013380" y="4303078"/>
-            <a:ext cx="385251" cy="147320"/>
-          </a:xfrm>
-          <a:prstGeom prst="rect">
-            <a:avLst/>
-          </a:prstGeom>
-          <a:noFill/>
-          <a:ln/>
-        </p:spPr>
-        <p:txBody>
-          <a:bodyPr wrap="square" lIns="0" tIns="0" rIns="0" bIns="0" rtlCol="0" anchor="ctr"/>
-          <a:lstStyle/>
-          <a:p>
-            <a:pPr algn="l" indent="0" marL="0">
-              <a:buNone/>
-            </a:pPr>
-            <a:r>
-              <a:rPr lang="en-US" sz="850" b="1" dirty="0">
-                <a:solidFill>
-                  <a:srgbClr val="0A3170"/>
-                </a:solidFill>
-                <a:latin typeface="Arial" pitchFamily="34" charset="0"/>
-                <a:ea typeface="Arial" pitchFamily="34" charset="-122"/>
-                <a:cs typeface="Arial" pitchFamily="34" charset="-120"/>
-              </a:rPr>
-              <a:t>TikTok</a:t>
-            </a:r>
-            <a:endParaRPr lang="en-US" sz="850" dirty="0"/>
-          </a:p>
-        </p:txBody>
-      </p:sp>
-      <p:sp>
-        <p:nvSpPr>
-          <p:cNvPr id="58" name="Text 30"/>
-          <p:cNvSpPr txBox="1"/>
-          <p:nvPr/>
-        </p:nvSpPr>
-        <p:spPr>
-          <a:xfrm>
-            <a:off x="10924381" y="5458778"/>
-            <a:ext cx="588169" cy="147320"/>
-          </a:xfrm>
-          <a:prstGeom prst="rect">
-            <a:avLst/>
-          </a:prstGeom>
-          <a:noFill/>
-          <a:ln/>
-        </p:spPr>
-        <p:txBody>
-          <a:bodyPr wrap="square" lIns="0" tIns="0" rIns="0" bIns="0" rtlCol="0" anchor="ctr"/>
-          <a:lstStyle/>
-          <a:p>
-            <a:pPr algn="l" indent="0" marL="0">
-              <a:buNone/>
-            </a:pPr>
-            <a:r>
-              <a:rPr lang="en-US" sz="850" b="1" dirty="0">
-                <a:solidFill>
-                  <a:srgbClr val="0A3170"/>
-                </a:solidFill>
-                <a:latin typeface="Arial" pitchFamily="34" charset="0"/>
-                <a:ea typeface="Arial" pitchFamily="34" charset="-122"/>
-                <a:cs typeface="Arial" pitchFamily="34" charset="-120"/>
-              </a:rPr>
-              <a:t>Instagram</a:t>
-            </a:r>
-            <a:endParaRPr lang="en-US" sz="850" dirty="0"/>
-          </a:p>
-        </p:txBody>
-      </p:sp>
-      <p:sp>
-        <p:nvSpPr>
-          <p:cNvPr id="59" name="Text 31"/>
-          <p:cNvSpPr txBox="1"/>
-          <p:nvPr/>
-        </p:nvSpPr>
-        <p:spPr>
-          <a:xfrm>
-            <a:off x="10552557" y="5791010"/>
-            <a:ext cx="1259586" cy="117856"/>
-          </a:xfrm>
-          <a:prstGeom prst="rect">
-            <a:avLst/>
-          </a:prstGeom>
-          <a:noFill/>
-          <a:ln/>
-        </p:spPr>
-        <p:txBody>
-          <a:bodyPr wrap="square" lIns="0" tIns="0" rIns="0" bIns="0" rtlCol="0" anchor="ctr"/>
-          <a:lstStyle/>
-          <a:p>
-            <a:pPr algn="ctr" indent="0" marL="0">
-              <a:buNone/>
-            </a:pPr>
-            <a:r>
-              <a:rPr lang="en-US" sz="700" b="1" spc="150" kern="0" dirty="0">
-                <a:solidFill>
-                  <a:srgbClr val="5B6B8E"/>
-                </a:solidFill>
-                <a:latin typeface="Arial" pitchFamily="34" charset="0"/>
-                <a:ea typeface="Arial" pitchFamily="34" charset="-122"/>
-                <a:cs typeface="Arial" pitchFamily="34" charset="-120"/>
-              </a:rPr>
-              <a:t>HOTLINE</a:t>
-            </a:r>
-            <a:endParaRPr lang="en-US" sz="700" dirty="0"/>
-          </a:p>
-        </p:txBody>
-      </p:sp>
-      <p:sp>
-        <p:nvSpPr>
-          <p:cNvPr id="60" name="Text 32"/>
-          <p:cNvSpPr txBox="1"/>
-          <p:nvPr/>
-        </p:nvSpPr>
-        <p:spPr>
-          <a:xfrm>
-            <a:off x="10552557" y="5886005"/>
-            <a:ext cx="1259586" cy="213614"/>
-          </a:xfrm>
-          <a:prstGeom prst="rect">
-            <a:avLst/>
-          </a:prstGeom>
-          <a:noFill/>
-          <a:ln/>
-        </p:spPr>
-        <p:txBody>
-          <a:bodyPr wrap="square" lIns="0" tIns="0" rIns="0" bIns="0" rtlCol="0" anchor="ctr"/>
-          <a:lstStyle/>
-          <a:p>
-            <a:pPr algn="ctr" indent="0" marL="0">
-              <a:buNone/>
-            </a:pPr>
-            <a:r>
-              <a:rPr lang="en-US" sz="1250" b="1" dirty="0">
-                <a:solidFill>
-                  <a:srgbClr val="0A3170"/>
-                </a:solidFill>
-                <a:latin typeface="Arial" pitchFamily="34" charset="0"/>
-                <a:ea typeface="Arial" pitchFamily="34" charset="-122"/>
-                <a:cs typeface="Arial" pitchFamily="34" charset="-120"/>
-              </a:rPr>
-              <a:t>0916 899 322</a:t>
-            </a:r>
-            <a:endParaRPr lang="en-US" sz="1250" dirty="0"/>
           </a:p>
         </p:txBody>
       </p:sp>

</xml_diff>

<commit_message>
Backdrop VOA: new tagline, split CUVIS and Mantiz sections, robot-only headline
Co-Authored-By: Claude Opus 5.5 <noreply@anthropic.com>
Claude-Session: https://claude.ai/code/session_013QJi2k1EkL4AWCx1Ymi9NU
</commit_message>
<xml_diff>
--- a/backdrop-voa/backdrop-VOA.pptx
+++ b/backdrop-voa/backdrop-VOA.pptx
@@ -1258,8 +1258,8 @@
         </p:blipFill>
         <p:spPr>
           <a:xfrm>
-            <a:off x="9779397" y="1593850"/>
-            <a:ext cx="1085850" cy="266700"/>
+            <a:off x="10045105" y="1619255"/>
+            <a:ext cx="878979" cy="215890"/>
           </a:xfrm>
           <a:prstGeom prst="rect">
             <a:avLst/>
@@ -1282,8 +1282,8 @@
         </p:blipFill>
         <p:spPr>
           <a:xfrm>
-            <a:off x="10954147" y="1574807"/>
-            <a:ext cx="283369" cy="304786"/>
+            <a:off x="10987584" y="1600206"/>
+            <a:ext cx="236141" cy="253988"/>
           </a:xfrm>
           <a:prstGeom prst="rect">
             <a:avLst/>
@@ -1306,8 +1306,8 @@
         </p:blipFill>
         <p:spPr>
           <a:xfrm>
-            <a:off x="11288316" y="1574826"/>
-            <a:ext cx="370185" cy="304748"/>
+            <a:off x="11274524" y="1600228"/>
+            <a:ext cx="308471" cy="253943"/>
           </a:xfrm>
           <a:prstGeom prst="rect">
             <a:avLst/>
@@ -1330,7 +1330,7 @@
         </p:blipFill>
         <p:spPr>
           <a:xfrm>
-            <a:off x="5473700" y="2451108"/>
+            <a:off x="5473700" y="2362208"/>
             <a:ext cx="1168797" cy="266683"/>
           </a:xfrm>
           <a:prstGeom prst="rect">
@@ -1354,8 +1354,8 @@
         </p:blipFill>
         <p:spPr>
           <a:xfrm>
-            <a:off x="6324600" y="2800389"/>
-            <a:ext cx="3789859" cy="3460673"/>
+            <a:off x="6324600" y="2736891"/>
+            <a:ext cx="3476923" cy="3174918"/>
           </a:xfrm>
           <a:prstGeom prst="rect">
             <a:avLst/>
@@ -1378,8 +1378,8 @@
         </p:blipFill>
         <p:spPr>
           <a:xfrm>
-            <a:off x="9860075" y="3737868"/>
-            <a:ext cx="236411" cy="176014"/>
+            <a:off x="10012290" y="3717925"/>
+            <a:ext cx="223884" cy="166687"/>
           </a:xfrm>
           <a:prstGeom prst="rect">
             <a:avLst/>
@@ -1402,8 +1402,8 @@
         </p:blipFill>
         <p:spPr>
           <a:xfrm>
-            <a:off x="10109245" y="3734891"/>
-            <a:ext cx="236348" cy="181967"/>
+            <a:off x="10248944" y="3715048"/>
+            <a:ext cx="223848" cy="172343"/>
           </a:xfrm>
           <a:prstGeom prst="rect">
             <a:avLst/>
@@ -1426,8 +1426,8 @@
         </p:blipFill>
         <p:spPr>
           <a:xfrm>
-            <a:off x="9860097" y="4230985"/>
-            <a:ext cx="236369" cy="205780"/>
+            <a:off x="10012316" y="4186436"/>
+            <a:ext cx="223832" cy="194866"/>
           </a:xfrm>
           <a:prstGeom prst="rect">
             <a:avLst/>
@@ -1450,8 +1450,8 @@
         </p:blipFill>
         <p:spPr>
           <a:xfrm>
-            <a:off x="10109223" y="4234458"/>
-            <a:ext cx="236392" cy="198834"/>
+            <a:off x="10248924" y="4189710"/>
+            <a:ext cx="223888" cy="188317"/>
           </a:xfrm>
           <a:prstGeom prst="rect">
             <a:avLst/>
@@ -1474,8 +1474,8 @@
         </p:blipFill>
         <p:spPr>
           <a:xfrm>
-            <a:off x="9934588" y="4759325"/>
-            <a:ext cx="323724" cy="355501"/>
+            <a:off x="10098603" y="4696619"/>
+            <a:ext cx="300595" cy="330101"/>
           </a:xfrm>
           <a:prstGeom prst="rect">
             <a:avLst/>
@@ -1498,8 +1498,8 @@
         </p:blipFill>
         <p:spPr>
           <a:xfrm>
-            <a:off x="9855248" y="5306318"/>
-            <a:ext cx="482503" cy="353715"/>
+            <a:off x="10023705" y="5217319"/>
+            <a:ext cx="450291" cy="330101"/>
           </a:xfrm>
           <a:prstGeom prst="rect">
             <a:avLst/>
@@ -1514,7 +1514,7 @@
         </p:nvSpPr>
         <p:spPr>
           <a:xfrm>
-            <a:off x="1473200" y="378143"/>
+            <a:off x="1473200" y="355918"/>
             <a:ext cx="7491799" cy="386715"/>
           </a:xfrm>
           <a:prstGeom prst="rect">
@@ -1567,8 +1567,8 @@
         </p:nvSpPr>
         <p:spPr>
           <a:xfrm>
-            <a:off x="1473200" y="798132"/>
-            <a:ext cx="7491799" cy="235712"/>
+            <a:off x="1473200" y="772350"/>
+            <a:ext cx="7491799" cy="287274"/>
           </a:xfrm>
           <a:prstGeom prst="rect">
             <a:avLst/>
@@ -1584,7 +1584,7 @@
               <a:buNone/>
             </a:pPr>
             <a:r>
-              <a:rPr lang="en-US" sz="1400" b="1" dirty="0">
+              <a:rPr lang="en-US" sz="1700" b="1" i="1" spc="25" kern="0" dirty="0">
                 <a:solidFill>
                   <a:srgbClr val="CFE6FF"/>
                 </a:solidFill>
@@ -1592,9 +1592,9 @@
                 <a:ea typeface="Arial" pitchFamily="34" charset="-122"/>
                 <a:cs typeface="Arial" pitchFamily="34" charset="-120"/>
               </a:rPr>
-              <a:t>Công nghệ tiên tiến trong Phẫu thuật Cột sống &amp; Chấn thương Chỉnh hình</a:t>
-            </a:r>
-            <a:endParaRPr lang="en-US" sz="1400" dirty="0"/>
+              <a:t>Kết nối công nghệ, Kiến tạo giá trị</a:t>
+            </a:r>
+            <a:endParaRPr lang="en-US" sz="1700" dirty="0"/>
           </a:p>
         </p:txBody>
       </p:sp>
@@ -2236,8 +2236,8 @@
         </p:nvSpPr>
         <p:spPr>
           <a:xfrm>
-            <a:off x="4930267" y="2130552"/>
-            <a:ext cx="7195566" cy="228346"/>
+            <a:off x="5070729" y="2132584"/>
+            <a:ext cx="4908042" cy="198882"/>
           </a:xfrm>
           <a:prstGeom prst="rect">
             <a:avLst/>
@@ -2253,7 +2253,7 @@
               <a:buNone/>
             </a:pPr>
             <a:r>
-              <a:rPr lang="en-US" sz="1350" b="1" spc="50" kern="0" dirty="0">
+              <a:rPr lang="en-US" sz="1150" b="1" spc="25" kern="0" dirty="0">
                 <a:solidFill>
                   <a:srgbClr val="FFFFFF"/>
                 </a:solidFill>
@@ -2267,7 +2267,7 @@
               <a:buNone/>
             </a:pPr>
             <a:r>
-              <a:rPr lang="en-US" sz="1350" b="1" spc="50" kern="0" dirty="0">
+              <a:rPr lang="en-US" sz="1150" b="1" spc="25" kern="0" dirty="0">
                 <a:solidFill>
                   <a:srgbClr val="8ED14F"/>
                 </a:solidFill>
@@ -2277,7 +2277,7 @@
               </a:rPr>
               <a:t>PHẪU THUẬT CỘT SỐNG</a:t>
             </a:r>
-            <a:endParaRPr lang="en-US" sz="1350" dirty="0"/>
+            <a:endParaRPr lang="en-US" sz="1150" dirty="0"/>
           </a:p>
         </p:txBody>
       </p:sp>
@@ -2289,7 +2289,7 @@
         </p:nvSpPr>
         <p:spPr>
           <a:xfrm>
-            <a:off x="7029450" y="2457196"/>
+            <a:off x="7029450" y="2368296"/>
             <a:ext cx="241300" cy="279908"/>
           </a:xfrm>
           <a:prstGeom prst="rect">
@@ -2328,7 +2328,7 @@
         </p:nvSpPr>
         <p:spPr>
           <a:xfrm>
-            <a:off x="7334250" y="2513140"/>
+            <a:off x="7334250" y="2424240"/>
             <a:ext cx="1458206" cy="167922"/>
           </a:xfrm>
           <a:prstGeom prst="rect">
@@ -2367,7 +2367,7 @@
         </p:nvSpPr>
         <p:spPr>
           <a:xfrm>
-            <a:off x="8202414" y="2939796"/>
+            <a:off x="8227814" y="2850896"/>
             <a:ext cx="241300" cy="279908"/>
           </a:xfrm>
           <a:prstGeom prst="rect">
@@ -2406,7 +2406,7 @@
         </p:nvSpPr>
         <p:spPr>
           <a:xfrm>
-            <a:off x="8507214" y="2995740"/>
+            <a:off x="8532614" y="2906840"/>
             <a:ext cx="1131320" cy="167922"/>
           </a:xfrm>
           <a:prstGeom prst="rect">
@@ -2445,7 +2445,7 @@
         </p:nvSpPr>
         <p:spPr>
           <a:xfrm>
-            <a:off x="5441950" y="4712637"/>
+            <a:off x="5441950" y="4623737"/>
             <a:ext cx="241300" cy="279908"/>
           </a:xfrm>
           <a:prstGeom prst="rect">
@@ -2484,7 +2484,7 @@
         </p:nvSpPr>
         <p:spPr>
           <a:xfrm>
-            <a:off x="5746750" y="4600758"/>
+            <a:off x="5746750" y="4511858"/>
             <a:ext cx="710892" cy="503765"/>
           </a:xfrm>
           <a:prstGeom prst="rect">
@@ -2557,7 +2557,7 @@
         </p:nvSpPr>
         <p:spPr>
           <a:xfrm>
-            <a:off x="9823450" y="3241675"/>
+            <a:off x="9975850" y="3107531"/>
             <a:ext cx="1200249" cy="184150"/>
           </a:xfrm>
           <a:prstGeom prst="rect">
@@ -2596,8 +2596,8 @@
         </p:nvSpPr>
         <p:spPr>
           <a:xfrm>
-            <a:off x="9823450" y="3442589"/>
-            <a:ext cx="2026920" cy="125222"/>
+            <a:off x="9975850" y="3298666"/>
+            <a:ext cx="1911096" cy="267017"/>
           </a:xfrm>
           <a:prstGeom prst="rect">
             <a:avLst/>
@@ -2613,7 +2613,7 @@
               <a:buNone/>
             </a:pPr>
             <a:r>
-              <a:rPr lang="en-US" sz="750" b="1" dirty="0">
+              <a:rPr lang="en-US" sz="725" b="1" dirty="0">
                 <a:solidFill>
                   <a:srgbClr val="FFFFFF"/>
                 </a:solidFill>
@@ -2621,9 +2621,26 @@
                 <a:ea typeface="Arial" pitchFamily="34" charset="-122"/>
                 <a:cs typeface="Arial" pitchFamily="34" charset="-120"/>
               </a:rPr>
-              <a:t>Cấu trúc xốp tối ưu hóa tích hợp xương</a:t>
-            </a:r>
-            <a:endParaRPr lang="en-US" sz="750" dirty="0"/>
+              <a:t>Cấu trúc xốp tối ưu hóa</a:t>
+            </a:r>
+            <a:endParaRPr lang="en-US" sz="725" dirty="0"/>
+          </a:p>
+          <a:p>
+            <a:pPr algn="l" indent="0" marL="0">
+              <a:buNone/>
+            </a:pPr>
+            <a:r>
+              <a:rPr lang="en-US" sz="725" b="1" dirty="0">
+                <a:solidFill>
+                  <a:srgbClr val="FFFFFF"/>
+                </a:solidFill>
+                <a:latin typeface="Arial" pitchFamily="34" charset="0"/>
+                <a:ea typeface="Arial" pitchFamily="34" charset="-122"/>
+                <a:cs typeface="Arial" pitchFamily="34" charset="-120"/>
+              </a:rPr>
+              <a:t>tích hợp xương</a:t>
+            </a:r>
+            <a:endParaRPr lang="en-US" sz="725" dirty="0"/>
           </a:p>
         </p:txBody>
       </p:sp>
@@ -2635,8 +2652,8 @@
         </p:nvSpPr>
         <p:spPr>
           <a:xfrm>
-            <a:off x="10458450" y="3684524"/>
-            <a:ext cx="1061871" cy="162052"/>
+            <a:off x="10585450" y="3666776"/>
+            <a:ext cx="1026468" cy="154686"/>
           </a:xfrm>
           <a:prstGeom prst="rect">
             <a:avLst/>
@@ -2652,7 +2669,7 @@
               <a:buNone/>
             </a:pPr>
             <a:r>
-              <a:rPr lang="en-US" sz="950" b="1" spc="15" kern="0" dirty="0">
+              <a:rPr lang="en-US" sz="900" b="1" spc="15" kern="0" dirty="0">
                 <a:solidFill>
                   <a:srgbClr val="FFFFFF"/>
                 </a:solidFill>
@@ -2662,7 +2679,7 @@
               </a:rPr>
               <a:t>PANTHER</a:t>
             </a:r>
-            <a:endParaRPr lang="en-US" sz="950" dirty="0"/>
+            <a:endParaRPr lang="en-US" sz="900" dirty="0"/>
           </a:p>
         </p:txBody>
       </p:sp>
@@ -2674,8 +2691,8 @@
         </p:nvSpPr>
         <p:spPr>
           <a:xfrm>
-            <a:off x="10458450" y="3839464"/>
-            <a:ext cx="1061871" cy="125222"/>
+            <a:off x="10585450" y="3815366"/>
+            <a:ext cx="1026468" cy="117856"/>
           </a:xfrm>
           <a:prstGeom prst="rect">
             <a:avLst/>
@@ -2691,7 +2708,7 @@
               <a:buNone/>
             </a:pPr>
             <a:r>
-              <a:rPr lang="en-US" sz="750" dirty="0">
+              <a:rPr lang="en-US" sz="725" dirty="0">
                 <a:solidFill>
                   <a:srgbClr val="CFE6FF"/>
                 </a:solidFill>
@@ -2701,7 +2718,7 @@
               </a:rPr>
               <a:t>Lồng thắt lưng in 3D</a:t>
             </a:r>
-            <a:endParaRPr lang="en-US" sz="750" dirty="0"/>
+            <a:endParaRPr lang="en-US" sz="725" dirty="0"/>
           </a:p>
         </p:txBody>
       </p:sp>
@@ -2713,8 +2730,8 @@
         </p:nvSpPr>
         <p:spPr>
           <a:xfrm>
-            <a:off x="10458450" y="4192524"/>
-            <a:ext cx="717905" cy="162052"/>
+            <a:off x="10585450" y="4149376"/>
+            <a:ext cx="693926" cy="154686"/>
           </a:xfrm>
           <a:prstGeom prst="rect">
             <a:avLst/>
@@ -2730,7 +2747,7 @@
               <a:buNone/>
             </a:pPr>
             <a:r>
-              <a:rPr lang="en-US" sz="950" b="1" spc="15" kern="0" dirty="0">
+              <a:rPr lang="en-US" sz="900" b="1" spc="15" kern="0" dirty="0">
                 <a:solidFill>
                   <a:srgbClr val="FFFFFF"/>
                 </a:solidFill>
@@ -2740,7 +2757,7 @@
               </a:rPr>
               <a:t>PETRA</a:t>
             </a:r>
-            <a:endParaRPr lang="en-US" sz="950" dirty="0"/>
+            <a:endParaRPr lang="en-US" sz="900" dirty="0"/>
           </a:p>
         </p:txBody>
       </p:sp>
@@ -2752,8 +2769,8 @@
         </p:nvSpPr>
         <p:spPr>
           <a:xfrm>
-            <a:off x="10458450" y="4347464"/>
-            <a:ext cx="717905" cy="125222"/>
+            <a:off x="10585450" y="4297966"/>
+            <a:ext cx="693926" cy="117856"/>
           </a:xfrm>
           <a:prstGeom prst="rect">
             <a:avLst/>
@@ -2769,7 +2786,7 @@
               <a:buNone/>
             </a:pPr>
             <a:r>
-              <a:rPr lang="en-US" sz="750" dirty="0">
+              <a:rPr lang="en-US" sz="725" dirty="0">
                 <a:solidFill>
                   <a:srgbClr val="CFE6FF"/>
                 </a:solidFill>
@@ -2779,7 +2796,7 @@
               </a:rPr>
               <a:t>Lồng cổ in 3D</a:t>
             </a:r>
-            <a:endParaRPr lang="en-US" sz="750" dirty="0"/>
+            <a:endParaRPr lang="en-US" sz="725" dirty="0"/>
           </a:p>
         </p:txBody>
       </p:sp>
@@ -2791,8 +2808,8 @@
         </p:nvSpPr>
         <p:spPr>
           <a:xfrm>
-            <a:off x="10452100" y="4795774"/>
-            <a:ext cx="784187" cy="162052"/>
+            <a:off x="10591800" y="4727226"/>
+            <a:ext cx="758059" cy="154686"/>
           </a:xfrm>
           <a:prstGeom prst="rect">
             <a:avLst/>
@@ -2808,7 +2825,7 @@
               <a:buNone/>
             </a:pPr>
             <a:r>
-              <a:rPr lang="en-US" sz="950" b="1" spc="15" kern="0" dirty="0">
+              <a:rPr lang="en-US" sz="900" b="1" spc="15" kern="0" dirty="0">
                 <a:solidFill>
                   <a:srgbClr val="FFFFFF"/>
                 </a:solidFill>
@@ -2818,7 +2835,7 @@
               </a:rPr>
               <a:t>QUATTRO</a:t>
             </a:r>
-            <a:endParaRPr lang="en-US" sz="950" dirty="0"/>
+            <a:endParaRPr lang="en-US" sz="900" dirty="0"/>
           </a:p>
         </p:txBody>
       </p:sp>
@@ -2830,8 +2847,8 @@
         </p:nvSpPr>
         <p:spPr>
           <a:xfrm>
-            <a:off x="10452100" y="4950714"/>
-            <a:ext cx="784187" cy="125222"/>
+            <a:off x="10591800" y="4875816"/>
+            <a:ext cx="758059" cy="117856"/>
           </a:xfrm>
           <a:prstGeom prst="rect">
             <a:avLst/>
@@ -2847,7 +2864,7 @@
               <a:buNone/>
             </a:pPr>
             <a:r>
-              <a:rPr lang="en-US" sz="750" dirty="0">
+              <a:rPr lang="en-US" sz="725" dirty="0">
                 <a:solidFill>
                   <a:srgbClr val="CFE6FF"/>
                 </a:solidFill>
@@ -2857,7 +2874,7 @@
               </a:rPr>
               <a:t>Vít cuống sống</a:t>
             </a:r>
-            <a:endParaRPr lang="en-US" sz="750" dirty="0"/>
+            <a:endParaRPr lang="en-US" sz="725" dirty="0"/>
           </a:p>
         </p:txBody>
       </p:sp>
@@ -2869,8 +2886,8 @@
         </p:nvSpPr>
         <p:spPr>
           <a:xfrm>
-            <a:off x="10452100" y="5329174"/>
-            <a:ext cx="1424047" cy="162052"/>
+            <a:off x="10591800" y="5178076"/>
+            <a:ext cx="1258568" cy="154686"/>
           </a:xfrm>
           <a:prstGeom prst="rect">
             <a:avLst/>
@@ -2886,7 +2903,7 @@
               <a:buNone/>
             </a:pPr>
             <a:r>
-              <a:rPr lang="en-US" sz="950" b="1" spc="15" kern="0" dirty="0">
+              <a:rPr lang="en-US" sz="900" b="1" spc="15" kern="0" dirty="0">
                 <a:solidFill>
                   <a:srgbClr val="FFFFFF"/>
                 </a:solidFill>
@@ -2896,7 +2913,7 @@
               </a:rPr>
               <a:t>QUATTRO GADGET</a:t>
             </a:r>
-            <a:endParaRPr lang="en-US" sz="950" dirty="0"/>
+            <a:endParaRPr lang="en-US" sz="900" dirty="0"/>
           </a:p>
         </p:txBody>
       </p:sp>
@@ -2908,8 +2925,8 @@
         </p:nvSpPr>
         <p:spPr>
           <a:xfrm>
-            <a:off x="10452100" y="5496814"/>
-            <a:ext cx="1049994" cy="125222"/>
+            <a:off x="10591800" y="5326666"/>
+            <a:ext cx="1258568" cy="117856"/>
           </a:xfrm>
           <a:prstGeom prst="rect">
             <a:avLst/>
@@ -2925,7 +2942,7 @@
               <a:buNone/>
             </a:pPr>
             <a:r>
-              <a:rPr lang="en-US" sz="750" dirty="0">
+              <a:rPr lang="en-US" sz="725" dirty="0">
                 <a:solidFill>
                   <a:srgbClr val="CFE6FF"/>
                 </a:solidFill>
@@ -2933,9 +2950,9 @@
                 <a:ea typeface="Arial" pitchFamily="34" charset="-122"/>
                 <a:cs typeface="Arial" pitchFamily="34" charset="-120"/>
               </a:rPr>
-              <a:t>Vít qua da ít xâm lấn</a:t>
-            </a:r>
-            <a:endParaRPr lang="en-US" sz="750" dirty="0"/>
+              <a:t>Vít qua da</a:t>
+            </a:r>
+            <a:endParaRPr lang="en-US" sz="725" dirty="0"/>
           </a:p>
         </p:txBody>
       </p:sp>
@@ -2947,8 +2964,47 @@
         </p:nvSpPr>
         <p:spPr>
           <a:xfrm>
-            <a:off x="11411248" y="5482082"/>
-            <a:ext cx="290016" cy="154686"/>
+            <a:off x="10591800" y="5453666"/>
+            <a:ext cx="484221" cy="117856"/>
+          </a:xfrm>
+          <a:prstGeom prst="rect">
+            <a:avLst/>
+          </a:prstGeom>
+          <a:noFill/>
+          <a:ln/>
+        </p:spPr>
+        <p:txBody>
+          <a:bodyPr wrap="square" lIns="0" tIns="0" rIns="0" bIns="0" rtlCol="0" anchor="ctr"/>
+          <a:lstStyle/>
+          <a:p>
+            <a:pPr algn="l" indent="0" marL="0">
+              <a:buNone/>
+            </a:pPr>
+            <a:r>
+              <a:rPr lang="en-US" sz="725" dirty="0">
+                <a:solidFill>
+                  <a:srgbClr val="CFE6FF"/>
+                </a:solidFill>
+                <a:latin typeface="Arial" pitchFamily="34" charset="0"/>
+                <a:ea typeface="Arial" pitchFamily="34" charset="-122"/>
+                <a:cs typeface="Arial" pitchFamily="34" charset="-120"/>
+              </a:rPr>
+              <a:t>Ít xâm lấn</a:t>
+            </a:r>
+            <a:endParaRPr lang="en-US" sz="725" dirty="0"/>
+          </a:p>
+        </p:txBody>
+      </p:sp>
+      <p:sp>
+        <p:nvSpPr>
+          <p:cNvPr id="63" name="Text 35"/>
+          <p:cNvSpPr txBox="1"/>
+          <p:nvPr/>
+        </p:nvSpPr>
+        <p:spPr>
+          <a:xfrm>
+            <a:off x="11054655" y="5438934"/>
+            <a:ext cx="284361" cy="147320"/>
           </a:xfrm>
           <a:prstGeom prst="rect">
             <a:avLst/>
@@ -2964,7 +3020,7 @@
               <a:buNone/>
             </a:pPr>
             <a:r>
-              <a:rPr lang="en-US" sz="750" spc="50" kern="0" dirty="0">
+              <a:rPr lang="en-US" sz="725" spc="50" kern="0" dirty="0">
                 <a:solidFill>
                   <a:srgbClr val="CFE6FF"/>
                 </a:solidFill>
@@ -2974,7 +3030,7 @@
               </a:rPr>
               <a:t>MIS</a:t>
             </a:r>
-            <a:endParaRPr lang="en-US" sz="750" dirty="0"/>
+            <a:endParaRPr lang="en-US" sz="725" dirty="0"/>
           </a:p>
         </p:txBody>
       </p:sp>

</xml_diff>

<commit_message>
Backdrop VOA: Mantiz as 2x2 product blocks with image above caption
Co-Authored-By: Claude Opus 5.5 <noreply@anthropic.com>
Claude-Session: https://claude.ai/code/session_013QJi2k1EkL4AWCx1Ymi9NU
</commit_message>
<xml_diff>
--- a/backdrop-voa/backdrop-VOA.pptx
+++ b/backdrop-voa/backdrop-VOA.pptx
@@ -1378,8 +1378,8 @@
         </p:blipFill>
         <p:spPr>
           <a:xfrm>
-            <a:off x="10012290" y="3717925"/>
-            <a:ext cx="223884" cy="166687"/>
+            <a:off x="10024227" y="3216176"/>
+            <a:ext cx="342090" cy="254695"/>
           </a:xfrm>
           <a:prstGeom prst="rect">
             <a:avLst/>
@@ -1402,8 +1402,8 @@
         </p:blipFill>
         <p:spPr>
           <a:xfrm>
-            <a:off x="10248944" y="3715048"/>
-            <a:ext cx="223848" cy="172343"/>
+            <a:off x="10385452" y="3211810"/>
+            <a:ext cx="342151" cy="263426"/>
           </a:xfrm>
           <a:prstGeom prst="rect">
             <a:avLst/>
@@ -1426,8 +1426,8 @@
         </p:blipFill>
         <p:spPr>
           <a:xfrm>
-            <a:off x="10012316" y="4186436"/>
-            <a:ext cx="223832" cy="194866"/>
+            <a:off x="10900507" y="3194645"/>
+            <a:ext cx="342130" cy="297855"/>
           </a:xfrm>
           <a:prstGeom prst="rect">
             <a:avLst/>
@@ -1450,8 +1450,8 @@
         </p:blipFill>
         <p:spPr>
           <a:xfrm>
-            <a:off x="10248924" y="4189710"/>
-            <a:ext cx="223888" cy="188317"/>
+            <a:off x="11261727" y="3199606"/>
+            <a:ext cx="342202" cy="287834"/>
           </a:xfrm>
           <a:prstGeom prst="rect">
             <a:avLst/>
@@ -1474,8 +1474,8 @@
         </p:blipFill>
         <p:spPr>
           <a:xfrm>
-            <a:off x="10098603" y="4696619"/>
-            <a:ext cx="300595" cy="330101"/>
+            <a:off x="10017156" y="4686102"/>
+            <a:ext cx="647539" cy="711101"/>
           </a:xfrm>
           <a:prstGeom prst="rect">
             <a:avLst/>
@@ -1498,8 +1498,8 @@
         </p:blipFill>
         <p:spPr>
           <a:xfrm>
-            <a:off x="10023705" y="5217319"/>
-            <a:ext cx="450291" cy="330101"/>
+            <a:off x="10960133" y="4801989"/>
+            <a:ext cx="653985" cy="479425"/>
           </a:xfrm>
           <a:prstGeom prst="rect">
             <a:avLst/>
@@ -2557,7 +2557,7 @@
         </p:nvSpPr>
         <p:spPr>
           <a:xfrm>
-            <a:off x="9975850" y="3107531"/>
+            <a:off x="10213876" y="2413298"/>
             <a:ext cx="1200249" cy="184150"/>
           </a:xfrm>
           <a:prstGeom prst="rect">
@@ -2596,24 +2596,24 @@
         </p:nvSpPr>
         <p:spPr>
           <a:xfrm>
-            <a:off x="9975850" y="3298666"/>
-            <a:ext cx="1911096" cy="267017"/>
-          </a:xfrm>
-          <a:prstGeom prst="rect">
-            <a:avLst/>
-          </a:prstGeom>
-          <a:noFill/>
-          <a:ln/>
-        </p:spPr>
-        <p:txBody>
-          <a:bodyPr wrap="square" lIns="0" tIns="0" rIns="0" bIns="0" rtlCol="0" anchor="ctr"/>
-          <a:lstStyle/>
-          <a:p>
-            <a:pPr algn="l" indent="0" marL="0">
-              <a:buNone/>
-            </a:pPr>
-            <a:r>
-              <a:rPr lang="en-US" sz="725" b="1" dirty="0">
+            <a:off x="9858502" y="2616498"/>
+            <a:ext cx="1911096" cy="276225"/>
+          </a:xfrm>
+          <a:prstGeom prst="rect">
+            <a:avLst/>
+          </a:prstGeom>
+          <a:noFill/>
+          <a:ln/>
+        </p:spPr>
+        <p:txBody>
+          <a:bodyPr wrap="square" lIns="0" tIns="0" rIns="0" bIns="0" rtlCol="0" anchor="ctr"/>
+          <a:lstStyle/>
+          <a:p>
+            <a:pPr algn="ctr" indent="0" marL="0">
+              <a:buNone/>
+            </a:pPr>
+            <a:r>
+              <a:rPr lang="en-US" sz="750" b="1" dirty="0">
                 <a:solidFill>
                   <a:srgbClr val="FFFFFF"/>
                 </a:solidFill>
@@ -2623,14 +2623,148 @@
               </a:rPr>
               <a:t>Cấu trúc xốp tối ưu hóa</a:t>
             </a:r>
+            <a:endParaRPr lang="en-US" sz="750" dirty="0"/>
+          </a:p>
+          <a:p>
+            <a:pPr algn="ctr" indent="0" marL="0">
+              <a:buNone/>
+            </a:pPr>
+            <a:r>
+              <a:rPr lang="en-US" sz="750" b="1" dirty="0">
+                <a:solidFill>
+                  <a:srgbClr val="FFFFFF"/>
+                </a:solidFill>
+                <a:latin typeface="Arial" pitchFamily="34" charset="0"/>
+                <a:ea typeface="Arial" pitchFamily="34" charset="-122"/>
+                <a:cs typeface="Arial" pitchFamily="34" charset="-120"/>
+              </a:rPr>
+              <a:t>tích hợp xương</a:t>
+            </a:r>
+            <a:endParaRPr lang="en-US" sz="750" dirty="0"/>
+          </a:p>
+        </p:txBody>
+      </p:sp>
+      <p:sp>
+        <p:nvSpPr>
+          <p:cNvPr id="54" name="Text 26"/>
+          <p:cNvSpPr txBox="1"/>
+          <p:nvPr/>
+        </p:nvSpPr>
+        <p:spPr>
+          <a:xfrm>
+            <a:off x="10053093" y="3796613"/>
+            <a:ext cx="645515" cy="152384"/>
+          </a:xfrm>
+          <a:prstGeom prst="rect">
+            <a:avLst/>
+          </a:prstGeom>
+          <a:noFill/>
+          <a:ln/>
+        </p:spPr>
+        <p:txBody>
+          <a:bodyPr wrap="square" lIns="0" tIns="0" rIns="0" bIns="0" rtlCol="0" anchor="ctr"/>
+          <a:lstStyle/>
+          <a:p>
+            <a:pPr algn="ctr" indent="0" marL="0">
+              <a:buNone/>
+            </a:pPr>
+            <a:r>
+              <a:rPr lang="en-US" sz="900" b="1" spc="25" kern="0" dirty="0">
+                <a:solidFill>
+                  <a:srgbClr val="FFFFFF"/>
+                </a:solidFill>
+                <a:latin typeface="Arial" pitchFamily="34" charset="0"/>
+                <a:ea typeface="Arial" pitchFamily="34" charset="-122"/>
+                <a:cs typeface="Arial" pitchFamily="34" charset="-120"/>
+              </a:rPr>
+              <a:t>PANTHER</a:t>
+            </a:r>
+            <a:endParaRPr lang="en-US" sz="900" dirty="0"/>
+          </a:p>
+        </p:txBody>
+      </p:sp>
+      <p:sp>
+        <p:nvSpPr>
+          <p:cNvPr id="55" name="Text 27"/>
+          <p:cNvSpPr txBox="1"/>
+          <p:nvPr/>
+        </p:nvSpPr>
+        <p:spPr>
+          <a:xfrm>
+            <a:off x="10005580" y="3951093"/>
+            <a:ext cx="740640" cy="277606"/>
+          </a:xfrm>
+          <a:prstGeom prst="rect">
+            <a:avLst/>
+          </a:prstGeom>
+          <a:noFill/>
+          <a:ln/>
+        </p:spPr>
+        <p:txBody>
+          <a:bodyPr wrap="square" lIns="0" tIns="0" rIns="0" bIns="0" rtlCol="0" anchor="ctr"/>
+          <a:lstStyle/>
+          <a:p>
+            <a:pPr algn="ctr" indent="0" marL="0">
+              <a:buNone/>
+            </a:pPr>
+            <a:r>
+              <a:rPr lang="en-US" sz="725" dirty="0">
+                <a:solidFill>
+                  <a:srgbClr val="CFE6FF"/>
+                </a:solidFill>
+                <a:latin typeface="Arial" pitchFamily="34" charset="0"/>
+                <a:ea typeface="Arial" pitchFamily="34" charset="-122"/>
+                <a:cs typeface="Arial" pitchFamily="34" charset="-120"/>
+              </a:rPr>
+              <a:t>Lồng thắt lưng</a:t>
+            </a:r>
             <a:endParaRPr lang="en-US" sz="725" dirty="0"/>
           </a:p>
           <a:p>
-            <a:pPr algn="l" indent="0" marL="0">
-              <a:buNone/>
-            </a:pPr>
-            <a:r>
-              <a:rPr lang="en-US" sz="725" b="1" dirty="0">
+            <a:pPr algn="ctr" indent="0" marL="0">
+              <a:buNone/>
+            </a:pPr>
+            <a:r>
+              <a:rPr lang="en-US" sz="725" dirty="0">
+                <a:solidFill>
+                  <a:srgbClr val="CFE6FF"/>
+                </a:solidFill>
+                <a:latin typeface="Arial" pitchFamily="34" charset="0"/>
+                <a:ea typeface="Arial" pitchFamily="34" charset="-122"/>
+                <a:cs typeface="Arial" pitchFamily="34" charset="-120"/>
+              </a:rPr>
+              <a:t>in 3D</a:t>
+            </a:r>
+            <a:endParaRPr lang="en-US" sz="725" dirty="0"/>
+          </a:p>
+        </p:txBody>
+      </p:sp>
+      <p:sp>
+        <p:nvSpPr>
+          <p:cNvPr id="56" name="Text 28"/>
+          <p:cNvSpPr txBox="1"/>
+          <p:nvPr/>
+        </p:nvSpPr>
+        <p:spPr>
+          <a:xfrm>
+            <a:off x="11022256" y="3796613"/>
+            <a:ext cx="459790" cy="152384"/>
+          </a:xfrm>
+          <a:prstGeom prst="rect">
+            <a:avLst/>
+          </a:prstGeom>
+          <a:noFill/>
+          <a:ln/>
+        </p:spPr>
+        <p:txBody>
+          <a:bodyPr wrap="square" lIns="0" tIns="0" rIns="0" bIns="0" rtlCol="0" anchor="ctr"/>
+          <a:lstStyle/>
+          <a:p>
+            <a:pPr algn="ctr" indent="0" marL="0">
+              <a:buNone/>
+            </a:pPr>
+            <a:r>
+              <a:rPr lang="en-US" sz="900" b="1" spc="25" kern="0" dirty="0">
                 <a:solidFill>
                   <a:srgbClr val="FFFFFF"/>
                 </a:solidFill>
@@ -2638,38 +2772,94 @@
                 <a:ea typeface="Arial" pitchFamily="34" charset="-122"/>
                 <a:cs typeface="Arial" pitchFamily="34" charset="-120"/>
               </a:rPr>
-              <a:t>tích hợp xương</a:t>
+              <a:t>PETRA</a:t>
+            </a:r>
+            <a:endParaRPr lang="en-US" sz="900" dirty="0"/>
+          </a:p>
+        </p:txBody>
+      </p:sp>
+      <p:sp>
+        <p:nvSpPr>
+          <p:cNvPr id="57" name="Text 29"/>
+          <p:cNvSpPr txBox="1"/>
+          <p:nvPr/>
+        </p:nvSpPr>
+        <p:spPr>
+          <a:xfrm>
+            <a:off x="11048045" y="3951093"/>
+            <a:ext cx="408212" cy="277606"/>
+          </a:xfrm>
+          <a:prstGeom prst="rect">
+            <a:avLst/>
+          </a:prstGeom>
+          <a:noFill/>
+          <a:ln/>
+        </p:spPr>
+        <p:txBody>
+          <a:bodyPr wrap="square" lIns="0" tIns="0" rIns="0" bIns="0" rtlCol="0" anchor="ctr"/>
+          <a:lstStyle/>
+          <a:p>
+            <a:pPr algn="ctr" indent="0" marL="0">
+              <a:buNone/>
+            </a:pPr>
+            <a:r>
+              <a:rPr lang="en-US" sz="725" dirty="0">
+                <a:solidFill>
+                  <a:srgbClr val="CFE6FF"/>
+                </a:solidFill>
+                <a:latin typeface="Arial" pitchFamily="34" charset="0"/>
+                <a:ea typeface="Arial" pitchFamily="34" charset="-122"/>
+                <a:cs typeface="Arial" pitchFamily="34" charset="-120"/>
+              </a:rPr>
+              <a:t>Lồng cổ</a:t>
             </a:r>
             <a:endParaRPr lang="en-US" sz="725" dirty="0"/>
           </a:p>
-        </p:txBody>
-      </p:sp>
-      <p:sp>
-        <p:nvSpPr>
-          <p:cNvPr id="54" name="Text 26"/>
-          <p:cNvSpPr txBox="1"/>
-          <p:nvPr/>
-        </p:nvSpPr>
-        <p:spPr>
-          <a:xfrm>
-            <a:off x="10585450" y="3666776"/>
-            <a:ext cx="1026468" cy="154686"/>
-          </a:xfrm>
-          <a:prstGeom prst="rect">
-            <a:avLst/>
-          </a:prstGeom>
-          <a:noFill/>
-          <a:ln/>
-        </p:spPr>
-        <p:txBody>
-          <a:bodyPr wrap="square" lIns="0" tIns="0" rIns="0" bIns="0" rtlCol="0" anchor="ctr"/>
-          <a:lstStyle/>
-          <a:p>
-            <a:pPr algn="l" indent="0" marL="0">
-              <a:buNone/>
-            </a:pPr>
-            <a:r>
-              <a:rPr lang="en-US" sz="900" b="1" spc="15" kern="0" dirty="0">
+          <a:p>
+            <a:pPr algn="ctr" indent="0" marL="0">
+              <a:buNone/>
+            </a:pPr>
+            <a:r>
+              <a:rPr lang="en-US" sz="725" dirty="0">
+                <a:solidFill>
+                  <a:srgbClr val="CFE6FF"/>
+                </a:solidFill>
+                <a:latin typeface="Arial" pitchFamily="34" charset="0"/>
+                <a:ea typeface="Arial" pitchFamily="34" charset="-122"/>
+                <a:cs typeface="Arial" pitchFamily="34" charset="-120"/>
+              </a:rPr>
+              <a:t>in 3D</a:t>
+            </a:r>
+            <a:endParaRPr lang="en-US" sz="725" dirty="0"/>
+          </a:p>
+        </p:txBody>
+      </p:sp>
+      <p:sp>
+        <p:nvSpPr>
+          <p:cNvPr id="58" name="Text 30"/>
+          <p:cNvSpPr txBox="1"/>
+          <p:nvPr/>
+        </p:nvSpPr>
+        <p:spPr>
+          <a:xfrm>
+            <a:off x="10011035" y="5494742"/>
+            <a:ext cx="659880" cy="152384"/>
+          </a:xfrm>
+          <a:prstGeom prst="rect">
+            <a:avLst/>
+          </a:prstGeom>
+          <a:noFill/>
+          <a:ln/>
+        </p:spPr>
+        <p:txBody>
+          <a:bodyPr wrap="square" lIns="0" tIns="0" rIns="0" bIns="0" rtlCol="0" anchor="ctr"/>
+          <a:lstStyle/>
+          <a:p>
+            <a:pPr algn="ctr" indent="0" marL="0">
+              <a:buNone/>
+            </a:pPr>
+            <a:r>
+              <a:rPr lang="en-US" sz="900" b="1" spc="25" kern="0" dirty="0">
                 <a:solidFill>
                   <a:srgbClr val="FFFFFF"/>
                 </a:solidFill>
@@ -2677,7 +2867,7 @@
                 <a:ea typeface="Arial" pitchFamily="34" charset="-122"/>
                 <a:cs typeface="Arial" pitchFamily="34" charset="-120"/>
               </a:rPr>
-              <a:t>PANTHER</a:t>
+              <a:t>QUATTRO</a:t>
             </a:r>
             <a:endParaRPr lang="en-US" sz="900" dirty="0"/>
           </a:p>
@@ -2685,26 +2875,26 @@
       </p:sp>
       <p:sp>
         <p:nvSpPr>
-          <p:cNvPr id="55" name="Text 27"/>
-          <p:cNvSpPr txBox="1"/>
-          <p:nvPr/>
-        </p:nvSpPr>
-        <p:spPr>
-          <a:xfrm>
-            <a:off x="10585450" y="3815366"/>
-            <a:ext cx="1026468" cy="117856"/>
-          </a:xfrm>
-          <a:prstGeom prst="rect">
-            <a:avLst/>
-          </a:prstGeom>
-          <a:noFill/>
-          <a:ln/>
-        </p:spPr>
-        <p:txBody>
-          <a:bodyPr wrap="square" lIns="0" tIns="0" rIns="0" bIns="0" rtlCol="0" anchor="ctr"/>
-          <a:lstStyle/>
-          <a:p>
-            <a:pPr algn="l" indent="0" marL="0">
+          <p:cNvPr id="59" name="Text 31"/>
+          <p:cNvSpPr txBox="1"/>
+          <p:nvPr/>
+        </p:nvSpPr>
+        <p:spPr>
+          <a:xfrm>
+            <a:off x="9961945" y="5658795"/>
+            <a:ext cx="758059" cy="138803"/>
+          </a:xfrm>
+          <a:prstGeom prst="rect">
+            <a:avLst/>
+          </a:prstGeom>
+          <a:noFill/>
+          <a:ln/>
+        </p:spPr>
+        <p:txBody>
+          <a:bodyPr wrap="square" lIns="0" tIns="0" rIns="0" bIns="0" rtlCol="0" anchor="ctr"/>
+          <a:lstStyle/>
+          <a:p>
+            <a:pPr algn="ctr" indent="0" marL="0">
               <a:buNone/>
             </a:pPr>
             <a:r>
@@ -2716,7 +2906,7 @@
                 <a:ea typeface="Arial" pitchFamily="34" charset="-122"/>
                 <a:cs typeface="Arial" pitchFamily="34" charset="-120"/>
               </a:rPr>
-              <a:t>Lồng thắt lưng in 3D</a:t>
+              <a:t>Vít cuống sống</a:t>
             </a:r>
             <a:endParaRPr lang="en-US" sz="725" dirty="0"/>
           </a:p>
@@ -2724,30 +2914,30 @@
       </p:sp>
       <p:sp>
         <p:nvSpPr>
-          <p:cNvPr id="56" name="Text 28"/>
-          <p:cNvSpPr txBox="1"/>
-          <p:nvPr/>
-        </p:nvSpPr>
-        <p:spPr>
-          <a:xfrm>
-            <a:off x="10585450" y="4149376"/>
-            <a:ext cx="693926" cy="154686"/>
-          </a:xfrm>
-          <a:prstGeom prst="rect">
-            <a:avLst/>
-          </a:prstGeom>
-          <a:noFill/>
-          <a:ln/>
-        </p:spPr>
-        <p:txBody>
-          <a:bodyPr wrap="square" lIns="0" tIns="0" rIns="0" bIns="0" rtlCol="0" anchor="ctr"/>
-          <a:lstStyle/>
-          <a:p>
-            <a:pPr algn="l" indent="0" marL="0">
-              <a:buNone/>
-            </a:pPr>
-            <a:r>
-              <a:rPr lang="en-US" sz="900" b="1" spc="15" kern="0" dirty="0">
+          <p:cNvPr id="60" name="Text 32"/>
+          <p:cNvSpPr txBox="1"/>
+          <p:nvPr/>
+        </p:nvSpPr>
+        <p:spPr>
+          <a:xfrm>
+            <a:off x="10957185" y="5484233"/>
+            <a:ext cx="659880" cy="304768"/>
+          </a:xfrm>
+          <a:prstGeom prst="rect">
+            <a:avLst/>
+          </a:prstGeom>
+          <a:noFill/>
+          <a:ln/>
+        </p:spPr>
+        <p:txBody>
+          <a:bodyPr wrap="square" lIns="0" tIns="0" rIns="0" bIns="0" rtlCol="0" anchor="ctr"/>
+          <a:lstStyle/>
+          <a:p>
+            <a:pPr algn="ctr" indent="0" marL="0">
+              <a:buNone/>
+            </a:pPr>
+            <a:r>
+              <a:rPr lang="en-US" sz="900" b="1" spc="25" kern="0" dirty="0">
                 <a:solidFill>
                   <a:srgbClr val="FFFFFF"/>
                 </a:solidFill>
@@ -2755,34 +2945,51 @@
                 <a:ea typeface="Arial" pitchFamily="34" charset="-122"/>
                 <a:cs typeface="Arial" pitchFamily="34" charset="-120"/>
               </a:rPr>
-              <a:t>PETRA</a:t>
+              <a:t>QUATTRO</a:t>
             </a:r>
             <a:endParaRPr lang="en-US" sz="900" dirty="0"/>
           </a:p>
-        </p:txBody>
-      </p:sp>
-      <p:sp>
-        <p:nvSpPr>
-          <p:cNvPr id="57" name="Text 29"/>
-          <p:cNvSpPr txBox="1"/>
-          <p:nvPr/>
-        </p:nvSpPr>
-        <p:spPr>
-          <a:xfrm>
-            <a:off x="10585450" y="4297966"/>
-            <a:ext cx="693926" cy="117856"/>
-          </a:xfrm>
-          <a:prstGeom prst="rect">
-            <a:avLst/>
-          </a:prstGeom>
-          <a:noFill/>
-          <a:ln/>
-        </p:spPr>
-        <p:txBody>
-          <a:bodyPr wrap="square" lIns="0" tIns="0" rIns="0" bIns="0" rtlCol="0" anchor="ctr"/>
-          <a:lstStyle/>
-          <a:p>
-            <a:pPr algn="l" indent="0" marL="0">
+          <a:p>
+            <a:pPr algn="ctr" indent="0" marL="0">
+              <a:buNone/>
+            </a:pPr>
+            <a:r>
+              <a:rPr lang="en-US" sz="900" b="1" spc="25" kern="0" dirty="0">
+                <a:solidFill>
+                  <a:srgbClr val="FFFFFF"/>
+                </a:solidFill>
+                <a:latin typeface="Arial" pitchFamily="34" charset="0"/>
+                <a:ea typeface="Arial" pitchFamily="34" charset="-122"/>
+                <a:cs typeface="Arial" pitchFamily="34" charset="-120"/>
+              </a:rPr>
+              <a:t>GADGET</a:t>
+            </a:r>
+            <a:endParaRPr lang="en-US" sz="900" dirty="0"/>
+          </a:p>
+        </p:txBody>
+      </p:sp>
+      <p:sp>
+        <p:nvSpPr>
+          <p:cNvPr id="61" name="Text 33"/>
+          <p:cNvSpPr txBox="1"/>
+          <p:nvPr/>
+        </p:nvSpPr>
+        <p:spPr>
+          <a:xfrm>
+            <a:off x="11036255" y="5780588"/>
+            <a:ext cx="501640" cy="277606"/>
+          </a:xfrm>
+          <a:prstGeom prst="rect">
+            <a:avLst/>
+          </a:prstGeom>
+          <a:noFill/>
+          <a:ln/>
+        </p:spPr>
+        <p:txBody>
+          <a:bodyPr wrap="square" lIns="0" tIns="0" rIns="0" bIns="0" rtlCol="0" anchor="ctr"/>
+          <a:lstStyle/>
+          <a:p>
+            <a:pPr algn="ctr" indent="0" marL="0">
               <a:buNone/>
             </a:pPr>
             <a:r>
@@ -2794,73 +3001,12 @@
                 <a:ea typeface="Arial" pitchFamily="34" charset="-122"/>
                 <a:cs typeface="Arial" pitchFamily="34" charset="-120"/>
               </a:rPr>
-              <a:t>Lồng cổ in 3D</a:t>
+              <a:t>Vít qua da</a:t>
             </a:r>
             <a:endParaRPr lang="en-US" sz="725" dirty="0"/>
           </a:p>
-        </p:txBody>
-      </p:sp>
-      <p:sp>
-        <p:nvSpPr>
-          <p:cNvPr id="58" name="Text 30"/>
-          <p:cNvSpPr txBox="1"/>
-          <p:nvPr/>
-        </p:nvSpPr>
-        <p:spPr>
-          <a:xfrm>
-            <a:off x="10591800" y="4727226"/>
-            <a:ext cx="758059" cy="154686"/>
-          </a:xfrm>
-          <a:prstGeom prst="rect">
-            <a:avLst/>
-          </a:prstGeom>
-          <a:noFill/>
-          <a:ln/>
-        </p:spPr>
-        <p:txBody>
-          <a:bodyPr wrap="square" lIns="0" tIns="0" rIns="0" bIns="0" rtlCol="0" anchor="ctr"/>
-          <a:lstStyle/>
-          <a:p>
-            <a:pPr algn="l" indent="0" marL="0">
-              <a:buNone/>
-            </a:pPr>
-            <a:r>
-              <a:rPr lang="en-US" sz="900" b="1" spc="15" kern="0" dirty="0">
-                <a:solidFill>
-                  <a:srgbClr val="FFFFFF"/>
-                </a:solidFill>
-                <a:latin typeface="Arial" pitchFamily="34" charset="0"/>
-                <a:ea typeface="Arial" pitchFamily="34" charset="-122"/>
-                <a:cs typeface="Arial" pitchFamily="34" charset="-120"/>
-              </a:rPr>
-              <a:t>QUATTRO</a:t>
-            </a:r>
-            <a:endParaRPr lang="en-US" sz="900" dirty="0"/>
-          </a:p>
-        </p:txBody>
-      </p:sp>
-      <p:sp>
-        <p:nvSpPr>
-          <p:cNvPr id="59" name="Text 31"/>
-          <p:cNvSpPr txBox="1"/>
-          <p:nvPr/>
-        </p:nvSpPr>
-        <p:spPr>
-          <a:xfrm>
-            <a:off x="10591800" y="4875816"/>
-            <a:ext cx="758059" cy="117856"/>
-          </a:xfrm>
-          <a:prstGeom prst="rect">
-            <a:avLst/>
-          </a:prstGeom>
-          <a:noFill/>
-          <a:ln/>
-        </p:spPr>
-        <p:txBody>
-          <a:bodyPr wrap="square" lIns="0" tIns="0" rIns="0" bIns="0" rtlCol="0" anchor="ctr"/>
-          <a:lstStyle/>
-          <a:p>
-            <a:pPr algn="l" indent="0" marL="0">
+          <a:p>
+            <a:pPr algn="ctr" indent="0" marL="0">
               <a:buNone/>
             </a:pPr>
             <a:r>
@@ -2872,7 +3018,7 @@
                 <a:ea typeface="Arial" pitchFamily="34" charset="-122"/>
                 <a:cs typeface="Arial" pitchFamily="34" charset="-120"/>
               </a:rPr>
-              <a:t>Vít cuống sống</a:t>
+              <a:t>ít xâm lấn</a:t>
             </a:r>
             <a:endParaRPr lang="en-US" sz="725" dirty="0"/>
           </a:p>
@@ -2880,131 +3026,14 @@
       </p:sp>
       <p:sp>
         <p:nvSpPr>
-          <p:cNvPr id="60" name="Text 32"/>
-          <p:cNvSpPr txBox="1"/>
-          <p:nvPr/>
-        </p:nvSpPr>
-        <p:spPr>
-          <a:xfrm>
-            <a:off x="10591800" y="5178076"/>
-            <a:ext cx="1258568" cy="154686"/>
-          </a:xfrm>
-          <a:prstGeom prst="rect">
-            <a:avLst/>
-          </a:prstGeom>
-          <a:noFill/>
-          <a:ln/>
-        </p:spPr>
-        <p:txBody>
-          <a:bodyPr wrap="square" lIns="0" tIns="0" rIns="0" bIns="0" rtlCol="0" anchor="ctr"/>
-          <a:lstStyle/>
-          <a:p>
-            <a:pPr algn="l" indent="0" marL="0">
-              <a:buNone/>
-            </a:pPr>
-            <a:r>
-              <a:rPr lang="en-US" sz="900" b="1" spc="15" kern="0" dirty="0">
-                <a:solidFill>
-                  <a:srgbClr val="FFFFFF"/>
-                </a:solidFill>
-                <a:latin typeface="Arial" pitchFamily="34" charset="0"/>
-                <a:ea typeface="Arial" pitchFamily="34" charset="-122"/>
-                <a:cs typeface="Arial" pitchFamily="34" charset="-120"/>
-              </a:rPr>
-              <a:t>QUATTRO GADGET</a:t>
-            </a:r>
-            <a:endParaRPr lang="en-US" sz="900" dirty="0"/>
-          </a:p>
-        </p:txBody>
-      </p:sp>
-      <p:sp>
-        <p:nvSpPr>
-          <p:cNvPr id="61" name="Text 33"/>
-          <p:cNvSpPr txBox="1"/>
-          <p:nvPr/>
-        </p:nvSpPr>
-        <p:spPr>
-          <a:xfrm>
-            <a:off x="10591800" y="5326666"/>
-            <a:ext cx="1258568" cy="117856"/>
-          </a:xfrm>
-          <a:prstGeom prst="rect">
-            <a:avLst/>
-          </a:prstGeom>
-          <a:noFill/>
-          <a:ln/>
-        </p:spPr>
-        <p:txBody>
-          <a:bodyPr wrap="square" lIns="0" tIns="0" rIns="0" bIns="0" rtlCol="0" anchor="ctr"/>
-          <a:lstStyle/>
-          <a:p>
-            <a:pPr algn="l" indent="0" marL="0">
-              <a:buNone/>
-            </a:pPr>
-            <a:r>
-              <a:rPr lang="en-US" sz="725" dirty="0">
-                <a:solidFill>
-                  <a:srgbClr val="CFE6FF"/>
-                </a:solidFill>
-                <a:latin typeface="Arial" pitchFamily="34" charset="0"/>
-                <a:ea typeface="Arial" pitchFamily="34" charset="-122"/>
-                <a:cs typeface="Arial" pitchFamily="34" charset="-120"/>
-              </a:rPr>
-              <a:t>Vít qua da</a:t>
-            </a:r>
-            <a:endParaRPr lang="en-US" sz="725" dirty="0"/>
-          </a:p>
-        </p:txBody>
-      </p:sp>
-      <p:sp>
-        <p:nvSpPr>
           <p:cNvPr id="62" name="Text 34"/>
           <p:cNvSpPr txBox="1"/>
           <p:nvPr/>
         </p:nvSpPr>
         <p:spPr>
           <a:xfrm>
-            <a:off x="10591800" y="5453666"/>
-            <a:ext cx="484221" cy="117856"/>
-          </a:xfrm>
-          <a:prstGeom prst="rect">
-            <a:avLst/>
-          </a:prstGeom>
-          <a:noFill/>
-          <a:ln/>
-        </p:spPr>
-        <p:txBody>
-          <a:bodyPr wrap="square" lIns="0" tIns="0" rIns="0" bIns="0" rtlCol="0" anchor="ctr"/>
-          <a:lstStyle/>
-          <a:p>
-            <a:pPr algn="l" indent="0" marL="0">
-              <a:buNone/>
-            </a:pPr>
-            <a:r>
-              <a:rPr lang="en-US" sz="725" dirty="0">
-                <a:solidFill>
-                  <a:srgbClr val="CFE6FF"/>
-                </a:solidFill>
-                <a:latin typeface="Arial" pitchFamily="34" charset="0"/>
-                <a:ea typeface="Arial" pitchFamily="34" charset="-122"/>
-                <a:cs typeface="Arial" pitchFamily="34" charset="-120"/>
-              </a:rPr>
-              <a:t>Ít xâm lấn</a:t>
-            </a:r>
-            <a:endParaRPr lang="en-US" sz="725" dirty="0"/>
-          </a:p>
-        </p:txBody>
-      </p:sp>
-      <p:sp>
-        <p:nvSpPr>
-          <p:cNvPr id="63" name="Text 35"/>
-          <p:cNvSpPr txBox="1"/>
-          <p:nvPr/>
-        </p:nvSpPr>
-        <p:spPr>
-          <a:xfrm>
-            <a:off x="11054655" y="5438934"/>
-            <a:ext cx="284361" cy="147320"/>
+            <a:off x="11105753" y="6078220"/>
+            <a:ext cx="362744" cy="168612"/>
           </a:xfrm>
           <a:prstGeom prst="rect">
             <a:avLst/>
@@ -3020,9 +3049,9 @@
               <a:buNone/>
             </a:pPr>
             <a:r>
-              <a:rPr lang="en-US" sz="725" spc="50" kern="0" dirty="0">
-                <a:solidFill>
-                  <a:srgbClr val="CFE6FF"/>
+              <a:rPr lang="en-US" sz="650" spc="100" kern="0" dirty="0">
+                <a:solidFill>
+                  <a:srgbClr val="0A3170"/>
                 </a:solidFill>
                 <a:latin typeface="Arial" pitchFamily="34" charset="0"/>
                 <a:ea typeface="Arial" pitchFamily="34" charset="-122"/>
@@ -3030,7 +3059,7 @@
               </a:rPr>
               <a:t>MIS</a:t>
             </a:r>
-            <a:endParaRPr lang="en-US" sz="725" dirty="0"/>
+            <a:endParaRPr lang="en-US" sz="650" dirty="0"/>
           </a:p>
         </p:txBody>
       </p:sp>

</xml_diff>

<commit_message>
Backdrop VOA: real Facebook/TikTok/Instagram/Zalo QR codes sized for 5m print, hotline in header
Co-Authored-By: Claude Opus 5.5 <noreply@anthropic.com>
Claude-Session: https://claude.ai/code/session_013QJi2k1EkL4AWCx1Ymi9NU
</commit_message>
<xml_diff>
--- a/backdrop-voa/backdrop-VOA.pptx
+++ b/backdrop-voa/backdrop-VOA.pptx
@@ -922,8 +922,8 @@
         </p:blipFill>
         <p:spPr>
           <a:xfrm>
-            <a:off x="8216900" y="279400"/>
-            <a:ext cx="749300" cy="749300"/>
+            <a:off x="9359900" y="546100"/>
+            <a:ext cx="495300" cy="495300"/>
           </a:xfrm>
           <a:prstGeom prst="rect">
             <a:avLst/>
@@ -946,8 +946,8 @@
         </p:blipFill>
         <p:spPr>
           <a:xfrm>
-            <a:off x="9156700" y="279400"/>
-            <a:ext cx="749300" cy="749300"/>
+            <a:off x="10007600" y="546100"/>
+            <a:ext cx="495300" cy="495300"/>
           </a:xfrm>
           <a:prstGeom prst="rect">
             <a:avLst/>
@@ -970,8 +970,8 @@
         </p:blipFill>
         <p:spPr>
           <a:xfrm>
-            <a:off x="10096500" y="279400"/>
-            <a:ext cx="749300" cy="749300"/>
+            <a:off x="10655300" y="546100"/>
+            <a:ext cx="495300" cy="495300"/>
           </a:xfrm>
           <a:prstGeom prst="rect">
             <a:avLst/>
@@ -994,8 +994,8 @@
         </p:blipFill>
         <p:spPr>
           <a:xfrm>
-            <a:off x="11036300" y="279400"/>
-            <a:ext cx="749300" cy="749300"/>
+            <a:off x="11303000" y="546100"/>
+            <a:ext cx="495300" cy="495300"/>
           </a:xfrm>
           <a:prstGeom prst="rect">
             <a:avLst/>
@@ -1606,8 +1606,8 @@
         </p:nvSpPr>
         <p:spPr>
           <a:xfrm>
-            <a:off x="8369201" y="1039114"/>
-            <a:ext cx="506956" cy="125222"/>
+            <a:off x="8625086" y="279781"/>
+            <a:ext cx="1848320" cy="132588"/>
           </a:xfrm>
           <a:prstGeom prst="rect">
             <a:avLst/>
@@ -1623,7 +1623,99 @@
               <a:buNone/>
             </a:pPr>
             <a:r>
-              <a:rPr lang="en-US" sz="750" b="1" dirty="0">
+              <a:rPr lang="en-US" sz="800" b="1" spc="150" kern="0" dirty="0">
+                <a:solidFill>
+                  <a:srgbClr val="CFE6FF"/>
+                </a:solidFill>
+                <a:latin typeface="Arial" pitchFamily="34" charset="0"/>
+                <a:ea typeface="Arial" pitchFamily="34" charset="-122"/>
+                <a:cs typeface="Arial" pitchFamily="34" charset="-120"/>
+              </a:rPr>
+              <a:t>KẾT NỐI VỚI CHÚNG TÔI</a:t>
+            </a:r>
+            <a:endParaRPr lang="en-US" sz="800" dirty="0"/>
+          </a:p>
+        </p:txBody>
+      </p:sp>
+      <p:sp>
+        <p:nvSpPr>
+          <p:cNvPr id="31" name="Text 3"/>
+          <p:cNvSpPr txBox="1"/>
+          <p:nvPr/>
+        </p:nvSpPr>
+        <p:spPr>
+          <a:xfrm>
+            <a:off x="10360720" y="231902"/>
+            <a:ext cx="1682276" cy="228346"/>
+          </a:xfrm>
+          <a:prstGeom prst="rect">
+            <a:avLst/>
+          </a:prstGeom>
+          <a:noFill/>
+          <a:ln/>
+        </p:spPr>
+        <p:txBody>
+          <a:bodyPr wrap="square" lIns="0" tIns="0" rIns="0" bIns="0" rtlCol="0" anchor="ctr"/>
+          <a:lstStyle/>
+          <a:p>
+            <a:pPr algn="l" indent="0" marL="0">
+              <a:buNone/>
+            </a:pPr>
+            <a:r>
+              <a:rPr lang="en-US" sz="1000" b="1" dirty="0">
+                <a:solidFill>
+                  <a:srgbClr val="FFFFFF"/>
+                </a:solidFill>
+                <a:latin typeface="Arial" pitchFamily="34" charset="0"/>
+                <a:ea typeface="Arial" pitchFamily="34" charset="-122"/>
+                <a:cs typeface="Arial" pitchFamily="34" charset="-120"/>
+              </a:rPr>
+              <a:t>Hotline </a:t>
+            </a:r>
+            <a:pPr algn="l" indent="0" marL="0">
+              <a:buNone/>
+            </a:pPr>
+            <a:r>
+              <a:rPr lang="en-US" sz="1000" b="1" dirty="0">
+                <a:solidFill>
+                  <a:srgbClr val="8ED14F"/>
+                </a:solidFill>
+                <a:latin typeface="Arial" pitchFamily="34" charset="0"/>
+                <a:ea typeface="Arial" pitchFamily="34" charset="-122"/>
+                <a:cs typeface="Arial" pitchFamily="34" charset="-120"/>
+              </a:rPr>
+              <a:t>0916 899 322</a:t>
+            </a:r>
+            <a:endParaRPr lang="en-US" sz="1000" dirty="0"/>
+          </a:p>
+        </p:txBody>
+      </p:sp>
+      <p:sp>
+        <p:nvSpPr>
+          <p:cNvPr id="32" name="Text 4"/>
+          <p:cNvSpPr txBox="1"/>
+          <p:nvPr/>
+        </p:nvSpPr>
+        <p:spPr>
+          <a:xfrm>
+            <a:off x="9414867" y="1046480"/>
+            <a:ext cx="439317" cy="110490"/>
+          </a:xfrm>
+          <a:prstGeom prst="rect">
+            <a:avLst/>
+          </a:prstGeom>
+          <a:noFill/>
+          <a:ln/>
+        </p:spPr>
+        <p:txBody>
+          <a:bodyPr wrap="square" lIns="0" tIns="0" rIns="0" bIns="0" rtlCol="0" anchor="ctr"/>
+          <a:lstStyle/>
+          <a:p>
+            <a:pPr algn="l" indent="0" marL="0">
+              <a:buNone/>
+            </a:pPr>
+            <a:r>
+              <a:rPr lang="en-US" sz="650" b="1" dirty="0">
                 <a:solidFill>
                   <a:srgbClr val="0A3170"/>
                 </a:solidFill>
@@ -1633,20 +1725,20 @@
               </a:rPr>
               <a:t>Facebook</a:t>
             </a:r>
-            <a:endParaRPr lang="en-US" sz="750" dirty="0"/>
-          </a:p>
-        </p:txBody>
-      </p:sp>
-      <p:sp>
-        <p:nvSpPr>
-          <p:cNvPr id="31" name="Text 3"/>
-          <p:cNvSpPr txBox="1"/>
-          <p:nvPr/>
-        </p:nvSpPr>
-        <p:spPr>
-          <a:xfrm>
-            <a:off x="9433421" y="1039114"/>
-            <a:ext cx="223278" cy="125222"/>
+            <a:endParaRPr lang="en-US" sz="650" dirty="0"/>
+          </a:p>
+        </p:txBody>
+      </p:sp>
+      <p:sp>
+        <p:nvSpPr>
+          <p:cNvPr id="33" name="Text 5"/>
+          <p:cNvSpPr txBox="1"/>
+          <p:nvPr/>
+        </p:nvSpPr>
+        <p:spPr>
+          <a:xfrm>
+            <a:off x="10170319" y="1046480"/>
+            <a:ext cx="193530" cy="110490"/>
           </a:xfrm>
           <a:prstGeom prst="rect">
             <a:avLst/>
@@ -1662,7 +1754,7 @@
               <a:buNone/>
             </a:pPr>
             <a:r>
-              <a:rPr lang="en-US" sz="750" b="1" dirty="0">
+              <a:rPr lang="en-US" sz="650" b="1" dirty="0">
                 <a:solidFill>
                   <a:srgbClr val="0A3170"/>
                 </a:solidFill>
@@ -1672,20 +1764,20 @@
               </a:rPr>
               <a:t>Zalo</a:t>
             </a:r>
-            <a:endParaRPr lang="en-US" sz="750" dirty="0"/>
-          </a:p>
-        </p:txBody>
-      </p:sp>
-      <p:sp>
-        <p:nvSpPr>
-          <p:cNvPr id="32" name="Text 4"/>
-          <p:cNvSpPr txBox="1"/>
-          <p:nvPr/>
-        </p:nvSpPr>
-        <p:spPr>
-          <a:xfrm>
-            <a:off x="10322024" y="1039114"/>
-            <a:ext cx="340007" cy="125222"/>
+            <a:endParaRPr lang="en-US" sz="650" dirty="0"/>
+          </a:p>
+        </p:txBody>
+      </p:sp>
+      <p:sp>
+        <p:nvSpPr>
+          <p:cNvPr id="34" name="Text 6"/>
+          <p:cNvSpPr txBox="1"/>
+          <p:nvPr/>
+        </p:nvSpPr>
+        <p:spPr>
+          <a:xfrm>
+            <a:off x="10773668" y="1046480"/>
+            <a:ext cx="294650" cy="110490"/>
           </a:xfrm>
           <a:prstGeom prst="rect">
             <a:avLst/>
@@ -1701,7 +1793,7 @@
               <a:buNone/>
             </a:pPr>
             <a:r>
-              <a:rPr lang="en-US" sz="750" b="1" dirty="0">
+              <a:rPr lang="en-US" sz="650" b="1" dirty="0">
                 <a:solidFill>
                   <a:srgbClr val="0A3170"/>
                 </a:solidFill>
@@ -1711,20 +1803,20 @@
               </a:rPr>
               <a:t>TikTok</a:t>
             </a:r>
-            <a:endParaRPr lang="en-US" sz="750" dirty="0"/>
-          </a:p>
-        </p:txBody>
-      </p:sp>
-      <p:sp>
-        <p:nvSpPr>
-          <p:cNvPr id="33" name="Text 5"/>
-          <p:cNvSpPr txBox="1"/>
-          <p:nvPr/>
-        </p:nvSpPr>
-        <p:spPr>
-          <a:xfrm>
-            <a:off x="11183243" y="1039114"/>
-            <a:ext cx="519059" cy="125222"/>
+            <a:endParaRPr lang="en-US" sz="650" dirty="0"/>
+          </a:p>
+        </p:txBody>
+      </p:sp>
+      <p:sp>
+        <p:nvSpPr>
+          <p:cNvPr id="35" name="Text 7"/>
+          <p:cNvSpPr txBox="1"/>
+          <p:nvPr/>
+        </p:nvSpPr>
+        <p:spPr>
+          <a:xfrm>
+            <a:off x="11353304" y="1046480"/>
+            <a:ext cx="449836" cy="110490"/>
           </a:xfrm>
           <a:prstGeom prst="rect">
             <a:avLst/>
@@ -1740,7 +1832,7 @@
               <a:buNone/>
             </a:pPr>
             <a:r>
-              <a:rPr lang="en-US" sz="750" b="1" dirty="0">
+              <a:rPr lang="en-US" sz="650" b="1" dirty="0">
                 <a:solidFill>
                   <a:srgbClr val="0A3170"/>
                 </a:solidFill>
@@ -1750,13 +1842,13 @@
               </a:rPr>
               <a:t>Instagram</a:t>
             </a:r>
-            <a:endParaRPr lang="en-US" sz="750" dirty="0"/>
-          </a:p>
-        </p:txBody>
-      </p:sp>
-      <p:sp>
-        <p:nvSpPr>
-          <p:cNvPr id="34" name="Text 6"/>
+            <a:endParaRPr lang="en-US" sz="650" dirty="0"/>
+          </a:p>
+        </p:txBody>
+      </p:sp>
+      <p:sp>
+        <p:nvSpPr>
+          <p:cNvPr id="36" name="Text 8"/>
           <p:cNvSpPr txBox="1"/>
           <p:nvPr/>
         </p:nvSpPr>
@@ -1795,7 +1887,7 @@
       </p:sp>
       <p:sp>
         <p:nvSpPr>
-          <p:cNvPr id="35" name="Text 7"/>
+          <p:cNvPr id="37" name="Text 9"/>
           <p:cNvSpPr txBox="1"/>
           <p:nvPr/>
         </p:nvSpPr>
@@ -1848,7 +1940,7 @@
       </p:sp>
       <p:sp>
         <p:nvSpPr>
-          <p:cNvPr id="36" name="Text 8"/>
+          <p:cNvPr id="38" name="Text 10"/>
           <p:cNvSpPr txBox="1"/>
           <p:nvPr/>
         </p:nvSpPr>
@@ -1901,7 +1993,7 @@
       </p:sp>
       <p:sp>
         <p:nvSpPr>
-          <p:cNvPr id="37" name="Text 9"/>
+          <p:cNvPr id="39" name="Text 11"/>
           <p:cNvSpPr txBox="1"/>
           <p:nvPr/>
         </p:nvSpPr>
@@ -1957,7 +2049,7 @@
       </p:sp>
       <p:sp>
         <p:nvSpPr>
-          <p:cNvPr id="38" name="Text 10"/>
+          <p:cNvPr id="40" name="Text 12"/>
           <p:cNvSpPr txBox="1"/>
           <p:nvPr/>
         </p:nvSpPr>
@@ -1996,7 +2088,7 @@
       </p:sp>
       <p:sp>
         <p:nvSpPr>
-          <p:cNvPr id="39" name="Text 11"/>
+          <p:cNvPr id="41" name="Text 13"/>
           <p:cNvSpPr txBox="1"/>
           <p:nvPr/>
         </p:nvSpPr>
@@ -2035,7 +2127,7 @@
       </p:sp>
       <p:sp>
         <p:nvSpPr>
-          <p:cNvPr id="40" name="Text 12"/>
+          <p:cNvPr id="42" name="Text 14"/>
           <p:cNvSpPr txBox="1"/>
           <p:nvPr/>
         </p:nvSpPr>
@@ -2074,7 +2166,7 @@
       </p:sp>
       <p:sp>
         <p:nvSpPr>
-          <p:cNvPr id="41" name="Text 13"/>
+          <p:cNvPr id="43" name="Text 15"/>
           <p:cNvSpPr txBox="1"/>
           <p:nvPr/>
         </p:nvSpPr>
@@ -2113,7 +2205,7 @@
       </p:sp>
       <p:sp>
         <p:nvSpPr>
-          <p:cNvPr id="42" name="Text 14"/>
+          <p:cNvPr id="44" name="Text 16"/>
           <p:cNvSpPr txBox="1"/>
           <p:nvPr/>
         </p:nvSpPr>
@@ -2152,7 +2244,7 @@
       </p:sp>
       <p:sp>
         <p:nvSpPr>
-          <p:cNvPr id="43" name="Text 15"/>
+          <p:cNvPr id="45" name="Text 17"/>
           <p:cNvSpPr txBox="1"/>
           <p:nvPr/>
         </p:nvSpPr>
@@ -2191,7 +2283,7 @@
       </p:sp>
       <p:sp>
         <p:nvSpPr>
-          <p:cNvPr id="44" name="Text 16"/>
+          <p:cNvPr id="46" name="Text 18"/>
           <p:cNvSpPr txBox="1"/>
           <p:nvPr/>
         </p:nvSpPr>
@@ -2230,7 +2322,7 @@
       </p:sp>
       <p:sp>
         <p:nvSpPr>
-          <p:cNvPr id="45" name="Text 17"/>
+          <p:cNvPr id="47" name="Text 19"/>
           <p:cNvSpPr txBox="1"/>
           <p:nvPr/>
         </p:nvSpPr>
@@ -2283,7 +2375,7 @@
       </p:sp>
       <p:sp>
         <p:nvSpPr>
-          <p:cNvPr id="46" name="Text 18"/>
+          <p:cNvPr id="48" name="Text 20"/>
           <p:cNvSpPr txBox="1"/>
           <p:nvPr/>
         </p:nvSpPr>
@@ -2322,7 +2414,7 @@
       </p:sp>
       <p:sp>
         <p:nvSpPr>
-          <p:cNvPr id="47" name="Text 19"/>
+          <p:cNvPr id="49" name="Text 21"/>
           <p:cNvSpPr txBox="1"/>
           <p:nvPr/>
         </p:nvSpPr>
@@ -2361,7 +2453,7 @@
       </p:sp>
       <p:sp>
         <p:nvSpPr>
-          <p:cNvPr id="48" name="Text 20"/>
+          <p:cNvPr id="50" name="Text 22"/>
           <p:cNvSpPr txBox="1"/>
           <p:nvPr/>
         </p:nvSpPr>
@@ -2400,7 +2492,7 @@
       </p:sp>
       <p:sp>
         <p:nvSpPr>
-          <p:cNvPr id="49" name="Text 21"/>
+          <p:cNvPr id="51" name="Text 23"/>
           <p:cNvSpPr txBox="1"/>
           <p:nvPr/>
         </p:nvSpPr>
@@ -2439,7 +2531,7 @@
       </p:sp>
       <p:sp>
         <p:nvSpPr>
-          <p:cNvPr id="50" name="Text 22"/>
+          <p:cNvPr id="52" name="Text 24"/>
           <p:cNvSpPr txBox="1"/>
           <p:nvPr/>
         </p:nvSpPr>
@@ -2478,7 +2570,7 @@
       </p:sp>
       <p:sp>
         <p:nvSpPr>
-          <p:cNvPr id="51" name="Text 23"/>
+          <p:cNvPr id="53" name="Text 25"/>
           <p:cNvSpPr txBox="1"/>
           <p:nvPr/>
         </p:nvSpPr>
@@ -2551,7 +2643,7 @@
       </p:sp>
       <p:sp>
         <p:nvSpPr>
-          <p:cNvPr id="52" name="Text 24"/>
+          <p:cNvPr id="54" name="Text 26"/>
           <p:cNvSpPr txBox="1"/>
           <p:nvPr/>
         </p:nvSpPr>
@@ -2590,7 +2682,7 @@
       </p:sp>
       <p:sp>
         <p:nvSpPr>
-          <p:cNvPr id="53" name="Text 25"/>
+          <p:cNvPr id="55" name="Text 27"/>
           <p:cNvSpPr txBox="1"/>
           <p:nvPr/>
         </p:nvSpPr>
@@ -2646,7 +2738,7 @@
       </p:sp>
       <p:sp>
         <p:nvSpPr>
-          <p:cNvPr id="54" name="Text 26"/>
+          <p:cNvPr id="56" name="Text 28"/>
           <p:cNvSpPr txBox="1"/>
           <p:nvPr/>
         </p:nvSpPr>
@@ -2685,7 +2777,7 @@
       </p:sp>
       <p:sp>
         <p:nvSpPr>
-          <p:cNvPr id="55" name="Text 27"/>
+          <p:cNvPr id="57" name="Text 29"/>
           <p:cNvSpPr txBox="1"/>
           <p:nvPr/>
         </p:nvSpPr>
@@ -2741,7 +2833,7 @@
       </p:sp>
       <p:sp>
         <p:nvSpPr>
-          <p:cNvPr id="56" name="Text 28"/>
+          <p:cNvPr id="58" name="Text 30"/>
           <p:cNvSpPr txBox="1"/>
           <p:nvPr/>
         </p:nvSpPr>
@@ -2780,7 +2872,7 @@
       </p:sp>
       <p:sp>
         <p:nvSpPr>
-          <p:cNvPr id="57" name="Text 29"/>
+          <p:cNvPr id="59" name="Text 31"/>
           <p:cNvSpPr txBox="1"/>
           <p:nvPr/>
         </p:nvSpPr>
@@ -2836,7 +2928,7 @@
       </p:sp>
       <p:sp>
         <p:nvSpPr>
-          <p:cNvPr id="58" name="Text 30"/>
+          <p:cNvPr id="60" name="Text 32"/>
           <p:cNvSpPr txBox="1"/>
           <p:nvPr/>
         </p:nvSpPr>
@@ -2875,7 +2967,7 @@
       </p:sp>
       <p:sp>
         <p:nvSpPr>
-          <p:cNvPr id="59" name="Text 31"/>
+          <p:cNvPr id="61" name="Text 33"/>
           <p:cNvSpPr txBox="1"/>
           <p:nvPr/>
         </p:nvSpPr>
@@ -2914,7 +3006,7 @@
       </p:sp>
       <p:sp>
         <p:nvSpPr>
-          <p:cNvPr id="60" name="Text 32"/>
+          <p:cNvPr id="62" name="Text 34"/>
           <p:cNvSpPr txBox="1"/>
           <p:nvPr/>
         </p:nvSpPr>
@@ -2970,7 +3062,7 @@
       </p:sp>
       <p:sp>
         <p:nvSpPr>
-          <p:cNvPr id="61" name="Text 33"/>
+          <p:cNvPr id="63" name="Text 35"/>
           <p:cNvSpPr txBox="1"/>
           <p:nvPr/>
         </p:nvSpPr>
@@ -3026,7 +3118,7 @@
       </p:sp>
       <p:sp>
         <p:nvSpPr>
-          <p:cNvPr id="62" name="Text 34"/>
+          <p:cNvPr id="64" name="Text 36"/>
           <p:cNvSpPr txBox="1"/>
           <p:nvPr/>
         </p:nvSpPr>

</xml_diff>

<commit_message>
Backdrop VOA: 5m x 2.5m (2:1) layout, remove connect label
Co-Authored-By: Claude Opus 5.5 <noreply@anthropic.com>
Claude-Session: https://claude.ai/code/session_013QJi2k1EkL4AWCx1Ymi9NU
</commit_message>
<xml_diff>
--- a/backdrop-voa/backdrop-VOA.pptx
+++ b/backdrop-voa/backdrop-VOA.pptx
@@ -10,8 +10,8 @@
   <p:notesMasterIdLst>
     <p:notesMasterId r:id="rId3"/>
   </p:notesMasterIdLst>
-  <p:sldSz cx="12192000" cy="6858000"/>
-  <p:notesSz cx="6858000" cy="12192000"/>
+  <p:sldSz cx="12191695" cy="6096305"/>
+  <p:notesSz cx="6096305" cy="12191695"/>
   <p:defaultTextStyle>
     <a:lvl1pPr marL="0" algn="l" defTabSz="914400" rtl="0" eaLnBrk="1" latinLnBrk="0" hangingPunct="1">
       <a:defRPr sz="1800" kern="1200">
@@ -898,8 +898,8 @@
         </p:blipFill>
         <p:spPr>
           <a:xfrm>
-            <a:off x="457229" y="340519"/>
-            <a:ext cx="749242" cy="741363"/>
+            <a:off x="444550" y="263823"/>
+            <a:ext cx="660300" cy="653355"/>
           </a:xfrm>
           <a:prstGeom prst="rect">
             <a:avLst/>
@@ -922,7 +922,7 @@
         </p:blipFill>
         <p:spPr>
           <a:xfrm>
-            <a:off x="9359900" y="546100"/>
+            <a:off x="9359900" y="425450"/>
             <a:ext cx="495300" cy="495300"/>
           </a:xfrm>
           <a:prstGeom prst="rect">
@@ -946,7 +946,7 @@
         </p:blipFill>
         <p:spPr>
           <a:xfrm>
-            <a:off x="10007600" y="546100"/>
+            <a:off x="10007600" y="425450"/>
             <a:ext cx="495300" cy="495300"/>
           </a:xfrm>
           <a:prstGeom prst="rect">
@@ -970,7 +970,7 @@
         </p:blipFill>
         <p:spPr>
           <a:xfrm>
-            <a:off x="10655300" y="546100"/>
+            <a:off x="10655300" y="425450"/>
             <a:ext cx="495300" cy="495300"/>
           </a:xfrm>
           <a:prstGeom prst="rect">
@@ -994,7 +994,7 @@
         </p:blipFill>
         <p:spPr>
           <a:xfrm>
-            <a:off x="11303000" y="546100"/>
+            <a:off x="11303000" y="425450"/>
             <a:ext cx="495300" cy="495300"/>
           </a:xfrm>
           <a:prstGeom prst="rect">
@@ -1018,8 +1018,8 @@
         </p:blipFill>
         <p:spPr>
           <a:xfrm>
-            <a:off x="539750" y="1492262"/>
-            <a:ext cx="1142702" cy="482575"/>
+            <a:off x="539750" y="1263652"/>
+            <a:ext cx="992386" cy="419095"/>
           </a:xfrm>
           <a:prstGeom prst="rect">
             <a:avLst/>
@@ -1042,7 +1042,7 @@
         </p:blipFill>
         <p:spPr>
           <a:xfrm>
-            <a:off x="3790652" y="1631958"/>
+            <a:off x="3790652" y="1371608"/>
             <a:ext cx="511870" cy="203185"/>
           </a:xfrm>
           <a:prstGeom prst="rect">
@@ -1066,7 +1066,7 @@
         </p:blipFill>
         <p:spPr>
           <a:xfrm>
-            <a:off x="4378722" y="1631953"/>
+            <a:off x="4378722" y="1371603"/>
             <a:ext cx="491728" cy="203193"/>
           </a:xfrm>
           <a:prstGeom prst="rect">
@@ -1090,8 +1090,8 @@
         </p:blipFill>
         <p:spPr>
           <a:xfrm>
-            <a:off x="711200" y="3360738"/>
-            <a:ext cx="1117600" cy="279400"/>
+            <a:off x="749300" y="2883396"/>
+            <a:ext cx="1016000" cy="254000"/>
           </a:xfrm>
           <a:prstGeom prst="rect">
             <a:avLst/>
@@ -1114,8 +1114,8 @@
         </p:blipFill>
         <p:spPr>
           <a:xfrm>
-            <a:off x="2063879" y="3244155"/>
-            <a:ext cx="2806443" cy="944265"/>
+            <a:off x="2070611" y="2743696"/>
+            <a:ext cx="2792878" cy="939701"/>
           </a:xfrm>
           <a:prstGeom prst="rect">
             <a:avLst/>
@@ -1138,8 +1138,8 @@
         </p:blipFill>
         <p:spPr>
           <a:xfrm>
-            <a:off x="3566716" y="4906967"/>
-            <a:ext cx="1146870" cy="279391"/>
+            <a:off x="3631605" y="4370295"/>
+            <a:ext cx="1042591" cy="253987"/>
           </a:xfrm>
           <a:prstGeom prst="rect">
             <a:avLst/>
@@ -1162,8 +1162,8 @@
         </p:blipFill>
         <p:spPr>
           <a:xfrm>
-            <a:off x="539809" y="4715272"/>
-            <a:ext cx="2806582" cy="916682"/>
+            <a:off x="527051" y="4155380"/>
+            <a:ext cx="2832099" cy="925016"/>
           </a:xfrm>
           <a:prstGeom prst="rect">
             <a:avLst/>
@@ -1186,7 +1186,7 @@
         </p:blipFill>
         <p:spPr>
           <a:xfrm>
-            <a:off x="5397500" y="1593855"/>
+            <a:off x="5397500" y="1333505"/>
             <a:ext cx="1052513" cy="266691"/>
           </a:xfrm>
           <a:prstGeom prst="rect">
@@ -1210,7 +1210,7 @@
         </p:blipFill>
         <p:spPr>
           <a:xfrm>
-            <a:off x="6538913" y="1644673"/>
+            <a:off x="6538913" y="1384323"/>
             <a:ext cx="232767" cy="165053"/>
           </a:xfrm>
           <a:prstGeom prst="rect">
@@ -1234,7 +1234,7 @@
         </p:blipFill>
         <p:spPr>
           <a:xfrm>
-            <a:off x="6822480" y="1644650"/>
+            <a:off x="6822480" y="1384300"/>
             <a:ext cx="415925" cy="165100"/>
           </a:xfrm>
           <a:prstGeom prst="rect">
@@ -1258,7 +1258,7 @@
         </p:blipFill>
         <p:spPr>
           <a:xfrm>
-            <a:off x="10045105" y="1619255"/>
+            <a:off x="10045105" y="1358905"/>
             <a:ext cx="878979" cy="215890"/>
           </a:xfrm>
           <a:prstGeom prst="rect">
@@ -1282,7 +1282,7 @@
         </p:blipFill>
         <p:spPr>
           <a:xfrm>
-            <a:off x="10987584" y="1600206"/>
+            <a:off x="10987584" y="1339856"/>
             <a:ext cx="236141" cy="253988"/>
           </a:xfrm>
           <a:prstGeom prst="rect">
@@ -1306,7 +1306,7 @@
         </p:blipFill>
         <p:spPr>
           <a:xfrm>
-            <a:off x="11274524" y="1600228"/>
+            <a:off x="11274524" y="1339878"/>
             <a:ext cx="308471" cy="253943"/>
           </a:xfrm>
           <a:prstGeom prst="rect">
@@ -1330,7 +1330,7 @@
         </p:blipFill>
         <p:spPr>
           <a:xfrm>
-            <a:off x="5473700" y="2362208"/>
+            <a:off x="5473700" y="2032008"/>
             <a:ext cx="1168797" cy="266683"/>
           </a:xfrm>
           <a:prstGeom prst="rect">
@@ -1354,8 +1354,8 @@
         </p:blipFill>
         <p:spPr>
           <a:xfrm>
-            <a:off x="6324600" y="2736891"/>
-            <a:ext cx="3476923" cy="3174918"/>
+            <a:off x="6324600" y="2317773"/>
+            <a:ext cx="3129260" cy="2857454"/>
           </a:xfrm>
           <a:prstGeom prst="rect">
             <a:avLst/>
@@ -1378,8 +1378,8 @@
         </p:blipFill>
         <p:spPr>
           <a:xfrm>
-            <a:off x="10024227" y="3216176"/>
-            <a:ext cx="342090" cy="254695"/>
+            <a:off x="9999013" y="2779713"/>
+            <a:ext cx="354617" cy="264021"/>
           </a:xfrm>
           <a:prstGeom prst="rect">
             <a:avLst/>
@@ -1402,8 +1402,8 @@
         </p:blipFill>
         <p:spPr>
           <a:xfrm>
-            <a:off x="10385452" y="3211810"/>
-            <a:ext cx="342151" cy="263426"/>
+            <a:off x="10372753" y="2775248"/>
+            <a:ext cx="354651" cy="273050"/>
           </a:xfrm>
           <a:prstGeom prst="rect">
             <a:avLst/>
@@ -1426,8 +1426,8 @@
         </p:blipFill>
         <p:spPr>
           <a:xfrm>
-            <a:off x="10900507" y="3194645"/>
-            <a:ext cx="342130" cy="297855"/>
+            <a:off x="10900688" y="2757388"/>
+            <a:ext cx="354667" cy="308769"/>
           </a:xfrm>
           <a:prstGeom prst="rect">
             <a:avLst/>
@@ -1450,8 +1450,8 @@
         </p:blipFill>
         <p:spPr>
           <a:xfrm>
-            <a:off x="11261727" y="3199606"/>
-            <a:ext cx="342202" cy="287834"/>
+            <a:off x="11274426" y="2762548"/>
+            <a:ext cx="354706" cy="298351"/>
           </a:xfrm>
           <a:prstGeom prst="rect">
             <a:avLst/>
@@ -1474,8 +1474,8 @@
         </p:blipFill>
         <p:spPr>
           <a:xfrm>
-            <a:off x="10017156" y="4686102"/>
-            <a:ext cx="647539" cy="711101"/>
+            <a:off x="10103374" y="4165402"/>
+            <a:ext cx="462502" cy="507901"/>
           </a:xfrm>
           <a:prstGeom prst="rect">
             <a:avLst/>
@@ -1498,8 +1498,8 @@
         </p:blipFill>
         <p:spPr>
           <a:xfrm>
-            <a:off x="10960133" y="4801989"/>
-            <a:ext cx="653985" cy="479425"/>
+            <a:off x="10960121" y="4175026"/>
+            <a:ext cx="666707" cy="488752"/>
           </a:xfrm>
           <a:prstGeom prst="rect">
             <a:avLst/>
@@ -1514,8 +1514,8 @@
         </p:nvSpPr>
         <p:spPr>
           <a:xfrm>
-            <a:off x="1473200" y="355918"/>
-            <a:ext cx="7491799" cy="386715"/>
+            <a:off x="1358900" y="279273"/>
+            <a:ext cx="6911548" cy="355755"/>
           </a:xfrm>
           <a:prstGeom prst="rect">
             <a:avLst/>
@@ -1531,7 +1531,7 @@
               <a:buNone/>
             </a:pPr>
             <a:r>
-              <a:rPr lang="en-US" sz="2500" b="1" spc="50" kern="0" dirty="0">
+              <a:rPr lang="en-US" sz="2300" b="1" spc="50" kern="0" dirty="0">
                 <a:solidFill>
                   <a:srgbClr val="FFFFFF"/>
                 </a:solidFill>
@@ -1545,7 +1545,7 @@
               <a:buNone/>
             </a:pPr>
             <a:r>
-              <a:rPr lang="en-US" sz="2500" b="1" spc="50" kern="0" dirty="0">
+              <a:rPr lang="en-US" sz="2300" b="1" spc="50" kern="0" dirty="0">
                 <a:solidFill>
                   <a:srgbClr val="8ED14F"/>
                 </a:solidFill>
@@ -1555,7 +1555,7 @@
               </a:rPr>
               <a:t>THĂNG LONG QUỐC TẾ</a:t>
             </a:r>
-            <a:endParaRPr lang="en-US" sz="2500" dirty="0"/>
+            <a:endParaRPr lang="en-US" sz="2300" dirty="0"/>
           </a:p>
         </p:txBody>
       </p:sp>
@@ -1567,8 +1567,8 @@
         </p:nvSpPr>
         <p:spPr>
           <a:xfrm>
-            <a:off x="1473200" y="772350"/>
-            <a:ext cx="7491799" cy="287274"/>
+            <a:off x="1358900" y="644021"/>
+            <a:ext cx="6911548" cy="250444"/>
           </a:xfrm>
           <a:prstGeom prst="rect">
             <a:avLst/>
@@ -1584,7 +1584,7 @@
               <a:buNone/>
             </a:pPr>
             <a:r>
-              <a:rPr lang="en-US" sz="1700" b="1" i="1" spc="25" kern="0" dirty="0">
+              <a:rPr lang="en-US" sz="1500" b="1" i="1" spc="25" kern="0" dirty="0">
                 <a:solidFill>
                   <a:srgbClr val="CFE6FF"/>
                 </a:solidFill>
@@ -1594,7 +1594,7 @@
               </a:rPr>
               <a:t>Kết nối công nghệ, Kiến tạo giá trị</a:t>
             </a:r>
-            <a:endParaRPr lang="en-US" sz="1700" dirty="0"/>
+            <a:endParaRPr lang="en-US" sz="1500" dirty="0"/>
           </a:p>
         </p:txBody>
       </p:sp>
@@ -1606,8 +1606,8 @@
         </p:nvSpPr>
         <p:spPr>
           <a:xfrm>
-            <a:off x="8625086" y="279781"/>
-            <a:ext cx="1848320" cy="132588"/>
+            <a:off x="10360720" y="111252"/>
+            <a:ext cx="1682276" cy="228346"/>
           </a:xfrm>
           <a:prstGeom prst="rect">
             <a:avLst/>
@@ -1623,7 +1623,216 @@
               <a:buNone/>
             </a:pPr>
             <a:r>
-              <a:rPr lang="en-US" sz="800" b="1" spc="150" kern="0" dirty="0">
+              <a:rPr lang="en-US" sz="1000" b="1" dirty="0">
+                <a:solidFill>
+                  <a:srgbClr val="FFFFFF"/>
+                </a:solidFill>
+                <a:latin typeface="Arial" pitchFamily="34" charset="0"/>
+                <a:ea typeface="Arial" pitchFamily="34" charset="-122"/>
+                <a:cs typeface="Arial" pitchFamily="34" charset="-120"/>
+              </a:rPr>
+              <a:t>Hotline </a:t>
+            </a:r>
+            <a:pPr algn="l" indent="0" marL="0">
+              <a:buNone/>
+            </a:pPr>
+            <a:r>
+              <a:rPr lang="en-US" sz="1000" b="1" dirty="0">
+                <a:solidFill>
+                  <a:srgbClr val="8ED14F"/>
+                </a:solidFill>
+                <a:latin typeface="Arial" pitchFamily="34" charset="0"/>
+                <a:ea typeface="Arial" pitchFamily="34" charset="-122"/>
+                <a:cs typeface="Arial" pitchFamily="34" charset="-120"/>
+              </a:rPr>
+              <a:t>0916 899 322</a:t>
+            </a:r>
+            <a:endParaRPr lang="en-US" sz="1000" dirty="0"/>
+          </a:p>
+        </p:txBody>
+      </p:sp>
+      <p:sp>
+        <p:nvSpPr>
+          <p:cNvPr id="31" name="Text 3"/>
+          <p:cNvSpPr txBox="1"/>
+          <p:nvPr/>
+        </p:nvSpPr>
+        <p:spPr>
+          <a:xfrm>
+            <a:off x="9414867" y="925830"/>
+            <a:ext cx="439317" cy="110490"/>
+          </a:xfrm>
+          <a:prstGeom prst="rect">
+            <a:avLst/>
+          </a:prstGeom>
+          <a:noFill/>
+          <a:ln/>
+        </p:spPr>
+        <p:txBody>
+          <a:bodyPr wrap="square" lIns="0" tIns="0" rIns="0" bIns="0" rtlCol="0" anchor="ctr"/>
+          <a:lstStyle/>
+          <a:p>
+            <a:pPr algn="l" indent="0" marL="0">
+              <a:buNone/>
+            </a:pPr>
+            <a:r>
+              <a:rPr lang="en-US" sz="650" b="1" dirty="0">
+                <a:solidFill>
+                  <a:srgbClr val="0A3170"/>
+                </a:solidFill>
+                <a:latin typeface="Arial" pitchFamily="34" charset="0"/>
+                <a:ea typeface="Arial" pitchFamily="34" charset="-122"/>
+                <a:cs typeface="Arial" pitchFamily="34" charset="-120"/>
+              </a:rPr>
+              <a:t>Facebook</a:t>
+            </a:r>
+            <a:endParaRPr lang="en-US" sz="650" dirty="0"/>
+          </a:p>
+        </p:txBody>
+      </p:sp>
+      <p:sp>
+        <p:nvSpPr>
+          <p:cNvPr id="32" name="Text 4"/>
+          <p:cNvSpPr txBox="1"/>
+          <p:nvPr/>
+        </p:nvSpPr>
+        <p:spPr>
+          <a:xfrm>
+            <a:off x="10170319" y="925830"/>
+            <a:ext cx="193530" cy="110490"/>
+          </a:xfrm>
+          <a:prstGeom prst="rect">
+            <a:avLst/>
+          </a:prstGeom>
+          <a:noFill/>
+          <a:ln/>
+        </p:spPr>
+        <p:txBody>
+          <a:bodyPr wrap="square" lIns="0" tIns="0" rIns="0" bIns="0" rtlCol="0" anchor="ctr"/>
+          <a:lstStyle/>
+          <a:p>
+            <a:pPr algn="l" indent="0" marL="0">
+              <a:buNone/>
+            </a:pPr>
+            <a:r>
+              <a:rPr lang="en-US" sz="650" b="1" dirty="0">
+                <a:solidFill>
+                  <a:srgbClr val="0A3170"/>
+                </a:solidFill>
+                <a:latin typeface="Arial" pitchFamily="34" charset="0"/>
+                <a:ea typeface="Arial" pitchFamily="34" charset="-122"/>
+                <a:cs typeface="Arial" pitchFamily="34" charset="-120"/>
+              </a:rPr>
+              <a:t>Zalo</a:t>
+            </a:r>
+            <a:endParaRPr lang="en-US" sz="650" dirty="0"/>
+          </a:p>
+        </p:txBody>
+      </p:sp>
+      <p:sp>
+        <p:nvSpPr>
+          <p:cNvPr id="33" name="Text 5"/>
+          <p:cNvSpPr txBox="1"/>
+          <p:nvPr/>
+        </p:nvSpPr>
+        <p:spPr>
+          <a:xfrm>
+            <a:off x="10773668" y="925830"/>
+            <a:ext cx="294650" cy="110490"/>
+          </a:xfrm>
+          <a:prstGeom prst="rect">
+            <a:avLst/>
+          </a:prstGeom>
+          <a:noFill/>
+          <a:ln/>
+        </p:spPr>
+        <p:txBody>
+          <a:bodyPr wrap="square" lIns="0" tIns="0" rIns="0" bIns="0" rtlCol="0" anchor="ctr"/>
+          <a:lstStyle/>
+          <a:p>
+            <a:pPr algn="l" indent="0" marL="0">
+              <a:buNone/>
+            </a:pPr>
+            <a:r>
+              <a:rPr lang="en-US" sz="650" b="1" dirty="0">
+                <a:solidFill>
+                  <a:srgbClr val="0A3170"/>
+                </a:solidFill>
+                <a:latin typeface="Arial" pitchFamily="34" charset="0"/>
+                <a:ea typeface="Arial" pitchFamily="34" charset="-122"/>
+                <a:cs typeface="Arial" pitchFamily="34" charset="-120"/>
+              </a:rPr>
+              <a:t>TikTok</a:t>
+            </a:r>
+            <a:endParaRPr lang="en-US" sz="650" dirty="0"/>
+          </a:p>
+        </p:txBody>
+      </p:sp>
+      <p:sp>
+        <p:nvSpPr>
+          <p:cNvPr id="34" name="Text 6"/>
+          <p:cNvSpPr txBox="1"/>
+          <p:nvPr/>
+        </p:nvSpPr>
+        <p:spPr>
+          <a:xfrm>
+            <a:off x="11353304" y="925830"/>
+            <a:ext cx="449836" cy="110490"/>
+          </a:xfrm>
+          <a:prstGeom prst="rect">
+            <a:avLst/>
+          </a:prstGeom>
+          <a:noFill/>
+          <a:ln/>
+        </p:spPr>
+        <p:txBody>
+          <a:bodyPr wrap="square" lIns="0" tIns="0" rIns="0" bIns="0" rtlCol="0" anchor="ctr"/>
+          <a:lstStyle/>
+          <a:p>
+            <a:pPr algn="l" indent="0" marL="0">
+              <a:buNone/>
+            </a:pPr>
+            <a:r>
+              <a:rPr lang="en-US" sz="650" b="1" dirty="0">
+                <a:solidFill>
+                  <a:srgbClr val="0A3170"/>
+                </a:solidFill>
+                <a:latin typeface="Arial" pitchFamily="34" charset="0"/>
+                <a:ea typeface="Arial" pitchFamily="34" charset="-122"/>
+                <a:cs typeface="Arial" pitchFamily="34" charset="-120"/>
+              </a:rPr>
+              <a:t>Instagram</a:t>
+            </a:r>
+            <a:endParaRPr lang="en-US" sz="650" dirty="0"/>
+          </a:p>
+        </p:txBody>
+      </p:sp>
+      <p:sp>
+        <p:nvSpPr>
+          <p:cNvPr id="35" name="Text 7"/>
+          <p:cNvSpPr txBox="1"/>
+          <p:nvPr/>
+        </p:nvSpPr>
+        <p:spPr>
+          <a:xfrm>
+            <a:off x="222123" y="1810766"/>
+            <a:ext cx="4965954" cy="169418"/>
+          </a:xfrm>
+          <a:prstGeom prst="rect">
+            <a:avLst/>
+          </a:prstGeom>
+          <a:noFill/>
+          <a:ln/>
+        </p:spPr>
+        <p:txBody>
+          <a:bodyPr wrap="square" lIns="0" tIns="0" rIns="0" bIns="0" rtlCol="0" anchor="ctr"/>
+          <a:lstStyle/>
+          <a:p>
+            <a:pPr algn="ctr" indent="0" marL="0">
+              <a:buNone/>
+            </a:pPr>
+            <a:r>
+              <a:rPr lang="en-US" sz="1000" b="1" spc="75" kern="0" dirty="0">
                 <a:solidFill>
                   <a:srgbClr val="CFE6FF"/>
                 </a:solidFill>
@@ -1631,22 +1840,22 @@
                 <a:ea typeface="Arial" pitchFamily="34" charset="-122"/>
                 <a:cs typeface="Arial" pitchFamily="34" charset="-120"/>
               </a:rPr>
-              <a:t>KẾT NỐI VỚI CHÚNG TÔI</a:t>
-            </a:r>
-            <a:endParaRPr lang="en-US" sz="800" dirty="0"/>
-          </a:p>
-        </p:txBody>
-      </p:sp>
-      <p:sp>
-        <p:nvSpPr>
-          <p:cNvPr id="31" name="Text 3"/>
-          <p:cNvSpPr txBox="1"/>
-          <p:nvPr/>
-        </p:nvSpPr>
-        <p:spPr>
-          <a:xfrm>
-            <a:off x="10360720" y="231902"/>
-            <a:ext cx="1682276" cy="228346"/>
+              <a:t>VẬT LIỆU XƯƠNG SINH HỌC COLLAGEN KHOÁNG HÓA</a:t>
+            </a:r>
+            <a:endParaRPr lang="en-US" sz="1000" dirty="0"/>
+          </a:p>
+        </p:txBody>
+      </p:sp>
+      <p:sp>
+        <p:nvSpPr>
+          <p:cNvPr id="36" name="Text 8"/>
+          <p:cNvSpPr txBox="1"/>
+          <p:nvPr/>
+        </p:nvSpPr>
+        <p:spPr>
+          <a:xfrm>
+            <a:off x="1534616" y="2002028"/>
+            <a:ext cx="2972627" cy="250444"/>
           </a:xfrm>
           <a:prstGeom prst="rect">
             <a:avLst/>
@@ -1662,7 +1871,7 @@
               <a:buNone/>
             </a:pPr>
             <a:r>
-              <a:rPr lang="en-US" sz="1000" b="1" dirty="0">
+              <a:rPr lang="en-US" sz="1500" b="1" dirty="0">
                 <a:solidFill>
                   <a:srgbClr val="FFFFFF"/>
                 </a:solidFill>
@@ -1670,13 +1879,13 @@
                 <a:ea typeface="Arial" pitchFamily="34" charset="-122"/>
                 <a:cs typeface="Arial" pitchFamily="34" charset="-120"/>
               </a:rPr>
-              <a:t>Hotline </a:t>
+              <a:t>Đạt chứng nhận </a:t>
             </a:r>
             <a:pPr algn="l" indent="0" marL="0">
               <a:buNone/>
             </a:pPr>
             <a:r>
-              <a:rPr lang="en-US" sz="1000" b="1" dirty="0">
+              <a:rPr lang="en-US" sz="1500" b="1" dirty="0">
                 <a:solidFill>
                   <a:srgbClr val="8ED14F"/>
                 </a:solidFill>
@@ -1684,22 +1893,22 @@
                 <a:ea typeface="Arial" pitchFamily="34" charset="-122"/>
                 <a:cs typeface="Arial" pitchFamily="34" charset="-120"/>
               </a:rPr>
-              <a:t>0916 899 322</a:t>
-            </a:r>
-            <a:endParaRPr lang="en-US" sz="1000" dirty="0"/>
-          </a:p>
-        </p:txBody>
-      </p:sp>
-      <p:sp>
-        <p:nvSpPr>
-          <p:cNvPr id="32" name="Text 4"/>
-          <p:cNvSpPr txBox="1"/>
-          <p:nvPr/>
-        </p:nvSpPr>
-        <p:spPr>
-          <a:xfrm>
-            <a:off x="9414867" y="1046480"/>
-            <a:ext cx="439317" cy="110490"/>
+              <a:t>FDA Hoa Kỳ</a:t>
+            </a:r>
+            <a:endParaRPr lang="en-US" sz="1500" dirty="0"/>
+          </a:p>
+        </p:txBody>
+      </p:sp>
+      <p:sp>
+        <p:nvSpPr>
+          <p:cNvPr id="37" name="Text 9"/>
+          <p:cNvSpPr txBox="1"/>
+          <p:nvPr/>
+        </p:nvSpPr>
+        <p:spPr>
+          <a:xfrm>
+            <a:off x="1216521" y="2256028"/>
+            <a:ext cx="3697885" cy="250444"/>
           </a:xfrm>
           <a:prstGeom prst="rect">
             <a:avLst/>
@@ -1715,7 +1924,710 @@
               <a:buNone/>
             </a:pPr>
             <a:r>
-              <a:rPr lang="en-US" sz="650" b="1" dirty="0">
+              <a:rPr lang="en-US" sz="1500" b="1" dirty="0">
+                <a:solidFill>
+                  <a:srgbClr val="FFFFFF"/>
+                </a:solidFill>
+                <a:latin typeface="Arial" pitchFamily="34" charset="0"/>
+                <a:ea typeface="Arial" pitchFamily="34" charset="-122"/>
+                <a:cs typeface="Arial" pitchFamily="34" charset="-120"/>
+              </a:rPr>
+              <a:t>Tương đồng cao với </a:t>
+            </a:r>
+            <a:pPr algn="l" indent="0" marL="0">
+              <a:buNone/>
+            </a:pPr>
+            <a:r>
+              <a:rPr lang="en-US" sz="1500" b="1" dirty="0">
+                <a:solidFill>
+                  <a:srgbClr val="8ED14F"/>
+                </a:solidFill>
+                <a:latin typeface="Arial" pitchFamily="34" charset="0"/>
+                <a:ea typeface="Arial" pitchFamily="34" charset="-122"/>
+                <a:cs typeface="Arial" pitchFamily="34" charset="-120"/>
+              </a:rPr>
+              <a:t>xương tự thân</a:t>
+            </a:r>
+            <a:endParaRPr lang="en-US" sz="1500" dirty="0"/>
+          </a:p>
+        </p:txBody>
+      </p:sp>
+      <p:sp>
+        <p:nvSpPr>
+          <p:cNvPr id="38" name="Text 10"/>
+          <p:cNvSpPr txBox="1"/>
+          <p:nvPr/>
+        </p:nvSpPr>
+        <p:spPr>
+          <a:xfrm>
+            <a:off x="749333" y="3231630"/>
+            <a:ext cx="1015835" cy="383032"/>
+          </a:xfrm>
+          <a:prstGeom prst="rect">
+            <a:avLst/>
+          </a:prstGeom>
+          <a:noFill/>
+          <a:ln/>
+        </p:spPr>
+        <p:txBody>
+          <a:bodyPr wrap="square" lIns="0" tIns="0" rIns="0" bIns="0" rtlCol="0" anchor="ctr"/>
+          <a:lstStyle/>
+          <a:p>
+            <a:pPr algn="ctr" indent="0" marL="0">
+              <a:buNone/>
+            </a:pPr>
+            <a:r>
+              <a:rPr lang="en-US" sz="1100" b="1" dirty="0">
+                <a:solidFill>
+                  <a:srgbClr val="FFFFFF"/>
+                </a:solidFill>
+                <a:latin typeface="Arial" pitchFamily="34" charset="0"/>
+                <a:ea typeface="Arial" pitchFamily="34" charset="-122"/>
+                <a:cs typeface="Arial" pitchFamily="34" charset="-120"/>
+              </a:rPr>
+              <a:t>Chấn thương</a:t>
+            </a:r>
+            <a:endParaRPr lang="en-US" sz="1100" dirty="0"/>
+          </a:p>
+          <a:p>
+            <a:pPr algn="ctr" indent="0" marL="0">
+              <a:buNone/>
+            </a:pPr>
+            <a:r>
+              <a:rPr lang="en-US" sz="1100" b="1" dirty="0">
+                <a:solidFill>
+                  <a:srgbClr val="FFFFFF"/>
+                </a:solidFill>
+                <a:latin typeface="Arial" pitchFamily="34" charset="0"/>
+                <a:ea typeface="Arial" pitchFamily="34" charset="-122"/>
+                <a:cs typeface="Arial" pitchFamily="34" charset="-120"/>
+              </a:rPr>
+              <a:t>chỉnh hình</a:t>
+            </a:r>
+            <a:endParaRPr lang="en-US" sz="1100" dirty="0"/>
+          </a:p>
+        </p:txBody>
+      </p:sp>
+      <p:sp>
+        <p:nvSpPr>
+          <p:cNvPr id="39" name="Text 11"/>
+          <p:cNvSpPr txBox="1"/>
+          <p:nvPr/>
+        </p:nvSpPr>
+        <p:spPr>
+          <a:xfrm>
+            <a:off x="3555683" y="4731730"/>
+            <a:ext cx="1194435" cy="191516"/>
+          </a:xfrm>
+          <a:prstGeom prst="rect">
+            <a:avLst/>
+          </a:prstGeom>
+          <a:noFill/>
+          <a:ln/>
+        </p:spPr>
+        <p:txBody>
+          <a:bodyPr wrap="square" lIns="0" tIns="0" rIns="0" bIns="0" rtlCol="0" anchor="ctr"/>
+          <a:lstStyle/>
+          <a:p>
+            <a:pPr algn="ctr" indent="0" marL="0">
+              <a:buNone/>
+            </a:pPr>
+            <a:r>
+              <a:rPr lang="en-US" sz="1100" b="1" dirty="0">
+                <a:solidFill>
+                  <a:srgbClr val="FFFFFF"/>
+                </a:solidFill>
+                <a:latin typeface="Arial" pitchFamily="34" charset="0"/>
+                <a:ea typeface="Arial" pitchFamily="34" charset="-122"/>
+                <a:cs typeface="Arial" pitchFamily="34" charset="-120"/>
+              </a:rPr>
+              <a:t>Ngoại thần kinh</a:t>
+            </a:r>
+            <a:endParaRPr lang="en-US" sz="1100" dirty="0"/>
+          </a:p>
+        </p:txBody>
+      </p:sp>
+      <p:sp>
+        <p:nvSpPr>
+          <p:cNvPr id="40" name="Text 12"/>
+          <p:cNvSpPr txBox="1"/>
+          <p:nvPr/>
+        </p:nvSpPr>
+        <p:spPr>
+          <a:xfrm>
+            <a:off x="502076" y="5409803"/>
+            <a:ext cx="1544282" cy="218678"/>
+          </a:xfrm>
+          <a:prstGeom prst="rect">
+            <a:avLst/>
+          </a:prstGeom>
+          <a:noFill/>
+          <a:ln/>
+        </p:spPr>
+        <p:txBody>
+          <a:bodyPr wrap="square" lIns="0" tIns="0" rIns="0" bIns="0" rtlCol="0" anchor="ctr"/>
+          <a:lstStyle/>
+          <a:p>
+            <a:pPr algn="ctr" indent="0" marL="0">
+              <a:buNone/>
+            </a:pPr>
+            <a:r>
+              <a:rPr lang="en-US" sz="1350" b="1" dirty="0">
+                <a:solidFill>
+                  <a:srgbClr val="8ED14F"/>
+                </a:solidFill>
+                <a:latin typeface="Arial" pitchFamily="34" charset="0"/>
+                <a:ea typeface="Arial" pitchFamily="34" charset="-122"/>
+                <a:cs typeface="Arial" pitchFamily="34" charset="-120"/>
+              </a:rPr>
+              <a:t>45 : 55</a:t>
+            </a:r>
+            <a:endParaRPr lang="en-US" sz="1350" dirty="0"/>
+          </a:p>
+        </p:txBody>
+      </p:sp>
+      <p:sp>
+        <p:nvSpPr>
+          <p:cNvPr id="41" name="Text 13"/>
+          <p:cNvSpPr txBox="1"/>
+          <p:nvPr/>
+        </p:nvSpPr>
+        <p:spPr>
+          <a:xfrm>
+            <a:off x="502076" y="5623814"/>
+            <a:ext cx="1544282" cy="125222"/>
+          </a:xfrm>
+          <a:prstGeom prst="rect">
+            <a:avLst/>
+          </a:prstGeom>
+          <a:noFill/>
+          <a:ln/>
+        </p:spPr>
+        <p:txBody>
+          <a:bodyPr wrap="square" lIns="0" tIns="0" rIns="0" bIns="0" rtlCol="0" anchor="ctr"/>
+          <a:lstStyle/>
+          <a:p>
+            <a:pPr algn="ctr" indent="0" marL="0">
+              <a:buNone/>
+            </a:pPr>
+            <a:r>
+              <a:rPr lang="en-US" sz="750" dirty="0">
+                <a:solidFill>
+                  <a:srgbClr val="CFE6FF"/>
+                </a:solidFill>
+                <a:latin typeface="Arial" pitchFamily="34" charset="0"/>
+                <a:ea typeface="Arial" pitchFamily="34" charset="-122"/>
+                <a:cs typeface="Arial" pitchFamily="34" charset="-120"/>
+              </a:rPr>
+              <a:t>Collagen I : nano-HA</a:t>
+            </a:r>
+            <a:endParaRPr lang="en-US" sz="750" dirty="0"/>
+          </a:p>
+        </p:txBody>
+      </p:sp>
+      <p:sp>
+        <p:nvSpPr>
+          <p:cNvPr id="42" name="Text 14"/>
+          <p:cNvSpPr txBox="1"/>
+          <p:nvPr/>
+        </p:nvSpPr>
+        <p:spPr>
+          <a:xfrm>
+            <a:off x="1939704" y="5409803"/>
+            <a:ext cx="1537043" cy="218678"/>
+          </a:xfrm>
+          <a:prstGeom prst="rect">
+            <a:avLst/>
+          </a:prstGeom>
+          <a:noFill/>
+          <a:ln/>
+        </p:spPr>
+        <p:txBody>
+          <a:bodyPr wrap="square" lIns="0" tIns="0" rIns="0" bIns="0" rtlCol="0" anchor="ctr"/>
+          <a:lstStyle/>
+          <a:p>
+            <a:pPr algn="ctr" indent="0" marL="0">
+              <a:buNone/>
+            </a:pPr>
+            <a:r>
+              <a:rPr lang="en-US" sz="1350" b="1" dirty="0">
+                <a:solidFill>
+                  <a:srgbClr val="8ED14F"/>
+                </a:solidFill>
+                <a:latin typeface="Arial" pitchFamily="34" charset="0"/>
+                <a:ea typeface="Arial" pitchFamily="34" charset="-122"/>
+                <a:cs typeface="Arial" pitchFamily="34" charset="-120"/>
+              </a:rPr>
+              <a:t>70–80%</a:t>
+            </a:r>
+            <a:endParaRPr lang="en-US" sz="1350" dirty="0"/>
+          </a:p>
+        </p:txBody>
+      </p:sp>
+      <p:sp>
+        <p:nvSpPr>
+          <p:cNvPr id="43" name="Text 15"/>
+          <p:cNvSpPr txBox="1"/>
+          <p:nvPr/>
+        </p:nvSpPr>
+        <p:spPr>
+          <a:xfrm>
+            <a:off x="1939704" y="5623814"/>
+            <a:ext cx="1537043" cy="125222"/>
+          </a:xfrm>
+          <a:prstGeom prst="rect">
+            <a:avLst/>
+          </a:prstGeom>
+          <a:noFill/>
+          <a:ln/>
+        </p:spPr>
+        <p:txBody>
+          <a:bodyPr wrap="square" lIns="0" tIns="0" rIns="0" bIns="0" rtlCol="0" anchor="ctr"/>
+          <a:lstStyle/>
+          <a:p>
+            <a:pPr algn="ctr" indent="0" marL="0">
+              <a:buNone/>
+            </a:pPr>
+            <a:r>
+              <a:rPr lang="en-US" sz="750" dirty="0">
+                <a:solidFill>
+                  <a:srgbClr val="CFE6FF"/>
+                </a:solidFill>
+                <a:latin typeface="Arial" pitchFamily="34" charset="0"/>
+                <a:ea typeface="Arial" pitchFamily="34" charset="-122"/>
+                <a:cs typeface="Arial" pitchFamily="34" charset="-120"/>
+              </a:rPr>
+              <a:t>Độ xốp</a:t>
+            </a:r>
+            <a:endParaRPr lang="en-US" sz="750" dirty="0"/>
+          </a:p>
+        </p:txBody>
+      </p:sp>
+      <p:sp>
+        <p:nvSpPr>
+          <p:cNvPr id="44" name="Text 16"/>
+          <p:cNvSpPr txBox="1"/>
+          <p:nvPr/>
+        </p:nvSpPr>
+        <p:spPr>
+          <a:xfrm>
+            <a:off x="3370537" y="5409803"/>
+            <a:ext cx="1537043" cy="218678"/>
+          </a:xfrm>
+          <a:prstGeom prst="rect">
+            <a:avLst/>
+          </a:prstGeom>
+          <a:noFill/>
+          <a:ln/>
+        </p:spPr>
+        <p:txBody>
+          <a:bodyPr wrap="square" lIns="0" tIns="0" rIns="0" bIns="0" rtlCol="0" anchor="ctr"/>
+          <a:lstStyle/>
+          <a:p>
+            <a:pPr algn="ctr" indent="0" marL="0">
+              <a:buNone/>
+            </a:pPr>
+            <a:r>
+              <a:rPr lang="en-US" sz="1350" b="1" dirty="0">
+                <a:solidFill>
+                  <a:srgbClr val="8ED14F"/>
+                </a:solidFill>
+                <a:latin typeface="Arial" pitchFamily="34" charset="0"/>
+                <a:ea typeface="Arial" pitchFamily="34" charset="-122"/>
+                <a:cs typeface="Arial" pitchFamily="34" charset="-120"/>
+              </a:rPr>
+              <a:t>&gt;200.000</a:t>
+            </a:r>
+            <a:endParaRPr lang="en-US" sz="1350" dirty="0"/>
+          </a:p>
+        </p:txBody>
+      </p:sp>
+      <p:sp>
+        <p:nvSpPr>
+          <p:cNvPr id="45" name="Text 17"/>
+          <p:cNvSpPr txBox="1"/>
+          <p:nvPr/>
+        </p:nvSpPr>
+        <p:spPr>
+          <a:xfrm>
+            <a:off x="3370537" y="5623814"/>
+            <a:ext cx="1537043" cy="125222"/>
+          </a:xfrm>
+          <a:prstGeom prst="rect">
+            <a:avLst/>
+          </a:prstGeom>
+          <a:noFill/>
+          <a:ln/>
+        </p:spPr>
+        <p:txBody>
+          <a:bodyPr wrap="square" lIns="0" tIns="0" rIns="0" bIns="0" rtlCol="0" anchor="ctr"/>
+          <a:lstStyle/>
+          <a:p>
+            <a:pPr algn="ctr" indent="0" marL="0">
+              <a:buNone/>
+            </a:pPr>
+            <a:r>
+              <a:rPr lang="en-US" sz="750" dirty="0">
+                <a:solidFill>
+                  <a:srgbClr val="CFE6FF"/>
+                </a:solidFill>
+                <a:latin typeface="Arial" pitchFamily="34" charset="0"/>
+                <a:ea typeface="Arial" pitchFamily="34" charset="-122"/>
+                <a:cs typeface="Arial" pitchFamily="34" charset="-120"/>
+              </a:rPr>
+              <a:t>Ca lâm sàng</a:t>
+            </a:r>
+            <a:endParaRPr lang="en-US" sz="750" dirty="0"/>
+          </a:p>
+        </p:txBody>
+      </p:sp>
+      <p:sp>
+        <p:nvSpPr>
+          <p:cNvPr id="46" name="Text 18"/>
+          <p:cNvSpPr txBox="1"/>
+          <p:nvPr/>
+        </p:nvSpPr>
+        <p:spPr>
+          <a:xfrm>
+            <a:off x="5069840" y="1802384"/>
+            <a:ext cx="4922520" cy="198882"/>
+          </a:xfrm>
+          <a:prstGeom prst="rect">
+            <a:avLst/>
+          </a:prstGeom>
+          <a:noFill/>
+          <a:ln/>
+        </p:spPr>
+        <p:txBody>
+          <a:bodyPr wrap="square" lIns="0" tIns="0" rIns="0" bIns="0" rtlCol="0" anchor="ctr"/>
+          <a:lstStyle/>
+          <a:p>
+            <a:pPr algn="ctr" indent="0" marL="0">
+              <a:buNone/>
+            </a:pPr>
+            <a:r>
+              <a:rPr lang="en-US" sz="1150" b="1" spc="25" kern="0" dirty="0">
+                <a:solidFill>
+                  <a:srgbClr val="FFFFFF"/>
+                </a:solidFill>
+                <a:latin typeface="Arial" pitchFamily="34" charset="0"/>
+                <a:ea typeface="Arial" pitchFamily="34" charset="-122"/>
+                <a:cs typeface="Arial" pitchFamily="34" charset="-120"/>
+              </a:rPr>
+              <a:t>GIẢI PHÁP TÍCH HỢP CHO </a:t>
+            </a:r>
+            <a:pPr algn="ctr" indent="0" marL="0">
+              <a:buNone/>
+            </a:pPr>
+            <a:r>
+              <a:rPr lang="en-US" sz="1150" b="1" spc="25" kern="0" dirty="0">
+                <a:solidFill>
+                  <a:srgbClr val="8ED14F"/>
+                </a:solidFill>
+                <a:latin typeface="Arial" pitchFamily="34" charset="0"/>
+                <a:ea typeface="Arial" pitchFamily="34" charset="-122"/>
+                <a:cs typeface="Arial" pitchFamily="34" charset="-120"/>
+              </a:rPr>
+              <a:t>PHẪU THUẬT CỘT SỐNG</a:t>
+            </a:r>
+            <a:endParaRPr lang="en-US" sz="1150" dirty="0"/>
+          </a:p>
+        </p:txBody>
+      </p:sp>
+      <p:sp>
+        <p:nvSpPr>
+          <p:cNvPr id="47" name="Text 19"/>
+          <p:cNvSpPr txBox="1"/>
+          <p:nvPr/>
+        </p:nvSpPr>
+        <p:spPr>
+          <a:xfrm>
+            <a:off x="7029450" y="2038096"/>
+            <a:ext cx="241300" cy="279908"/>
+          </a:xfrm>
+          <a:prstGeom prst="rect">
+            <a:avLst/>
+          </a:prstGeom>
+          <a:noFill/>
+          <a:ln/>
+        </p:spPr>
+        <p:txBody>
+          <a:bodyPr wrap="square" lIns="0" tIns="0" rIns="0" bIns="0" rtlCol="0" anchor="ctr"/>
+          <a:lstStyle/>
+          <a:p>
+            <a:pPr algn="ctr" indent="0" marL="0">
+              <a:buNone/>
+            </a:pPr>
+            <a:r>
+              <a:rPr lang="en-US" sz="850" b="1" dirty="0">
+                <a:solidFill>
+                  <a:srgbClr val="04122E"/>
+                </a:solidFill>
+                <a:latin typeface="Arial" pitchFamily="34" charset="0"/>
+                <a:ea typeface="Arial" pitchFamily="34" charset="-122"/>
+                <a:cs typeface="Arial" pitchFamily="34" charset="-120"/>
+              </a:rPr>
+              <a:t>01</a:t>
+            </a:r>
+            <a:endParaRPr lang="en-US" sz="850" dirty="0"/>
+          </a:p>
+        </p:txBody>
+      </p:sp>
+      <p:sp>
+        <p:nvSpPr>
+          <p:cNvPr id="48" name="Text 20"/>
+          <p:cNvSpPr txBox="1"/>
+          <p:nvPr/>
+        </p:nvSpPr>
+        <p:spPr>
+          <a:xfrm>
+            <a:off x="7334250" y="2094039"/>
+            <a:ext cx="1458206" cy="167922"/>
+          </a:xfrm>
+          <a:prstGeom prst="rect">
+            <a:avLst/>
+          </a:prstGeom>
+          <a:noFill/>
+          <a:ln/>
+        </p:spPr>
+        <p:txBody>
+          <a:bodyPr wrap="square" lIns="0" tIns="0" rIns="0" bIns="0" rtlCol="0" anchor="ctr"/>
+          <a:lstStyle/>
+          <a:p>
+            <a:pPr algn="l" indent="0" marL="0">
+              <a:buNone/>
+            </a:pPr>
+            <a:r>
+              <a:rPr lang="en-US" sz="950" b="1" dirty="0">
+                <a:solidFill>
+                  <a:srgbClr val="FFFFFF"/>
+                </a:solidFill>
+                <a:latin typeface="Arial" pitchFamily="34" charset="0"/>
+                <a:ea typeface="Arial" pitchFamily="34" charset="-122"/>
+                <a:cs typeface="Arial" pitchFamily="34" charset="-120"/>
+              </a:rPr>
+              <a:t>Giảm phơi nhiễm tia X</a:t>
+            </a:r>
+            <a:endParaRPr lang="en-US" sz="950" dirty="0"/>
+          </a:p>
+        </p:txBody>
+      </p:sp>
+      <p:sp>
+        <p:nvSpPr>
+          <p:cNvPr id="49" name="Text 21"/>
+          <p:cNvSpPr txBox="1"/>
+          <p:nvPr/>
+        </p:nvSpPr>
+        <p:spPr>
+          <a:xfrm>
+            <a:off x="8240514" y="2520696"/>
+            <a:ext cx="241300" cy="279908"/>
+          </a:xfrm>
+          <a:prstGeom prst="rect">
+            <a:avLst/>
+          </a:prstGeom>
+          <a:noFill/>
+          <a:ln/>
+        </p:spPr>
+        <p:txBody>
+          <a:bodyPr wrap="square" lIns="0" tIns="0" rIns="0" bIns="0" rtlCol="0" anchor="ctr"/>
+          <a:lstStyle/>
+          <a:p>
+            <a:pPr algn="ctr" indent="0" marL="0">
+              <a:buNone/>
+            </a:pPr>
+            <a:r>
+              <a:rPr lang="en-US" sz="850" b="1" dirty="0">
+                <a:solidFill>
+                  <a:srgbClr val="04122E"/>
+                </a:solidFill>
+                <a:latin typeface="Arial" pitchFamily="34" charset="0"/>
+                <a:ea typeface="Arial" pitchFamily="34" charset="-122"/>
+                <a:cs typeface="Arial" pitchFamily="34" charset="-120"/>
+              </a:rPr>
+              <a:t>02</a:t>
+            </a:r>
+            <a:endParaRPr lang="en-US" sz="850" dirty="0"/>
+          </a:p>
+        </p:txBody>
+      </p:sp>
+      <p:sp>
+        <p:nvSpPr>
+          <p:cNvPr id="50" name="Text 22"/>
+          <p:cNvSpPr txBox="1"/>
+          <p:nvPr/>
+        </p:nvSpPr>
+        <p:spPr>
+          <a:xfrm>
+            <a:off x="8545314" y="2576639"/>
+            <a:ext cx="1131320" cy="167922"/>
+          </a:xfrm>
+          <a:prstGeom prst="rect">
+            <a:avLst/>
+          </a:prstGeom>
+          <a:noFill/>
+          <a:ln/>
+        </p:spPr>
+        <p:txBody>
+          <a:bodyPr wrap="square" lIns="0" tIns="0" rIns="0" bIns="0" rtlCol="0" anchor="ctr"/>
+          <a:lstStyle/>
+          <a:p>
+            <a:pPr algn="l" indent="0" marL="0">
+              <a:buNone/>
+            </a:pPr>
+            <a:r>
+              <a:rPr lang="en-US" sz="950" b="1" dirty="0">
+                <a:solidFill>
+                  <a:srgbClr val="FFFFFF"/>
+                </a:solidFill>
+                <a:latin typeface="Arial" pitchFamily="34" charset="0"/>
+                <a:ea typeface="Arial" pitchFamily="34" charset="-122"/>
+                <a:cs typeface="Arial" pitchFamily="34" charset="-120"/>
+              </a:rPr>
+              <a:t>Độ chính xác cao</a:t>
+            </a:r>
+            <a:endParaRPr lang="en-US" sz="950" dirty="0"/>
+          </a:p>
+        </p:txBody>
+      </p:sp>
+      <p:sp>
+        <p:nvSpPr>
+          <p:cNvPr id="51" name="Text 23"/>
+          <p:cNvSpPr txBox="1"/>
+          <p:nvPr/>
+        </p:nvSpPr>
+        <p:spPr>
+          <a:xfrm>
+            <a:off x="5441950" y="4293537"/>
+            <a:ext cx="241300" cy="279908"/>
+          </a:xfrm>
+          <a:prstGeom prst="rect">
+            <a:avLst/>
+          </a:prstGeom>
+          <a:noFill/>
+          <a:ln/>
+        </p:spPr>
+        <p:txBody>
+          <a:bodyPr wrap="square" lIns="0" tIns="0" rIns="0" bIns="0" rtlCol="0" anchor="ctr"/>
+          <a:lstStyle/>
+          <a:p>
+            <a:pPr algn="ctr" indent="0" marL="0">
+              <a:buNone/>
+            </a:pPr>
+            <a:r>
+              <a:rPr lang="en-US" sz="850" b="1" dirty="0">
+                <a:solidFill>
+                  <a:srgbClr val="04122E"/>
+                </a:solidFill>
+                <a:latin typeface="Arial" pitchFamily="34" charset="0"/>
+                <a:ea typeface="Arial" pitchFamily="34" charset="-122"/>
+                <a:cs typeface="Arial" pitchFamily="34" charset="-120"/>
+              </a:rPr>
+              <a:t>03</a:t>
+            </a:r>
+            <a:endParaRPr lang="en-US" sz="850" dirty="0"/>
+          </a:p>
+        </p:txBody>
+      </p:sp>
+      <p:sp>
+        <p:nvSpPr>
+          <p:cNvPr id="52" name="Text 24"/>
+          <p:cNvSpPr txBox="1"/>
+          <p:nvPr/>
+        </p:nvSpPr>
+        <p:spPr>
+          <a:xfrm>
+            <a:off x="5746750" y="4181658"/>
+            <a:ext cx="710892" cy="503765"/>
+          </a:xfrm>
+          <a:prstGeom prst="rect">
+            <a:avLst/>
+          </a:prstGeom>
+          <a:noFill/>
+          <a:ln/>
+        </p:spPr>
+        <p:txBody>
+          <a:bodyPr wrap="square" lIns="0" tIns="0" rIns="0" bIns="0" rtlCol="0" anchor="ctr"/>
+          <a:lstStyle/>
+          <a:p>
+            <a:pPr algn="l" indent="0" marL="0">
+              <a:buNone/>
+            </a:pPr>
+            <a:r>
+              <a:rPr lang="en-US" sz="950" b="1" dirty="0">
+                <a:solidFill>
+                  <a:srgbClr val="FFFFFF"/>
+                </a:solidFill>
+                <a:latin typeface="Arial" pitchFamily="34" charset="0"/>
+                <a:ea typeface="Arial" pitchFamily="34" charset="-122"/>
+                <a:cs typeface="Arial" pitchFamily="34" charset="-120"/>
+              </a:rPr>
+              <a:t>Tối ưu hóa</a:t>
+            </a:r>
+            <a:endParaRPr lang="en-US" sz="950" dirty="0"/>
+          </a:p>
+          <a:p>
+            <a:pPr algn="l" indent="0" marL="0">
+              <a:buNone/>
+            </a:pPr>
+            <a:r>
+              <a:rPr lang="en-US" sz="950" b="1" dirty="0">
+                <a:solidFill>
+                  <a:srgbClr val="FFFFFF"/>
+                </a:solidFill>
+                <a:latin typeface="Arial" pitchFamily="34" charset="0"/>
+                <a:ea typeface="Arial" pitchFamily="34" charset="-122"/>
+                <a:cs typeface="Arial" pitchFamily="34" charset="-120"/>
+              </a:rPr>
+              <a:t>quy trình</a:t>
+            </a:r>
+            <a:endParaRPr lang="en-US" sz="950" dirty="0"/>
+          </a:p>
+          <a:p>
+            <a:pPr algn="l" indent="0" marL="0">
+              <a:buNone/>
+            </a:pPr>
+            <a:r>
+              <a:rPr lang="en-US" sz="950" b="1" dirty="0">
+                <a:solidFill>
+                  <a:srgbClr val="FFFFFF"/>
+                </a:solidFill>
+                <a:latin typeface="Arial" pitchFamily="34" charset="0"/>
+                <a:ea typeface="Arial" pitchFamily="34" charset="-122"/>
+                <a:cs typeface="Arial" pitchFamily="34" charset="-120"/>
+              </a:rPr>
+              <a:t>phẫu thuật</a:t>
+            </a:r>
+            <a:endParaRPr lang="en-US" sz="950" dirty="0"/>
+          </a:p>
+        </p:txBody>
+      </p:sp>
+      <p:sp>
+        <p:nvSpPr>
+          <p:cNvPr id="53" name="Text 25"/>
+          <p:cNvSpPr txBox="1"/>
+          <p:nvPr/>
+        </p:nvSpPr>
+        <p:spPr>
+          <a:xfrm>
+            <a:off x="10213876" y="2121198"/>
+            <a:ext cx="1200249" cy="184150"/>
+          </a:xfrm>
+          <a:prstGeom prst="rect">
+            <a:avLst/>
+          </a:prstGeom>
+          <a:noFill/>
+          <a:ln/>
+        </p:spPr>
+        <p:txBody>
+          <a:bodyPr wrap="square" lIns="0" tIns="0" rIns="0" bIns="0" rtlCol="0" anchor="ctr"/>
+          <a:lstStyle/>
+          <a:p>
+            <a:pPr algn="ctr" indent="0" marL="0">
+              <a:buNone/>
+            </a:pPr>
+            <a:r>
+              <a:rPr lang="en-US" sz="750" b="1" spc="100" kern="0" dirty="0">
                 <a:solidFill>
                   <a:srgbClr val="0A3170"/>
                 </a:solidFill>
@@ -1723,139 +2635,22 @@
                 <a:ea typeface="Arial" pitchFamily="34" charset="-122"/>
                 <a:cs typeface="Arial" pitchFamily="34" charset="-120"/>
               </a:rPr>
-              <a:t>Facebook</a:t>
-            </a:r>
-            <a:endParaRPr lang="en-US" sz="650" dirty="0"/>
-          </a:p>
-        </p:txBody>
-      </p:sp>
-      <p:sp>
-        <p:nvSpPr>
-          <p:cNvPr id="33" name="Text 5"/>
-          <p:cNvSpPr txBox="1"/>
-          <p:nvPr/>
-        </p:nvSpPr>
-        <p:spPr>
-          <a:xfrm>
-            <a:off x="10170319" y="1046480"/>
-            <a:ext cx="193530" cy="110490"/>
-          </a:xfrm>
-          <a:prstGeom prst="rect">
-            <a:avLst/>
-          </a:prstGeom>
-          <a:noFill/>
-          <a:ln/>
-        </p:spPr>
-        <p:txBody>
-          <a:bodyPr wrap="square" lIns="0" tIns="0" rIns="0" bIns="0" rtlCol="0" anchor="ctr"/>
-          <a:lstStyle/>
-          <a:p>
-            <a:pPr algn="l" indent="0" marL="0">
-              <a:buNone/>
-            </a:pPr>
-            <a:r>
-              <a:rPr lang="en-US" sz="650" b="1" dirty="0">
-                <a:solidFill>
-                  <a:srgbClr val="0A3170"/>
-                </a:solidFill>
-                <a:latin typeface="Arial" pitchFamily="34" charset="0"/>
-                <a:ea typeface="Arial" pitchFamily="34" charset="-122"/>
-                <a:cs typeface="Arial" pitchFamily="34" charset="-120"/>
-              </a:rPr>
-              <a:t>Zalo</a:t>
-            </a:r>
-            <a:endParaRPr lang="en-US" sz="650" dirty="0"/>
-          </a:p>
-        </p:txBody>
-      </p:sp>
-      <p:sp>
-        <p:nvSpPr>
-          <p:cNvPr id="34" name="Text 6"/>
-          <p:cNvSpPr txBox="1"/>
-          <p:nvPr/>
-        </p:nvSpPr>
-        <p:spPr>
-          <a:xfrm>
-            <a:off x="10773668" y="1046480"/>
-            <a:ext cx="294650" cy="110490"/>
-          </a:xfrm>
-          <a:prstGeom prst="rect">
-            <a:avLst/>
-          </a:prstGeom>
-          <a:noFill/>
-          <a:ln/>
-        </p:spPr>
-        <p:txBody>
-          <a:bodyPr wrap="square" lIns="0" tIns="0" rIns="0" bIns="0" rtlCol="0" anchor="ctr"/>
-          <a:lstStyle/>
-          <a:p>
-            <a:pPr algn="l" indent="0" marL="0">
-              <a:buNone/>
-            </a:pPr>
-            <a:r>
-              <a:rPr lang="en-US" sz="650" b="1" dirty="0">
-                <a:solidFill>
-                  <a:srgbClr val="0A3170"/>
-                </a:solidFill>
-                <a:latin typeface="Arial" pitchFamily="34" charset="0"/>
-                <a:ea typeface="Arial" pitchFamily="34" charset="-122"/>
-                <a:cs typeface="Arial" pitchFamily="34" charset="-120"/>
-              </a:rPr>
-              <a:t>TikTok</a:t>
-            </a:r>
-            <a:endParaRPr lang="en-US" sz="650" dirty="0"/>
-          </a:p>
-        </p:txBody>
-      </p:sp>
-      <p:sp>
-        <p:nvSpPr>
-          <p:cNvPr id="35" name="Text 7"/>
-          <p:cNvSpPr txBox="1"/>
-          <p:nvPr/>
-        </p:nvSpPr>
-        <p:spPr>
-          <a:xfrm>
-            <a:off x="11353304" y="1046480"/>
-            <a:ext cx="449836" cy="110490"/>
-          </a:xfrm>
-          <a:prstGeom prst="rect">
-            <a:avLst/>
-          </a:prstGeom>
-          <a:noFill/>
-          <a:ln/>
-        </p:spPr>
-        <p:txBody>
-          <a:bodyPr wrap="square" lIns="0" tIns="0" rIns="0" bIns="0" rtlCol="0" anchor="ctr"/>
-          <a:lstStyle/>
-          <a:p>
-            <a:pPr algn="l" indent="0" marL="0">
-              <a:buNone/>
-            </a:pPr>
-            <a:r>
-              <a:rPr lang="en-US" sz="650" b="1" dirty="0">
-                <a:solidFill>
-                  <a:srgbClr val="0A3170"/>
-                </a:solidFill>
-                <a:latin typeface="Arial" pitchFamily="34" charset="0"/>
-                <a:ea typeface="Arial" pitchFamily="34" charset="-122"/>
-                <a:cs typeface="Arial" pitchFamily="34" charset="-120"/>
-              </a:rPr>
-              <a:t>Instagram</a:t>
-            </a:r>
-            <a:endParaRPr lang="en-US" sz="650" dirty="0"/>
-          </a:p>
-        </p:txBody>
-      </p:sp>
-      <p:sp>
-        <p:nvSpPr>
-          <p:cNvPr id="36" name="Text 8"/>
-          <p:cNvSpPr txBox="1"/>
-          <p:nvPr/>
-        </p:nvSpPr>
-        <p:spPr>
-          <a:xfrm>
-            <a:off x="236601" y="2153158"/>
-            <a:ext cx="4936998" cy="176784"/>
+              <a:t>CÔNG NGHỆ IN 3D</a:t>
+            </a:r>
+            <a:endParaRPr lang="en-US" sz="750" dirty="0"/>
+          </a:p>
+        </p:txBody>
+      </p:sp>
+      <p:sp>
+        <p:nvSpPr>
+          <p:cNvPr id="54" name="Text 26"/>
+          <p:cNvSpPr txBox="1"/>
+          <p:nvPr/>
+        </p:nvSpPr>
+        <p:spPr>
+          <a:xfrm>
+            <a:off x="9829546" y="2305348"/>
+            <a:ext cx="1969008" cy="276225"/>
           </a:xfrm>
           <a:prstGeom prst="rect">
             <a:avLst/>
@@ -1871,7 +2666,102 @@
               <a:buNone/>
             </a:pPr>
             <a:r>
-              <a:rPr lang="en-US" sz="1050" b="1" spc="75" kern="0" dirty="0">
+              <a:rPr lang="en-US" sz="750" b="1" dirty="0">
+                <a:solidFill>
+                  <a:srgbClr val="FFFFFF"/>
+                </a:solidFill>
+                <a:latin typeface="Arial" pitchFamily="34" charset="0"/>
+                <a:ea typeface="Arial" pitchFamily="34" charset="-122"/>
+                <a:cs typeface="Arial" pitchFamily="34" charset="-120"/>
+              </a:rPr>
+              <a:t>Cấu trúc xốp tối ưu hóa</a:t>
+            </a:r>
+            <a:endParaRPr lang="en-US" sz="750" dirty="0"/>
+          </a:p>
+          <a:p>
+            <a:pPr algn="ctr" indent="0" marL="0">
+              <a:buNone/>
+            </a:pPr>
+            <a:r>
+              <a:rPr lang="en-US" sz="750" b="1" dirty="0">
+                <a:solidFill>
+                  <a:srgbClr val="FFFFFF"/>
+                </a:solidFill>
+                <a:latin typeface="Arial" pitchFamily="34" charset="0"/>
+                <a:ea typeface="Arial" pitchFamily="34" charset="-122"/>
+                <a:cs typeface="Arial" pitchFamily="34" charset="-120"/>
+              </a:rPr>
+              <a:t>tích hợp xương</a:t>
+            </a:r>
+            <a:endParaRPr lang="en-US" sz="750" dirty="0"/>
+          </a:p>
+        </p:txBody>
+      </p:sp>
+      <p:sp>
+        <p:nvSpPr>
+          <p:cNvPr id="55" name="Text 27"/>
+          <p:cNvSpPr txBox="1"/>
+          <p:nvPr/>
+        </p:nvSpPr>
+        <p:spPr>
+          <a:xfrm>
+            <a:off x="10040393" y="3263213"/>
+            <a:ext cx="645515" cy="152384"/>
+          </a:xfrm>
+          <a:prstGeom prst="rect">
+            <a:avLst/>
+          </a:prstGeom>
+          <a:noFill/>
+          <a:ln/>
+        </p:spPr>
+        <p:txBody>
+          <a:bodyPr wrap="square" lIns="0" tIns="0" rIns="0" bIns="0" rtlCol="0" anchor="ctr"/>
+          <a:lstStyle/>
+          <a:p>
+            <a:pPr algn="ctr" indent="0" marL="0">
+              <a:buNone/>
+            </a:pPr>
+            <a:r>
+              <a:rPr lang="en-US" sz="900" b="1" spc="25" kern="0" dirty="0">
+                <a:solidFill>
+                  <a:srgbClr val="FFFFFF"/>
+                </a:solidFill>
+                <a:latin typeface="Arial" pitchFamily="34" charset="0"/>
+                <a:ea typeface="Arial" pitchFamily="34" charset="-122"/>
+                <a:cs typeface="Arial" pitchFamily="34" charset="-120"/>
+              </a:rPr>
+              <a:t>PANTHER</a:t>
+            </a:r>
+            <a:endParaRPr lang="en-US" sz="900" dirty="0"/>
+          </a:p>
+        </p:txBody>
+      </p:sp>
+      <p:sp>
+        <p:nvSpPr>
+          <p:cNvPr id="56" name="Text 28"/>
+          <p:cNvSpPr txBox="1"/>
+          <p:nvPr/>
+        </p:nvSpPr>
+        <p:spPr>
+          <a:xfrm>
+            <a:off x="9992880" y="3417693"/>
+            <a:ext cx="740640" cy="277606"/>
+          </a:xfrm>
+          <a:prstGeom prst="rect">
+            <a:avLst/>
+          </a:prstGeom>
+          <a:noFill/>
+          <a:ln/>
+        </p:spPr>
+        <p:txBody>
+          <a:bodyPr wrap="square" lIns="0" tIns="0" rIns="0" bIns="0" rtlCol="0" anchor="ctr"/>
+          <a:lstStyle/>
+          <a:p>
+            <a:pPr algn="ctr" indent="0" marL="0">
+              <a:buNone/>
+            </a:pPr>
+            <a:r>
+              <a:rPr lang="en-US" sz="725" dirty="0">
                 <a:solidFill>
                   <a:srgbClr val="CFE6FF"/>
                 </a:solidFill>
@@ -1879,38 +2769,55 @@
                 <a:ea typeface="Arial" pitchFamily="34" charset="-122"/>
                 <a:cs typeface="Arial" pitchFamily="34" charset="-120"/>
               </a:rPr>
-              <a:t>VẬT LIỆU XƯƠNG SINH HỌC COLLAGEN KHOÁNG HÓA</a:t>
-            </a:r>
-            <a:endParaRPr lang="en-US" sz="1050" dirty="0"/>
-          </a:p>
-        </p:txBody>
-      </p:sp>
-      <p:sp>
-        <p:nvSpPr>
-          <p:cNvPr id="37" name="Text 9"/>
-          <p:cNvSpPr txBox="1"/>
-          <p:nvPr/>
-        </p:nvSpPr>
-        <p:spPr>
-          <a:xfrm>
-            <a:off x="1416943" y="2374646"/>
-            <a:ext cx="3269879" cy="279908"/>
-          </a:xfrm>
-          <a:prstGeom prst="rect">
-            <a:avLst/>
-          </a:prstGeom>
-          <a:noFill/>
-          <a:ln/>
-        </p:spPr>
-        <p:txBody>
-          <a:bodyPr wrap="square" lIns="0" tIns="0" rIns="0" bIns="0" rtlCol="0" anchor="ctr"/>
-          <a:lstStyle/>
-          <a:p>
-            <a:pPr algn="l" indent="0" marL="0">
-              <a:buNone/>
-            </a:pPr>
-            <a:r>
-              <a:rPr lang="en-US" sz="1650" b="1" dirty="0">
+              <a:t>Lồng thắt lưng</a:t>
+            </a:r>
+            <a:endParaRPr lang="en-US" sz="725" dirty="0"/>
+          </a:p>
+          <a:p>
+            <a:pPr algn="ctr" indent="0" marL="0">
+              <a:buNone/>
+            </a:pPr>
+            <a:r>
+              <a:rPr lang="en-US" sz="725" dirty="0">
+                <a:solidFill>
+                  <a:srgbClr val="CFE6FF"/>
+                </a:solidFill>
+                <a:latin typeface="Arial" pitchFamily="34" charset="0"/>
+                <a:ea typeface="Arial" pitchFamily="34" charset="-122"/>
+                <a:cs typeface="Arial" pitchFamily="34" charset="-120"/>
+              </a:rPr>
+              <a:t>in 3D</a:t>
+            </a:r>
+            <a:endParaRPr lang="en-US" sz="725" dirty="0"/>
+          </a:p>
+        </p:txBody>
+      </p:sp>
+      <p:sp>
+        <p:nvSpPr>
+          <p:cNvPr id="57" name="Text 29"/>
+          <p:cNvSpPr txBox="1"/>
+          <p:nvPr/>
+        </p:nvSpPr>
+        <p:spPr>
+          <a:xfrm>
+            <a:off x="11034956" y="3263213"/>
+            <a:ext cx="459790" cy="152384"/>
+          </a:xfrm>
+          <a:prstGeom prst="rect">
+            <a:avLst/>
+          </a:prstGeom>
+          <a:noFill/>
+          <a:ln/>
+        </p:spPr>
+        <p:txBody>
+          <a:bodyPr wrap="square" lIns="0" tIns="0" rIns="0" bIns="0" rtlCol="0" anchor="ctr"/>
+          <a:lstStyle/>
+          <a:p>
+            <a:pPr algn="ctr" indent="0" marL="0">
+              <a:buNone/>
+            </a:pPr>
+            <a:r>
+              <a:rPr lang="en-US" sz="900" b="1" spc="25" kern="0" dirty="0">
                 <a:solidFill>
                   <a:srgbClr val="FFFFFF"/>
                 </a:solidFill>
@@ -1918,52 +2825,94 @@
                 <a:ea typeface="Arial" pitchFamily="34" charset="-122"/>
                 <a:cs typeface="Arial" pitchFamily="34" charset="-120"/>
               </a:rPr>
-              <a:t>Đạt chứng nhận </a:t>
-            </a:r>
-            <a:pPr algn="l" indent="0" marL="0">
-              <a:buNone/>
-            </a:pPr>
-            <a:r>
-              <a:rPr lang="en-US" sz="1650" b="1" dirty="0">
-                <a:solidFill>
-                  <a:srgbClr val="8ED14F"/>
-                </a:solidFill>
-                <a:latin typeface="Arial" pitchFamily="34" charset="0"/>
-                <a:ea typeface="Arial" pitchFamily="34" charset="-122"/>
-                <a:cs typeface="Arial" pitchFamily="34" charset="-120"/>
-              </a:rPr>
-              <a:t>FDA Hoa Kỳ</a:t>
-            </a:r>
-            <a:endParaRPr lang="en-US" sz="1650" dirty="0"/>
-          </a:p>
-        </p:txBody>
-      </p:sp>
-      <p:sp>
-        <p:nvSpPr>
-          <p:cNvPr id="38" name="Text 10"/>
-          <p:cNvSpPr txBox="1"/>
-          <p:nvPr/>
-        </p:nvSpPr>
-        <p:spPr>
-          <a:xfrm>
-            <a:off x="1067098" y="2679446"/>
-            <a:ext cx="4067526" cy="279908"/>
-          </a:xfrm>
-          <a:prstGeom prst="rect">
-            <a:avLst/>
-          </a:prstGeom>
-          <a:noFill/>
-          <a:ln/>
-        </p:spPr>
-        <p:txBody>
-          <a:bodyPr wrap="square" lIns="0" tIns="0" rIns="0" bIns="0" rtlCol="0" anchor="ctr"/>
-          <a:lstStyle/>
-          <a:p>
-            <a:pPr algn="l" indent="0" marL="0">
-              <a:buNone/>
-            </a:pPr>
-            <a:r>
-              <a:rPr lang="en-US" sz="1650" b="1" dirty="0">
+              <a:t>PETRA</a:t>
+            </a:r>
+            <a:endParaRPr lang="en-US" sz="900" dirty="0"/>
+          </a:p>
+        </p:txBody>
+      </p:sp>
+      <p:sp>
+        <p:nvSpPr>
+          <p:cNvPr id="58" name="Text 30"/>
+          <p:cNvSpPr txBox="1"/>
+          <p:nvPr/>
+        </p:nvSpPr>
+        <p:spPr>
+          <a:xfrm>
+            <a:off x="11060745" y="3417693"/>
+            <a:ext cx="408212" cy="277606"/>
+          </a:xfrm>
+          <a:prstGeom prst="rect">
+            <a:avLst/>
+          </a:prstGeom>
+          <a:noFill/>
+          <a:ln/>
+        </p:spPr>
+        <p:txBody>
+          <a:bodyPr wrap="square" lIns="0" tIns="0" rIns="0" bIns="0" rtlCol="0" anchor="ctr"/>
+          <a:lstStyle/>
+          <a:p>
+            <a:pPr algn="ctr" indent="0" marL="0">
+              <a:buNone/>
+            </a:pPr>
+            <a:r>
+              <a:rPr lang="en-US" sz="725" dirty="0">
+                <a:solidFill>
+                  <a:srgbClr val="CFE6FF"/>
+                </a:solidFill>
+                <a:latin typeface="Arial" pitchFamily="34" charset="0"/>
+                <a:ea typeface="Arial" pitchFamily="34" charset="-122"/>
+                <a:cs typeface="Arial" pitchFamily="34" charset="-120"/>
+              </a:rPr>
+              <a:t>Lồng cổ</a:t>
+            </a:r>
+            <a:endParaRPr lang="en-US" sz="725" dirty="0"/>
+          </a:p>
+          <a:p>
+            <a:pPr algn="ctr" indent="0" marL="0">
+              <a:buNone/>
+            </a:pPr>
+            <a:r>
+              <a:rPr lang="en-US" sz="725" dirty="0">
+                <a:solidFill>
+                  <a:srgbClr val="CFE6FF"/>
+                </a:solidFill>
+                <a:latin typeface="Arial" pitchFamily="34" charset="0"/>
+                <a:ea typeface="Arial" pitchFamily="34" charset="-122"/>
+                <a:cs typeface="Arial" pitchFamily="34" charset="-120"/>
+              </a:rPr>
+              <a:t>in 3D</a:t>
+            </a:r>
+            <a:endParaRPr lang="en-US" sz="725" dirty="0"/>
+          </a:p>
+        </p:txBody>
+      </p:sp>
+      <p:sp>
+        <p:nvSpPr>
+          <p:cNvPr id="59" name="Text 31"/>
+          <p:cNvSpPr txBox="1"/>
+          <p:nvPr/>
+        </p:nvSpPr>
+        <p:spPr>
+          <a:xfrm>
+            <a:off x="10004685" y="4770842"/>
+            <a:ext cx="659880" cy="152384"/>
+          </a:xfrm>
+          <a:prstGeom prst="rect">
+            <a:avLst/>
+          </a:prstGeom>
+          <a:noFill/>
+          <a:ln/>
+        </p:spPr>
+        <p:txBody>
+          <a:bodyPr wrap="square" lIns="0" tIns="0" rIns="0" bIns="0" rtlCol="0" anchor="ctr"/>
+          <a:lstStyle/>
+          <a:p>
+            <a:pPr algn="ctr" indent="0" marL="0">
+              <a:buNone/>
+            </a:pPr>
+            <a:r>
+              <a:rPr lang="en-US" sz="900" b="1" spc="25" kern="0" dirty="0">
                 <a:solidFill>
                   <a:srgbClr val="FFFFFF"/>
                 </a:solidFill>
@@ -1971,36 +2920,22 @@
                 <a:ea typeface="Arial" pitchFamily="34" charset="-122"/>
                 <a:cs typeface="Arial" pitchFamily="34" charset="-120"/>
               </a:rPr>
-              <a:t>Tương đồng cao với </a:t>
-            </a:r>
-            <a:pPr algn="l" indent="0" marL="0">
-              <a:buNone/>
-            </a:pPr>
-            <a:r>
-              <a:rPr lang="en-US" sz="1650" b="1" dirty="0">
-                <a:solidFill>
-                  <a:srgbClr val="8ED14F"/>
-                </a:solidFill>
-                <a:latin typeface="Arial" pitchFamily="34" charset="0"/>
-                <a:ea typeface="Arial" pitchFamily="34" charset="-122"/>
-                <a:cs typeface="Arial" pitchFamily="34" charset="-120"/>
-              </a:rPr>
-              <a:t>xương tự thân</a:t>
-            </a:r>
-            <a:endParaRPr lang="en-US" sz="1650" dirty="0"/>
-          </a:p>
-        </p:txBody>
-      </p:sp>
-      <p:sp>
-        <p:nvSpPr>
-          <p:cNvPr id="39" name="Text 11"/>
-          <p:cNvSpPr txBox="1"/>
-          <p:nvPr/>
-        </p:nvSpPr>
-        <p:spPr>
-          <a:xfrm>
-            <a:off x="715877" y="3732339"/>
-            <a:ext cx="1108246" cy="412496"/>
+              <a:t>QUATTRO</a:t>
+            </a:r>
+            <a:endParaRPr lang="en-US" sz="900" dirty="0"/>
+          </a:p>
+        </p:txBody>
+      </p:sp>
+      <p:sp>
+        <p:nvSpPr>
+          <p:cNvPr id="60" name="Text 32"/>
+          <p:cNvSpPr txBox="1"/>
+          <p:nvPr/>
+        </p:nvSpPr>
+        <p:spPr>
+          <a:xfrm>
+            <a:off x="9955595" y="4934895"/>
+            <a:ext cx="758059" cy="138803"/>
           </a:xfrm>
           <a:prstGeom prst="rect">
             <a:avLst/>
@@ -2016,7 +2951,46 @@
               <a:buNone/>
             </a:pPr>
             <a:r>
-              <a:rPr lang="en-US" sz="1200" b="1" dirty="0">
+              <a:rPr lang="en-US" sz="725" dirty="0">
+                <a:solidFill>
+                  <a:srgbClr val="CFE6FF"/>
+                </a:solidFill>
+                <a:latin typeface="Arial" pitchFamily="34" charset="0"/>
+                <a:ea typeface="Arial" pitchFamily="34" charset="-122"/>
+                <a:cs typeface="Arial" pitchFamily="34" charset="-120"/>
+              </a:rPr>
+              <a:t>Vít cuống sống</a:t>
+            </a:r>
+            <a:endParaRPr lang="en-US" sz="725" dirty="0"/>
+          </a:p>
+        </p:txBody>
+      </p:sp>
+      <p:sp>
+        <p:nvSpPr>
+          <p:cNvPr id="61" name="Text 33"/>
+          <p:cNvSpPr txBox="1"/>
+          <p:nvPr/>
+        </p:nvSpPr>
+        <p:spPr>
+          <a:xfrm>
+            <a:off x="10963535" y="4760333"/>
+            <a:ext cx="659880" cy="304768"/>
+          </a:xfrm>
+          <a:prstGeom prst="rect">
+            <a:avLst/>
+          </a:prstGeom>
+          <a:noFill/>
+          <a:ln/>
+        </p:spPr>
+        <p:txBody>
+          <a:bodyPr wrap="square" lIns="0" tIns="0" rIns="0" bIns="0" rtlCol="0" anchor="ctr"/>
+          <a:lstStyle/>
+          <a:p>
+            <a:pPr algn="ctr" indent="0" marL="0">
+              <a:buNone/>
+            </a:pPr>
+            <a:r>
+              <a:rPr lang="en-US" sz="900" b="1" spc="25" kern="0" dirty="0">
                 <a:solidFill>
                   <a:srgbClr val="FFFFFF"/>
                 </a:solidFill>
@@ -2024,16 +2998,16 @@
                 <a:ea typeface="Arial" pitchFamily="34" charset="-122"/>
                 <a:cs typeface="Arial" pitchFamily="34" charset="-120"/>
               </a:rPr>
-              <a:t>Chấn thương</a:t>
-            </a:r>
-            <a:endParaRPr lang="en-US" sz="1200" dirty="0"/>
+              <a:t>QUATTRO</a:t>
+            </a:r>
+            <a:endParaRPr lang="en-US" sz="900" dirty="0"/>
           </a:p>
           <a:p>
             <a:pPr algn="ctr" indent="0" marL="0">
               <a:buNone/>
             </a:pPr>
             <a:r>
-              <a:rPr lang="en-US" sz="1200" b="1" dirty="0">
+              <a:rPr lang="en-US" sz="900" b="1" spc="25" kern="0" dirty="0">
                 <a:solidFill>
                   <a:srgbClr val="FFFFFF"/>
                 </a:solidFill>
@@ -2041,22 +3015,22 @@
                 <a:ea typeface="Arial" pitchFamily="34" charset="-122"/>
                 <a:cs typeface="Arial" pitchFamily="34" charset="-120"/>
               </a:rPr>
-              <a:t>chỉnh hình</a:t>
-            </a:r>
-            <a:endParaRPr lang="en-US" sz="1200" dirty="0"/>
-          </a:p>
-        </p:txBody>
-      </p:sp>
-      <p:sp>
-        <p:nvSpPr>
-          <p:cNvPr id="40" name="Text 12"/>
-          <p:cNvSpPr txBox="1"/>
-          <p:nvPr/>
-        </p:nvSpPr>
-        <p:spPr>
-          <a:xfrm>
-            <a:off x="3488690" y="5292789"/>
-            <a:ext cx="1303020" cy="206248"/>
+              <a:t>GADGET</a:t>
+            </a:r>
+            <a:endParaRPr lang="en-US" sz="900" dirty="0"/>
+          </a:p>
+        </p:txBody>
+      </p:sp>
+      <p:sp>
+        <p:nvSpPr>
+          <p:cNvPr id="62" name="Text 34"/>
+          <p:cNvSpPr txBox="1"/>
+          <p:nvPr/>
+        </p:nvSpPr>
+        <p:spPr>
+          <a:xfrm>
+            <a:off x="11042605" y="5056688"/>
+            <a:ext cx="501640" cy="277606"/>
           </a:xfrm>
           <a:prstGeom prst="rect">
             <a:avLst/>
@@ -2072,85 +3046,24 @@
               <a:buNone/>
             </a:pPr>
             <a:r>
-              <a:rPr lang="en-US" sz="1200" b="1" dirty="0">
-                <a:solidFill>
-                  <a:srgbClr val="FFFFFF"/>
-                </a:solidFill>
-                <a:latin typeface="Arial" pitchFamily="34" charset="0"/>
-                <a:ea typeface="Arial" pitchFamily="34" charset="-122"/>
-                <a:cs typeface="Arial" pitchFamily="34" charset="-120"/>
-              </a:rPr>
-              <a:t>Ngoại thần kinh</a:t>
-            </a:r>
-            <a:endParaRPr lang="en-US" sz="1200" dirty="0"/>
-          </a:p>
-        </p:txBody>
-      </p:sp>
-      <p:sp>
-        <p:nvSpPr>
-          <p:cNvPr id="41" name="Text 13"/>
-          <p:cNvSpPr txBox="1"/>
-          <p:nvPr/>
-        </p:nvSpPr>
-        <p:spPr>
-          <a:xfrm>
-            <a:off x="515366" y="6028436"/>
-            <a:ext cx="1534668" cy="243078"/>
-          </a:xfrm>
-          <a:prstGeom prst="rect">
-            <a:avLst/>
-          </a:prstGeom>
-          <a:noFill/>
-          <a:ln/>
-        </p:spPr>
-        <p:txBody>
-          <a:bodyPr wrap="square" lIns="0" tIns="0" rIns="0" bIns="0" rtlCol="0" anchor="ctr"/>
-          <a:lstStyle/>
+              <a:rPr lang="en-US" sz="725" dirty="0">
+                <a:solidFill>
+                  <a:srgbClr val="CFE6FF"/>
+                </a:solidFill>
+                <a:latin typeface="Arial" pitchFamily="34" charset="0"/>
+                <a:ea typeface="Arial" pitchFamily="34" charset="-122"/>
+                <a:cs typeface="Arial" pitchFamily="34" charset="-120"/>
+              </a:rPr>
+              <a:t>Vít qua da</a:t>
+            </a:r>
+            <a:endParaRPr lang="en-US" sz="725" dirty="0"/>
+          </a:p>
           <a:p>
             <a:pPr algn="ctr" indent="0" marL="0">
               <a:buNone/>
             </a:pPr>
             <a:r>
-              <a:rPr lang="en-US" sz="1500" b="1" dirty="0">
-                <a:solidFill>
-                  <a:srgbClr val="8ED14F"/>
-                </a:solidFill>
-                <a:latin typeface="Arial" pitchFamily="34" charset="0"/>
-                <a:ea typeface="Arial" pitchFamily="34" charset="-122"/>
-                <a:cs typeface="Arial" pitchFamily="34" charset="-120"/>
-              </a:rPr>
-              <a:t>45 : 55</a:t>
-            </a:r>
-            <a:endParaRPr lang="en-US" sz="1500" dirty="0"/>
-          </a:p>
-        </p:txBody>
-      </p:sp>
-      <p:sp>
-        <p:nvSpPr>
-          <p:cNvPr id="42" name="Text 14"/>
-          <p:cNvSpPr txBox="1"/>
-          <p:nvPr/>
-        </p:nvSpPr>
-        <p:spPr>
-          <a:xfrm>
-            <a:off x="515366" y="6264656"/>
-            <a:ext cx="1534668" cy="132588"/>
-          </a:xfrm>
-          <a:prstGeom prst="rect">
-            <a:avLst/>
-          </a:prstGeom>
-          <a:noFill/>
-          <a:ln/>
-        </p:spPr>
-        <p:txBody>
-          <a:bodyPr wrap="square" lIns="0" tIns="0" rIns="0" bIns="0" rtlCol="0" anchor="ctr"/>
-          <a:lstStyle/>
-          <a:p>
-            <a:pPr algn="ctr" indent="0" marL="0">
-              <a:buNone/>
-            </a:pPr>
-            <a:r>
-              <a:rPr lang="en-US" sz="800" dirty="0">
+              <a:rPr lang="en-US" sz="725" dirty="0">
                 <a:solidFill>
                   <a:srgbClr val="CFE6FF"/>
                 </a:solidFill>
@@ -2158,906 +3071,10 @@
                 <a:ea typeface="Arial" pitchFamily="34" charset="-122"/>
                 <a:cs typeface="Arial" pitchFamily="34" charset="-120"/>
               </a:rPr>
-              <a:t>Collagen I : nano-HA</a:t>
-            </a:r>
-            <a:endParaRPr lang="en-US" sz="800" dirty="0"/>
-          </a:p>
-        </p:txBody>
-      </p:sp>
-      <p:sp>
-        <p:nvSpPr>
-          <p:cNvPr id="43" name="Text 15"/>
-          <p:cNvSpPr txBox="1"/>
-          <p:nvPr/>
-        </p:nvSpPr>
-        <p:spPr>
-          <a:xfrm>
-            <a:off x="1944561" y="6028436"/>
-            <a:ext cx="1527429" cy="243078"/>
-          </a:xfrm>
-          <a:prstGeom prst="rect">
-            <a:avLst/>
-          </a:prstGeom>
-          <a:noFill/>
-          <a:ln/>
-        </p:spPr>
-        <p:txBody>
-          <a:bodyPr wrap="square" lIns="0" tIns="0" rIns="0" bIns="0" rtlCol="0" anchor="ctr"/>
-          <a:lstStyle/>
-          <a:p>
-            <a:pPr algn="ctr" indent="0" marL="0">
-              <a:buNone/>
-            </a:pPr>
-            <a:r>
-              <a:rPr lang="en-US" sz="1500" b="1" dirty="0">
-                <a:solidFill>
-                  <a:srgbClr val="8ED14F"/>
-                </a:solidFill>
-                <a:latin typeface="Arial" pitchFamily="34" charset="0"/>
-                <a:ea typeface="Arial" pitchFamily="34" charset="-122"/>
-                <a:cs typeface="Arial" pitchFamily="34" charset="-120"/>
-              </a:rPr>
-              <a:t>70–80%</a:t>
-            </a:r>
-            <a:endParaRPr lang="en-US" sz="1500" dirty="0"/>
-          </a:p>
-        </p:txBody>
-      </p:sp>
-      <p:sp>
-        <p:nvSpPr>
-          <p:cNvPr id="44" name="Text 16"/>
-          <p:cNvSpPr txBox="1"/>
-          <p:nvPr/>
-        </p:nvSpPr>
-        <p:spPr>
-          <a:xfrm>
-            <a:off x="1944561" y="6264656"/>
-            <a:ext cx="1527429" cy="132588"/>
-          </a:xfrm>
-          <a:prstGeom prst="rect">
-            <a:avLst/>
-          </a:prstGeom>
-          <a:noFill/>
-          <a:ln/>
-        </p:spPr>
-        <p:txBody>
-          <a:bodyPr wrap="square" lIns="0" tIns="0" rIns="0" bIns="0" rtlCol="0" anchor="ctr"/>
-          <a:lstStyle/>
-          <a:p>
-            <a:pPr algn="ctr" indent="0" marL="0">
-              <a:buNone/>
-            </a:pPr>
-            <a:r>
-              <a:rPr lang="en-US" sz="800" dirty="0">
-                <a:solidFill>
-                  <a:srgbClr val="CFE6FF"/>
-                </a:solidFill>
-                <a:latin typeface="Arial" pitchFamily="34" charset="0"/>
-                <a:ea typeface="Arial" pitchFamily="34" charset="-122"/>
-                <a:cs typeface="Arial" pitchFamily="34" charset="-120"/>
-              </a:rPr>
-              <a:t>Độ xốp</a:t>
-            </a:r>
-            <a:endParaRPr lang="en-US" sz="800" dirty="0"/>
-          </a:p>
-        </p:txBody>
-      </p:sp>
-      <p:sp>
-        <p:nvSpPr>
-          <p:cNvPr id="45" name="Text 17"/>
-          <p:cNvSpPr txBox="1"/>
-          <p:nvPr/>
-        </p:nvSpPr>
-        <p:spPr>
-          <a:xfrm>
-            <a:off x="3366961" y="6028436"/>
-            <a:ext cx="1527429" cy="243078"/>
-          </a:xfrm>
-          <a:prstGeom prst="rect">
-            <a:avLst/>
-          </a:prstGeom>
-          <a:noFill/>
-          <a:ln/>
-        </p:spPr>
-        <p:txBody>
-          <a:bodyPr wrap="square" lIns="0" tIns="0" rIns="0" bIns="0" rtlCol="0" anchor="ctr"/>
-          <a:lstStyle/>
-          <a:p>
-            <a:pPr algn="ctr" indent="0" marL="0">
-              <a:buNone/>
-            </a:pPr>
-            <a:r>
-              <a:rPr lang="en-US" sz="1500" b="1" dirty="0">
-                <a:solidFill>
-                  <a:srgbClr val="8ED14F"/>
-                </a:solidFill>
-                <a:latin typeface="Arial" pitchFamily="34" charset="0"/>
-                <a:ea typeface="Arial" pitchFamily="34" charset="-122"/>
-                <a:cs typeface="Arial" pitchFamily="34" charset="-120"/>
-              </a:rPr>
-              <a:t>&gt;200.000</a:t>
-            </a:r>
-            <a:endParaRPr lang="en-US" sz="1500" dirty="0"/>
-          </a:p>
-        </p:txBody>
-      </p:sp>
-      <p:sp>
-        <p:nvSpPr>
-          <p:cNvPr id="46" name="Text 18"/>
-          <p:cNvSpPr txBox="1"/>
-          <p:nvPr/>
-        </p:nvSpPr>
-        <p:spPr>
-          <a:xfrm>
-            <a:off x="3366961" y="6264656"/>
-            <a:ext cx="1527429" cy="132588"/>
-          </a:xfrm>
-          <a:prstGeom prst="rect">
-            <a:avLst/>
-          </a:prstGeom>
-          <a:noFill/>
-          <a:ln/>
-        </p:spPr>
-        <p:txBody>
-          <a:bodyPr wrap="square" lIns="0" tIns="0" rIns="0" bIns="0" rtlCol="0" anchor="ctr"/>
-          <a:lstStyle/>
-          <a:p>
-            <a:pPr algn="ctr" indent="0" marL="0">
-              <a:buNone/>
-            </a:pPr>
-            <a:r>
-              <a:rPr lang="en-US" sz="800" dirty="0">
-                <a:solidFill>
-                  <a:srgbClr val="CFE6FF"/>
-                </a:solidFill>
-                <a:latin typeface="Arial" pitchFamily="34" charset="0"/>
-                <a:ea typeface="Arial" pitchFamily="34" charset="-122"/>
-                <a:cs typeface="Arial" pitchFamily="34" charset="-120"/>
-              </a:rPr>
-              <a:t>Ca lâm sàng</a:t>
-            </a:r>
-            <a:endParaRPr lang="en-US" sz="800" dirty="0"/>
-          </a:p>
-        </p:txBody>
-      </p:sp>
-      <p:sp>
-        <p:nvSpPr>
-          <p:cNvPr id="47" name="Text 19"/>
-          <p:cNvSpPr txBox="1"/>
-          <p:nvPr/>
-        </p:nvSpPr>
-        <p:spPr>
-          <a:xfrm>
-            <a:off x="5070729" y="2132584"/>
-            <a:ext cx="4908042" cy="198882"/>
-          </a:xfrm>
-          <a:prstGeom prst="rect">
-            <a:avLst/>
-          </a:prstGeom>
-          <a:noFill/>
-          <a:ln/>
-        </p:spPr>
-        <p:txBody>
-          <a:bodyPr wrap="square" lIns="0" tIns="0" rIns="0" bIns="0" rtlCol="0" anchor="ctr"/>
-          <a:lstStyle/>
-          <a:p>
-            <a:pPr algn="ctr" indent="0" marL="0">
-              <a:buNone/>
-            </a:pPr>
-            <a:r>
-              <a:rPr lang="en-US" sz="1150" b="1" spc="25" kern="0" dirty="0">
-                <a:solidFill>
-                  <a:srgbClr val="FFFFFF"/>
-                </a:solidFill>
-                <a:latin typeface="Arial" pitchFamily="34" charset="0"/>
-                <a:ea typeface="Arial" pitchFamily="34" charset="-122"/>
-                <a:cs typeface="Arial" pitchFamily="34" charset="-120"/>
-              </a:rPr>
-              <a:t>GIẢI PHÁP TÍCH HỢP CHO </a:t>
-            </a:r>
-            <a:pPr algn="ctr" indent="0" marL="0">
-              <a:buNone/>
-            </a:pPr>
-            <a:r>
-              <a:rPr lang="en-US" sz="1150" b="1" spc="25" kern="0" dirty="0">
-                <a:solidFill>
-                  <a:srgbClr val="8ED14F"/>
-                </a:solidFill>
-                <a:latin typeface="Arial" pitchFamily="34" charset="0"/>
-                <a:ea typeface="Arial" pitchFamily="34" charset="-122"/>
-                <a:cs typeface="Arial" pitchFamily="34" charset="-120"/>
-              </a:rPr>
-              <a:t>PHẪU THUẬT CỘT SỐNG</a:t>
-            </a:r>
-            <a:endParaRPr lang="en-US" sz="1150" dirty="0"/>
-          </a:p>
-        </p:txBody>
-      </p:sp>
-      <p:sp>
-        <p:nvSpPr>
-          <p:cNvPr id="48" name="Text 20"/>
-          <p:cNvSpPr txBox="1"/>
-          <p:nvPr/>
-        </p:nvSpPr>
-        <p:spPr>
-          <a:xfrm>
-            <a:off x="7029450" y="2368296"/>
-            <a:ext cx="241300" cy="279908"/>
-          </a:xfrm>
-          <a:prstGeom prst="rect">
-            <a:avLst/>
-          </a:prstGeom>
-          <a:noFill/>
-          <a:ln/>
-        </p:spPr>
-        <p:txBody>
-          <a:bodyPr wrap="square" lIns="0" tIns="0" rIns="0" bIns="0" rtlCol="0" anchor="ctr"/>
-          <a:lstStyle/>
-          <a:p>
-            <a:pPr algn="ctr" indent="0" marL="0">
-              <a:buNone/>
-            </a:pPr>
-            <a:r>
-              <a:rPr lang="en-US" sz="850" b="1" dirty="0">
-                <a:solidFill>
-                  <a:srgbClr val="04122E"/>
-                </a:solidFill>
-                <a:latin typeface="Arial" pitchFamily="34" charset="0"/>
-                <a:ea typeface="Arial" pitchFamily="34" charset="-122"/>
-                <a:cs typeface="Arial" pitchFamily="34" charset="-120"/>
-              </a:rPr>
-              <a:t>01</a:t>
-            </a:r>
-            <a:endParaRPr lang="en-US" sz="850" dirty="0"/>
-          </a:p>
-        </p:txBody>
-      </p:sp>
-      <p:sp>
-        <p:nvSpPr>
-          <p:cNvPr id="49" name="Text 21"/>
-          <p:cNvSpPr txBox="1"/>
-          <p:nvPr/>
-        </p:nvSpPr>
-        <p:spPr>
-          <a:xfrm>
-            <a:off x="7334250" y="2424240"/>
-            <a:ext cx="1458206" cy="167922"/>
-          </a:xfrm>
-          <a:prstGeom prst="rect">
-            <a:avLst/>
-          </a:prstGeom>
-          <a:noFill/>
-          <a:ln/>
-        </p:spPr>
-        <p:txBody>
-          <a:bodyPr wrap="square" lIns="0" tIns="0" rIns="0" bIns="0" rtlCol="0" anchor="ctr"/>
-          <a:lstStyle/>
-          <a:p>
-            <a:pPr algn="l" indent="0" marL="0">
-              <a:buNone/>
-            </a:pPr>
-            <a:r>
-              <a:rPr lang="en-US" sz="950" b="1" dirty="0">
-                <a:solidFill>
-                  <a:srgbClr val="FFFFFF"/>
-                </a:solidFill>
-                <a:latin typeface="Arial" pitchFamily="34" charset="0"/>
-                <a:ea typeface="Arial" pitchFamily="34" charset="-122"/>
-                <a:cs typeface="Arial" pitchFamily="34" charset="-120"/>
-              </a:rPr>
-              <a:t>Giảm phơi nhiễm tia X</a:t>
-            </a:r>
-            <a:endParaRPr lang="en-US" sz="950" dirty="0"/>
-          </a:p>
-        </p:txBody>
-      </p:sp>
-      <p:sp>
-        <p:nvSpPr>
-          <p:cNvPr id="50" name="Text 22"/>
-          <p:cNvSpPr txBox="1"/>
-          <p:nvPr/>
-        </p:nvSpPr>
-        <p:spPr>
-          <a:xfrm>
-            <a:off x="8227814" y="2850896"/>
-            <a:ext cx="241300" cy="279908"/>
-          </a:xfrm>
-          <a:prstGeom prst="rect">
-            <a:avLst/>
-          </a:prstGeom>
-          <a:noFill/>
-          <a:ln/>
-        </p:spPr>
-        <p:txBody>
-          <a:bodyPr wrap="square" lIns="0" tIns="0" rIns="0" bIns="0" rtlCol="0" anchor="ctr"/>
-          <a:lstStyle/>
-          <a:p>
-            <a:pPr algn="ctr" indent="0" marL="0">
-              <a:buNone/>
-            </a:pPr>
-            <a:r>
-              <a:rPr lang="en-US" sz="850" b="1" dirty="0">
-                <a:solidFill>
-                  <a:srgbClr val="04122E"/>
-                </a:solidFill>
-                <a:latin typeface="Arial" pitchFamily="34" charset="0"/>
-                <a:ea typeface="Arial" pitchFamily="34" charset="-122"/>
-                <a:cs typeface="Arial" pitchFamily="34" charset="-120"/>
-              </a:rPr>
-              <a:t>02</a:t>
-            </a:r>
-            <a:endParaRPr lang="en-US" sz="850" dirty="0"/>
-          </a:p>
-        </p:txBody>
-      </p:sp>
-      <p:sp>
-        <p:nvSpPr>
-          <p:cNvPr id="51" name="Text 23"/>
-          <p:cNvSpPr txBox="1"/>
-          <p:nvPr/>
-        </p:nvSpPr>
-        <p:spPr>
-          <a:xfrm>
-            <a:off x="8532614" y="2906840"/>
-            <a:ext cx="1131320" cy="167922"/>
-          </a:xfrm>
-          <a:prstGeom prst="rect">
-            <a:avLst/>
-          </a:prstGeom>
-          <a:noFill/>
-          <a:ln/>
-        </p:spPr>
-        <p:txBody>
-          <a:bodyPr wrap="square" lIns="0" tIns="0" rIns="0" bIns="0" rtlCol="0" anchor="ctr"/>
-          <a:lstStyle/>
-          <a:p>
-            <a:pPr algn="l" indent="0" marL="0">
-              <a:buNone/>
-            </a:pPr>
-            <a:r>
-              <a:rPr lang="en-US" sz="950" b="1" dirty="0">
-                <a:solidFill>
-                  <a:srgbClr val="FFFFFF"/>
-                </a:solidFill>
-                <a:latin typeface="Arial" pitchFamily="34" charset="0"/>
-                <a:ea typeface="Arial" pitchFamily="34" charset="-122"/>
-                <a:cs typeface="Arial" pitchFamily="34" charset="-120"/>
-              </a:rPr>
-              <a:t>Độ chính xác cao</a:t>
-            </a:r>
-            <a:endParaRPr lang="en-US" sz="950" dirty="0"/>
-          </a:p>
-        </p:txBody>
-      </p:sp>
-      <p:sp>
-        <p:nvSpPr>
-          <p:cNvPr id="52" name="Text 24"/>
-          <p:cNvSpPr txBox="1"/>
-          <p:nvPr/>
-        </p:nvSpPr>
-        <p:spPr>
-          <a:xfrm>
-            <a:off x="5441950" y="4623737"/>
-            <a:ext cx="241300" cy="279908"/>
-          </a:xfrm>
-          <a:prstGeom prst="rect">
-            <a:avLst/>
-          </a:prstGeom>
-          <a:noFill/>
-          <a:ln/>
-        </p:spPr>
-        <p:txBody>
-          <a:bodyPr wrap="square" lIns="0" tIns="0" rIns="0" bIns="0" rtlCol="0" anchor="ctr"/>
-          <a:lstStyle/>
-          <a:p>
-            <a:pPr algn="ctr" indent="0" marL="0">
-              <a:buNone/>
-            </a:pPr>
-            <a:r>
-              <a:rPr lang="en-US" sz="850" b="1" dirty="0">
-                <a:solidFill>
-                  <a:srgbClr val="04122E"/>
-                </a:solidFill>
-                <a:latin typeface="Arial" pitchFamily="34" charset="0"/>
-                <a:ea typeface="Arial" pitchFamily="34" charset="-122"/>
-                <a:cs typeface="Arial" pitchFamily="34" charset="-120"/>
-              </a:rPr>
-              <a:t>03</a:t>
-            </a:r>
-            <a:endParaRPr lang="en-US" sz="850" dirty="0"/>
-          </a:p>
-        </p:txBody>
-      </p:sp>
-      <p:sp>
-        <p:nvSpPr>
-          <p:cNvPr id="53" name="Text 25"/>
-          <p:cNvSpPr txBox="1"/>
-          <p:nvPr/>
-        </p:nvSpPr>
-        <p:spPr>
-          <a:xfrm>
-            <a:off x="5746750" y="4511858"/>
-            <a:ext cx="710892" cy="503765"/>
-          </a:xfrm>
-          <a:prstGeom prst="rect">
-            <a:avLst/>
-          </a:prstGeom>
-          <a:noFill/>
-          <a:ln/>
-        </p:spPr>
-        <p:txBody>
-          <a:bodyPr wrap="square" lIns="0" tIns="0" rIns="0" bIns="0" rtlCol="0" anchor="ctr"/>
-          <a:lstStyle/>
-          <a:p>
-            <a:pPr algn="l" indent="0" marL="0">
-              <a:buNone/>
-            </a:pPr>
-            <a:r>
-              <a:rPr lang="en-US" sz="950" b="1" dirty="0">
-                <a:solidFill>
-                  <a:srgbClr val="FFFFFF"/>
-                </a:solidFill>
-                <a:latin typeface="Arial" pitchFamily="34" charset="0"/>
-                <a:ea typeface="Arial" pitchFamily="34" charset="-122"/>
-                <a:cs typeface="Arial" pitchFamily="34" charset="-120"/>
-              </a:rPr>
-              <a:t>Tối ưu hóa</a:t>
-            </a:r>
-            <a:endParaRPr lang="en-US" sz="950" dirty="0"/>
-          </a:p>
-          <a:p>
-            <a:pPr algn="l" indent="0" marL="0">
-              <a:buNone/>
-            </a:pPr>
-            <a:r>
-              <a:rPr lang="en-US" sz="950" b="1" dirty="0">
-                <a:solidFill>
-                  <a:srgbClr val="FFFFFF"/>
-                </a:solidFill>
-                <a:latin typeface="Arial" pitchFamily="34" charset="0"/>
-                <a:ea typeface="Arial" pitchFamily="34" charset="-122"/>
-                <a:cs typeface="Arial" pitchFamily="34" charset="-120"/>
-              </a:rPr>
-              <a:t>quy trình</a:t>
-            </a:r>
-            <a:endParaRPr lang="en-US" sz="950" dirty="0"/>
-          </a:p>
-          <a:p>
-            <a:pPr algn="l" indent="0" marL="0">
-              <a:buNone/>
-            </a:pPr>
-            <a:r>
-              <a:rPr lang="en-US" sz="950" b="1" dirty="0">
-                <a:solidFill>
-                  <a:srgbClr val="FFFFFF"/>
-                </a:solidFill>
-                <a:latin typeface="Arial" pitchFamily="34" charset="0"/>
-                <a:ea typeface="Arial" pitchFamily="34" charset="-122"/>
-                <a:cs typeface="Arial" pitchFamily="34" charset="-120"/>
-              </a:rPr>
-              <a:t>phẫu thuật</a:t>
-            </a:r>
-            <a:endParaRPr lang="en-US" sz="950" dirty="0"/>
-          </a:p>
-        </p:txBody>
-      </p:sp>
-      <p:sp>
-        <p:nvSpPr>
-          <p:cNvPr id="54" name="Text 26"/>
-          <p:cNvSpPr txBox="1"/>
-          <p:nvPr/>
-        </p:nvSpPr>
-        <p:spPr>
-          <a:xfrm>
-            <a:off x="10213876" y="2413298"/>
-            <a:ext cx="1200249" cy="184150"/>
-          </a:xfrm>
-          <a:prstGeom prst="rect">
-            <a:avLst/>
-          </a:prstGeom>
-          <a:noFill/>
-          <a:ln/>
-        </p:spPr>
-        <p:txBody>
-          <a:bodyPr wrap="square" lIns="0" tIns="0" rIns="0" bIns="0" rtlCol="0" anchor="ctr"/>
-          <a:lstStyle/>
-          <a:p>
-            <a:pPr algn="ctr" indent="0" marL="0">
-              <a:buNone/>
-            </a:pPr>
-            <a:r>
-              <a:rPr lang="en-US" sz="750" b="1" spc="100" kern="0" dirty="0">
-                <a:solidFill>
-                  <a:srgbClr val="0A3170"/>
-                </a:solidFill>
-                <a:latin typeface="Arial" pitchFamily="34" charset="0"/>
-                <a:ea typeface="Arial" pitchFamily="34" charset="-122"/>
-                <a:cs typeface="Arial" pitchFamily="34" charset="-120"/>
-              </a:rPr>
-              <a:t>CÔNG NGHỆ IN 3D</a:t>
-            </a:r>
-            <a:endParaRPr lang="en-US" sz="750" dirty="0"/>
-          </a:p>
-        </p:txBody>
-      </p:sp>
-      <p:sp>
-        <p:nvSpPr>
-          <p:cNvPr id="55" name="Text 27"/>
-          <p:cNvSpPr txBox="1"/>
-          <p:nvPr/>
-        </p:nvSpPr>
-        <p:spPr>
-          <a:xfrm>
-            <a:off x="9858502" y="2616498"/>
-            <a:ext cx="1911096" cy="276225"/>
-          </a:xfrm>
-          <a:prstGeom prst="rect">
-            <a:avLst/>
-          </a:prstGeom>
-          <a:noFill/>
-          <a:ln/>
-        </p:spPr>
-        <p:txBody>
-          <a:bodyPr wrap="square" lIns="0" tIns="0" rIns="0" bIns="0" rtlCol="0" anchor="ctr"/>
-          <a:lstStyle/>
-          <a:p>
-            <a:pPr algn="ctr" indent="0" marL="0">
-              <a:buNone/>
-            </a:pPr>
-            <a:r>
-              <a:rPr lang="en-US" sz="750" b="1" dirty="0">
-                <a:solidFill>
-                  <a:srgbClr val="FFFFFF"/>
-                </a:solidFill>
-                <a:latin typeface="Arial" pitchFamily="34" charset="0"/>
-                <a:ea typeface="Arial" pitchFamily="34" charset="-122"/>
-                <a:cs typeface="Arial" pitchFamily="34" charset="-120"/>
-              </a:rPr>
-              <a:t>Cấu trúc xốp tối ưu hóa</a:t>
-            </a:r>
-            <a:endParaRPr lang="en-US" sz="750" dirty="0"/>
-          </a:p>
-          <a:p>
-            <a:pPr algn="ctr" indent="0" marL="0">
-              <a:buNone/>
-            </a:pPr>
-            <a:r>
-              <a:rPr lang="en-US" sz="750" b="1" dirty="0">
-                <a:solidFill>
-                  <a:srgbClr val="FFFFFF"/>
-                </a:solidFill>
-                <a:latin typeface="Arial" pitchFamily="34" charset="0"/>
-                <a:ea typeface="Arial" pitchFamily="34" charset="-122"/>
-                <a:cs typeface="Arial" pitchFamily="34" charset="-120"/>
-              </a:rPr>
-              <a:t>tích hợp xương</a:t>
-            </a:r>
-            <a:endParaRPr lang="en-US" sz="750" dirty="0"/>
-          </a:p>
-        </p:txBody>
-      </p:sp>
-      <p:sp>
-        <p:nvSpPr>
-          <p:cNvPr id="56" name="Text 28"/>
-          <p:cNvSpPr txBox="1"/>
-          <p:nvPr/>
-        </p:nvSpPr>
-        <p:spPr>
-          <a:xfrm>
-            <a:off x="10053093" y="3796613"/>
-            <a:ext cx="645515" cy="152384"/>
-          </a:xfrm>
-          <a:prstGeom prst="rect">
-            <a:avLst/>
-          </a:prstGeom>
-          <a:noFill/>
-          <a:ln/>
-        </p:spPr>
-        <p:txBody>
-          <a:bodyPr wrap="square" lIns="0" tIns="0" rIns="0" bIns="0" rtlCol="0" anchor="ctr"/>
-          <a:lstStyle/>
-          <a:p>
-            <a:pPr algn="ctr" indent="0" marL="0">
-              <a:buNone/>
-            </a:pPr>
-            <a:r>
-              <a:rPr lang="en-US" sz="900" b="1" spc="25" kern="0" dirty="0">
-                <a:solidFill>
-                  <a:srgbClr val="FFFFFF"/>
-                </a:solidFill>
-                <a:latin typeface="Arial" pitchFamily="34" charset="0"/>
-                <a:ea typeface="Arial" pitchFamily="34" charset="-122"/>
-                <a:cs typeface="Arial" pitchFamily="34" charset="-120"/>
-              </a:rPr>
-              <a:t>PANTHER</a:t>
-            </a:r>
-            <a:endParaRPr lang="en-US" sz="900" dirty="0"/>
-          </a:p>
-        </p:txBody>
-      </p:sp>
-      <p:sp>
-        <p:nvSpPr>
-          <p:cNvPr id="57" name="Text 29"/>
-          <p:cNvSpPr txBox="1"/>
-          <p:nvPr/>
-        </p:nvSpPr>
-        <p:spPr>
-          <a:xfrm>
-            <a:off x="10005580" y="3951093"/>
-            <a:ext cx="740640" cy="277606"/>
-          </a:xfrm>
-          <a:prstGeom prst="rect">
-            <a:avLst/>
-          </a:prstGeom>
-          <a:noFill/>
-          <a:ln/>
-        </p:spPr>
-        <p:txBody>
-          <a:bodyPr wrap="square" lIns="0" tIns="0" rIns="0" bIns="0" rtlCol="0" anchor="ctr"/>
-          <a:lstStyle/>
-          <a:p>
-            <a:pPr algn="ctr" indent="0" marL="0">
-              <a:buNone/>
-            </a:pPr>
-            <a:r>
-              <a:rPr lang="en-US" sz="725" dirty="0">
-                <a:solidFill>
-                  <a:srgbClr val="CFE6FF"/>
-                </a:solidFill>
-                <a:latin typeface="Arial" pitchFamily="34" charset="0"/>
-                <a:ea typeface="Arial" pitchFamily="34" charset="-122"/>
-                <a:cs typeface="Arial" pitchFamily="34" charset="-120"/>
-              </a:rPr>
-              <a:t>Lồng thắt lưng</a:t>
+              <a:t>ít xâm lấn</a:t>
             </a:r>
             <a:endParaRPr lang="en-US" sz="725" dirty="0"/>
           </a:p>
-          <a:p>
-            <a:pPr algn="ctr" indent="0" marL="0">
-              <a:buNone/>
-            </a:pPr>
-            <a:r>
-              <a:rPr lang="en-US" sz="725" dirty="0">
-                <a:solidFill>
-                  <a:srgbClr val="CFE6FF"/>
-                </a:solidFill>
-                <a:latin typeface="Arial" pitchFamily="34" charset="0"/>
-                <a:ea typeface="Arial" pitchFamily="34" charset="-122"/>
-                <a:cs typeface="Arial" pitchFamily="34" charset="-120"/>
-              </a:rPr>
-              <a:t>in 3D</a:t>
-            </a:r>
-            <a:endParaRPr lang="en-US" sz="725" dirty="0"/>
-          </a:p>
-        </p:txBody>
-      </p:sp>
-      <p:sp>
-        <p:nvSpPr>
-          <p:cNvPr id="58" name="Text 30"/>
-          <p:cNvSpPr txBox="1"/>
-          <p:nvPr/>
-        </p:nvSpPr>
-        <p:spPr>
-          <a:xfrm>
-            <a:off x="11022256" y="3796613"/>
-            <a:ext cx="459790" cy="152384"/>
-          </a:xfrm>
-          <a:prstGeom prst="rect">
-            <a:avLst/>
-          </a:prstGeom>
-          <a:noFill/>
-          <a:ln/>
-        </p:spPr>
-        <p:txBody>
-          <a:bodyPr wrap="square" lIns="0" tIns="0" rIns="0" bIns="0" rtlCol="0" anchor="ctr"/>
-          <a:lstStyle/>
-          <a:p>
-            <a:pPr algn="ctr" indent="0" marL="0">
-              <a:buNone/>
-            </a:pPr>
-            <a:r>
-              <a:rPr lang="en-US" sz="900" b="1" spc="25" kern="0" dirty="0">
-                <a:solidFill>
-                  <a:srgbClr val="FFFFFF"/>
-                </a:solidFill>
-                <a:latin typeface="Arial" pitchFamily="34" charset="0"/>
-                <a:ea typeface="Arial" pitchFamily="34" charset="-122"/>
-                <a:cs typeface="Arial" pitchFamily="34" charset="-120"/>
-              </a:rPr>
-              <a:t>PETRA</a:t>
-            </a:r>
-            <a:endParaRPr lang="en-US" sz="900" dirty="0"/>
-          </a:p>
-        </p:txBody>
-      </p:sp>
-      <p:sp>
-        <p:nvSpPr>
-          <p:cNvPr id="59" name="Text 31"/>
-          <p:cNvSpPr txBox="1"/>
-          <p:nvPr/>
-        </p:nvSpPr>
-        <p:spPr>
-          <a:xfrm>
-            <a:off x="11048045" y="3951093"/>
-            <a:ext cx="408212" cy="277606"/>
-          </a:xfrm>
-          <a:prstGeom prst="rect">
-            <a:avLst/>
-          </a:prstGeom>
-          <a:noFill/>
-          <a:ln/>
-        </p:spPr>
-        <p:txBody>
-          <a:bodyPr wrap="square" lIns="0" tIns="0" rIns="0" bIns="0" rtlCol="0" anchor="ctr"/>
-          <a:lstStyle/>
-          <a:p>
-            <a:pPr algn="ctr" indent="0" marL="0">
-              <a:buNone/>
-            </a:pPr>
-            <a:r>
-              <a:rPr lang="en-US" sz="725" dirty="0">
-                <a:solidFill>
-                  <a:srgbClr val="CFE6FF"/>
-                </a:solidFill>
-                <a:latin typeface="Arial" pitchFamily="34" charset="0"/>
-                <a:ea typeface="Arial" pitchFamily="34" charset="-122"/>
-                <a:cs typeface="Arial" pitchFamily="34" charset="-120"/>
-              </a:rPr>
-              <a:t>Lồng cổ</a:t>
-            </a:r>
-            <a:endParaRPr lang="en-US" sz="725" dirty="0"/>
-          </a:p>
-          <a:p>
-            <a:pPr algn="ctr" indent="0" marL="0">
-              <a:buNone/>
-            </a:pPr>
-            <a:r>
-              <a:rPr lang="en-US" sz="725" dirty="0">
-                <a:solidFill>
-                  <a:srgbClr val="CFE6FF"/>
-                </a:solidFill>
-                <a:latin typeface="Arial" pitchFamily="34" charset="0"/>
-                <a:ea typeface="Arial" pitchFamily="34" charset="-122"/>
-                <a:cs typeface="Arial" pitchFamily="34" charset="-120"/>
-              </a:rPr>
-              <a:t>in 3D</a:t>
-            </a:r>
-            <a:endParaRPr lang="en-US" sz="725" dirty="0"/>
-          </a:p>
-        </p:txBody>
-      </p:sp>
-      <p:sp>
-        <p:nvSpPr>
-          <p:cNvPr id="60" name="Text 32"/>
-          <p:cNvSpPr txBox="1"/>
-          <p:nvPr/>
-        </p:nvSpPr>
-        <p:spPr>
-          <a:xfrm>
-            <a:off x="10011035" y="5494742"/>
-            <a:ext cx="659880" cy="152384"/>
-          </a:xfrm>
-          <a:prstGeom prst="rect">
-            <a:avLst/>
-          </a:prstGeom>
-          <a:noFill/>
-          <a:ln/>
-        </p:spPr>
-        <p:txBody>
-          <a:bodyPr wrap="square" lIns="0" tIns="0" rIns="0" bIns="0" rtlCol="0" anchor="ctr"/>
-          <a:lstStyle/>
-          <a:p>
-            <a:pPr algn="ctr" indent="0" marL="0">
-              <a:buNone/>
-            </a:pPr>
-            <a:r>
-              <a:rPr lang="en-US" sz="900" b="1" spc="25" kern="0" dirty="0">
-                <a:solidFill>
-                  <a:srgbClr val="FFFFFF"/>
-                </a:solidFill>
-                <a:latin typeface="Arial" pitchFamily="34" charset="0"/>
-                <a:ea typeface="Arial" pitchFamily="34" charset="-122"/>
-                <a:cs typeface="Arial" pitchFamily="34" charset="-120"/>
-              </a:rPr>
-              <a:t>QUATTRO</a:t>
-            </a:r>
-            <a:endParaRPr lang="en-US" sz="900" dirty="0"/>
-          </a:p>
-        </p:txBody>
-      </p:sp>
-      <p:sp>
-        <p:nvSpPr>
-          <p:cNvPr id="61" name="Text 33"/>
-          <p:cNvSpPr txBox="1"/>
-          <p:nvPr/>
-        </p:nvSpPr>
-        <p:spPr>
-          <a:xfrm>
-            <a:off x="9961945" y="5658795"/>
-            <a:ext cx="758059" cy="138803"/>
-          </a:xfrm>
-          <a:prstGeom prst="rect">
-            <a:avLst/>
-          </a:prstGeom>
-          <a:noFill/>
-          <a:ln/>
-        </p:spPr>
-        <p:txBody>
-          <a:bodyPr wrap="square" lIns="0" tIns="0" rIns="0" bIns="0" rtlCol="0" anchor="ctr"/>
-          <a:lstStyle/>
-          <a:p>
-            <a:pPr algn="ctr" indent="0" marL="0">
-              <a:buNone/>
-            </a:pPr>
-            <a:r>
-              <a:rPr lang="en-US" sz="725" dirty="0">
-                <a:solidFill>
-                  <a:srgbClr val="CFE6FF"/>
-                </a:solidFill>
-                <a:latin typeface="Arial" pitchFamily="34" charset="0"/>
-                <a:ea typeface="Arial" pitchFamily="34" charset="-122"/>
-                <a:cs typeface="Arial" pitchFamily="34" charset="-120"/>
-              </a:rPr>
-              <a:t>Vít cuống sống</a:t>
-            </a:r>
-            <a:endParaRPr lang="en-US" sz="725" dirty="0"/>
-          </a:p>
-        </p:txBody>
-      </p:sp>
-      <p:sp>
-        <p:nvSpPr>
-          <p:cNvPr id="62" name="Text 34"/>
-          <p:cNvSpPr txBox="1"/>
-          <p:nvPr/>
-        </p:nvSpPr>
-        <p:spPr>
-          <a:xfrm>
-            <a:off x="10957185" y="5484233"/>
-            <a:ext cx="659880" cy="304768"/>
-          </a:xfrm>
-          <a:prstGeom prst="rect">
-            <a:avLst/>
-          </a:prstGeom>
-          <a:noFill/>
-          <a:ln/>
-        </p:spPr>
-        <p:txBody>
-          <a:bodyPr wrap="square" lIns="0" tIns="0" rIns="0" bIns="0" rtlCol="0" anchor="ctr"/>
-          <a:lstStyle/>
-          <a:p>
-            <a:pPr algn="ctr" indent="0" marL="0">
-              <a:buNone/>
-            </a:pPr>
-            <a:r>
-              <a:rPr lang="en-US" sz="900" b="1" spc="25" kern="0" dirty="0">
-                <a:solidFill>
-                  <a:srgbClr val="FFFFFF"/>
-                </a:solidFill>
-                <a:latin typeface="Arial" pitchFamily="34" charset="0"/>
-                <a:ea typeface="Arial" pitchFamily="34" charset="-122"/>
-                <a:cs typeface="Arial" pitchFamily="34" charset="-120"/>
-              </a:rPr>
-              <a:t>QUATTRO</a:t>
-            </a:r>
-            <a:endParaRPr lang="en-US" sz="900" dirty="0"/>
-          </a:p>
-          <a:p>
-            <a:pPr algn="ctr" indent="0" marL="0">
-              <a:buNone/>
-            </a:pPr>
-            <a:r>
-              <a:rPr lang="en-US" sz="900" b="1" spc="25" kern="0" dirty="0">
-                <a:solidFill>
-                  <a:srgbClr val="FFFFFF"/>
-                </a:solidFill>
-                <a:latin typeface="Arial" pitchFamily="34" charset="0"/>
-                <a:ea typeface="Arial" pitchFamily="34" charset="-122"/>
-                <a:cs typeface="Arial" pitchFamily="34" charset="-120"/>
-              </a:rPr>
-              <a:t>GADGET</a:t>
-            </a:r>
-            <a:endParaRPr lang="en-US" sz="900" dirty="0"/>
-          </a:p>
         </p:txBody>
       </p:sp>
       <p:sp>
@@ -3068,63 +3085,7 @@
         </p:nvSpPr>
         <p:spPr>
           <a:xfrm>
-            <a:off x="11036255" y="5780588"/>
-            <a:ext cx="501640" cy="277606"/>
-          </a:xfrm>
-          <a:prstGeom prst="rect">
-            <a:avLst/>
-          </a:prstGeom>
-          <a:noFill/>
-          <a:ln/>
-        </p:spPr>
-        <p:txBody>
-          <a:bodyPr wrap="square" lIns="0" tIns="0" rIns="0" bIns="0" rtlCol="0" anchor="ctr"/>
-          <a:lstStyle/>
-          <a:p>
-            <a:pPr algn="ctr" indent="0" marL="0">
-              <a:buNone/>
-            </a:pPr>
-            <a:r>
-              <a:rPr lang="en-US" sz="725" dirty="0">
-                <a:solidFill>
-                  <a:srgbClr val="CFE6FF"/>
-                </a:solidFill>
-                <a:latin typeface="Arial" pitchFamily="34" charset="0"/>
-                <a:ea typeface="Arial" pitchFamily="34" charset="-122"/>
-                <a:cs typeface="Arial" pitchFamily="34" charset="-120"/>
-              </a:rPr>
-              <a:t>Vít qua da</a:t>
-            </a:r>
-            <a:endParaRPr lang="en-US" sz="725" dirty="0"/>
-          </a:p>
-          <a:p>
-            <a:pPr algn="ctr" indent="0" marL="0">
-              <a:buNone/>
-            </a:pPr>
-            <a:r>
-              <a:rPr lang="en-US" sz="725" dirty="0">
-                <a:solidFill>
-                  <a:srgbClr val="CFE6FF"/>
-                </a:solidFill>
-                <a:latin typeface="Arial" pitchFamily="34" charset="0"/>
-                <a:ea typeface="Arial" pitchFamily="34" charset="-122"/>
-                <a:cs typeface="Arial" pitchFamily="34" charset="-120"/>
-              </a:rPr>
-              <a:t>ít xâm lấn</a:t>
-            </a:r>
-            <a:endParaRPr lang="en-US" sz="725" dirty="0"/>
-          </a:p>
-        </p:txBody>
-      </p:sp>
-      <p:sp>
-        <p:nvSpPr>
-          <p:cNvPr id="64" name="Text 36"/>
-          <p:cNvSpPr txBox="1"/>
-          <p:nvPr/>
-        </p:nvSpPr>
-        <p:spPr>
-          <a:xfrm>
-            <a:off x="11105753" y="6078220"/>
+            <a:off x="11112103" y="5354320"/>
             <a:ext cx="362744" cy="168612"/>
           </a:xfrm>
           <a:prstGeom prst="rect">

</xml_diff>

<commit_message>
Backdrop VOA: robot anchored to bottom; PPT shadows baked per image and callout lines as top layer
Co-Authored-By: Claude Opus 5.5 <noreply@anthropic.com>
Claude-Session: https://claude.ai/code/session_013QJi2k1EkL4AWCx1Ymi9NU
</commit_message>
<xml_diff>
--- a/backdrop-voa/backdrop-VOA.pptx
+++ b/backdrop-voa/backdrop-VOA.pptx
@@ -1100,7 +1100,7 @@
       </p:pic>
       <p:pic>
         <p:nvPicPr>
-          <p:cNvPr id="11" name="Image 9" descr="40.png">    </p:cNvPr>
+          <p:cNvPr id="11" name="Image 9" descr="sh_40.png">    </p:cNvPr>
           <p:cNvPicPr>
             <a:picLocks noChangeAspect="1"/>
           </p:cNvPicPr>
@@ -1114,8 +1114,8 @@
         </p:blipFill>
         <p:spPr>
           <a:xfrm>
-            <a:off x="2070611" y="2743696"/>
-            <a:ext cx="2792878" cy="939701"/>
+            <a:off x="1812740" y="2485825"/>
+            <a:ext cx="3308621" cy="1455444"/>
           </a:xfrm>
           <a:prstGeom prst="rect">
             <a:avLst/>
@@ -1148,7 +1148,7 @@
       </p:pic>
       <p:pic>
         <p:nvPicPr>
-          <p:cNvPr id="13" name="Image 11" descr="36.png">    </p:cNvPr>
+          <p:cNvPr id="13" name="Image 11" descr="sh_36.png">    </p:cNvPr>
           <p:cNvPicPr>
             <a:picLocks noChangeAspect="1"/>
           </p:cNvPicPr>
@@ -1162,8 +1162,8 @@
         </p:blipFill>
         <p:spPr>
           <a:xfrm>
-            <a:off x="527051" y="4155380"/>
-            <a:ext cx="2832099" cy="925016"/>
+            <a:off x="270328" y="3898658"/>
+            <a:ext cx="3345544" cy="1438462"/>
           </a:xfrm>
           <a:prstGeom prst="rect">
             <a:avLst/>
@@ -1354,8 +1354,8 @@
         </p:blipFill>
         <p:spPr>
           <a:xfrm>
-            <a:off x="6324600" y="2317773"/>
-            <a:ext cx="3129260" cy="2857454"/>
+            <a:off x="5934619" y="2372285"/>
+            <a:ext cx="4012309" cy="3707280"/>
           </a:xfrm>
           <a:prstGeom prst="rect">
             <a:avLst/>
@@ -1506,9 +1506,33 @@
           </a:prstGeom>
         </p:spPr>
       </p:pic>
-      <p:sp>
-        <p:nvSpPr>
-          <p:cNvPr id="28" name="Text 0"/>
+      <p:pic>
+        <p:nvPicPr>
+          <p:cNvPr id="28" name="Image 26" descr="Callout lines">    </p:cNvPr>
+          <p:cNvPicPr>
+            <a:picLocks noChangeAspect="1"/>
+          </p:cNvPicPr>
+          <p:nvPr/>
+        </p:nvPicPr>
+        <p:blipFill>
+          <a:blip r:embed="rId28"/>
+          <a:stretch>
+            <a:fillRect/>
+          </a:stretch>
+        </p:blipFill>
+        <p:spPr>
+          <a:xfrm>
+            <a:off x="0" y="0"/>
+            <a:ext cx="12191695" cy="6096305"/>
+          </a:xfrm>
+          <a:prstGeom prst="rect">
+            <a:avLst/>
+          </a:prstGeom>
+        </p:spPr>
+      </p:pic>
+      <p:sp>
+        <p:nvSpPr>
+          <p:cNvPr id="29" name="Text 0"/>
           <p:cNvSpPr txBox="1"/>
           <p:nvPr/>
         </p:nvSpPr>
@@ -1561,7 +1585,7 @@
       </p:sp>
       <p:sp>
         <p:nvSpPr>
-          <p:cNvPr id="29" name="Text 1"/>
+          <p:cNvPr id="30" name="Text 1"/>
           <p:cNvSpPr txBox="1"/>
           <p:nvPr/>
         </p:nvSpPr>
@@ -1600,7 +1624,7 @@
       </p:sp>
       <p:sp>
         <p:nvSpPr>
-          <p:cNvPr id="30" name="Text 2"/>
+          <p:cNvPr id="31" name="Text 2"/>
           <p:cNvSpPr txBox="1"/>
           <p:nvPr/>
         </p:nvSpPr>
@@ -1653,7 +1677,7 @@
       </p:sp>
       <p:sp>
         <p:nvSpPr>
-          <p:cNvPr id="31" name="Text 3"/>
+          <p:cNvPr id="32" name="Text 3"/>
           <p:cNvSpPr txBox="1"/>
           <p:nvPr/>
         </p:nvSpPr>
@@ -1692,7 +1716,7 @@
       </p:sp>
       <p:sp>
         <p:nvSpPr>
-          <p:cNvPr id="32" name="Text 4"/>
+          <p:cNvPr id="33" name="Text 4"/>
           <p:cNvSpPr txBox="1"/>
           <p:nvPr/>
         </p:nvSpPr>
@@ -1731,7 +1755,7 @@
       </p:sp>
       <p:sp>
         <p:nvSpPr>
-          <p:cNvPr id="33" name="Text 5"/>
+          <p:cNvPr id="34" name="Text 5"/>
           <p:cNvSpPr txBox="1"/>
           <p:nvPr/>
         </p:nvSpPr>
@@ -1770,7 +1794,7 @@
       </p:sp>
       <p:sp>
         <p:nvSpPr>
-          <p:cNvPr id="34" name="Text 6"/>
+          <p:cNvPr id="35" name="Text 6"/>
           <p:cNvSpPr txBox="1"/>
           <p:nvPr/>
         </p:nvSpPr>
@@ -1809,7 +1833,7 @@
       </p:sp>
       <p:sp>
         <p:nvSpPr>
-          <p:cNvPr id="35" name="Text 7"/>
+          <p:cNvPr id="36" name="Text 7"/>
           <p:cNvSpPr txBox="1"/>
           <p:nvPr/>
         </p:nvSpPr>
@@ -1848,7 +1872,7 @@
       </p:sp>
       <p:sp>
         <p:nvSpPr>
-          <p:cNvPr id="36" name="Text 8"/>
+          <p:cNvPr id="37" name="Text 8"/>
           <p:cNvSpPr txBox="1"/>
           <p:nvPr/>
         </p:nvSpPr>
@@ -1901,7 +1925,7 @@
       </p:sp>
       <p:sp>
         <p:nvSpPr>
-          <p:cNvPr id="37" name="Text 9"/>
+          <p:cNvPr id="38" name="Text 9"/>
           <p:cNvSpPr txBox="1"/>
           <p:nvPr/>
         </p:nvSpPr>
@@ -1954,7 +1978,7 @@
       </p:sp>
       <p:sp>
         <p:nvSpPr>
-          <p:cNvPr id="38" name="Text 10"/>
+          <p:cNvPr id="39" name="Text 10"/>
           <p:cNvSpPr txBox="1"/>
           <p:nvPr/>
         </p:nvSpPr>
@@ -2010,7 +2034,7 @@
       </p:sp>
       <p:sp>
         <p:nvSpPr>
-          <p:cNvPr id="39" name="Text 11"/>
+          <p:cNvPr id="40" name="Text 11"/>
           <p:cNvSpPr txBox="1"/>
           <p:nvPr/>
         </p:nvSpPr>
@@ -2049,7 +2073,7 @@
       </p:sp>
       <p:sp>
         <p:nvSpPr>
-          <p:cNvPr id="40" name="Text 12"/>
+          <p:cNvPr id="41" name="Text 12"/>
           <p:cNvSpPr txBox="1"/>
           <p:nvPr/>
         </p:nvSpPr>
@@ -2088,7 +2112,7 @@
       </p:sp>
       <p:sp>
         <p:nvSpPr>
-          <p:cNvPr id="41" name="Text 13"/>
+          <p:cNvPr id="42" name="Text 13"/>
           <p:cNvSpPr txBox="1"/>
           <p:nvPr/>
         </p:nvSpPr>
@@ -2127,7 +2151,7 @@
       </p:sp>
       <p:sp>
         <p:nvSpPr>
-          <p:cNvPr id="42" name="Text 14"/>
+          <p:cNvPr id="43" name="Text 14"/>
           <p:cNvSpPr txBox="1"/>
           <p:nvPr/>
         </p:nvSpPr>
@@ -2166,7 +2190,7 @@
       </p:sp>
       <p:sp>
         <p:nvSpPr>
-          <p:cNvPr id="43" name="Text 15"/>
+          <p:cNvPr id="44" name="Text 15"/>
           <p:cNvSpPr txBox="1"/>
           <p:nvPr/>
         </p:nvSpPr>
@@ -2205,7 +2229,7 @@
       </p:sp>
       <p:sp>
         <p:nvSpPr>
-          <p:cNvPr id="44" name="Text 16"/>
+          <p:cNvPr id="45" name="Text 16"/>
           <p:cNvSpPr txBox="1"/>
           <p:nvPr/>
         </p:nvSpPr>
@@ -2244,7 +2268,7 @@
       </p:sp>
       <p:sp>
         <p:nvSpPr>
-          <p:cNvPr id="45" name="Text 17"/>
+          <p:cNvPr id="46" name="Text 17"/>
           <p:cNvSpPr txBox="1"/>
           <p:nvPr/>
         </p:nvSpPr>
@@ -2283,7 +2307,7 @@
       </p:sp>
       <p:sp>
         <p:nvSpPr>
-          <p:cNvPr id="46" name="Text 18"/>
+          <p:cNvPr id="47" name="Text 18"/>
           <p:cNvSpPr txBox="1"/>
           <p:nvPr/>
         </p:nvSpPr>
@@ -2336,13 +2360,13 @@
       </p:sp>
       <p:sp>
         <p:nvSpPr>
-          <p:cNvPr id="47" name="Text 19"/>
-          <p:cNvSpPr txBox="1"/>
-          <p:nvPr/>
-        </p:nvSpPr>
-        <p:spPr>
-          <a:xfrm>
-            <a:off x="7029450" y="2038096"/>
+          <p:cNvPr id="48" name="Text 19"/>
+          <p:cNvSpPr txBox="1"/>
+          <p:nvPr/>
+        </p:nvSpPr>
+        <p:spPr>
+          <a:xfrm>
+            <a:off x="7029450" y="2203196"/>
             <a:ext cx="241300" cy="279908"/>
           </a:xfrm>
           <a:prstGeom prst="rect">
@@ -2375,13 +2399,13 @@
       </p:sp>
       <p:sp>
         <p:nvSpPr>
-          <p:cNvPr id="48" name="Text 20"/>
-          <p:cNvSpPr txBox="1"/>
-          <p:nvPr/>
-        </p:nvSpPr>
-        <p:spPr>
-          <a:xfrm>
-            <a:off x="7334250" y="2094039"/>
+          <p:cNvPr id="49" name="Text 20"/>
+          <p:cNvSpPr txBox="1"/>
+          <p:nvPr/>
+        </p:nvSpPr>
+        <p:spPr>
+          <a:xfrm>
+            <a:off x="7334250" y="2259140"/>
             <a:ext cx="1458206" cy="167922"/>
           </a:xfrm>
           <a:prstGeom prst="rect">
@@ -2414,13 +2438,13 @@
       </p:sp>
       <p:sp>
         <p:nvSpPr>
-          <p:cNvPr id="49" name="Text 21"/>
-          <p:cNvSpPr txBox="1"/>
-          <p:nvPr/>
-        </p:nvSpPr>
-        <p:spPr>
-          <a:xfrm>
-            <a:off x="8240514" y="2520696"/>
+          <p:cNvPr id="50" name="Text 21"/>
+          <p:cNvSpPr txBox="1"/>
+          <p:nvPr/>
+        </p:nvSpPr>
+        <p:spPr>
+          <a:xfrm>
+            <a:off x="8240514" y="2787396"/>
             <a:ext cx="241300" cy="279908"/>
           </a:xfrm>
           <a:prstGeom prst="rect">
@@ -2453,13 +2477,13 @@
       </p:sp>
       <p:sp>
         <p:nvSpPr>
-          <p:cNvPr id="50" name="Text 22"/>
-          <p:cNvSpPr txBox="1"/>
-          <p:nvPr/>
-        </p:nvSpPr>
-        <p:spPr>
-          <a:xfrm>
-            <a:off x="8545314" y="2576639"/>
+          <p:cNvPr id="51" name="Text 22"/>
+          <p:cNvSpPr txBox="1"/>
+          <p:nvPr/>
+        </p:nvSpPr>
+        <p:spPr>
+          <a:xfrm>
+            <a:off x="8545314" y="2843340"/>
             <a:ext cx="1131320" cy="167922"/>
           </a:xfrm>
           <a:prstGeom prst="rect">
@@ -2492,13 +2516,13 @@
       </p:sp>
       <p:sp>
         <p:nvSpPr>
-          <p:cNvPr id="51" name="Text 23"/>
-          <p:cNvSpPr txBox="1"/>
-          <p:nvPr/>
-        </p:nvSpPr>
-        <p:spPr>
-          <a:xfrm>
-            <a:off x="5441950" y="4293537"/>
+          <p:cNvPr id="52" name="Text 23"/>
+          <p:cNvSpPr txBox="1"/>
+          <p:nvPr/>
+        </p:nvSpPr>
+        <p:spPr>
+          <a:xfrm>
+            <a:off x="5441950" y="4642787"/>
             <a:ext cx="241300" cy="279908"/>
           </a:xfrm>
           <a:prstGeom prst="rect">
@@ -2531,13 +2555,13 @@
       </p:sp>
       <p:sp>
         <p:nvSpPr>
-          <p:cNvPr id="52" name="Text 24"/>
-          <p:cNvSpPr txBox="1"/>
-          <p:nvPr/>
-        </p:nvSpPr>
-        <p:spPr>
-          <a:xfrm>
-            <a:off x="5746750" y="4181658"/>
+          <p:cNvPr id="53" name="Text 24"/>
+          <p:cNvSpPr txBox="1"/>
+          <p:nvPr/>
+        </p:nvSpPr>
+        <p:spPr>
+          <a:xfrm>
+            <a:off x="5746750" y="4530908"/>
             <a:ext cx="710892" cy="503765"/>
           </a:xfrm>
           <a:prstGeom prst="rect">
@@ -2604,7 +2628,7 @@
       </p:sp>
       <p:sp>
         <p:nvSpPr>
-          <p:cNvPr id="53" name="Text 25"/>
+          <p:cNvPr id="54" name="Text 25"/>
           <p:cNvSpPr txBox="1"/>
           <p:nvPr/>
         </p:nvSpPr>
@@ -2643,7 +2667,7 @@
       </p:sp>
       <p:sp>
         <p:nvSpPr>
-          <p:cNvPr id="54" name="Text 26"/>
+          <p:cNvPr id="55" name="Text 26"/>
           <p:cNvSpPr txBox="1"/>
           <p:nvPr/>
         </p:nvSpPr>
@@ -2699,7 +2723,7 @@
       </p:sp>
       <p:sp>
         <p:nvSpPr>
-          <p:cNvPr id="55" name="Text 27"/>
+          <p:cNvPr id="56" name="Text 27"/>
           <p:cNvSpPr txBox="1"/>
           <p:nvPr/>
         </p:nvSpPr>
@@ -2738,7 +2762,7 @@
       </p:sp>
       <p:sp>
         <p:nvSpPr>
-          <p:cNvPr id="56" name="Text 28"/>
+          <p:cNvPr id="57" name="Text 28"/>
           <p:cNvSpPr txBox="1"/>
           <p:nvPr/>
         </p:nvSpPr>
@@ -2794,7 +2818,7 @@
       </p:sp>
       <p:sp>
         <p:nvSpPr>
-          <p:cNvPr id="57" name="Text 29"/>
+          <p:cNvPr id="58" name="Text 29"/>
           <p:cNvSpPr txBox="1"/>
           <p:nvPr/>
         </p:nvSpPr>
@@ -2833,7 +2857,7 @@
       </p:sp>
       <p:sp>
         <p:nvSpPr>
-          <p:cNvPr id="58" name="Text 30"/>
+          <p:cNvPr id="59" name="Text 30"/>
           <p:cNvSpPr txBox="1"/>
           <p:nvPr/>
         </p:nvSpPr>
@@ -2889,7 +2913,7 @@
       </p:sp>
       <p:sp>
         <p:nvSpPr>
-          <p:cNvPr id="59" name="Text 31"/>
+          <p:cNvPr id="60" name="Text 31"/>
           <p:cNvSpPr txBox="1"/>
           <p:nvPr/>
         </p:nvSpPr>
@@ -2928,7 +2952,7 @@
       </p:sp>
       <p:sp>
         <p:nvSpPr>
-          <p:cNvPr id="60" name="Text 32"/>
+          <p:cNvPr id="61" name="Text 32"/>
           <p:cNvSpPr txBox="1"/>
           <p:nvPr/>
         </p:nvSpPr>
@@ -2967,7 +2991,7 @@
       </p:sp>
       <p:sp>
         <p:nvSpPr>
-          <p:cNvPr id="61" name="Text 33"/>
+          <p:cNvPr id="62" name="Text 33"/>
           <p:cNvSpPr txBox="1"/>
           <p:nvPr/>
         </p:nvSpPr>
@@ -3023,7 +3047,7 @@
       </p:sp>
       <p:sp>
         <p:nvSpPr>
-          <p:cNvPr id="62" name="Text 34"/>
+          <p:cNvPr id="63" name="Text 34"/>
           <p:cNvSpPr txBox="1"/>
           <p:nvPr/>
         </p:nvSpPr>
@@ -3079,7 +3103,7 @@
       </p:sp>
       <p:sp>
         <p:nvSpPr>
-          <p:cNvPr id="63" name="Text 35"/>
+          <p:cNvPr id="64" name="Text 35"/>
           <p:cNvSpPr txBox="1"/>
           <p:nvPr/>
         </p:nvSpPr>

</xml_diff>

<commit_message>
Backdrop VOA: shrink robot area, enlarge Allgens and Mantiz
Co-Authored-By: Claude Opus 5.5 <noreply@anthropic.com>
Claude-Session: https://claude.ai/code/session_013QJi2k1EkL4AWCx1Ymi9NU
</commit_message>
<xml_diff>
--- a/backdrop-voa/backdrop-VOA.pptx
+++ b/backdrop-voa/backdrop-VOA.pptx
@@ -1018,8 +1018,8 @@
         </p:blipFill>
         <p:spPr>
           <a:xfrm>
-            <a:off x="539750" y="1263652"/>
-            <a:ext cx="992386" cy="419095"/>
+            <a:off x="539750" y="1244608"/>
+            <a:ext cx="1082576" cy="457183"/>
           </a:xfrm>
           <a:prstGeom prst="rect">
             <a:avLst/>
@@ -1042,7 +1042,7 @@
         </p:blipFill>
         <p:spPr>
           <a:xfrm>
-            <a:off x="3790652" y="1371608"/>
+            <a:off x="4362152" y="1371608"/>
             <a:ext cx="511870" cy="203185"/>
           </a:xfrm>
           <a:prstGeom prst="rect">
@@ -1066,7 +1066,7 @@
         </p:blipFill>
         <p:spPr>
           <a:xfrm>
-            <a:off x="4378722" y="1371603"/>
+            <a:off x="4950222" y="1371603"/>
             <a:ext cx="491728" cy="203193"/>
           </a:xfrm>
           <a:prstGeom prst="rect">
@@ -1090,8 +1090,8 @@
         </p:blipFill>
         <p:spPr>
           <a:xfrm>
-            <a:off x="749300" y="2883396"/>
-            <a:ext cx="1016000" cy="254000"/>
+            <a:off x="736600" y="2890838"/>
+            <a:ext cx="1168400" cy="292100"/>
           </a:xfrm>
           <a:prstGeom prst="rect">
             <a:avLst/>
@@ -1114,8 +1114,8 @@
         </p:blipFill>
         <p:spPr>
           <a:xfrm>
-            <a:off x="1812740" y="2485825"/>
-            <a:ext cx="3308621" cy="1455444"/>
+            <a:off x="1983063" y="2477668"/>
+            <a:ext cx="3666474" cy="1562841"/>
           </a:xfrm>
           <a:prstGeom prst="rect">
             <a:avLst/>
@@ -1138,8 +1138,8 @@
         </p:blipFill>
         <p:spPr>
           <a:xfrm>
-            <a:off x="3631605" y="4370295"/>
-            <a:ext cx="1042591" cy="253987"/>
+            <a:off x="4061420" y="4338647"/>
+            <a:ext cx="1198959" cy="292080"/>
           </a:xfrm>
           <a:prstGeom prst="rect">
             <a:avLst/>
@@ -1162,8 +1162,8 @@
         </p:blipFill>
         <p:spPr>
           <a:xfrm>
-            <a:off x="270328" y="3898658"/>
-            <a:ext cx="3345544" cy="1438462"/>
+            <a:off x="278603" y="3827710"/>
+            <a:ext cx="3773395" cy="1574206"/>
           </a:xfrm>
           <a:prstGeom prst="rect">
             <a:avLst/>
@@ -1186,7 +1186,7 @@
         </p:blipFill>
         <p:spPr>
           <a:xfrm>
-            <a:off x="5397500" y="1333505"/>
+            <a:off x="5969000" y="1333505"/>
             <a:ext cx="1052513" cy="266691"/>
           </a:xfrm>
           <a:prstGeom prst="rect">
@@ -1210,7 +1210,7 @@
         </p:blipFill>
         <p:spPr>
           <a:xfrm>
-            <a:off x="6538913" y="1384323"/>
+            <a:off x="7110413" y="1384323"/>
             <a:ext cx="232767" cy="165053"/>
           </a:xfrm>
           <a:prstGeom prst="rect">
@@ -1234,7 +1234,7 @@
         </p:blipFill>
         <p:spPr>
           <a:xfrm>
-            <a:off x="6822480" y="1384300"/>
+            <a:off x="7393980" y="1384300"/>
             <a:ext cx="415925" cy="165100"/>
           </a:xfrm>
           <a:prstGeom prst="rect">
@@ -1258,8 +1258,8 @@
         </p:blipFill>
         <p:spPr>
           <a:xfrm>
-            <a:off x="10045105" y="1358905"/>
-            <a:ext cx="878979" cy="215890"/>
+            <a:off x="9634538" y="1339860"/>
+            <a:ext cx="1034058" cy="253979"/>
           </a:xfrm>
           <a:prstGeom prst="rect">
             <a:avLst/>
@@ -1282,8 +1282,8 @@
         </p:blipFill>
         <p:spPr>
           <a:xfrm>
-            <a:off x="10987584" y="1339856"/>
-            <a:ext cx="236141" cy="253988"/>
+            <a:off x="10732095" y="1320807"/>
+            <a:ext cx="271562" cy="292087"/>
           </a:xfrm>
           <a:prstGeom prst="rect">
             <a:avLst/>
@@ -1306,8 +1306,8 @@
         </p:blipFill>
         <p:spPr>
           <a:xfrm>
-            <a:off x="11274524" y="1339878"/>
-            <a:ext cx="308471" cy="253943"/>
+            <a:off x="11054457" y="1320806"/>
+            <a:ext cx="354806" cy="292088"/>
           </a:xfrm>
           <a:prstGeom prst="rect">
             <a:avLst/>
@@ -1330,8 +1330,8 @@
         </p:blipFill>
         <p:spPr>
           <a:xfrm>
-            <a:off x="5473700" y="2032008"/>
-            <a:ext cx="1168797" cy="266683"/>
+            <a:off x="6045200" y="2209809"/>
+            <a:ext cx="1001812" cy="228582"/>
           </a:xfrm>
           <a:prstGeom prst="rect">
             <a:avLst/>
@@ -1354,8 +1354,8 @@
         </p:blipFill>
         <p:spPr>
           <a:xfrm>
-            <a:off x="5934619" y="2372285"/>
-            <a:ext cx="4012309" cy="3707280"/>
+            <a:off x="6400801" y="3035307"/>
+            <a:ext cx="3289595" cy="3047987"/>
           </a:xfrm>
           <a:prstGeom prst="rect">
             <a:avLst/>
@@ -1378,8 +1378,8 @@
         </p:blipFill>
         <p:spPr>
           <a:xfrm>
-            <a:off x="9999013" y="2779713"/>
-            <a:ext cx="354617" cy="264021"/>
+            <a:off x="9442861" y="2676128"/>
+            <a:ext cx="485349" cy="361355"/>
           </a:xfrm>
           <a:prstGeom prst="rect">
             <a:avLst/>
@@ -1402,8 +1402,8 @@
         </p:blipFill>
         <p:spPr>
           <a:xfrm>
-            <a:off x="10372753" y="2775248"/>
-            <a:ext cx="354651" cy="273050"/>
+            <a:off x="9947301" y="2669977"/>
+            <a:ext cx="485326" cy="373658"/>
           </a:xfrm>
           <a:prstGeom prst="rect">
             <a:avLst/>
@@ -1426,8 +1426,8 @@
         </p:blipFill>
         <p:spPr>
           <a:xfrm>
-            <a:off x="10900688" y="2757388"/>
-            <a:ext cx="354667" cy="308769"/>
+            <a:off x="10611299" y="2645569"/>
+            <a:ext cx="485274" cy="422473"/>
           </a:xfrm>
           <a:prstGeom prst="rect">
             <a:avLst/>
@@ -1450,8 +1450,8 @@
         </p:blipFill>
         <p:spPr>
           <a:xfrm>
-            <a:off x="11274426" y="2762548"/>
-            <a:ext cx="354706" cy="298351"/>
+            <a:off x="11115720" y="2652713"/>
+            <a:ext cx="485288" cy="408186"/>
           </a:xfrm>
           <a:prstGeom prst="rect">
             <a:avLst/>
@@ -1474,8 +1474,8 @@
         </p:blipFill>
         <p:spPr>
           <a:xfrm>
-            <a:off x="10103374" y="4165402"/>
-            <a:ext cx="462502" cy="507901"/>
+            <a:off x="9585356" y="4072037"/>
+            <a:ext cx="647539" cy="711101"/>
           </a:xfrm>
           <a:prstGeom prst="rect">
             <a:avLst/>
@@ -1498,8 +1498,8 @@
         </p:blipFill>
         <p:spPr>
           <a:xfrm>
-            <a:off x="10960121" y="4175026"/>
-            <a:ext cx="666707" cy="488752"/>
+            <a:off x="10668057" y="4085530"/>
+            <a:ext cx="933336" cy="684213"/>
           </a:xfrm>
           <a:prstGeom prst="rect">
             <a:avLst/>
@@ -1839,8 +1839,8 @@
         </p:nvSpPr>
         <p:spPr>
           <a:xfrm>
-            <a:off x="222123" y="1810766"/>
-            <a:ext cx="4965954" cy="169418"/>
+            <a:off x="182118" y="1809242"/>
+            <a:ext cx="5617464" cy="191516"/>
           </a:xfrm>
           <a:prstGeom prst="rect">
             <a:avLst/>
@@ -1856,7 +1856,7 @@
               <a:buNone/>
             </a:pPr>
             <a:r>
-              <a:rPr lang="en-US" sz="1000" b="1" spc="75" kern="0" dirty="0">
+              <a:rPr lang="en-US" sz="1100" b="1" spc="75" kern="0" dirty="0">
                 <a:solidFill>
                   <a:srgbClr val="CFE6FF"/>
                 </a:solidFill>
@@ -1866,7 +1866,7 @@
               </a:rPr>
               <a:t>VẬT LIỆU XƯƠNG SINH HỌC COLLAGEN KHOÁNG HÓA</a:t>
             </a:r>
-            <a:endParaRPr lang="en-US" sz="1000" dirty="0"/>
+            <a:endParaRPr lang="en-US" sz="1100" dirty="0"/>
           </a:p>
         </p:txBody>
       </p:sp>
@@ -1878,8 +1878,8 @@
         </p:nvSpPr>
         <p:spPr>
           <a:xfrm>
-            <a:off x="1534616" y="2002028"/>
-            <a:ext cx="2972627" cy="250444"/>
+            <a:off x="1689993" y="2019046"/>
+            <a:ext cx="3269879" cy="279908"/>
           </a:xfrm>
           <a:prstGeom prst="rect">
             <a:avLst/>
@@ -1895,44 +1895,599 @@
               <a:buNone/>
             </a:pPr>
             <a:r>
+              <a:rPr lang="en-US" sz="1650" b="1" dirty="0">
+                <a:solidFill>
+                  <a:srgbClr val="FFFFFF"/>
+                </a:solidFill>
+                <a:latin typeface="Arial" pitchFamily="34" charset="0"/>
+                <a:ea typeface="Arial" pitchFamily="34" charset="-122"/>
+                <a:cs typeface="Arial" pitchFamily="34" charset="-120"/>
+              </a:rPr>
+              <a:t>Đạt chứng nhận </a:t>
+            </a:r>
+            <a:pPr algn="l" indent="0" marL="0">
+              <a:buNone/>
+            </a:pPr>
+            <a:r>
+              <a:rPr lang="en-US" sz="1650" b="1" dirty="0">
+                <a:solidFill>
+                  <a:srgbClr val="8ED14F"/>
+                </a:solidFill>
+                <a:latin typeface="Arial" pitchFamily="34" charset="0"/>
+                <a:ea typeface="Arial" pitchFamily="34" charset="-122"/>
+                <a:cs typeface="Arial" pitchFamily="34" charset="-120"/>
+              </a:rPr>
+              <a:t>FDA Hoa Kỳ</a:t>
+            </a:r>
+            <a:endParaRPr lang="en-US" sz="1650" dirty="0"/>
+          </a:p>
+        </p:txBody>
+      </p:sp>
+      <p:sp>
+        <p:nvSpPr>
+          <p:cNvPr id="38" name="Text 9"/>
+          <p:cNvSpPr txBox="1"/>
+          <p:nvPr/>
+        </p:nvSpPr>
+        <p:spPr>
+          <a:xfrm>
+            <a:off x="1340148" y="2298446"/>
+            <a:ext cx="4067526" cy="279908"/>
+          </a:xfrm>
+          <a:prstGeom prst="rect">
+            <a:avLst/>
+          </a:prstGeom>
+          <a:noFill/>
+          <a:ln/>
+        </p:spPr>
+        <p:txBody>
+          <a:bodyPr wrap="square" lIns="0" tIns="0" rIns="0" bIns="0" rtlCol="0" anchor="ctr"/>
+          <a:lstStyle/>
+          <a:p>
+            <a:pPr algn="l" indent="0" marL="0">
+              <a:buNone/>
+            </a:pPr>
+            <a:r>
+              <a:rPr lang="en-US" sz="1650" b="1" dirty="0">
+                <a:solidFill>
+                  <a:srgbClr val="FFFFFF"/>
+                </a:solidFill>
+                <a:latin typeface="Arial" pitchFamily="34" charset="0"/>
+                <a:ea typeface="Arial" pitchFamily="34" charset="-122"/>
+                <a:cs typeface="Arial" pitchFamily="34" charset="-120"/>
+              </a:rPr>
+              <a:t>Tương đồng cao với </a:t>
+            </a:r>
+            <a:pPr algn="l" indent="0" marL="0">
+              <a:buNone/>
+            </a:pPr>
+            <a:r>
+              <a:rPr lang="en-US" sz="1650" b="1" dirty="0">
+                <a:solidFill>
+                  <a:srgbClr val="8ED14F"/>
+                </a:solidFill>
+                <a:latin typeface="Arial" pitchFamily="34" charset="0"/>
+                <a:ea typeface="Arial" pitchFamily="34" charset="-122"/>
+                <a:cs typeface="Arial" pitchFamily="34" charset="-120"/>
+              </a:rPr>
+              <a:t>xương tự thân</a:t>
+            </a:r>
+            <a:endParaRPr lang="en-US" sz="1650" dirty="0"/>
+          </a:p>
+        </p:txBody>
+      </p:sp>
+      <p:sp>
+        <p:nvSpPr>
+          <p:cNvPr id="39" name="Text 10"/>
+          <p:cNvSpPr txBox="1"/>
+          <p:nvPr/>
+        </p:nvSpPr>
+        <p:spPr>
+          <a:xfrm>
+            <a:off x="743603" y="3274124"/>
+            <a:ext cx="1154394" cy="427228"/>
+          </a:xfrm>
+          <a:prstGeom prst="rect">
+            <a:avLst/>
+          </a:prstGeom>
+          <a:noFill/>
+          <a:ln/>
+        </p:spPr>
+        <p:txBody>
+          <a:bodyPr wrap="square" lIns="0" tIns="0" rIns="0" bIns="0" rtlCol="0" anchor="ctr"/>
+          <a:lstStyle/>
+          <a:p>
+            <a:pPr algn="ctr" indent="0" marL="0">
+              <a:buNone/>
+            </a:pPr>
+            <a:r>
+              <a:rPr lang="en-US" sz="1250" b="1" dirty="0">
+                <a:solidFill>
+                  <a:srgbClr val="FFFFFF"/>
+                </a:solidFill>
+                <a:latin typeface="Arial" pitchFamily="34" charset="0"/>
+                <a:ea typeface="Arial" pitchFamily="34" charset="-122"/>
+                <a:cs typeface="Arial" pitchFamily="34" charset="-120"/>
+              </a:rPr>
+              <a:t>Chấn thương</a:t>
+            </a:r>
+            <a:endParaRPr lang="en-US" sz="1250" dirty="0"/>
+          </a:p>
+          <a:p>
+            <a:pPr algn="ctr" indent="0" marL="0">
+              <a:buNone/>
+            </a:pPr>
+            <a:r>
+              <a:rPr lang="en-US" sz="1250" b="1" dirty="0">
+                <a:solidFill>
+                  <a:srgbClr val="FFFFFF"/>
+                </a:solidFill>
+                <a:latin typeface="Arial" pitchFamily="34" charset="0"/>
+                <a:ea typeface="Arial" pitchFamily="34" charset="-122"/>
+                <a:cs typeface="Arial" pitchFamily="34" charset="-120"/>
+              </a:rPr>
+              <a:t>chỉnh hình</a:t>
+            </a:r>
+            <a:endParaRPr lang="en-US" sz="1250" dirty="0"/>
+          </a:p>
+        </p:txBody>
+      </p:sp>
+      <p:sp>
+        <p:nvSpPr>
+          <p:cNvPr id="40" name="Text 11"/>
+          <p:cNvSpPr txBox="1"/>
+          <p:nvPr/>
+        </p:nvSpPr>
+        <p:spPr>
+          <a:xfrm>
+            <a:off x="3982244" y="4736656"/>
+            <a:ext cx="1357313" cy="213614"/>
+          </a:xfrm>
+          <a:prstGeom prst="rect">
+            <a:avLst/>
+          </a:prstGeom>
+          <a:noFill/>
+          <a:ln/>
+        </p:spPr>
+        <p:txBody>
+          <a:bodyPr wrap="square" lIns="0" tIns="0" rIns="0" bIns="0" rtlCol="0" anchor="ctr"/>
+          <a:lstStyle/>
+          <a:p>
+            <a:pPr algn="ctr" indent="0" marL="0">
+              <a:buNone/>
+            </a:pPr>
+            <a:r>
+              <a:rPr lang="en-US" sz="1250" b="1" dirty="0">
+                <a:solidFill>
+                  <a:srgbClr val="FFFFFF"/>
+                </a:solidFill>
+                <a:latin typeface="Arial" pitchFamily="34" charset="0"/>
+                <a:ea typeface="Arial" pitchFamily="34" charset="-122"/>
+                <a:cs typeface="Arial" pitchFamily="34" charset="-120"/>
+              </a:rPr>
+              <a:t>Ngoại thần kinh</a:t>
+            </a:r>
+            <a:endParaRPr lang="en-US" sz="1250" dirty="0"/>
+          </a:p>
+        </p:txBody>
+      </p:sp>
+      <p:sp>
+        <p:nvSpPr>
+          <p:cNvPr id="41" name="Text 12"/>
+          <p:cNvSpPr txBox="1"/>
+          <p:nvPr/>
+        </p:nvSpPr>
+        <p:spPr>
+          <a:xfrm>
+            <a:off x="488741" y="5380736"/>
+            <a:ext cx="1761452" cy="243078"/>
+          </a:xfrm>
+          <a:prstGeom prst="rect">
+            <a:avLst/>
+          </a:prstGeom>
+          <a:noFill/>
+          <a:ln/>
+        </p:spPr>
+        <p:txBody>
+          <a:bodyPr wrap="square" lIns="0" tIns="0" rIns="0" bIns="0" rtlCol="0" anchor="ctr"/>
+          <a:lstStyle/>
+          <a:p>
+            <a:pPr algn="ctr" indent="0" marL="0">
+              <a:buNone/>
+            </a:pPr>
+            <a:r>
               <a:rPr lang="en-US" sz="1500" b="1" dirty="0">
                 <a:solidFill>
+                  <a:srgbClr val="8ED14F"/>
+                </a:solidFill>
+                <a:latin typeface="Arial" pitchFamily="34" charset="0"/>
+                <a:ea typeface="Arial" pitchFamily="34" charset="-122"/>
+                <a:cs typeface="Arial" pitchFamily="34" charset="-120"/>
+              </a:rPr>
+              <a:t>45 : 55</a:t>
+            </a:r>
+            <a:endParaRPr lang="en-US" sz="1500" dirty="0"/>
+          </a:p>
+        </p:txBody>
+      </p:sp>
+      <p:sp>
+        <p:nvSpPr>
+          <p:cNvPr id="42" name="Text 13"/>
+          <p:cNvSpPr txBox="1"/>
+          <p:nvPr/>
+        </p:nvSpPr>
+        <p:spPr>
+          <a:xfrm>
+            <a:off x="488741" y="5616956"/>
+            <a:ext cx="1761452" cy="132588"/>
+          </a:xfrm>
+          <a:prstGeom prst="rect">
+            <a:avLst/>
+          </a:prstGeom>
+          <a:noFill/>
+          <a:ln/>
+        </p:spPr>
+        <p:txBody>
+          <a:bodyPr wrap="square" lIns="0" tIns="0" rIns="0" bIns="0" rtlCol="0" anchor="ctr"/>
+          <a:lstStyle/>
+          <a:p>
+            <a:pPr algn="ctr" indent="0" marL="0">
+              <a:buNone/>
+            </a:pPr>
+            <a:r>
+              <a:rPr lang="en-US" sz="800" dirty="0">
+                <a:solidFill>
+                  <a:srgbClr val="CFE6FF"/>
+                </a:solidFill>
+                <a:latin typeface="Arial" pitchFamily="34" charset="0"/>
+                <a:ea typeface="Arial" pitchFamily="34" charset="-122"/>
+                <a:cs typeface="Arial" pitchFamily="34" charset="-120"/>
+              </a:rPr>
+              <a:t>Collagen I : nano-HA</a:t>
+            </a:r>
+            <a:endParaRPr lang="en-US" sz="800" dirty="0"/>
+          </a:p>
+        </p:txBody>
+      </p:sp>
+      <p:sp>
+        <p:nvSpPr>
+          <p:cNvPr id="43" name="Text 14"/>
+          <p:cNvSpPr txBox="1"/>
+          <p:nvPr/>
+        </p:nvSpPr>
+        <p:spPr>
+          <a:xfrm>
+            <a:off x="2116869" y="5380736"/>
+            <a:ext cx="1754213" cy="243078"/>
+          </a:xfrm>
+          <a:prstGeom prst="rect">
+            <a:avLst/>
+          </a:prstGeom>
+          <a:noFill/>
+          <a:ln/>
+        </p:spPr>
+        <p:txBody>
+          <a:bodyPr wrap="square" lIns="0" tIns="0" rIns="0" bIns="0" rtlCol="0" anchor="ctr"/>
+          <a:lstStyle/>
+          <a:p>
+            <a:pPr algn="ctr" indent="0" marL="0">
+              <a:buNone/>
+            </a:pPr>
+            <a:r>
+              <a:rPr lang="en-US" sz="1500" b="1" dirty="0">
+                <a:solidFill>
+                  <a:srgbClr val="8ED14F"/>
+                </a:solidFill>
+                <a:latin typeface="Arial" pitchFamily="34" charset="0"/>
+                <a:ea typeface="Arial" pitchFamily="34" charset="-122"/>
+                <a:cs typeface="Arial" pitchFamily="34" charset="-120"/>
+              </a:rPr>
+              <a:t>70–80%</a:t>
+            </a:r>
+            <a:endParaRPr lang="en-US" sz="1500" dirty="0"/>
+          </a:p>
+        </p:txBody>
+      </p:sp>
+      <p:sp>
+        <p:nvSpPr>
+          <p:cNvPr id="44" name="Text 15"/>
+          <p:cNvSpPr txBox="1"/>
+          <p:nvPr/>
+        </p:nvSpPr>
+        <p:spPr>
+          <a:xfrm>
+            <a:off x="2116869" y="5616956"/>
+            <a:ext cx="1754213" cy="132588"/>
+          </a:xfrm>
+          <a:prstGeom prst="rect">
+            <a:avLst/>
+          </a:prstGeom>
+          <a:noFill/>
+          <a:ln/>
+        </p:spPr>
+        <p:txBody>
+          <a:bodyPr wrap="square" lIns="0" tIns="0" rIns="0" bIns="0" rtlCol="0" anchor="ctr"/>
+          <a:lstStyle/>
+          <a:p>
+            <a:pPr algn="ctr" indent="0" marL="0">
+              <a:buNone/>
+            </a:pPr>
+            <a:r>
+              <a:rPr lang="en-US" sz="800" dirty="0">
+                <a:solidFill>
+                  <a:srgbClr val="CFE6FF"/>
+                </a:solidFill>
+                <a:latin typeface="Arial" pitchFamily="34" charset="0"/>
+                <a:ea typeface="Arial" pitchFamily="34" charset="-122"/>
+                <a:cs typeface="Arial" pitchFamily="34" charset="-120"/>
+              </a:rPr>
+              <a:t>Độ xốp</a:t>
+            </a:r>
+            <a:endParaRPr lang="en-US" sz="800" dirty="0"/>
+          </a:p>
+        </p:txBody>
+      </p:sp>
+      <p:sp>
+        <p:nvSpPr>
+          <p:cNvPr id="45" name="Text 16"/>
+          <p:cNvSpPr txBox="1"/>
+          <p:nvPr/>
+        </p:nvSpPr>
+        <p:spPr>
+          <a:xfrm>
+            <a:off x="3738202" y="5380736"/>
+            <a:ext cx="1754213" cy="243078"/>
+          </a:xfrm>
+          <a:prstGeom prst="rect">
+            <a:avLst/>
+          </a:prstGeom>
+          <a:noFill/>
+          <a:ln/>
+        </p:spPr>
+        <p:txBody>
+          <a:bodyPr wrap="square" lIns="0" tIns="0" rIns="0" bIns="0" rtlCol="0" anchor="ctr"/>
+          <a:lstStyle/>
+          <a:p>
+            <a:pPr algn="ctr" indent="0" marL="0">
+              <a:buNone/>
+            </a:pPr>
+            <a:r>
+              <a:rPr lang="en-US" sz="1500" b="1" dirty="0">
+                <a:solidFill>
+                  <a:srgbClr val="8ED14F"/>
+                </a:solidFill>
+                <a:latin typeface="Arial" pitchFamily="34" charset="0"/>
+                <a:ea typeface="Arial" pitchFamily="34" charset="-122"/>
+                <a:cs typeface="Arial" pitchFamily="34" charset="-120"/>
+              </a:rPr>
+              <a:t>&gt;200.000</a:t>
+            </a:r>
+            <a:endParaRPr lang="en-US" sz="1500" dirty="0"/>
+          </a:p>
+        </p:txBody>
+      </p:sp>
+      <p:sp>
+        <p:nvSpPr>
+          <p:cNvPr id="46" name="Text 17"/>
+          <p:cNvSpPr txBox="1"/>
+          <p:nvPr/>
+        </p:nvSpPr>
+        <p:spPr>
+          <a:xfrm>
+            <a:off x="3738202" y="5616956"/>
+            <a:ext cx="1754213" cy="132588"/>
+          </a:xfrm>
+          <a:prstGeom prst="rect">
+            <a:avLst/>
+          </a:prstGeom>
+          <a:noFill/>
+          <a:ln/>
+        </p:spPr>
+        <p:txBody>
+          <a:bodyPr wrap="square" lIns="0" tIns="0" rIns="0" bIns="0" rtlCol="0" anchor="ctr"/>
+          <a:lstStyle/>
+          <a:p>
+            <a:pPr algn="ctr" indent="0" marL="0">
+              <a:buNone/>
+            </a:pPr>
+            <a:r>
+              <a:rPr lang="en-US" sz="800" dirty="0">
+                <a:solidFill>
+                  <a:srgbClr val="CFE6FF"/>
+                </a:solidFill>
+                <a:latin typeface="Arial" pitchFamily="34" charset="0"/>
+                <a:ea typeface="Arial" pitchFamily="34" charset="-122"/>
+                <a:cs typeface="Arial" pitchFamily="34" charset="-120"/>
+              </a:rPr>
+              <a:t>Ca lâm sàng</a:t>
+            </a:r>
+            <a:endParaRPr lang="en-US" sz="800" dirty="0"/>
+          </a:p>
+        </p:txBody>
+      </p:sp>
+      <p:sp>
+        <p:nvSpPr>
+          <p:cNvPr id="47" name="Text 18"/>
+          <p:cNvSpPr txBox="1"/>
+          <p:nvPr/>
+        </p:nvSpPr>
+        <p:spPr>
+          <a:xfrm>
+            <a:off x="5722239" y="1788160"/>
+            <a:ext cx="3605022" cy="405130"/>
+          </a:xfrm>
+          <a:prstGeom prst="rect">
+            <a:avLst/>
+          </a:prstGeom>
+          <a:noFill/>
+          <a:ln/>
+        </p:spPr>
+        <p:txBody>
+          <a:bodyPr wrap="square" lIns="0" tIns="0" rIns="0" bIns="0" rtlCol="0" anchor="ctr"/>
+          <a:lstStyle/>
+          <a:p>
+            <a:pPr algn="ctr" indent="0" marL="0">
+              <a:buNone/>
+            </a:pPr>
+            <a:r>
+              <a:rPr lang="en-US" sz="1100" b="1" spc="25" kern="0" dirty="0">
+                <a:solidFill>
                   <a:srgbClr val="FFFFFF"/>
                 </a:solidFill>
                 <a:latin typeface="Arial" pitchFamily="34" charset="0"/>
                 <a:ea typeface="Arial" pitchFamily="34" charset="-122"/>
                 <a:cs typeface="Arial" pitchFamily="34" charset="-120"/>
               </a:rPr>
-              <a:t>Đạt chứng nhận </a:t>
-            </a:r>
+              <a:t>GIẢI PHÁP TÍCH HỢP CHO</a:t>
+            </a:r>
+            <a:endParaRPr lang="en-US" sz="1100" dirty="0"/>
+          </a:p>
+          <a:p>
+            <a:pPr algn="ctr" indent="0" marL="0">
+              <a:buNone/>
+            </a:pPr>
+            <a:r>
+              <a:rPr lang="en-US" sz="1100" b="1" spc="25" kern="0" dirty="0">
+                <a:solidFill>
+                  <a:srgbClr val="8ED14F"/>
+                </a:solidFill>
+                <a:latin typeface="Arial" pitchFamily="34" charset="0"/>
+                <a:ea typeface="Arial" pitchFamily="34" charset="-122"/>
+                <a:cs typeface="Arial" pitchFamily="34" charset="-120"/>
+              </a:rPr>
+              <a:t>PHẪU THUẬT CỘT SỐNG</a:t>
+            </a:r>
+            <a:endParaRPr lang="en-US" sz="1100" dirty="0"/>
+          </a:p>
+        </p:txBody>
+      </p:sp>
+      <p:sp>
+        <p:nvSpPr>
+          <p:cNvPr id="48" name="Text 19"/>
+          <p:cNvSpPr txBox="1"/>
+          <p:nvPr/>
+        </p:nvSpPr>
+        <p:spPr>
+          <a:xfrm>
+            <a:off x="7593112" y="2790444"/>
+            <a:ext cx="203200" cy="235712"/>
+          </a:xfrm>
+          <a:prstGeom prst="rect">
+            <a:avLst/>
+          </a:prstGeom>
+          <a:noFill/>
+          <a:ln/>
+        </p:spPr>
+        <p:txBody>
+          <a:bodyPr wrap="square" lIns="0" tIns="0" rIns="0" bIns="0" rtlCol="0" anchor="ctr"/>
+          <a:lstStyle/>
+          <a:p>
+            <a:pPr algn="ctr" indent="0" marL="0">
+              <a:buNone/>
+            </a:pPr>
+            <a:r>
+              <a:rPr lang="en-US" sz="750" b="1" dirty="0">
+                <a:solidFill>
+                  <a:srgbClr val="04122E"/>
+                </a:solidFill>
+                <a:latin typeface="Arial" pitchFamily="34" charset="0"/>
+                <a:ea typeface="Arial" pitchFamily="34" charset="-122"/>
+                <a:cs typeface="Arial" pitchFamily="34" charset="-120"/>
+              </a:rPr>
+              <a:t>01</a:t>
+            </a:r>
+            <a:endParaRPr lang="en-US" sz="750" dirty="0"/>
+          </a:p>
+        </p:txBody>
+      </p:sp>
+      <p:sp>
+        <p:nvSpPr>
+          <p:cNvPr id="49" name="Text 20"/>
+          <p:cNvSpPr txBox="1"/>
+          <p:nvPr/>
+        </p:nvSpPr>
+        <p:spPr>
+          <a:xfrm>
+            <a:off x="7859812" y="2833152"/>
+            <a:ext cx="1304717" cy="150197"/>
+          </a:xfrm>
+          <a:prstGeom prst="rect">
+            <a:avLst/>
+          </a:prstGeom>
+          <a:noFill/>
+          <a:ln/>
+        </p:spPr>
+        <p:txBody>
+          <a:bodyPr wrap="square" lIns="0" tIns="0" rIns="0" bIns="0" rtlCol="0" anchor="ctr"/>
+          <a:lstStyle/>
+          <a:p>
             <a:pPr algn="l" indent="0" marL="0">
               <a:buNone/>
             </a:pPr>
             <a:r>
-              <a:rPr lang="en-US" sz="1500" b="1" dirty="0">
-                <a:solidFill>
-                  <a:srgbClr val="8ED14F"/>
-                </a:solidFill>
-                <a:latin typeface="Arial" pitchFamily="34" charset="0"/>
-                <a:ea typeface="Arial" pitchFamily="34" charset="-122"/>
-                <a:cs typeface="Arial" pitchFamily="34" charset="-120"/>
-              </a:rPr>
-              <a:t>FDA Hoa Kỳ</a:t>
-            </a:r>
-            <a:endParaRPr lang="en-US" sz="1500" dirty="0"/>
-          </a:p>
-        </p:txBody>
-      </p:sp>
-      <p:sp>
-        <p:nvSpPr>
-          <p:cNvPr id="38" name="Text 9"/>
-          <p:cNvSpPr txBox="1"/>
-          <p:nvPr/>
-        </p:nvSpPr>
-        <p:spPr>
-          <a:xfrm>
-            <a:off x="1216521" y="2256028"/>
-            <a:ext cx="3697885" cy="250444"/>
+              <a:rPr lang="en-US" sz="850" b="1" dirty="0">
+                <a:solidFill>
+                  <a:srgbClr val="FFFFFF"/>
+                </a:solidFill>
+                <a:latin typeface="Arial" pitchFamily="34" charset="0"/>
+                <a:ea typeface="Arial" pitchFamily="34" charset="-122"/>
+                <a:cs typeface="Arial" pitchFamily="34" charset="-120"/>
+              </a:rPr>
+              <a:t>Giảm phơi nhiễm tia X</a:t>
+            </a:r>
+            <a:endParaRPr lang="en-US" sz="850" dirty="0"/>
+          </a:p>
+        </p:txBody>
+      </p:sp>
+      <p:sp>
+        <p:nvSpPr>
+          <p:cNvPr id="50" name="Text 21"/>
+          <p:cNvSpPr txBox="1"/>
+          <p:nvPr/>
+        </p:nvSpPr>
+        <p:spPr>
+          <a:xfrm>
+            <a:off x="7849691" y="3323844"/>
+            <a:ext cx="203200" cy="235712"/>
+          </a:xfrm>
+          <a:prstGeom prst="rect">
+            <a:avLst/>
+          </a:prstGeom>
+          <a:noFill/>
+          <a:ln/>
+        </p:spPr>
+        <p:txBody>
+          <a:bodyPr wrap="square" lIns="0" tIns="0" rIns="0" bIns="0" rtlCol="0" anchor="ctr"/>
+          <a:lstStyle/>
+          <a:p>
+            <a:pPr algn="ctr" indent="0" marL="0">
+              <a:buNone/>
+            </a:pPr>
+            <a:r>
+              <a:rPr lang="en-US" sz="750" b="1" dirty="0">
+                <a:solidFill>
+                  <a:srgbClr val="04122E"/>
+                </a:solidFill>
+                <a:latin typeface="Arial" pitchFamily="34" charset="0"/>
+                <a:ea typeface="Arial" pitchFamily="34" charset="-122"/>
+                <a:cs typeface="Arial" pitchFamily="34" charset="-120"/>
+              </a:rPr>
+              <a:t>02</a:t>
+            </a:r>
+            <a:endParaRPr lang="en-US" sz="750" dirty="0"/>
+          </a:p>
+        </p:txBody>
+      </p:sp>
+      <p:sp>
+        <p:nvSpPr>
+          <p:cNvPr id="51" name="Text 22"/>
+          <p:cNvSpPr txBox="1"/>
+          <p:nvPr/>
+        </p:nvSpPr>
+        <p:spPr>
+          <a:xfrm>
+            <a:off x="8116391" y="3366552"/>
+            <a:ext cx="1012216" cy="150197"/>
           </a:xfrm>
           <a:prstGeom prst="rect">
             <a:avLst/>
@@ -1948,7 +2503,7 @@
               <a:buNone/>
             </a:pPr>
             <a:r>
-              <a:rPr lang="en-US" sz="1500" b="1" dirty="0">
+              <a:rPr lang="en-US" sz="850" b="1" dirty="0">
                 <a:solidFill>
                   <a:srgbClr val="FFFFFF"/>
                 </a:solidFill>
@@ -1956,36 +2511,134 @@
                 <a:ea typeface="Arial" pitchFamily="34" charset="-122"/>
                 <a:cs typeface="Arial" pitchFamily="34" charset="-120"/>
               </a:rPr>
-              <a:t>Tương đồng cao với </a:t>
-            </a:r>
+              <a:t>Độ chính xác cao</a:t>
+            </a:r>
+            <a:endParaRPr lang="en-US" sz="850" dirty="0"/>
+          </a:p>
+        </p:txBody>
+      </p:sp>
+      <p:sp>
+        <p:nvSpPr>
+          <p:cNvPr id="52" name="Text 23"/>
+          <p:cNvSpPr txBox="1"/>
+          <p:nvPr/>
+        </p:nvSpPr>
+        <p:spPr>
+          <a:xfrm>
+            <a:off x="6000750" y="3886315"/>
+            <a:ext cx="203200" cy="235712"/>
+          </a:xfrm>
+          <a:prstGeom prst="rect">
+            <a:avLst/>
+          </a:prstGeom>
+          <a:noFill/>
+          <a:ln/>
+        </p:spPr>
+        <p:txBody>
+          <a:bodyPr wrap="square" lIns="0" tIns="0" rIns="0" bIns="0" rtlCol="0" anchor="ctr"/>
+          <a:lstStyle/>
+          <a:p>
+            <a:pPr algn="ctr" indent="0" marL="0">
+              <a:buNone/>
+            </a:pPr>
+            <a:r>
+              <a:rPr lang="en-US" sz="750" b="1" dirty="0">
+                <a:solidFill>
+                  <a:srgbClr val="04122E"/>
+                </a:solidFill>
+                <a:latin typeface="Arial" pitchFamily="34" charset="0"/>
+                <a:ea typeface="Arial" pitchFamily="34" charset="-122"/>
+                <a:cs typeface="Arial" pitchFamily="34" charset="-120"/>
+              </a:rPr>
+              <a:t>03</a:t>
+            </a:r>
+            <a:endParaRPr lang="en-US" sz="750" dirty="0"/>
+          </a:p>
+        </p:txBody>
+      </p:sp>
+      <p:sp>
+        <p:nvSpPr>
+          <p:cNvPr id="53" name="Text 24"/>
+          <p:cNvSpPr txBox="1"/>
+          <p:nvPr/>
+        </p:nvSpPr>
+        <p:spPr>
+          <a:xfrm>
+            <a:off x="6267450" y="3778925"/>
+            <a:ext cx="636014" cy="450592"/>
+          </a:xfrm>
+          <a:prstGeom prst="rect">
+            <a:avLst/>
+          </a:prstGeom>
+          <a:noFill/>
+          <a:ln/>
+        </p:spPr>
+        <p:txBody>
+          <a:bodyPr wrap="square" lIns="0" tIns="0" rIns="0" bIns="0" rtlCol="0" anchor="ctr"/>
+          <a:lstStyle/>
+          <a:p>
             <a:pPr algn="l" indent="0" marL="0">
               <a:buNone/>
             </a:pPr>
             <a:r>
-              <a:rPr lang="en-US" sz="1500" b="1" dirty="0">
-                <a:solidFill>
-                  <a:srgbClr val="8ED14F"/>
-                </a:solidFill>
-                <a:latin typeface="Arial" pitchFamily="34" charset="0"/>
-                <a:ea typeface="Arial" pitchFamily="34" charset="-122"/>
-                <a:cs typeface="Arial" pitchFamily="34" charset="-120"/>
-              </a:rPr>
-              <a:t>xương tự thân</a:t>
-            </a:r>
-            <a:endParaRPr lang="en-US" sz="1500" dirty="0"/>
-          </a:p>
-        </p:txBody>
-      </p:sp>
-      <p:sp>
-        <p:nvSpPr>
-          <p:cNvPr id="39" name="Text 10"/>
-          <p:cNvSpPr txBox="1"/>
-          <p:nvPr/>
-        </p:nvSpPr>
-        <p:spPr>
-          <a:xfrm>
-            <a:off x="749333" y="3231630"/>
-            <a:ext cx="1015835" cy="383032"/>
+              <a:rPr lang="en-US" sz="850" b="1" dirty="0">
+                <a:solidFill>
+                  <a:srgbClr val="FFFFFF"/>
+                </a:solidFill>
+                <a:latin typeface="Arial" pitchFamily="34" charset="0"/>
+                <a:ea typeface="Arial" pitchFamily="34" charset="-122"/>
+                <a:cs typeface="Arial" pitchFamily="34" charset="-120"/>
+              </a:rPr>
+              <a:t>Tối ưu hóa</a:t>
+            </a:r>
+            <a:endParaRPr lang="en-US" sz="850" dirty="0"/>
+          </a:p>
+          <a:p>
+            <a:pPr algn="l" indent="0" marL="0">
+              <a:buNone/>
+            </a:pPr>
+            <a:r>
+              <a:rPr lang="en-US" sz="850" b="1" dirty="0">
+                <a:solidFill>
+                  <a:srgbClr val="FFFFFF"/>
+                </a:solidFill>
+                <a:latin typeface="Arial" pitchFamily="34" charset="0"/>
+                <a:ea typeface="Arial" pitchFamily="34" charset="-122"/>
+                <a:cs typeface="Arial" pitchFamily="34" charset="-120"/>
+              </a:rPr>
+              <a:t>quy trình</a:t>
+            </a:r>
+            <a:endParaRPr lang="en-US" sz="850" dirty="0"/>
+          </a:p>
+          <a:p>
+            <a:pPr algn="l" indent="0" marL="0">
+              <a:buNone/>
+            </a:pPr>
+            <a:r>
+              <a:rPr lang="en-US" sz="850" b="1" dirty="0">
+                <a:solidFill>
+                  <a:srgbClr val="FFFFFF"/>
+                </a:solidFill>
+                <a:latin typeface="Arial" pitchFamily="34" charset="0"/>
+                <a:ea typeface="Arial" pitchFamily="34" charset="-122"/>
+                <a:cs typeface="Arial" pitchFamily="34" charset="-120"/>
+              </a:rPr>
+              <a:t>phẫu thuật</a:t>
+            </a:r>
+            <a:endParaRPr lang="en-US" sz="850" dirty="0"/>
+          </a:p>
+        </p:txBody>
+      </p:sp>
+      <p:sp>
+        <p:nvSpPr>
+          <p:cNvPr id="54" name="Text 25"/>
+          <p:cNvSpPr txBox="1"/>
+          <p:nvPr/>
+        </p:nvSpPr>
+        <p:spPr>
+          <a:xfrm>
+            <a:off x="9893201" y="1933960"/>
+            <a:ext cx="1257399" cy="191516"/>
           </a:xfrm>
           <a:prstGeom prst="rect">
             <a:avLst/>
@@ -2001,7 +2654,46 @@
               <a:buNone/>
             </a:pPr>
             <a:r>
-              <a:rPr lang="en-US" sz="1100" b="1" dirty="0">
+              <a:rPr lang="en-US" sz="800" b="1" spc="100" kern="0" dirty="0">
+                <a:solidFill>
+                  <a:srgbClr val="0A3170"/>
+                </a:solidFill>
+                <a:latin typeface="Arial" pitchFamily="34" charset="0"/>
+                <a:ea typeface="Arial" pitchFamily="34" charset="-122"/>
+                <a:cs typeface="Arial" pitchFamily="34" charset="-120"/>
+              </a:rPr>
+              <a:t>CÔNG NGHỆ IN 3D</a:t>
+            </a:r>
+            <a:endParaRPr lang="en-US" sz="800" dirty="0"/>
+          </a:p>
+        </p:txBody>
+      </p:sp>
+      <p:sp>
+        <p:nvSpPr>
+          <p:cNvPr id="55" name="Text 26"/>
+          <p:cNvSpPr txBox="1"/>
+          <p:nvPr/>
+        </p:nvSpPr>
+        <p:spPr>
+          <a:xfrm>
+            <a:off x="9233408" y="2123063"/>
+            <a:ext cx="2577084" cy="303848"/>
+          </a:xfrm>
+          <a:prstGeom prst="rect">
+            <a:avLst/>
+          </a:prstGeom>
+          <a:noFill/>
+          <a:ln/>
+        </p:spPr>
+        <p:txBody>
+          <a:bodyPr wrap="square" lIns="0" tIns="0" rIns="0" bIns="0" rtlCol="0" anchor="ctr"/>
+          <a:lstStyle/>
+          <a:p>
+            <a:pPr algn="ctr" indent="0" marL="0">
+              <a:buNone/>
+            </a:pPr>
+            <a:r>
+              <a:rPr lang="en-US" sz="825" b="1" dirty="0">
                 <a:solidFill>
                   <a:srgbClr val="FFFFFF"/>
                 </a:solidFill>
@@ -2009,16 +2701,16 @@
                 <a:ea typeface="Arial" pitchFamily="34" charset="-122"/>
                 <a:cs typeface="Arial" pitchFamily="34" charset="-120"/>
               </a:rPr>
-              <a:t>Chấn thương</a:t>
-            </a:r>
-            <a:endParaRPr lang="en-US" sz="1100" dirty="0"/>
+              <a:t>Cấu trúc xốp tối ưu hóa</a:t>
+            </a:r>
+            <a:endParaRPr lang="en-US" sz="825" dirty="0"/>
           </a:p>
           <a:p>
             <a:pPr algn="ctr" indent="0" marL="0">
               <a:buNone/>
             </a:pPr>
             <a:r>
-              <a:rPr lang="en-US" sz="1100" b="1" dirty="0">
+              <a:rPr lang="en-US" sz="825" b="1" dirty="0">
                 <a:solidFill>
                   <a:srgbClr val="FFFFFF"/>
                 </a:solidFill>
@@ -2026,22 +2718,22 @@
                 <a:ea typeface="Arial" pitchFamily="34" charset="-122"/>
                 <a:cs typeface="Arial" pitchFamily="34" charset="-120"/>
               </a:rPr>
-              <a:t>chỉnh hình</a:t>
-            </a:r>
-            <a:endParaRPr lang="en-US" sz="1100" dirty="0"/>
-          </a:p>
-        </p:txBody>
-      </p:sp>
-      <p:sp>
-        <p:nvSpPr>
-          <p:cNvPr id="40" name="Text 11"/>
-          <p:cNvSpPr txBox="1"/>
-          <p:nvPr/>
-        </p:nvSpPr>
-        <p:spPr>
-          <a:xfrm>
-            <a:off x="3555683" y="4731730"/>
-            <a:ext cx="1194435" cy="191516"/>
+              <a:t>tích hợp xương</a:t>
+            </a:r>
+            <a:endParaRPr lang="en-US" sz="825" dirty="0"/>
+          </a:p>
+        </p:txBody>
+      </p:sp>
+      <p:sp>
+        <p:nvSpPr>
+          <p:cNvPr id="56" name="Text 27"/>
+          <p:cNvSpPr txBox="1"/>
+          <p:nvPr/>
+        </p:nvSpPr>
+        <p:spPr>
+          <a:xfrm>
+            <a:off x="9563252" y="3308092"/>
+            <a:ext cx="748897" cy="177820"/>
           </a:xfrm>
           <a:prstGeom prst="rect">
             <a:avLst/>
@@ -2057,7 +2749,7 @@
               <a:buNone/>
             </a:pPr>
             <a:r>
-              <a:rPr lang="en-US" sz="1100" b="1" dirty="0">
+              <a:rPr lang="en-US" sz="1050" b="1" spc="25" kern="0" dirty="0">
                 <a:solidFill>
                   <a:srgbClr val="FFFFFF"/>
                 </a:solidFill>
@@ -2065,22 +2757,22 @@
                 <a:ea typeface="Arial" pitchFamily="34" charset="-122"/>
                 <a:cs typeface="Arial" pitchFamily="34" charset="-120"/>
               </a:rPr>
-              <a:t>Ngoại thần kinh</a:t>
-            </a:r>
-            <a:endParaRPr lang="en-US" sz="1100" dirty="0"/>
-          </a:p>
-        </p:txBody>
-      </p:sp>
-      <p:sp>
-        <p:nvSpPr>
-          <p:cNvPr id="41" name="Text 12"/>
-          <p:cNvSpPr txBox="1"/>
-          <p:nvPr/>
-        </p:nvSpPr>
-        <p:spPr>
-          <a:xfrm>
-            <a:off x="502076" y="5409803"/>
-            <a:ext cx="1544282" cy="218678"/>
+              <a:t>PANTHER</a:t>
+            </a:r>
+            <a:endParaRPr lang="en-US" sz="1050" dirty="0"/>
+          </a:p>
+        </p:txBody>
+      </p:sp>
+      <p:sp>
+        <p:nvSpPr>
+          <p:cNvPr id="57" name="Text 28"/>
+          <p:cNvSpPr txBox="1"/>
+          <p:nvPr/>
+        </p:nvSpPr>
+        <p:spPr>
+          <a:xfrm>
+            <a:off x="9529093" y="3484269"/>
+            <a:ext cx="817215" cy="306380"/>
           </a:xfrm>
           <a:prstGeom prst="rect">
             <a:avLst/>
@@ -2096,46 +2788,24 @@
               <a:buNone/>
             </a:pPr>
             <a:r>
-              <a:rPr lang="en-US" sz="1350" b="1" dirty="0">
-                <a:solidFill>
-                  <a:srgbClr val="8ED14F"/>
-                </a:solidFill>
-                <a:latin typeface="Arial" pitchFamily="34" charset="0"/>
-                <a:ea typeface="Arial" pitchFamily="34" charset="-122"/>
-                <a:cs typeface="Arial" pitchFamily="34" charset="-120"/>
-              </a:rPr>
-              <a:t>45 : 55</a:t>
-            </a:r>
-            <a:endParaRPr lang="en-US" sz="1350" dirty="0"/>
-          </a:p>
-        </p:txBody>
-      </p:sp>
-      <p:sp>
-        <p:nvSpPr>
-          <p:cNvPr id="42" name="Text 13"/>
-          <p:cNvSpPr txBox="1"/>
-          <p:nvPr/>
-        </p:nvSpPr>
-        <p:spPr>
-          <a:xfrm>
-            <a:off x="502076" y="5623814"/>
-            <a:ext cx="1544282" cy="125222"/>
-          </a:xfrm>
-          <a:prstGeom prst="rect">
-            <a:avLst/>
-          </a:prstGeom>
-          <a:noFill/>
-          <a:ln/>
-        </p:spPr>
-        <p:txBody>
-          <a:bodyPr wrap="square" lIns="0" tIns="0" rIns="0" bIns="0" rtlCol="0" anchor="ctr"/>
-          <a:lstStyle/>
+              <a:rPr lang="en-US" sz="800" dirty="0">
+                <a:solidFill>
+                  <a:srgbClr val="CFE6FF"/>
+                </a:solidFill>
+                <a:latin typeface="Arial" pitchFamily="34" charset="0"/>
+                <a:ea typeface="Arial" pitchFamily="34" charset="-122"/>
+                <a:cs typeface="Arial" pitchFamily="34" charset="-120"/>
+              </a:rPr>
+              <a:t>Lồng thắt lưng</a:t>
+            </a:r>
+            <a:endParaRPr lang="en-US" sz="800" dirty="0"/>
+          </a:p>
           <a:p>
             <a:pPr algn="ctr" indent="0" marL="0">
               <a:buNone/>
             </a:pPr>
             <a:r>
-              <a:rPr lang="en-US" sz="750" dirty="0">
+              <a:rPr lang="en-US" sz="800" dirty="0">
                 <a:solidFill>
                   <a:srgbClr val="CFE6FF"/>
                 </a:solidFill>
@@ -2143,22 +2813,22 @@
                 <a:ea typeface="Arial" pitchFamily="34" charset="-122"/>
                 <a:cs typeface="Arial" pitchFamily="34" charset="-120"/>
               </a:rPr>
-              <a:t>Collagen I : nano-HA</a:t>
-            </a:r>
-            <a:endParaRPr lang="en-US" sz="750" dirty="0"/>
-          </a:p>
-        </p:txBody>
-      </p:sp>
-      <p:sp>
-        <p:nvSpPr>
-          <p:cNvPr id="43" name="Text 14"/>
-          <p:cNvSpPr txBox="1"/>
-          <p:nvPr/>
-        </p:nvSpPr>
-        <p:spPr>
-          <a:xfrm>
-            <a:off x="1939704" y="5409803"/>
-            <a:ext cx="1537043" cy="218678"/>
+              <a:t>in 3D</a:t>
+            </a:r>
+            <a:endParaRPr lang="en-US" sz="800" dirty="0"/>
+          </a:p>
+        </p:txBody>
+      </p:sp>
+      <p:sp>
+        <p:nvSpPr>
+          <p:cNvPr id="58" name="Text 29"/>
+          <p:cNvSpPr txBox="1"/>
+          <p:nvPr/>
+        </p:nvSpPr>
+        <p:spPr>
+          <a:xfrm>
+            <a:off x="10839438" y="3308092"/>
+            <a:ext cx="533424" cy="177820"/>
           </a:xfrm>
           <a:prstGeom prst="rect">
             <a:avLst/>
@@ -2174,30 +2844,30 @@
               <a:buNone/>
             </a:pPr>
             <a:r>
-              <a:rPr lang="en-US" sz="1350" b="1" dirty="0">
-                <a:solidFill>
-                  <a:srgbClr val="8ED14F"/>
-                </a:solidFill>
-                <a:latin typeface="Arial" pitchFamily="34" charset="0"/>
-                <a:ea typeface="Arial" pitchFamily="34" charset="-122"/>
-                <a:cs typeface="Arial" pitchFamily="34" charset="-120"/>
-              </a:rPr>
-              <a:t>70–80%</a:t>
-            </a:r>
-            <a:endParaRPr lang="en-US" sz="1350" dirty="0"/>
-          </a:p>
-        </p:txBody>
-      </p:sp>
-      <p:sp>
-        <p:nvSpPr>
-          <p:cNvPr id="44" name="Text 15"/>
-          <p:cNvSpPr txBox="1"/>
-          <p:nvPr/>
-        </p:nvSpPr>
-        <p:spPr>
-          <a:xfrm>
-            <a:off x="1939704" y="5623814"/>
-            <a:ext cx="1537043" cy="125222"/>
+              <a:rPr lang="en-US" sz="1050" b="1" spc="25" kern="0" dirty="0">
+                <a:solidFill>
+                  <a:srgbClr val="FFFFFF"/>
+                </a:solidFill>
+                <a:latin typeface="Arial" pitchFamily="34" charset="0"/>
+                <a:ea typeface="Arial" pitchFamily="34" charset="-122"/>
+                <a:cs typeface="Arial" pitchFamily="34" charset="-120"/>
+              </a:rPr>
+              <a:t>PETRA</a:t>
+            </a:r>
+            <a:endParaRPr lang="en-US" sz="1050" dirty="0"/>
+          </a:p>
+        </p:txBody>
+      </p:sp>
+      <p:sp>
+        <p:nvSpPr>
+          <p:cNvPr id="59" name="Text 30"/>
+          <p:cNvSpPr txBox="1"/>
+          <p:nvPr/>
+        </p:nvSpPr>
+        <p:spPr>
+          <a:xfrm>
+            <a:off x="10880949" y="3484269"/>
+            <a:ext cx="450402" cy="306380"/>
           </a:xfrm>
           <a:prstGeom prst="rect">
             <a:avLst/>
@@ -2213,7 +2883,7 @@
               <a:buNone/>
             </a:pPr>
             <a:r>
-              <a:rPr lang="en-US" sz="750" dirty="0">
+              <a:rPr lang="en-US" sz="800" dirty="0">
                 <a:solidFill>
                   <a:srgbClr val="CFE6FF"/>
                 </a:solidFill>
@@ -2221,61 +2891,39 @@
                 <a:ea typeface="Arial" pitchFamily="34" charset="-122"/>
                 <a:cs typeface="Arial" pitchFamily="34" charset="-120"/>
               </a:rPr>
-              <a:t>Độ xốp</a:t>
-            </a:r>
-            <a:endParaRPr lang="en-US" sz="750" dirty="0"/>
-          </a:p>
-        </p:txBody>
-      </p:sp>
-      <p:sp>
-        <p:nvSpPr>
-          <p:cNvPr id="45" name="Text 16"/>
-          <p:cNvSpPr txBox="1"/>
-          <p:nvPr/>
-        </p:nvSpPr>
-        <p:spPr>
-          <a:xfrm>
-            <a:off x="3370537" y="5409803"/>
-            <a:ext cx="1537043" cy="218678"/>
-          </a:xfrm>
-          <a:prstGeom prst="rect">
-            <a:avLst/>
-          </a:prstGeom>
-          <a:noFill/>
-          <a:ln/>
-        </p:spPr>
-        <p:txBody>
-          <a:bodyPr wrap="square" lIns="0" tIns="0" rIns="0" bIns="0" rtlCol="0" anchor="ctr"/>
-          <a:lstStyle/>
+              <a:t>Lồng cổ</a:t>
+            </a:r>
+            <a:endParaRPr lang="en-US" sz="800" dirty="0"/>
+          </a:p>
           <a:p>
             <a:pPr algn="ctr" indent="0" marL="0">
               <a:buNone/>
             </a:pPr>
             <a:r>
-              <a:rPr lang="en-US" sz="1350" b="1" dirty="0">
-                <a:solidFill>
-                  <a:srgbClr val="8ED14F"/>
-                </a:solidFill>
-                <a:latin typeface="Arial" pitchFamily="34" charset="0"/>
-                <a:ea typeface="Arial" pitchFamily="34" charset="-122"/>
-                <a:cs typeface="Arial" pitchFamily="34" charset="-120"/>
-              </a:rPr>
-              <a:t>&gt;200.000</a:t>
-            </a:r>
-            <a:endParaRPr lang="en-US" sz="1350" dirty="0"/>
-          </a:p>
-        </p:txBody>
-      </p:sp>
-      <p:sp>
-        <p:nvSpPr>
-          <p:cNvPr id="46" name="Text 17"/>
-          <p:cNvSpPr txBox="1"/>
-          <p:nvPr/>
-        </p:nvSpPr>
-        <p:spPr>
-          <a:xfrm>
-            <a:off x="3370537" y="5623814"/>
-            <a:ext cx="1537043" cy="125222"/>
+              <a:rPr lang="en-US" sz="800" dirty="0">
+                <a:solidFill>
+                  <a:srgbClr val="CFE6FF"/>
+                </a:solidFill>
+                <a:latin typeface="Arial" pitchFamily="34" charset="0"/>
+                <a:ea typeface="Arial" pitchFamily="34" charset="-122"/>
+                <a:cs typeface="Arial" pitchFamily="34" charset="-120"/>
+              </a:rPr>
+              <a:t>in 3D</a:t>
+            </a:r>
+            <a:endParaRPr lang="en-US" sz="800" dirty="0"/>
+          </a:p>
+        </p:txBody>
+      </p:sp>
+      <p:sp>
+        <p:nvSpPr>
+          <p:cNvPr id="60" name="Text 31"/>
+          <p:cNvSpPr txBox="1"/>
+          <p:nvPr/>
+        </p:nvSpPr>
+        <p:spPr>
+          <a:xfrm>
+            <a:off x="9526307" y="4878923"/>
+            <a:ext cx="765637" cy="177820"/>
           </a:xfrm>
           <a:prstGeom prst="rect">
             <a:avLst/>
@@ -2291,7 +2939,46 @@
               <a:buNone/>
             </a:pPr>
             <a:r>
-              <a:rPr lang="en-US" sz="750" dirty="0">
+              <a:rPr lang="en-US" sz="1050" b="1" spc="25" kern="0" dirty="0">
+                <a:solidFill>
+                  <a:srgbClr val="FFFFFF"/>
+                </a:solidFill>
+                <a:latin typeface="Arial" pitchFamily="34" charset="0"/>
+                <a:ea typeface="Arial" pitchFamily="34" charset="-122"/>
+                <a:cs typeface="Arial" pitchFamily="34" charset="-120"/>
+              </a:rPr>
+              <a:t>QUATTRO</a:t>
+            </a:r>
+            <a:endParaRPr lang="en-US" sz="1050" dirty="0"/>
+          </a:p>
+        </p:txBody>
+      </p:sp>
+      <p:sp>
+        <p:nvSpPr>
+          <p:cNvPr id="61" name="Text 32"/>
+          <p:cNvSpPr txBox="1"/>
+          <p:nvPr/>
+        </p:nvSpPr>
+        <p:spPr>
+          <a:xfrm>
+            <a:off x="9490903" y="5065665"/>
+            <a:ext cx="836444" cy="153190"/>
+          </a:xfrm>
+          <a:prstGeom prst="rect">
+            <a:avLst/>
+          </a:prstGeom>
+          <a:noFill/>
+          <a:ln/>
+        </p:spPr>
+        <p:txBody>
+          <a:bodyPr wrap="square" lIns="0" tIns="0" rIns="0" bIns="0" rtlCol="0" anchor="ctr"/>
+          <a:lstStyle/>
+          <a:p>
+            <a:pPr algn="ctr" indent="0" marL="0">
+              <a:buNone/>
+            </a:pPr>
+            <a:r>
+              <a:rPr lang="en-US" sz="800" dirty="0">
                 <a:solidFill>
                   <a:srgbClr val="CFE6FF"/>
                 </a:solidFill>
@@ -2299,22 +2986,22 @@
                 <a:ea typeface="Arial" pitchFamily="34" charset="-122"/>
                 <a:cs typeface="Arial" pitchFamily="34" charset="-120"/>
               </a:rPr>
-              <a:t>Ca lâm sàng</a:t>
-            </a:r>
-            <a:endParaRPr lang="en-US" sz="750" dirty="0"/>
-          </a:p>
-        </p:txBody>
-      </p:sp>
-      <p:sp>
-        <p:nvSpPr>
-          <p:cNvPr id="47" name="Text 18"/>
-          <p:cNvSpPr txBox="1"/>
-          <p:nvPr/>
-        </p:nvSpPr>
-        <p:spPr>
-          <a:xfrm>
-            <a:off x="5069840" y="1802384"/>
-            <a:ext cx="4922520" cy="198882"/>
+              <a:t>Vít cuống sống</a:t>
+            </a:r>
+            <a:endParaRPr lang="en-US" sz="800" dirty="0"/>
+          </a:p>
+        </p:txBody>
+      </p:sp>
+      <p:sp>
+        <p:nvSpPr>
+          <p:cNvPr id="62" name="Text 33"/>
+          <p:cNvSpPr txBox="1"/>
+          <p:nvPr/>
+        </p:nvSpPr>
+        <p:spPr>
+          <a:xfrm>
+            <a:off x="10751857" y="4866660"/>
+            <a:ext cx="765637" cy="355640"/>
           </a:xfrm>
           <a:prstGeom prst="rect">
             <a:avLst/>
@@ -2330,7 +3017,7 @@
               <a:buNone/>
             </a:pPr>
             <a:r>
-              <a:rPr lang="en-US" sz="1150" b="1" spc="25" kern="0" dirty="0">
+              <a:rPr lang="en-US" sz="1050" b="1" spc="25" kern="0" dirty="0">
                 <a:solidFill>
                   <a:srgbClr val="FFFFFF"/>
                 </a:solidFill>
@@ -2338,36 +3025,39 @@
                 <a:ea typeface="Arial" pitchFamily="34" charset="-122"/>
                 <a:cs typeface="Arial" pitchFamily="34" charset="-120"/>
               </a:rPr>
-              <a:t>GIẢI PHÁP TÍCH HỢP CHO </a:t>
-            </a:r>
+              <a:t>QUATTRO</a:t>
+            </a:r>
+            <a:endParaRPr lang="en-US" sz="1050" dirty="0"/>
+          </a:p>
+          <a:p>
             <a:pPr algn="ctr" indent="0" marL="0">
               <a:buNone/>
             </a:pPr>
             <a:r>
-              <a:rPr lang="en-US" sz="1150" b="1" spc="25" kern="0" dirty="0">
-                <a:solidFill>
-                  <a:srgbClr val="8ED14F"/>
-                </a:solidFill>
-                <a:latin typeface="Arial" pitchFamily="34" charset="0"/>
-                <a:ea typeface="Arial" pitchFamily="34" charset="-122"/>
-                <a:cs typeface="Arial" pitchFamily="34" charset="-120"/>
-              </a:rPr>
-              <a:t>PHẪU THUẬT CỘT SỐNG</a:t>
-            </a:r>
-            <a:endParaRPr lang="en-US" sz="1150" dirty="0"/>
-          </a:p>
-        </p:txBody>
-      </p:sp>
-      <p:sp>
-        <p:nvSpPr>
-          <p:cNvPr id="48" name="Text 19"/>
-          <p:cNvSpPr txBox="1"/>
-          <p:nvPr/>
-        </p:nvSpPr>
-        <p:spPr>
-          <a:xfrm>
-            <a:off x="7029450" y="2203196"/>
-            <a:ext cx="241300" cy="279908"/>
+              <a:rPr lang="en-US" sz="1050" b="1" spc="25" kern="0" dirty="0">
+                <a:solidFill>
+                  <a:srgbClr val="FFFFFF"/>
+                </a:solidFill>
+                <a:latin typeface="Arial" pitchFamily="34" charset="0"/>
+                <a:ea typeface="Arial" pitchFamily="34" charset="-122"/>
+                <a:cs typeface="Arial" pitchFamily="34" charset="-120"/>
+              </a:rPr>
+              <a:t>GADGET</a:t>
+            </a:r>
+            <a:endParaRPr lang="en-US" sz="1050" dirty="0"/>
+          </a:p>
+        </p:txBody>
+      </p:sp>
+      <p:sp>
+        <p:nvSpPr>
+          <p:cNvPr id="63" name="Text 34"/>
+          <p:cNvSpPr txBox="1"/>
+          <p:nvPr/>
+        </p:nvSpPr>
+        <p:spPr>
+          <a:xfrm>
+            <a:off x="10857953" y="5208393"/>
+            <a:ext cx="553444" cy="306380"/>
           </a:xfrm>
           <a:prstGeom prst="rect">
             <a:avLst/>
@@ -2383,147 +3073,47 @@
               <a:buNone/>
             </a:pPr>
             <a:r>
-              <a:rPr lang="en-US" sz="850" b="1" dirty="0">
-                <a:solidFill>
-                  <a:srgbClr val="04122E"/>
-                </a:solidFill>
-                <a:latin typeface="Arial" pitchFamily="34" charset="0"/>
-                <a:ea typeface="Arial" pitchFamily="34" charset="-122"/>
-                <a:cs typeface="Arial" pitchFamily="34" charset="-120"/>
-              </a:rPr>
-              <a:t>01</a:t>
-            </a:r>
-            <a:endParaRPr lang="en-US" sz="850" dirty="0"/>
-          </a:p>
-        </p:txBody>
-      </p:sp>
-      <p:sp>
-        <p:nvSpPr>
-          <p:cNvPr id="49" name="Text 20"/>
-          <p:cNvSpPr txBox="1"/>
-          <p:nvPr/>
-        </p:nvSpPr>
-        <p:spPr>
-          <a:xfrm>
-            <a:off x="7334250" y="2259140"/>
-            <a:ext cx="1458206" cy="167922"/>
-          </a:xfrm>
-          <a:prstGeom prst="rect">
-            <a:avLst/>
-          </a:prstGeom>
-          <a:noFill/>
-          <a:ln/>
-        </p:spPr>
-        <p:txBody>
-          <a:bodyPr wrap="square" lIns="0" tIns="0" rIns="0" bIns="0" rtlCol="0" anchor="ctr"/>
-          <a:lstStyle/>
-          <a:p>
-            <a:pPr algn="l" indent="0" marL="0">
-              <a:buNone/>
-            </a:pPr>
-            <a:r>
-              <a:rPr lang="en-US" sz="950" b="1" dirty="0">
-                <a:solidFill>
-                  <a:srgbClr val="FFFFFF"/>
-                </a:solidFill>
-                <a:latin typeface="Arial" pitchFamily="34" charset="0"/>
-                <a:ea typeface="Arial" pitchFamily="34" charset="-122"/>
-                <a:cs typeface="Arial" pitchFamily="34" charset="-120"/>
-              </a:rPr>
-              <a:t>Giảm phơi nhiễm tia X</a:t>
-            </a:r>
-            <a:endParaRPr lang="en-US" sz="950" dirty="0"/>
-          </a:p>
-        </p:txBody>
-      </p:sp>
-      <p:sp>
-        <p:nvSpPr>
-          <p:cNvPr id="50" name="Text 21"/>
-          <p:cNvSpPr txBox="1"/>
-          <p:nvPr/>
-        </p:nvSpPr>
-        <p:spPr>
-          <a:xfrm>
-            <a:off x="8240514" y="2787396"/>
-            <a:ext cx="241300" cy="279908"/>
-          </a:xfrm>
-          <a:prstGeom prst="rect">
-            <a:avLst/>
-          </a:prstGeom>
-          <a:noFill/>
-          <a:ln/>
-        </p:spPr>
-        <p:txBody>
-          <a:bodyPr wrap="square" lIns="0" tIns="0" rIns="0" bIns="0" rtlCol="0" anchor="ctr"/>
-          <a:lstStyle/>
+              <a:rPr lang="en-US" sz="800" dirty="0">
+                <a:solidFill>
+                  <a:srgbClr val="CFE6FF"/>
+                </a:solidFill>
+                <a:latin typeface="Arial" pitchFamily="34" charset="0"/>
+                <a:ea typeface="Arial" pitchFamily="34" charset="-122"/>
+                <a:cs typeface="Arial" pitchFamily="34" charset="-120"/>
+              </a:rPr>
+              <a:t>Vít qua da</a:t>
+            </a:r>
+            <a:endParaRPr lang="en-US" sz="800" dirty="0"/>
+          </a:p>
           <a:p>
             <a:pPr algn="ctr" indent="0" marL="0">
               <a:buNone/>
             </a:pPr>
             <a:r>
-              <a:rPr lang="en-US" sz="850" b="1" dirty="0">
-                <a:solidFill>
-                  <a:srgbClr val="04122E"/>
-                </a:solidFill>
-                <a:latin typeface="Arial" pitchFamily="34" charset="0"/>
-                <a:ea typeface="Arial" pitchFamily="34" charset="-122"/>
-                <a:cs typeface="Arial" pitchFamily="34" charset="-120"/>
-              </a:rPr>
-              <a:t>02</a:t>
-            </a:r>
-            <a:endParaRPr lang="en-US" sz="850" dirty="0"/>
-          </a:p>
-        </p:txBody>
-      </p:sp>
-      <p:sp>
-        <p:nvSpPr>
-          <p:cNvPr id="51" name="Text 22"/>
-          <p:cNvSpPr txBox="1"/>
-          <p:nvPr/>
-        </p:nvSpPr>
-        <p:spPr>
-          <a:xfrm>
-            <a:off x="8545314" y="2843340"/>
-            <a:ext cx="1131320" cy="167922"/>
-          </a:xfrm>
-          <a:prstGeom prst="rect">
-            <a:avLst/>
-          </a:prstGeom>
-          <a:noFill/>
-          <a:ln/>
-        </p:spPr>
-        <p:txBody>
-          <a:bodyPr wrap="square" lIns="0" tIns="0" rIns="0" bIns="0" rtlCol="0" anchor="ctr"/>
-          <a:lstStyle/>
-          <a:p>
-            <a:pPr algn="l" indent="0" marL="0">
-              <a:buNone/>
-            </a:pPr>
-            <a:r>
-              <a:rPr lang="en-US" sz="950" b="1" dirty="0">
-                <a:solidFill>
-                  <a:srgbClr val="FFFFFF"/>
-                </a:solidFill>
-                <a:latin typeface="Arial" pitchFamily="34" charset="0"/>
-                <a:ea typeface="Arial" pitchFamily="34" charset="-122"/>
-                <a:cs typeface="Arial" pitchFamily="34" charset="-120"/>
-              </a:rPr>
-              <a:t>Độ chính xác cao</a:t>
-            </a:r>
-            <a:endParaRPr lang="en-US" sz="950" dirty="0"/>
-          </a:p>
-        </p:txBody>
-      </p:sp>
-      <p:sp>
-        <p:nvSpPr>
-          <p:cNvPr id="52" name="Text 23"/>
-          <p:cNvSpPr txBox="1"/>
-          <p:nvPr/>
-        </p:nvSpPr>
-        <p:spPr>
-          <a:xfrm>
-            <a:off x="5441950" y="4642787"/>
-            <a:ext cx="241300" cy="279908"/>
+              <a:rPr lang="en-US" sz="800" dirty="0">
+                <a:solidFill>
+                  <a:srgbClr val="CFE6FF"/>
+                </a:solidFill>
+                <a:latin typeface="Arial" pitchFamily="34" charset="0"/>
+                <a:ea typeface="Arial" pitchFamily="34" charset="-122"/>
+                <a:cs typeface="Arial" pitchFamily="34" charset="-120"/>
+              </a:rPr>
+              <a:t>ít xâm lấn</a:t>
+            </a:r>
+            <a:endParaRPr lang="en-US" sz="800" dirty="0"/>
+          </a:p>
+        </p:txBody>
+      </p:sp>
+      <p:sp>
+        <p:nvSpPr>
+          <p:cNvPr id="64" name="Text 35"/>
+          <p:cNvSpPr txBox="1"/>
+          <p:nvPr/>
+        </p:nvSpPr>
+        <p:spPr>
+          <a:xfrm>
+            <a:off x="10947698" y="5532156"/>
+            <a:ext cx="373955" cy="178165"/>
           </a:xfrm>
           <a:prstGeom prst="rect">
             <a:avLst/>
@@ -2539,119 +3129,7 @@
               <a:buNone/>
             </a:pPr>
             <a:r>
-              <a:rPr lang="en-US" sz="850" b="1" dirty="0">
-                <a:solidFill>
-                  <a:srgbClr val="04122E"/>
-                </a:solidFill>
-                <a:latin typeface="Arial" pitchFamily="34" charset="0"/>
-                <a:ea typeface="Arial" pitchFamily="34" charset="-122"/>
-                <a:cs typeface="Arial" pitchFamily="34" charset="-120"/>
-              </a:rPr>
-              <a:t>03</a:t>
-            </a:r>
-            <a:endParaRPr lang="en-US" sz="850" dirty="0"/>
-          </a:p>
-        </p:txBody>
-      </p:sp>
-      <p:sp>
-        <p:nvSpPr>
-          <p:cNvPr id="53" name="Text 24"/>
-          <p:cNvSpPr txBox="1"/>
-          <p:nvPr/>
-        </p:nvSpPr>
-        <p:spPr>
-          <a:xfrm>
-            <a:off x="5746750" y="4530908"/>
-            <a:ext cx="710892" cy="503765"/>
-          </a:xfrm>
-          <a:prstGeom prst="rect">
-            <a:avLst/>
-          </a:prstGeom>
-          <a:noFill/>
-          <a:ln/>
-        </p:spPr>
-        <p:txBody>
-          <a:bodyPr wrap="square" lIns="0" tIns="0" rIns="0" bIns="0" rtlCol="0" anchor="ctr"/>
-          <a:lstStyle/>
-          <a:p>
-            <a:pPr algn="l" indent="0" marL="0">
-              <a:buNone/>
-            </a:pPr>
-            <a:r>
-              <a:rPr lang="en-US" sz="950" b="1" dirty="0">
-                <a:solidFill>
-                  <a:srgbClr val="FFFFFF"/>
-                </a:solidFill>
-                <a:latin typeface="Arial" pitchFamily="34" charset="0"/>
-                <a:ea typeface="Arial" pitchFamily="34" charset="-122"/>
-                <a:cs typeface="Arial" pitchFamily="34" charset="-120"/>
-              </a:rPr>
-              <a:t>Tối ưu hóa</a:t>
-            </a:r>
-            <a:endParaRPr lang="en-US" sz="950" dirty="0"/>
-          </a:p>
-          <a:p>
-            <a:pPr algn="l" indent="0" marL="0">
-              <a:buNone/>
-            </a:pPr>
-            <a:r>
-              <a:rPr lang="en-US" sz="950" b="1" dirty="0">
-                <a:solidFill>
-                  <a:srgbClr val="FFFFFF"/>
-                </a:solidFill>
-                <a:latin typeface="Arial" pitchFamily="34" charset="0"/>
-                <a:ea typeface="Arial" pitchFamily="34" charset="-122"/>
-                <a:cs typeface="Arial" pitchFamily="34" charset="-120"/>
-              </a:rPr>
-              <a:t>quy trình</a:t>
-            </a:r>
-            <a:endParaRPr lang="en-US" sz="950" dirty="0"/>
-          </a:p>
-          <a:p>
-            <a:pPr algn="l" indent="0" marL="0">
-              <a:buNone/>
-            </a:pPr>
-            <a:r>
-              <a:rPr lang="en-US" sz="950" b="1" dirty="0">
-                <a:solidFill>
-                  <a:srgbClr val="FFFFFF"/>
-                </a:solidFill>
-                <a:latin typeface="Arial" pitchFamily="34" charset="0"/>
-                <a:ea typeface="Arial" pitchFamily="34" charset="-122"/>
-                <a:cs typeface="Arial" pitchFamily="34" charset="-120"/>
-              </a:rPr>
-              <a:t>phẫu thuật</a:t>
-            </a:r>
-            <a:endParaRPr lang="en-US" sz="950" dirty="0"/>
-          </a:p>
-        </p:txBody>
-      </p:sp>
-      <p:sp>
-        <p:nvSpPr>
-          <p:cNvPr id="54" name="Text 25"/>
-          <p:cNvSpPr txBox="1"/>
-          <p:nvPr/>
-        </p:nvSpPr>
-        <p:spPr>
-          <a:xfrm>
-            <a:off x="10213876" y="2121198"/>
-            <a:ext cx="1200249" cy="184150"/>
-          </a:xfrm>
-          <a:prstGeom prst="rect">
-            <a:avLst/>
-          </a:prstGeom>
-          <a:noFill/>
-          <a:ln/>
-        </p:spPr>
-        <p:txBody>
-          <a:bodyPr wrap="square" lIns="0" tIns="0" rIns="0" bIns="0" rtlCol="0" anchor="ctr"/>
-          <a:lstStyle/>
-          <a:p>
-            <a:pPr algn="ctr" indent="0" marL="0">
-              <a:buNone/>
-            </a:pPr>
-            <a:r>
-              <a:rPr lang="en-US" sz="750" b="1" spc="100" kern="0" dirty="0">
+              <a:rPr lang="en-US" sz="700" spc="100" kern="0" dirty="0">
                 <a:solidFill>
                   <a:srgbClr val="0A3170"/>
                 </a:solidFill>
@@ -2659,484 +3137,9 @@
                 <a:ea typeface="Arial" pitchFamily="34" charset="-122"/>
                 <a:cs typeface="Arial" pitchFamily="34" charset="-120"/>
               </a:rPr>
-              <a:t>CÔNG NGHỆ IN 3D</a:t>
-            </a:r>
-            <a:endParaRPr lang="en-US" sz="750" dirty="0"/>
-          </a:p>
-        </p:txBody>
-      </p:sp>
-      <p:sp>
-        <p:nvSpPr>
-          <p:cNvPr id="55" name="Text 26"/>
-          <p:cNvSpPr txBox="1"/>
-          <p:nvPr/>
-        </p:nvSpPr>
-        <p:spPr>
-          <a:xfrm>
-            <a:off x="9829546" y="2305348"/>
-            <a:ext cx="1969008" cy="276225"/>
-          </a:xfrm>
-          <a:prstGeom prst="rect">
-            <a:avLst/>
-          </a:prstGeom>
-          <a:noFill/>
-          <a:ln/>
-        </p:spPr>
-        <p:txBody>
-          <a:bodyPr wrap="square" lIns="0" tIns="0" rIns="0" bIns="0" rtlCol="0" anchor="ctr"/>
-          <a:lstStyle/>
-          <a:p>
-            <a:pPr algn="ctr" indent="0" marL="0">
-              <a:buNone/>
-            </a:pPr>
-            <a:r>
-              <a:rPr lang="en-US" sz="750" b="1" dirty="0">
-                <a:solidFill>
-                  <a:srgbClr val="FFFFFF"/>
-                </a:solidFill>
-                <a:latin typeface="Arial" pitchFamily="34" charset="0"/>
-                <a:ea typeface="Arial" pitchFamily="34" charset="-122"/>
-                <a:cs typeface="Arial" pitchFamily="34" charset="-120"/>
-              </a:rPr>
-              <a:t>Cấu trúc xốp tối ưu hóa</a:t>
-            </a:r>
-            <a:endParaRPr lang="en-US" sz="750" dirty="0"/>
-          </a:p>
-          <a:p>
-            <a:pPr algn="ctr" indent="0" marL="0">
-              <a:buNone/>
-            </a:pPr>
-            <a:r>
-              <a:rPr lang="en-US" sz="750" b="1" dirty="0">
-                <a:solidFill>
-                  <a:srgbClr val="FFFFFF"/>
-                </a:solidFill>
-                <a:latin typeface="Arial" pitchFamily="34" charset="0"/>
-                <a:ea typeface="Arial" pitchFamily="34" charset="-122"/>
-                <a:cs typeface="Arial" pitchFamily="34" charset="-120"/>
-              </a:rPr>
-              <a:t>tích hợp xương</a:t>
-            </a:r>
-            <a:endParaRPr lang="en-US" sz="750" dirty="0"/>
-          </a:p>
-        </p:txBody>
-      </p:sp>
-      <p:sp>
-        <p:nvSpPr>
-          <p:cNvPr id="56" name="Text 27"/>
-          <p:cNvSpPr txBox="1"/>
-          <p:nvPr/>
-        </p:nvSpPr>
-        <p:spPr>
-          <a:xfrm>
-            <a:off x="10040393" y="3263213"/>
-            <a:ext cx="645515" cy="152384"/>
-          </a:xfrm>
-          <a:prstGeom prst="rect">
-            <a:avLst/>
-          </a:prstGeom>
-          <a:noFill/>
-          <a:ln/>
-        </p:spPr>
-        <p:txBody>
-          <a:bodyPr wrap="square" lIns="0" tIns="0" rIns="0" bIns="0" rtlCol="0" anchor="ctr"/>
-          <a:lstStyle/>
-          <a:p>
-            <a:pPr algn="ctr" indent="0" marL="0">
-              <a:buNone/>
-            </a:pPr>
-            <a:r>
-              <a:rPr lang="en-US" sz="900" b="1" spc="25" kern="0" dirty="0">
-                <a:solidFill>
-                  <a:srgbClr val="FFFFFF"/>
-                </a:solidFill>
-                <a:latin typeface="Arial" pitchFamily="34" charset="0"/>
-                <a:ea typeface="Arial" pitchFamily="34" charset="-122"/>
-                <a:cs typeface="Arial" pitchFamily="34" charset="-120"/>
-              </a:rPr>
-              <a:t>PANTHER</a:t>
-            </a:r>
-            <a:endParaRPr lang="en-US" sz="900" dirty="0"/>
-          </a:p>
-        </p:txBody>
-      </p:sp>
-      <p:sp>
-        <p:nvSpPr>
-          <p:cNvPr id="57" name="Text 28"/>
-          <p:cNvSpPr txBox="1"/>
-          <p:nvPr/>
-        </p:nvSpPr>
-        <p:spPr>
-          <a:xfrm>
-            <a:off x="9992880" y="3417693"/>
-            <a:ext cx="740640" cy="277606"/>
-          </a:xfrm>
-          <a:prstGeom prst="rect">
-            <a:avLst/>
-          </a:prstGeom>
-          <a:noFill/>
-          <a:ln/>
-        </p:spPr>
-        <p:txBody>
-          <a:bodyPr wrap="square" lIns="0" tIns="0" rIns="0" bIns="0" rtlCol="0" anchor="ctr"/>
-          <a:lstStyle/>
-          <a:p>
-            <a:pPr algn="ctr" indent="0" marL="0">
-              <a:buNone/>
-            </a:pPr>
-            <a:r>
-              <a:rPr lang="en-US" sz="725" dirty="0">
-                <a:solidFill>
-                  <a:srgbClr val="CFE6FF"/>
-                </a:solidFill>
-                <a:latin typeface="Arial" pitchFamily="34" charset="0"/>
-                <a:ea typeface="Arial" pitchFamily="34" charset="-122"/>
-                <a:cs typeface="Arial" pitchFamily="34" charset="-120"/>
-              </a:rPr>
-              <a:t>Lồng thắt lưng</a:t>
-            </a:r>
-            <a:endParaRPr lang="en-US" sz="725" dirty="0"/>
-          </a:p>
-          <a:p>
-            <a:pPr algn="ctr" indent="0" marL="0">
-              <a:buNone/>
-            </a:pPr>
-            <a:r>
-              <a:rPr lang="en-US" sz="725" dirty="0">
-                <a:solidFill>
-                  <a:srgbClr val="CFE6FF"/>
-                </a:solidFill>
-                <a:latin typeface="Arial" pitchFamily="34" charset="0"/>
-                <a:ea typeface="Arial" pitchFamily="34" charset="-122"/>
-                <a:cs typeface="Arial" pitchFamily="34" charset="-120"/>
-              </a:rPr>
-              <a:t>in 3D</a:t>
-            </a:r>
-            <a:endParaRPr lang="en-US" sz="725" dirty="0"/>
-          </a:p>
-        </p:txBody>
-      </p:sp>
-      <p:sp>
-        <p:nvSpPr>
-          <p:cNvPr id="58" name="Text 29"/>
-          <p:cNvSpPr txBox="1"/>
-          <p:nvPr/>
-        </p:nvSpPr>
-        <p:spPr>
-          <a:xfrm>
-            <a:off x="11034956" y="3263213"/>
-            <a:ext cx="459790" cy="152384"/>
-          </a:xfrm>
-          <a:prstGeom prst="rect">
-            <a:avLst/>
-          </a:prstGeom>
-          <a:noFill/>
-          <a:ln/>
-        </p:spPr>
-        <p:txBody>
-          <a:bodyPr wrap="square" lIns="0" tIns="0" rIns="0" bIns="0" rtlCol="0" anchor="ctr"/>
-          <a:lstStyle/>
-          <a:p>
-            <a:pPr algn="ctr" indent="0" marL="0">
-              <a:buNone/>
-            </a:pPr>
-            <a:r>
-              <a:rPr lang="en-US" sz="900" b="1" spc="25" kern="0" dirty="0">
-                <a:solidFill>
-                  <a:srgbClr val="FFFFFF"/>
-                </a:solidFill>
-                <a:latin typeface="Arial" pitchFamily="34" charset="0"/>
-                <a:ea typeface="Arial" pitchFamily="34" charset="-122"/>
-                <a:cs typeface="Arial" pitchFamily="34" charset="-120"/>
-              </a:rPr>
-              <a:t>PETRA</a:t>
-            </a:r>
-            <a:endParaRPr lang="en-US" sz="900" dirty="0"/>
-          </a:p>
-        </p:txBody>
-      </p:sp>
-      <p:sp>
-        <p:nvSpPr>
-          <p:cNvPr id="59" name="Text 30"/>
-          <p:cNvSpPr txBox="1"/>
-          <p:nvPr/>
-        </p:nvSpPr>
-        <p:spPr>
-          <a:xfrm>
-            <a:off x="11060745" y="3417693"/>
-            <a:ext cx="408212" cy="277606"/>
-          </a:xfrm>
-          <a:prstGeom prst="rect">
-            <a:avLst/>
-          </a:prstGeom>
-          <a:noFill/>
-          <a:ln/>
-        </p:spPr>
-        <p:txBody>
-          <a:bodyPr wrap="square" lIns="0" tIns="0" rIns="0" bIns="0" rtlCol="0" anchor="ctr"/>
-          <a:lstStyle/>
-          <a:p>
-            <a:pPr algn="ctr" indent="0" marL="0">
-              <a:buNone/>
-            </a:pPr>
-            <a:r>
-              <a:rPr lang="en-US" sz="725" dirty="0">
-                <a:solidFill>
-                  <a:srgbClr val="CFE6FF"/>
-                </a:solidFill>
-                <a:latin typeface="Arial" pitchFamily="34" charset="0"/>
-                <a:ea typeface="Arial" pitchFamily="34" charset="-122"/>
-                <a:cs typeface="Arial" pitchFamily="34" charset="-120"/>
-              </a:rPr>
-              <a:t>Lồng cổ</a:t>
-            </a:r>
-            <a:endParaRPr lang="en-US" sz="725" dirty="0"/>
-          </a:p>
-          <a:p>
-            <a:pPr algn="ctr" indent="0" marL="0">
-              <a:buNone/>
-            </a:pPr>
-            <a:r>
-              <a:rPr lang="en-US" sz="725" dirty="0">
-                <a:solidFill>
-                  <a:srgbClr val="CFE6FF"/>
-                </a:solidFill>
-                <a:latin typeface="Arial" pitchFamily="34" charset="0"/>
-                <a:ea typeface="Arial" pitchFamily="34" charset="-122"/>
-                <a:cs typeface="Arial" pitchFamily="34" charset="-120"/>
-              </a:rPr>
-              <a:t>in 3D</a:t>
-            </a:r>
-            <a:endParaRPr lang="en-US" sz="725" dirty="0"/>
-          </a:p>
-        </p:txBody>
-      </p:sp>
-      <p:sp>
-        <p:nvSpPr>
-          <p:cNvPr id="60" name="Text 31"/>
-          <p:cNvSpPr txBox="1"/>
-          <p:nvPr/>
-        </p:nvSpPr>
-        <p:spPr>
-          <a:xfrm>
-            <a:off x="10004685" y="4770842"/>
-            <a:ext cx="659880" cy="152384"/>
-          </a:xfrm>
-          <a:prstGeom prst="rect">
-            <a:avLst/>
-          </a:prstGeom>
-          <a:noFill/>
-          <a:ln/>
-        </p:spPr>
-        <p:txBody>
-          <a:bodyPr wrap="square" lIns="0" tIns="0" rIns="0" bIns="0" rtlCol="0" anchor="ctr"/>
-          <a:lstStyle/>
-          <a:p>
-            <a:pPr algn="ctr" indent="0" marL="0">
-              <a:buNone/>
-            </a:pPr>
-            <a:r>
-              <a:rPr lang="en-US" sz="900" b="1" spc="25" kern="0" dirty="0">
-                <a:solidFill>
-                  <a:srgbClr val="FFFFFF"/>
-                </a:solidFill>
-                <a:latin typeface="Arial" pitchFamily="34" charset="0"/>
-                <a:ea typeface="Arial" pitchFamily="34" charset="-122"/>
-                <a:cs typeface="Arial" pitchFamily="34" charset="-120"/>
-              </a:rPr>
-              <a:t>QUATTRO</a:t>
-            </a:r>
-            <a:endParaRPr lang="en-US" sz="900" dirty="0"/>
-          </a:p>
-        </p:txBody>
-      </p:sp>
-      <p:sp>
-        <p:nvSpPr>
-          <p:cNvPr id="61" name="Text 32"/>
-          <p:cNvSpPr txBox="1"/>
-          <p:nvPr/>
-        </p:nvSpPr>
-        <p:spPr>
-          <a:xfrm>
-            <a:off x="9955595" y="4934895"/>
-            <a:ext cx="758059" cy="138803"/>
-          </a:xfrm>
-          <a:prstGeom prst="rect">
-            <a:avLst/>
-          </a:prstGeom>
-          <a:noFill/>
-          <a:ln/>
-        </p:spPr>
-        <p:txBody>
-          <a:bodyPr wrap="square" lIns="0" tIns="0" rIns="0" bIns="0" rtlCol="0" anchor="ctr"/>
-          <a:lstStyle/>
-          <a:p>
-            <a:pPr algn="ctr" indent="0" marL="0">
-              <a:buNone/>
-            </a:pPr>
-            <a:r>
-              <a:rPr lang="en-US" sz="725" dirty="0">
-                <a:solidFill>
-                  <a:srgbClr val="CFE6FF"/>
-                </a:solidFill>
-                <a:latin typeface="Arial" pitchFamily="34" charset="0"/>
-                <a:ea typeface="Arial" pitchFamily="34" charset="-122"/>
-                <a:cs typeface="Arial" pitchFamily="34" charset="-120"/>
-              </a:rPr>
-              <a:t>Vít cuống sống</a:t>
-            </a:r>
-            <a:endParaRPr lang="en-US" sz="725" dirty="0"/>
-          </a:p>
-        </p:txBody>
-      </p:sp>
-      <p:sp>
-        <p:nvSpPr>
-          <p:cNvPr id="62" name="Text 33"/>
-          <p:cNvSpPr txBox="1"/>
-          <p:nvPr/>
-        </p:nvSpPr>
-        <p:spPr>
-          <a:xfrm>
-            <a:off x="10963535" y="4760333"/>
-            <a:ext cx="659880" cy="304768"/>
-          </a:xfrm>
-          <a:prstGeom prst="rect">
-            <a:avLst/>
-          </a:prstGeom>
-          <a:noFill/>
-          <a:ln/>
-        </p:spPr>
-        <p:txBody>
-          <a:bodyPr wrap="square" lIns="0" tIns="0" rIns="0" bIns="0" rtlCol="0" anchor="ctr"/>
-          <a:lstStyle/>
-          <a:p>
-            <a:pPr algn="ctr" indent="0" marL="0">
-              <a:buNone/>
-            </a:pPr>
-            <a:r>
-              <a:rPr lang="en-US" sz="900" b="1" spc="25" kern="0" dirty="0">
-                <a:solidFill>
-                  <a:srgbClr val="FFFFFF"/>
-                </a:solidFill>
-                <a:latin typeface="Arial" pitchFamily="34" charset="0"/>
-                <a:ea typeface="Arial" pitchFamily="34" charset="-122"/>
-                <a:cs typeface="Arial" pitchFamily="34" charset="-120"/>
-              </a:rPr>
-              <a:t>QUATTRO</a:t>
-            </a:r>
-            <a:endParaRPr lang="en-US" sz="900" dirty="0"/>
-          </a:p>
-          <a:p>
-            <a:pPr algn="ctr" indent="0" marL="0">
-              <a:buNone/>
-            </a:pPr>
-            <a:r>
-              <a:rPr lang="en-US" sz="900" b="1" spc="25" kern="0" dirty="0">
-                <a:solidFill>
-                  <a:srgbClr val="FFFFFF"/>
-                </a:solidFill>
-                <a:latin typeface="Arial" pitchFamily="34" charset="0"/>
-                <a:ea typeface="Arial" pitchFamily="34" charset="-122"/>
-                <a:cs typeface="Arial" pitchFamily="34" charset="-120"/>
-              </a:rPr>
-              <a:t>GADGET</a:t>
-            </a:r>
-            <a:endParaRPr lang="en-US" sz="900" dirty="0"/>
-          </a:p>
-        </p:txBody>
-      </p:sp>
-      <p:sp>
-        <p:nvSpPr>
-          <p:cNvPr id="63" name="Text 34"/>
-          <p:cNvSpPr txBox="1"/>
-          <p:nvPr/>
-        </p:nvSpPr>
-        <p:spPr>
-          <a:xfrm>
-            <a:off x="11042605" y="5056688"/>
-            <a:ext cx="501640" cy="277606"/>
-          </a:xfrm>
-          <a:prstGeom prst="rect">
-            <a:avLst/>
-          </a:prstGeom>
-          <a:noFill/>
-          <a:ln/>
-        </p:spPr>
-        <p:txBody>
-          <a:bodyPr wrap="square" lIns="0" tIns="0" rIns="0" bIns="0" rtlCol="0" anchor="ctr"/>
-          <a:lstStyle/>
-          <a:p>
-            <a:pPr algn="ctr" indent="0" marL="0">
-              <a:buNone/>
-            </a:pPr>
-            <a:r>
-              <a:rPr lang="en-US" sz="725" dirty="0">
-                <a:solidFill>
-                  <a:srgbClr val="CFE6FF"/>
-                </a:solidFill>
-                <a:latin typeface="Arial" pitchFamily="34" charset="0"/>
-                <a:ea typeface="Arial" pitchFamily="34" charset="-122"/>
-                <a:cs typeface="Arial" pitchFamily="34" charset="-120"/>
-              </a:rPr>
-              <a:t>Vít qua da</a:t>
-            </a:r>
-            <a:endParaRPr lang="en-US" sz="725" dirty="0"/>
-          </a:p>
-          <a:p>
-            <a:pPr algn="ctr" indent="0" marL="0">
-              <a:buNone/>
-            </a:pPr>
-            <a:r>
-              <a:rPr lang="en-US" sz="725" dirty="0">
-                <a:solidFill>
-                  <a:srgbClr val="CFE6FF"/>
-                </a:solidFill>
-                <a:latin typeface="Arial" pitchFamily="34" charset="0"/>
-                <a:ea typeface="Arial" pitchFamily="34" charset="-122"/>
-                <a:cs typeface="Arial" pitchFamily="34" charset="-120"/>
-              </a:rPr>
-              <a:t>ít xâm lấn</a:t>
-            </a:r>
-            <a:endParaRPr lang="en-US" sz="725" dirty="0"/>
-          </a:p>
-        </p:txBody>
-      </p:sp>
-      <p:sp>
-        <p:nvSpPr>
-          <p:cNvPr id="64" name="Text 35"/>
-          <p:cNvSpPr txBox="1"/>
-          <p:nvPr/>
-        </p:nvSpPr>
-        <p:spPr>
-          <a:xfrm>
-            <a:off x="11112103" y="5354320"/>
-            <a:ext cx="362744" cy="168612"/>
-          </a:xfrm>
-          <a:prstGeom prst="rect">
-            <a:avLst/>
-          </a:prstGeom>
-          <a:noFill/>
-          <a:ln/>
-        </p:spPr>
-        <p:txBody>
-          <a:bodyPr wrap="square" lIns="0" tIns="0" rIns="0" bIns="0" rtlCol="0" anchor="ctr"/>
-          <a:lstStyle/>
-          <a:p>
-            <a:pPr algn="ctr" indent="0" marL="0">
-              <a:buNone/>
-            </a:pPr>
-            <a:r>
-              <a:rPr lang="en-US" sz="650" spc="100" kern="0" dirty="0">
-                <a:solidFill>
-                  <a:srgbClr val="0A3170"/>
-                </a:solidFill>
-                <a:latin typeface="Arial" pitchFamily="34" charset="0"/>
-                <a:ea typeface="Arial" pitchFamily="34" charset="-122"/>
-                <a:cs typeface="Arial" pitchFamily="34" charset="-120"/>
-              </a:rPr>
               <a:t>MIS</a:t>
             </a:r>
-            <a:endParaRPr lang="en-US" sz="650" dirty="0"/>
+            <a:endParaRPr lang="en-US" sz="700" dirty="0"/>
           </a:p>
         </p:txBody>
       </p:sp>

</xml_diff>

<commit_message>
Backdrop VOA: per-product QR codes linking to mobile product sheets
Co-Authored-By: Claude Opus 5.5 <noreply@anthropic.com>
Claude-Session: https://claude.ai/code/session_013QJi2k1EkL4AWCx1Ymi9NU
</commit_message>
<xml_diff>
--- a/backdrop-voa/backdrop-VOA.pptx
+++ b/backdrop-voa/backdrop-VOA.pptx
@@ -1090,7 +1090,7 @@
         </p:blipFill>
         <p:spPr>
           <a:xfrm>
-            <a:off x="736600" y="2890838"/>
+            <a:off x="736600" y="2630488"/>
             <a:ext cx="1168400" cy="292100"/>
           </a:xfrm>
           <a:prstGeom prst="rect">
@@ -1100,7 +1100,7 @@
       </p:pic>
       <p:pic>
         <p:nvPicPr>
-          <p:cNvPr id="11" name="Image 9" descr="sh_40.png">    </p:cNvPr>
+          <p:cNvPr id="11" name="Image 9" descr="QR bongold">    </p:cNvPr>
           <p:cNvPicPr>
             <a:picLocks noChangeAspect="1"/>
           </p:cNvPicPr>
@@ -1114,8 +1114,8 @@
         </p:blipFill>
         <p:spPr>
           <a:xfrm>
-            <a:off x="1983063" y="2477668"/>
-            <a:ext cx="3666474" cy="1562841"/>
+            <a:off x="1123950" y="3513138"/>
+            <a:ext cx="393700" cy="393700"/>
           </a:xfrm>
           <a:prstGeom prst="rect">
             <a:avLst/>
@@ -1124,7 +1124,7 @@
       </p:pic>
       <p:pic>
         <p:nvPicPr>
-          <p:cNvPr id="12" name="Image 10" descr="Skulheal">    </p:cNvPr>
+          <p:cNvPr id="12" name="Image 10" descr="sh_40.png">    </p:cNvPr>
           <p:cNvPicPr>
             <a:picLocks noChangeAspect="1"/>
           </p:cNvPicPr>
@@ -1138,8 +1138,8 @@
         </p:blipFill>
         <p:spPr>
           <a:xfrm>
-            <a:off x="4061420" y="4338647"/>
-            <a:ext cx="1198959" cy="292080"/>
+            <a:off x="1983063" y="2477668"/>
+            <a:ext cx="3666474" cy="1562841"/>
           </a:xfrm>
           <a:prstGeom prst="rect">
             <a:avLst/>
@@ -1148,7 +1148,7 @@
       </p:pic>
       <p:pic>
         <p:nvPicPr>
-          <p:cNvPr id="13" name="Image 11" descr="sh_36.png">    </p:cNvPr>
+          <p:cNvPr id="13" name="Image 11" descr="Skulheal">    </p:cNvPr>
           <p:cNvPicPr>
             <a:picLocks noChangeAspect="1"/>
           </p:cNvPicPr>
@@ -1162,8 +1162,8 @@
         </p:blipFill>
         <p:spPr>
           <a:xfrm>
-            <a:off x="278603" y="3827710"/>
-            <a:ext cx="3773395" cy="1574206"/>
+            <a:off x="4061420" y="4078297"/>
+            <a:ext cx="1198959" cy="292080"/>
           </a:xfrm>
           <a:prstGeom prst="rect">
             <a:avLst/>
@@ -1172,7 +1172,7 @@
       </p:pic>
       <p:pic>
         <p:nvPicPr>
-          <p:cNvPr id="14" name="Image 12" descr="Curexo">    </p:cNvPr>
+          <p:cNvPr id="14" name="Image 12" descr="QR skulheal">    </p:cNvPr>
           <p:cNvPicPr>
             <a:picLocks noChangeAspect="1"/>
           </p:cNvPicPr>
@@ -1186,8 +1186,8 @@
         </p:blipFill>
         <p:spPr>
           <a:xfrm>
-            <a:off x="5969000" y="1333505"/>
-            <a:ext cx="1052513" cy="266691"/>
+            <a:off x="4464050" y="4776788"/>
+            <a:ext cx="393700" cy="393700"/>
           </a:xfrm>
           <a:prstGeom prst="rect">
             <a:avLst/>
@@ -1196,7 +1196,7 @@
       </p:pic>
       <p:pic>
         <p:nvPicPr>
-          <p:cNvPr id="15" name="Image 13" descr="CE">    </p:cNvPr>
+          <p:cNvPr id="15" name="Image 13" descr="sh_36.png">    </p:cNvPr>
           <p:cNvPicPr>
             <a:picLocks noChangeAspect="1"/>
           </p:cNvPicPr>
@@ -1210,8 +1210,8 @@
         </p:blipFill>
         <p:spPr>
           <a:xfrm>
-            <a:off x="7110413" y="1384323"/>
-            <a:ext cx="232767" cy="165053"/>
+            <a:off x="278603" y="3827710"/>
+            <a:ext cx="3773395" cy="1574206"/>
           </a:xfrm>
           <a:prstGeom prst="rect">
             <a:avLst/>
@@ -1220,7 +1220,7 @@
       </p:pic>
       <p:pic>
         <p:nvPicPr>
-          <p:cNvPr id="16" name="Image 14" descr="FDA">    </p:cNvPr>
+          <p:cNvPr id="16" name="Image 14" descr="Curexo">    </p:cNvPr>
           <p:cNvPicPr>
             <a:picLocks noChangeAspect="1"/>
           </p:cNvPicPr>
@@ -1234,8 +1234,8 @@
         </p:blipFill>
         <p:spPr>
           <a:xfrm>
-            <a:off x="7393980" y="1384300"/>
-            <a:ext cx="415925" cy="165100"/>
+            <a:off x="5969000" y="1333505"/>
+            <a:ext cx="1052513" cy="266691"/>
           </a:xfrm>
           <a:prstGeom prst="rect">
             <a:avLst/>
@@ -1244,7 +1244,7 @@
       </p:pic>
       <p:pic>
         <p:nvPicPr>
-          <p:cNvPr id="17" name="Image 15" descr="Mantiz">    </p:cNvPr>
+          <p:cNvPr id="17" name="Image 15" descr="CE">    </p:cNvPr>
           <p:cNvPicPr>
             <a:picLocks noChangeAspect="1"/>
           </p:cNvPicPr>
@@ -1258,8 +1258,8 @@
         </p:blipFill>
         <p:spPr>
           <a:xfrm>
-            <a:off x="9634538" y="1339860"/>
-            <a:ext cx="1034058" cy="253979"/>
+            <a:off x="7110413" y="1384323"/>
+            <a:ext cx="232767" cy="165053"/>
           </a:xfrm>
           <a:prstGeom prst="rect">
             <a:avLst/>
@@ -1268,7 +1268,7 @@
       </p:pic>
       <p:pic>
         <p:nvPicPr>
-          <p:cNvPr id="18" name="Image 16" descr="ISO 13485">    </p:cNvPr>
+          <p:cNvPr id="18" name="Image 16" descr="FDA">    </p:cNvPr>
           <p:cNvPicPr>
             <a:picLocks noChangeAspect="1"/>
           </p:cNvPicPr>
@@ -1282,8 +1282,8 @@
         </p:blipFill>
         <p:spPr>
           <a:xfrm>
-            <a:off x="10732095" y="1320807"/>
-            <a:ext cx="271562" cy="292087"/>
+            <a:off x="7393980" y="1384300"/>
+            <a:ext cx="415925" cy="165100"/>
           </a:xfrm>
           <a:prstGeom prst="rect">
             <a:avLst/>
@@ -1292,7 +1292,7 @@
       </p:pic>
       <p:pic>
         <p:nvPicPr>
-          <p:cNvPr id="19" name="Image 17" descr="GMP">    </p:cNvPr>
+          <p:cNvPr id="19" name="Image 17" descr="Mantiz">    </p:cNvPr>
           <p:cNvPicPr>
             <a:picLocks noChangeAspect="1"/>
           </p:cNvPicPr>
@@ -1306,8 +1306,8 @@
         </p:blipFill>
         <p:spPr>
           <a:xfrm>
-            <a:off x="11054457" y="1320806"/>
-            <a:ext cx="354806" cy="292088"/>
+            <a:off x="9634538" y="1339860"/>
+            <a:ext cx="1034058" cy="253979"/>
           </a:xfrm>
           <a:prstGeom prst="rect">
             <a:avLst/>
@@ -1316,7 +1316,7 @@
       </p:pic>
       <p:pic>
         <p:nvPicPr>
-          <p:cNvPr id="20" name="Image 18" descr="CUVIS Spine">    </p:cNvPr>
+          <p:cNvPr id="20" name="Image 18" descr="ISO 13485">    </p:cNvPr>
           <p:cNvPicPr>
             <a:picLocks noChangeAspect="1"/>
           </p:cNvPicPr>
@@ -1330,8 +1330,8 @@
         </p:blipFill>
         <p:spPr>
           <a:xfrm>
-            <a:off x="6045200" y="2209809"/>
-            <a:ext cx="1001812" cy="228582"/>
+            <a:off x="10732095" y="1320807"/>
+            <a:ext cx="271562" cy="292087"/>
           </a:xfrm>
           <a:prstGeom prst="rect">
             <a:avLst/>
@@ -1340,7 +1340,7 @@
       </p:pic>
       <p:pic>
         <p:nvPicPr>
-          <p:cNvPr id="21" name="Image 19" descr="Robot CUVIS Spine">    </p:cNvPr>
+          <p:cNvPr id="21" name="Image 19" descr="GMP">    </p:cNvPr>
           <p:cNvPicPr>
             <a:picLocks noChangeAspect="1"/>
           </p:cNvPicPr>
@@ -1354,8 +1354,8 @@
         </p:blipFill>
         <p:spPr>
           <a:xfrm>
-            <a:off x="6400801" y="3035307"/>
-            <a:ext cx="3289595" cy="3047987"/>
+            <a:off x="11054457" y="1320806"/>
+            <a:ext cx="354806" cy="292088"/>
           </a:xfrm>
           <a:prstGeom prst="rect">
             <a:avLst/>
@@ -1364,7 +1364,7 @@
       </p:pic>
       <p:pic>
         <p:nvPicPr>
-          <p:cNvPr id="22" name="Image 20" descr="25.png">    </p:cNvPr>
+          <p:cNvPr id="22" name="Image 20" descr="CUVIS Spine">    </p:cNvPr>
           <p:cNvPicPr>
             <a:picLocks noChangeAspect="1"/>
           </p:cNvPicPr>
@@ -1378,8 +1378,8 @@
         </p:blipFill>
         <p:spPr>
           <a:xfrm>
-            <a:off x="9442861" y="2676128"/>
-            <a:ext cx="485349" cy="361355"/>
+            <a:off x="6045200" y="2209809"/>
+            <a:ext cx="1001812" cy="228582"/>
           </a:xfrm>
           <a:prstGeom prst="rect">
             <a:avLst/>
@@ -1388,7 +1388,7 @@
       </p:pic>
       <p:pic>
         <p:nvPicPr>
-          <p:cNvPr id="23" name="Image 21" descr="26.png">    </p:cNvPr>
+          <p:cNvPr id="23" name="Image 21" descr="QR cuvis">    </p:cNvPr>
           <p:cNvPicPr>
             <a:picLocks noChangeAspect="1"/>
           </p:cNvPicPr>
@@ -1402,8 +1402,8 @@
         </p:blipFill>
         <p:spPr>
           <a:xfrm>
-            <a:off x="9947301" y="2669977"/>
-            <a:ext cx="485326" cy="373658"/>
+            <a:off x="5969000" y="2508250"/>
+            <a:ext cx="406400" cy="406400"/>
           </a:xfrm>
           <a:prstGeom prst="rect">
             <a:avLst/>
@@ -1412,7 +1412,7 @@
       </p:pic>
       <p:pic>
         <p:nvPicPr>
-          <p:cNvPr id="24" name="Image 22" descr="28.png">    </p:cNvPr>
+          <p:cNvPr id="24" name="Image 22" descr="Robot CUVIS Spine">    </p:cNvPr>
           <p:cNvPicPr>
             <a:picLocks noChangeAspect="1"/>
           </p:cNvPicPr>
@@ -1426,8 +1426,8 @@
         </p:blipFill>
         <p:spPr>
           <a:xfrm>
-            <a:off x="10611299" y="2645569"/>
-            <a:ext cx="485274" cy="422473"/>
+            <a:off x="6400801" y="3035307"/>
+            <a:ext cx="3289595" cy="3047987"/>
           </a:xfrm>
           <a:prstGeom prst="rect">
             <a:avLst/>
@@ -1436,7 +1436,7 @@
       </p:pic>
       <p:pic>
         <p:nvPicPr>
-          <p:cNvPr id="25" name="Image 23" descr="29.png">    </p:cNvPr>
+          <p:cNvPr id="25" name="Image 23" descr="25.png">    </p:cNvPr>
           <p:cNvPicPr>
             <a:picLocks noChangeAspect="1"/>
           </p:cNvPicPr>
@@ -1450,8 +1450,8 @@
         </p:blipFill>
         <p:spPr>
           <a:xfrm>
-            <a:off x="11115720" y="2652713"/>
-            <a:ext cx="485288" cy="408186"/>
+            <a:off x="9417868" y="2792313"/>
+            <a:ext cx="500808" cy="372864"/>
           </a:xfrm>
           <a:prstGeom prst="rect">
             <a:avLst/>
@@ -1460,7 +1460,7 @@
       </p:pic>
       <p:pic>
         <p:nvPicPr>
-          <p:cNvPr id="26" name="Image 24" descr="31.png">    </p:cNvPr>
+          <p:cNvPr id="26" name="Image 24" descr="26.png">    </p:cNvPr>
           <p:cNvPicPr>
             <a:picLocks noChangeAspect="1"/>
           </p:cNvPicPr>
@@ -1474,8 +1474,8 @@
         </p:blipFill>
         <p:spPr>
           <a:xfrm>
-            <a:off x="9585356" y="4072037"/>
-            <a:ext cx="647539" cy="711101"/>
+            <a:off x="9937783" y="2785963"/>
+            <a:ext cx="500790" cy="385564"/>
           </a:xfrm>
           <a:prstGeom prst="rect">
             <a:avLst/>
@@ -1484,7 +1484,7 @@
       </p:pic>
       <p:pic>
         <p:nvPicPr>
-          <p:cNvPr id="27" name="Image 25" descr="33.png">    </p:cNvPr>
+          <p:cNvPr id="27" name="Image 25" descr="QR panther">    </p:cNvPr>
           <p:cNvPicPr>
             <a:picLocks noChangeAspect="1"/>
           </p:cNvPicPr>
@@ -1498,8 +1498,8 @@
         </p:blipFill>
         <p:spPr>
           <a:xfrm>
-            <a:off x="10668057" y="4085530"/>
-            <a:ext cx="933336" cy="684213"/>
+            <a:off x="10084594" y="3391495"/>
+            <a:ext cx="330200" cy="330200"/>
           </a:xfrm>
           <a:prstGeom prst="rect">
             <a:avLst/>
@@ -1508,7 +1508,7 @@
       </p:pic>
       <p:pic>
         <p:nvPicPr>
-          <p:cNvPr id="28" name="Image 26" descr="Callout lines">    </p:cNvPr>
+          <p:cNvPr id="28" name="Image 26" descr="28.png">    </p:cNvPr>
           <p:cNvPicPr>
             <a:picLocks noChangeAspect="1"/>
           </p:cNvPicPr>
@@ -1522,6 +1522,174 @@
         </p:blipFill>
         <p:spPr>
           <a:xfrm>
+            <a:off x="10605335" y="2760762"/>
+            <a:ext cx="500773" cy="435967"/>
+          </a:xfrm>
+          <a:prstGeom prst="rect">
+            <a:avLst/>
+          </a:prstGeom>
+        </p:spPr>
+      </p:pic>
+      <p:pic>
+        <p:nvPicPr>
+          <p:cNvPr id="29" name="Image 27" descr="29.png">    </p:cNvPr>
+          <p:cNvPicPr>
+            <a:picLocks noChangeAspect="1"/>
+          </p:cNvPicPr>
+          <p:nvPr/>
+        </p:nvPicPr>
+        <p:blipFill>
+          <a:blip r:embed="rId29"/>
+          <a:stretch>
+            <a:fillRect/>
+          </a:stretch>
+        </p:blipFill>
+        <p:spPr>
+          <a:xfrm>
+            <a:off x="11125258" y="2768104"/>
+            <a:ext cx="500740" cy="421184"/>
+          </a:xfrm>
+          <a:prstGeom prst="rect">
+            <a:avLst/>
+          </a:prstGeom>
+        </p:spPr>
+      </p:pic>
+      <p:pic>
+        <p:nvPicPr>
+          <p:cNvPr id="30" name="Image 28" descr="QR petra">    </p:cNvPr>
+          <p:cNvPicPr>
+            <a:picLocks noChangeAspect="1"/>
+          </p:cNvPicPr>
+          <p:nvPr/>
+        </p:nvPicPr>
+        <p:blipFill>
+          <a:blip r:embed="rId30"/>
+          <a:stretch>
+            <a:fillRect/>
+          </a:stretch>
+        </p:blipFill>
+        <p:spPr>
+          <a:xfrm>
+            <a:off x="11160522" y="3391495"/>
+            <a:ext cx="330200" cy="330200"/>
+          </a:xfrm>
+          <a:prstGeom prst="rect">
+            <a:avLst/>
+          </a:prstGeom>
+        </p:spPr>
+      </p:pic>
+      <p:pic>
+        <p:nvPicPr>
+          <p:cNvPr id="31" name="Image 29" descr="31.png">    </p:cNvPr>
+          <p:cNvPicPr>
+            <a:picLocks noChangeAspect="1"/>
+          </p:cNvPicPr>
+          <p:nvPr/>
+        </p:nvPicPr>
+        <p:blipFill>
+          <a:blip r:embed="rId31"/>
+          <a:stretch>
+            <a:fillRect/>
+          </a:stretch>
+        </p:blipFill>
+        <p:spPr>
+          <a:xfrm>
+            <a:off x="9639437" y="4247753"/>
+            <a:ext cx="520326" cy="571401"/>
+          </a:xfrm>
+          <a:prstGeom prst="rect">
+            <a:avLst/>
+          </a:prstGeom>
+        </p:spPr>
+      </p:pic>
+      <p:pic>
+        <p:nvPicPr>
+          <p:cNvPr id="32" name="Image 30" descr="QR quattro">    </p:cNvPr>
+          <p:cNvPicPr>
+            <a:picLocks noChangeAspect="1"/>
+          </p:cNvPicPr>
+          <p:nvPr/>
+        </p:nvPicPr>
+        <p:blipFill>
+          <a:blip r:embed="rId32"/>
+          <a:stretch>
+            <a:fillRect/>
+          </a:stretch>
+        </p:blipFill>
+        <p:spPr>
+          <a:xfrm>
+            <a:off x="10027543" y="4946253"/>
+            <a:ext cx="330200" cy="330200"/>
+          </a:xfrm>
+          <a:prstGeom prst="rect">
+            <a:avLst/>
+          </a:prstGeom>
+        </p:spPr>
+      </p:pic>
+      <p:pic>
+        <p:nvPicPr>
+          <p:cNvPr id="33" name="Image 31" descr="33.png">    </p:cNvPr>
+          <p:cNvPicPr>
+            <a:picLocks noChangeAspect="1"/>
+          </p:cNvPicPr>
+          <p:nvPr/>
+        </p:nvPicPr>
+        <p:blipFill>
+          <a:blip r:embed="rId33"/>
+          <a:stretch>
+            <a:fillRect/>
+          </a:stretch>
+        </p:blipFill>
+        <p:spPr>
+          <a:xfrm>
+            <a:off x="10754476" y="4247753"/>
+            <a:ext cx="779449" cy="571401"/>
+          </a:xfrm>
+          <a:prstGeom prst="rect">
+            <a:avLst/>
+          </a:prstGeom>
+        </p:spPr>
+      </p:pic>
+      <p:pic>
+        <p:nvPicPr>
+          <p:cNvPr id="34" name="Image 32" descr="QR gadget">    </p:cNvPr>
+          <p:cNvPicPr>
+            <a:picLocks noChangeAspect="1"/>
+          </p:cNvPicPr>
+          <p:nvPr/>
+        </p:nvPicPr>
+        <p:blipFill>
+          <a:blip r:embed="rId34"/>
+          <a:stretch>
+            <a:fillRect/>
+          </a:stretch>
+        </p:blipFill>
+        <p:spPr>
+          <a:xfrm>
+            <a:off x="11272143" y="5045273"/>
+            <a:ext cx="330200" cy="330200"/>
+          </a:xfrm>
+          <a:prstGeom prst="rect">
+            <a:avLst/>
+          </a:prstGeom>
+        </p:spPr>
+      </p:pic>
+      <p:pic>
+        <p:nvPicPr>
+          <p:cNvPr id="35" name="Image 33" descr="Callout lines">    </p:cNvPr>
+          <p:cNvPicPr>
+            <a:picLocks noChangeAspect="1"/>
+          </p:cNvPicPr>
+          <p:nvPr/>
+        </p:nvPicPr>
+        <p:blipFill>
+          <a:blip r:embed="rId35"/>
+          <a:stretch>
+            <a:fillRect/>
+          </a:stretch>
+        </p:blipFill>
+        <p:spPr>
+          <a:xfrm>
             <a:off x="0" y="0"/>
             <a:ext cx="12191695" cy="6096305"/>
           </a:xfrm>
@@ -1532,7 +1700,7 @@
       </p:pic>
       <p:sp>
         <p:nvSpPr>
-          <p:cNvPr id="29" name="Text 0"/>
+          <p:cNvPr id="36" name="Text 0"/>
           <p:cNvSpPr txBox="1"/>
           <p:nvPr/>
         </p:nvSpPr>
@@ -1585,7 +1753,7 @@
       </p:sp>
       <p:sp>
         <p:nvSpPr>
-          <p:cNvPr id="30" name="Text 1"/>
+          <p:cNvPr id="37" name="Text 1"/>
           <p:cNvSpPr txBox="1"/>
           <p:nvPr/>
         </p:nvSpPr>
@@ -1624,7 +1792,7 @@
       </p:sp>
       <p:sp>
         <p:nvSpPr>
-          <p:cNvPr id="31" name="Text 2"/>
+          <p:cNvPr id="38" name="Text 2"/>
           <p:cNvSpPr txBox="1"/>
           <p:nvPr/>
         </p:nvSpPr>
@@ -1677,7 +1845,7 @@
       </p:sp>
       <p:sp>
         <p:nvSpPr>
-          <p:cNvPr id="32" name="Text 3"/>
+          <p:cNvPr id="39" name="Text 3"/>
           <p:cNvSpPr txBox="1"/>
           <p:nvPr/>
         </p:nvSpPr>
@@ -1716,7 +1884,7 @@
       </p:sp>
       <p:sp>
         <p:nvSpPr>
-          <p:cNvPr id="33" name="Text 4"/>
+          <p:cNvPr id="40" name="Text 4"/>
           <p:cNvSpPr txBox="1"/>
           <p:nvPr/>
         </p:nvSpPr>
@@ -1755,7 +1923,7 @@
       </p:sp>
       <p:sp>
         <p:nvSpPr>
-          <p:cNvPr id="34" name="Text 5"/>
+          <p:cNvPr id="41" name="Text 5"/>
           <p:cNvSpPr txBox="1"/>
           <p:nvPr/>
         </p:nvSpPr>
@@ -1794,7 +1962,7 @@
       </p:sp>
       <p:sp>
         <p:nvSpPr>
-          <p:cNvPr id="35" name="Text 6"/>
+          <p:cNvPr id="42" name="Text 6"/>
           <p:cNvSpPr txBox="1"/>
           <p:nvPr/>
         </p:nvSpPr>
@@ -1833,7 +2001,7 @@
       </p:sp>
       <p:sp>
         <p:nvSpPr>
-          <p:cNvPr id="36" name="Text 7"/>
+          <p:cNvPr id="43" name="Text 7"/>
           <p:cNvSpPr txBox="1"/>
           <p:nvPr/>
         </p:nvSpPr>
@@ -1872,7 +2040,7 @@
       </p:sp>
       <p:sp>
         <p:nvSpPr>
-          <p:cNvPr id="37" name="Text 8"/>
+          <p:cNvPr id="44" name="Text 8"/>
           <p:cNvSpPr txBox="1"/>
           <p:nvPr/>
         </p:nvSpPr>
@@ -1925,7 +2093,7 @@
       </p:sp>
       <p:sp>
         <p:nvSpPr>
-          <p:cNvPr id="38" name="Text 9"/>
+          <p:cNvPr id="45" name="Text 9"/>
           <p:cNvSpPr txBox="1"/>
           <p:nvPr/>
         </p:nvSpPr>
@@ -1978,13 +2146,13 @@
       </p:sp>
       <p:sp>
         <p:nvSpPr>
-          <p:cNvPr id="39" name="Text 10"/>
+          <p:cNvPr id="46" name="Text 10"/>
           <p:cNvSpPr txBox="1"/>
           <p:nvPr/>
         </p:nvSpPr>
         <p:spPr>
           <a:xfrm>
-            <a:off x="743603" y="3274124"/>
+            <a:off x="743603" y="3013774"/>
             <a:ext cx="1154394" cy="427228"/>
           </a:xfrm>
           <a:prstGeom prst="rect">
@@ -2034,13 +2202,13 @@
       </p:sp>
       <p:sp>
         <p:nvSpPr>
-          <p:cNvPr id="40" name="Text 11"/>
+          <p:cNvPr id="47" name="Text 11"/>
           <p:cNvSpPr txBox="1"/>
           <p:nvPr/>
         </p:nvSpPr>
         <p:spPr>
           <a:xfrm>
-            <a:off x="3982244" y="4736656"/>
+            <a:off x="3982244" y="4476306"/>
             <a:ext cx="1357313" cy="213614"/>
           </a:xfrm>
           <a:prstGeom prst="rect">
@@ -2073,7 +2241,7 @@
       </p:sp>
       <p:sp>
         <p:nvSpPr>
-          <p:cNvPr id="41" name="Text 12"/>
+          <p:cNvPr id="48" name="Text 12"/>
           <p:cNvSpPr txBox="1"/>
           <p:nvPr/>
         </p:nvSpPr>
@@ -2112,7 +2280,7 @@
       </p:sp>
       <p:sp>
         <p:nvSpPr>
-          <p:cNvPr id="42" name="Text 13"/>
+          <p:cNvPr id="49" name="Text 13"/>
           <p:cNvSpPr txBox="1"/>
           <p:nvPr/>
         </p:nvSpPr>
@@ -2151,7 +2319,7 @@
       </p:sp>
       <p:sp>
         <p:nvSpPr>
-          <p:cNvPr id="43" name="Text 14"/>
+          <p:cNvPr id="50" name="Text 14"/>
           <p:cNvSpPr txBox="1"/>
           <p:nvPr/>
         </p:nvSpPr>
@@ -2190,7 +2358,7 @@
       </p:sp>
       <p:sp>
         <p:nvSpPr>
-          <p:cNvPr id="44" name="Text 15"/>
+          <p:cNvPr id="51" name="Text 15"/>
           <p:cNvSpPr txBox="1"/>
           <p:nvPr/>
         </p:nvSpPr>
@@ -2229,7 +2397,7 @@
       </p:sp>
       <p:sp>
         <p:nvSpPr>
-          <p:cNvPr id="45" name="Text 16"/>
+          <p:cNvPr id="52" name="Text 16"/>
           <p:cNvSpPr txBox="1"/>
           <p:nvPr/>
         </p:nvSpPr>
@@ -2268,7 +2436,7 @@
       </p:sp>
       <p:sp>
         <p:nvSpPr>
-          <p:cNvPr id="46" name="Text 17"/>
+          <p:cNvPr id="53" name="Text 17"/>
           <p:cNvSpPr txBox="1"/>
           <p:nvPr/>
         </p:nvSpPr>
@@ -2307,7 +2475,7 @@
       </p:sp>
       <p:sp>
         <p:nvSpPr>
-          <p:cNvPr id="47" name="Text 18"/>
+          <p:cNvPr id="54" name="Text 18"/>
           <p:cNvSpPr txBox="1"/>
           <p:nvPr/>
         </p:nvSpPr>
@@ -2363,7 +2531,7 @@
       </p:sp>
       <p:sp>
         <p:nvSpPr>
-          <p:cNvPr id="48" name="Text 19"/>
+          <p:cNvPr id="55" name="Text 19"/>
           <p:cNvSpPr txBox="1"/>
           <p:nvPr/>
         </p:nvSpPr>
@@ -2402,7 +2570,7 @@
       </p:sp>
       <p:sp>
         <p:nvSpPr>
-          <p:cNvPr id="49" name="Text 20"/>
+          <p:cNvPr id="56" name="Text 20"/>
           <p:cNvSpPr txBox="1"/>
           <p:nvPr/>
         </p:nvSpPr>
@@ -2441,7 +2609,7 @@
       </p:sp>
       <p:sp>
         <p:nvSpPr>
-          <p:cNvPr id="50" name="Text 21"/>
+          <p:cNvPr id="57" name="Text 21"/>
           <p:cNvSpPr txBox="1"/>
           <p:nvPr/>
         </p:nvSpPr>
@@ -2480,7 +2648,7 @@
       </p:sp>
       <p:sp>
         <p:nvSpPr>
-          <p:cNvPr id="51" name="Text 22"/>
+          <p:cNvPr id="58" name="Text 22"/>
           <p:cNvSpPr txBox="1"/>
           <p:nvPr/>
         </p:nvSpPr>
@@ -2519,7 +2687,7 @@
       </p:sp>
       <p:sp>
         <p:nvSpPr>
-          <p:cNvPr id="52" name="Text 23"/>
+          <p:cNvPr id="59" name="Text 23"/>
           <p:cNvSpPr txBox="1"/>
           <p:nvPr/>
         </p:nvSpPr>
@@ -2558,7 +2726,7 @@
       </p:sp>
       <p:sp>
         <p:nvSpPr>
-          <p:cNvPr id="53" name="Text 24"/>
+          <p:cNvPr id="60" name="Text 24"/>
           <p:cNvSpPr txBox="1"/>
           <p:nvPr/>
         </p:nvSpPr>
@@ -2631,13 +2799,13 @@
       </p:sp>
       <p:sp>
         <p:nvSpPr>
-          <p:cNvPr id="54" name="Text 25"/>
+          <p:cNvPr id="61" name="Text 25"/>
           <p:cNvSpPr txBox="1"/>
           <p:nvPr/>
         </p:nvSpPr>
         <p:spPr>
           <a:xfrm>
-            <a:off x="9893201" y="1933960"/>
+            <a:off x="9893201" y="2138450"/>
             <a:ext cx="1257399" cy="191516"/>
           </a:xfrm>
           <a:prstGeom prst="rect">
@@ -2670,14 +2838,14 @@
       </p:sp>
       <p:sp>
         <p:nvSpPr>
-          <p:cNvPr id="55" name="Text 26"/>
+          <p:cNvPr id="62" name="Text 26"/>
           <p:cNvSpPr txBox="1"/>
           <p:nvPr/>
         </p:nvSpPr>
         <p:spPr>
           <a:xfrm>
-            <a:off x="9233408" y="2123063"/>
-            <a:ext cx="2577084" cy="303848"/>
+            <a:off x="9204452" y="2321203"/>
+            <a:ext cx="2634996" cy="303848"/>
           </a:xfrm>
           <a:prstGeom prst="rect">
             <a:avLst/>
@@ -2726,14 +2894,14 @@
       </p:sp>
       <p:sp>
         <p:nvSpPr>
-          <p:cNvPr id="56" name="Text 27"/>
+          <p:cNvPr id="63" name="Text 27"/>
           <p:cNvSpPr txBox="1"/>
           <p:nvPr/>
         </p:nvSpPr>
         <p:spPr>
           <a:xfrm>
-            <a:off x="9563252" y="3308092"/>
-            <a:ext cx="748897" cy="177820"/>
+            <a:off x="9419410" y="3363607"/>
+            <a:ext cx="611130" cy="143982"/>
           </a:xfrm>
           <a:prstGeom prst="rect">
             <a:avLst/>
@@ -2749,7 +2917,7 @@
               <a:buNone/>
             </a:pPr>
             <a:r>
-              <a:rPr lang="en-US" sz="1050" b="1" spc="25" kern="0" dirty="0">
+              <a:rPr lang="en-US" sz="850" b="1" spc="25" kern="0" dirty="0">
                 <a:solidFill>
                   <a:srgbClr val="FFFFFF"/>
                 </a:solidFill>
@@ -2759,20 +2927,20 @@
               </a:rPr>
               <a:t>PANTHER</a:t>
             </a:r>
-            <a:endParaRPr lang="en-US" sz="1050" dirty="0"/>
-          </a:p>
-        </p:txBody>
-      </p:sp>
-      <p:sp>
-        <p:nvSpPr>
-          <p:cNvPr id="57" name="Text 28"/>
+            <a:endParaRPr lang="en-US" sz="850" dirty="0"/>
+          </a:p>
+        </p:txBody>
+      </p:sp>
+      <p:sp>
+        <p:nvSpPr>
+          <p:cNvPr id="64" name="Text 28"/>
           <p:cNvSpPr txBox="1"/>
           <p:nvPr/>
         </p:nvSpPr>
         <p:spPr>
           <a:xfrm>
-            <a:off x="9529093" y="3484269"/>
-            <a:ext cx="817215" cy="306380"/>
+            <a:off x="9380161" y="3498882"/>
+            <a:ext cx="689628" cy="258501"/>
           </a:xfrm>
           <a:prstGeom prst="rect">
             <a:avLst/>
@@ -2788,7 +2956,7 @@
               <a:buNone/>
             </a:pPr>
             <a:r>
-              <a:rPr lang="en-US" sz="800" dirty="0">
+              <a:rPr lang="en-US" sz="675" dirty="0">
                 <a:solidFill>
                   <a:srgbClr val="CFE6FF"/>
                 </a:solidFill>
@@ -2798,14 +2966,14 @@
               </a:rPr>
               <a:t>Lồng thắt lưng</a:t>
             </a:r>
-            <a:endParaRPr lang="en-US" sz="800" dirty="0"/>
+            <a:endParaRPr lang="en-US" sz="675" dirty="0"/>
           </a:p>
           <a:p>
             <a:pPr algn="ctr" indent="0" marL="0">
               <a:buNone/>
             </a:pPr>
             <a:r>
-              <a:rPr lang="en-US" sz="800" dirty="0">
+              <a:rPr lang="en-US" sz="675" dirty="0">
                 <a:solidFill>
                   <a:srgbClr val="CFE6FF"/>
                 </a:solidFill>
@@ -2815,20 +2983,20 @@
               </a:rPr>
               <a:t>in 3D</a:t>
             </a:r>
-            <a:endParaRPr lang="en-US" sz="800" dirty="0"/>
-          </a:p>
-        </p:txBody>
-      </p:sp>
-      <p:sp>
-        <p:nvSpPr>
-          <p:cNvPr id="58" name="Text 29"/>
+            <a:endParaRPr lang="en-US" sz="675" dirty="0"/>
+          </a:p>
+        </p:txBody>
+      </p:sp>
+      <p:sp>
+        <p:nvSpPr>
+          <p:cNvPr id="65" name="Text 29"/>
           <p:cNvSpPr txBox="1"/>
           <p:nvPr/>
         </p:nvSpPr>
         <p:spPr>
           <a:xfrm>
-            <a:off x="10839438" y="3308092"/>
-            <a:ext cx="533424" cy="177820"/>
+            <a:off x="10694853" y="3363607"/>
+            <a:ext cx="435245" cy="143982"/>
           </a:xfrm>
           <a:prstGeom prst="rect">
             <a:avLst/>
@@ -2844,7 +3012,7 @@
               <a:buNone/>
             </a:pPr>
             <a:r>
-              <a:rPr lang="en-US" sz="1050" b="1" spc="25" kern="0" dirty="0">
+              <a:rPr lang="en-US" sz="850" b="1" spc="25" kern="0" dirty="0">
                 <a:solidFill>
                   <a:srgbClr val="FFFFFF"/>
                 </a:solidFill>
@@ -2854,20 +3022,20 @@
               </a:rPr>
               <a:t>PETRA</a:t>
             </a:r>
-            <a:endParaRPr lang="en-US" sz="1050" dirty="0"/>
-          </a:p>
-        </p:txBody>
-      </p:sp>
-      <p:sp>
-        <p:nvSpPr>
-          <p:cNvPr id="59" name="Text 30"/>
+            <a:endParaRPr lang="en-US" sz="850" dirty="0"/>
+          </a:p>
+        </p:txBody>
+      </p:sp>
+      <p:sp>
+        <p:nvSpPr>
+          <p:cNvPr id="66" name="Text 30"/>
           <p:cNvSpPr txBox="1"/>
           <p:nvPr/>
         </p:nvSpPr>
         <p:spPr>
           <a:xfrm>
-            <a:off x="10880949" y="3484269"/>
-            <a:ext cx="450402" cy="306380"/>
+            <a:off x="10722451" y="3498882"/>
+            <a:ext cx="380048" cy="258501"/>
           </a:xfrm>
           <a:prstGeom prst="rect">
             <a:avLst/>
@@ -2883,7 +3051,7 @@
               <a:buNone/>
             </a:pPr>
             <a:r>
-              <a:rPr lang="en-US" sz="800" dirty="0">
+              <a:rPr lang="en-US" sz="675" dirty="0">
                 <a:solidFill>
                   <a:srgbClr val="CFE6FF"/>
                 </a:solidFill>
@@ -2893,14 +3061,14 @@
               </a:rPr>
               <a:t>Lồng cổ</a:t>
             </a:r>
-            <a:endParaRPr lang="en-US" sz="800" dirty="0"/>
+            <a:endParaRPr lang="en-US" sz="675" dirty="0"/>
           </a:p>
           <a:p>
             <a:pPr algn="ctr" indent="0" marL="0">
               <a:buNone/>
             </a:pPr>
             <a:r>
-              <a:rPr lang="en-US" sz="800" dirty="0">
+              <a:rPr lang="en-US" sz="675" dirty="0">
                 <a:solidFill>
                   <a:srgbClr val="CFE6FF"/>
                 </a:solidFill>
@@ -2910,20 +3078,20 @@
               </a:rPr>
               <a:t>in 3D</a:t>
             </a:r>
-            <a:endParaRPr lang="en-US" sz="800" dirty="0"/>
-          </a:p>
-        </p:txBody>
-      </p:sp>
-      <p:sp>
-        <p:nvSpPr>
-          <p:cNvPr id="60" name="Text 31"/>
+            <a:endParaRPr lang="en-US" sz="675" dirty="0"/>
+          </a:p>
+        </p:txBody>
+      </p:sp>
+      <p:sp>
+        <p:nvSpPr>
+          <p:cNvPr id="67" name="Text 31"/>
           <p:cNvSpPr txBox="1"/>
           <p:nvPr/>
         </p:nvSpPr>
         <p:spPr>
           <a:xfrm>
-            <a:off x="9526307" y="4878923"/>
-            <a:ext cx="765637" cy="177820"/>
+            <a:off x="9384049" y="4918365"/>
+            <a:ext cx="624703" cy="143982"/>
           </a:xfrm>
           <a:prstGeom prst="rect">
             <a:avLst/>
@@ -2939,7 +3107,7 @@
               <a:buNone/>
             </a:pPr>
             <a:r>
-              <a:rPr lang="en-US" sz="1050" b="1" spc="25" kern="0" dirty="0">
+              <a:rPr lang="en-US" sz="850" b="1" spc="25" kern="0" dirty="0">
                 <a:solidFill>
                   <a:srgbClr val="FFFFFF"/>
                 </a:solidFill>
@@ -2949,20 +3117,20 @@
               </a:rPr>
               <a:t>QUATTRO</a:t>
             </a:r>
-            <a:endParaRPr lang="en-US" sz="1050" dirty="0"/>
-          </a:p>
-        </p:txBody>
-      </p:sp>
-      <p:sp>
-        <p:nvSpPr>
-          <p:cNvPr id="61" name="Text 32"/>
+            <a:endParaRPr lang="en-US" sz="850" dirty="0"/>
+          </a:p>
+        </p:txBody>
+      </p:sp>
+      <p:sp>
+        <p:nvSpPr>
+          <p:cNvPr id="68" name="Text 32"/>
           <p:cNvSpPr txBox="1"/>
           <p:nvPr/>
         </p:nvSpPr>
         <p:spPr>
           <a:xfrm>
-            <a:off x="9490903" y="5065665"/>
-            <a:ext cx="836444" cy="153190"/>
+            <a:off x="9473752" y="5053640"/>
+            <a:ext cx="445199" cy="258501"/>
           </a:xfrm>
           <a:prstGeom prst="rect">
             <a:avLst/>
@@ -2978,7 +3146,7 @@
               <a:buNone/>
             </a:pPr>
             <a:r>
-              <a:rPr lang="en-US" sz="800" dirty="0">
+              <a:rPr lang="en-US" sz="675" dirty="0">
                 <a:solidFill>
                   <a:srgbClr val="CFE6FF"/>
                 </a:solidFill>
@@ -2986,22 +3154,39 @@
                 <a:ea typeface="Arial" pitchFamily="34" charset="-122"/>
                 <a:cs typeface="Arial" pitchFamily="34" charset="-120"/>
               </a:rPr>
-              <a:t>Vít cuống sống</a:t>
-            </a:r>
-            <a:endParaRPr lang="en-US" sz="800" dirty="0"/>
-          </a:p>
-        </p:txBody>
-      </p:sp>
-      <p:sp>
-        <p:nvSpPr>
-          <p:cNvPr id="62" name="Text 33"/>
+              <a:t>Vít cuống</a:t>
+            </a:r>
+            <a:endParaRPr lang="en-US" sz="675" dirty="0"/>
+          </a:p>
+          <a:p>
+            <a:pPr algn="ctr" indent="0" marL="0">
+              <a:buNone/>
+            </a:pPr>
+            <a:r>
+              <a:rPr lang="en-US" sz="675" dirty="0">
+                <a:solidFill>
+                  <a:srgbClr val="CFE6FF"/>
+                </a:solidFill>
+                <a:latin typeface="Arial" pitchFamily="34" charset="0"/>
+                <a:ea typeface="Arial" pitchFamily="34" charset="-122"/>
+                <a:cs typeface="Arial" pitchFamily="34" charset="-120"/>
+              </a:rPr>
+              <a:t>sống</a:t>
+            </a:r>
+            <a:endParaRPr lang="en-US" sz="675" dirty="0"/>
+          </a:p>
+        </p:txBody>
+      </p:sp>
+      <p:sp>
+        <p:nvSpPr>
+          <p:cNvPr id="69" name="Text 33"/>
           <p:cNvSpPr txBox="1"/>
           <p:nvPr/>
         </p:nvSpPr>
         <p:spPr>
           <a:xfrm>
-            <a:off x="10751857" y="4866660"/>
-            <a:ext cx="765637" cy="355640"/>
+            <a:off x="10628649" y="4907344"/>
+            <a:ext cx="624703" cy="287965"/>
           </a:xfrm>
           <a:prstGeom prst="rect">
             <a:avLst/>
@@ -3017,7 +3202,7 @@
               <a:buNone/>
             </a:pPr>
             <a:r>
-              <a:rPr lang="en-US" sz="1050" b="1" spc="25" kern="0" dirty="0">
+              <a:rPr lang="en-US" sz="850" b="1" spc="25" kern="0" dirty="0">
                 <a:solidFill>
                   <a:srgbClr val="FFFFFF"/>
                 </a:solidFill>
@@ -3027,14 +3212,14 @@
               </a:rPr>
               <a:t>QUATTRO</a:t>
             </a:r>
-            <a:endParaRPr lang="en-US" sz="1050" dirty="0"/>
+            <a:endParaRPr lang="en-US" sz="850" dirty="0"/>
           </a:p>
           <a:p>
             <a:pPr algn="ctr" indent="0" marL="0">
               <a:buNone/>
             </a:pPr>
             <a:r>
-              <a:rPr lang="en-US" sz="1050" b="1" spc="25" kern="0" dirty="0">
+              <a:rPr lang="en-US" sz="850" b="1" spc="25" kern="0" dirty="0">
                 <a:solidFill>
                   <a:srgbClr val="FFFFFF"/>
                 </a:solidFill>
@@ -3044,20 +3229,20 @@
               </a:rPr>
               <a:t>GADGET</a:t>
             </a:r>
-            <a:endParaRPr lang="en-US" sz="1050" dirty="0"/>
-          </a:p>
-        </p:txBody>
-      </p:sp>
-      <p:sp>
-        <p:nvSpPr>
-          <p:cNvPr id="63" name="Text 34"/>
+            <a:endParaRPr lang="en-US" sz="850" dirty="0"/>
+          </a:p>
+        </p:txBody>
+      </p:sp>
+      <p:sp>
+        <p:nvSpPr>
+          <p:cNvPr id="70" name="Text 34"/>
           <p:cNvSpPr txBox="1"/>
           <p:nvPr/>
         </p:nvSpPr>
         <p:spPr>
           <a:xfrm>
-            <a:off x="10857953" y="5208393"/>
-            <a:ext cx="553444" cy="306380"/>
+            <a:off x="10707486" y="5185585"/>
+            <a:ext cx="467029" cy="129250"/>
           </a:xfrm>
           <a:prstGeom prst="rect">
             <a:avLst/>
@@ -3073,7 +3258,7 @@
               <a:buNone/>
             </a:pPr>
             <a:r>
-              <a:rPr lang="en-US" sz="800" dirty="0">
+              <a:rPr lang="en-US" sz="675" dirty="0">
                 <a:solidFill>
                   <a:srgbClr val="CFE6FF"/>
                 </a:solidFill>
@@ -3083,37 +3268,20 @@
               </a:rPr>
               <a:t>Vít qua da</a:t>
             </a:r>
-            <a:endParaRPr lang="en-US" sz="800" dirty="0"/>
-          </a:p>
-          <a:p>
-            <a:pPr algn="ctr" indent="0" marL="0">
-              <a:buNone/>
-            </a:pPr>
-            <a:r>
-              <a:rPr lang="en-US" sz="800" dirty="0">
-                <a:solidFill>
-                  <a:srgbClr val="CFE6FF"/>
-                </a:solidFill>
-                <a:latin typeface="Arial" pitchFamily="34" charset="0"/>
-                <a:ea typeface="Arial" pitchFamily="34" charset="-122"/>
-                <a:cs typeface="Arial" pitchFamily="34" charset="-120"/>
-              </a:rPr>
-              <a:t>ít xâm lấn</a:t>
-            </a:r>
-            <a:endParaRPr lang="en-US" sz="800" dirty="0"/>
-          </a:p>
-        </p:txBody>
-      </p:sp>
-      <p:sp>
-        <p:nvSpPr>
-          <p:cNvPr id="64" name="Text 35"/>
+            <a:endParaRPr lang="en-US" sz="675" dirty="0"/>
+          </a:p>
+        </p:txBody>
+      </p:sp>
+      <p:sp>
+        <p:nvSpPr>
+          <p:cNvPr id="71" name="Text 35"/>
           <p:cNvSpPr txBox="1"/>
           <p:nvPr/>
         </p:nvSpPr>
         <p:spPr>
           <a:xfrm>
-            <a:off x="10947698" y="5532156"/>
-            <a:ext cx="373955" cy="178165"/>
+            <a:off x="10756801" y="5332059"/>
+            <a:ext cx="368399" cy="173446"/>
           </a:xfrm>
           <a:prstGeom prst="rect">
             <a:avLst/>
@@ -3129,7 +3297,7 @@
               <a:buNone/>
             </a:pPr>
             <a:r>
-              <a:rPr lang="en-US" sz="700" spc="100" kern="0" dirty="0">
+              <a:rPr lang="en-US" sz="675" spc="100" kern="0" dirty="0">
                 <a:solidFill>
                   <a:srgbClr val="0A3170"/>
                 </a:solidFill>
@@ -3139,7 +3307,7 @@
               </a:rPr>
               <a:t>MIS</a:t>
             </a:r>
-            <a:endParaRPr lang="en-US" sz="700" dirty="0"/>
+            <a:endParaRPr lang="en-US" sz="675" dirty="0"/>
           </a:p>
         </p:txBody>
       </p:sp>

</xml_diff>